<commit_message>
[T05 2026-10-15] docs: redistribute open tasks by effort (E-23)
Open tasks are split so that each member has about four hours left.
Sequence diagrams now go to the person who presents them; slides 2,
12, 14, 16 and 20, doc chapter 1, TODO.md, team roles, decision log
and UML README are aligned.

Co-Authored-By: Claude Opus 5.5 <noreply@anthropic.com>
Claude-Session: https://claude.ai/code/session_01H2bGsFaySUqsEjJ1PXuxUw
</commit_message>
<xml_diff>
--- a/4_praesentation/Abschlusspraesentation.pptx
+++ b/4_praesentation/Abschlusspraesentation.pptx
@@ -787,8 +787,7 @@
           <a:p>
             <a:r>
               <a:rPr lang="en-US" dirty="0"/>
-              <a:t>Vortragende(r): Kilian
-19 Use Cases in vier Bereichen, acht Akteure (je Lane ein Akteur). include = immer, extend = bedingt.</a:t>
+              <a:t>Vortragende(r): David</a:t>
             </a:r>
             <a:endParaRPr lang="en-US" dirty="0"/>
           </a:p>
@@ -965,8 +964,7 @@
           <a:p>
             <a:r>
               <a:rPr lang="en-US" dirty="0"/>
-              <a:t>Vortragende(r): Kilian
-BPMN 01: Medien nachreichen oder nach sieben Tagen verwerfen; KI erst nach Medienprüfung. Bestätigung, Terminablehnung und Timeout getrennt. Klassenbotschaften sind Operationen.</a:t>
+              <a:t>Vortragende(r): Maximilian</a:t>
             </a:r>
             <a:endParaRPr lang="en-US" dirty="0"/>
           </a:p>
@@ -1143,8 +1141,7 @@
           <a:p>
             <a:r>
               <a:rPr lang="en-US" dirty="0"/>
-              <a:t>Vortragende(r): David
-Scrum im Takt der Gruppentermine: Review, Retrospektive und Planning je Termin. Jede Änderung über Branch, Pull Request und Review; Merge durch Jakob als Qualitätsmanager. Abstimmung über WhatsApp, Dateien nur über GitHub.</a:t>
+              <a:t>Vortragende(r): Kilian</a:t>
             </a:r>
             <a:endParaRPr lang="en-US" dirty="0"/>
           </a:p>
@@ -9045,7 +9042,7 @@
                 <a:ea typeface="Calibri" pitchFamily="34" charset="-122"/>
                 <a:cs typeface="Calibri" pitchFamily="34" charset="-120"/>
               </a:rPr>
-              <a:t>Kilian, Jakob</a:t>
+              <a:t>David, Kilian, Maximilian, Jakob</a:t>
             </a:r>
             <a:endParaRPr lang="en-US" sz="1200" dirty="0"/>
           </a:p>
@@ -9187,7 +9184,7 @@
                 <a:ea typeface="Calibri" pitchFamily="34" charset="-122"/>
                 <a:cs typeface="Calibri" pitchFamily="34" charset="-120"/>
               </a:rPr>
-              <a:t>David</a:t>
+              <a:t>Kilian</a:t>
             </a:r>
             <a:endParaRPr lang="en-US" sz="1200" dirty="0"/>
           </a:p>
@@ -9904,7 +9901,7 @@
                           <a:ea typeface="Calibri" pitchFamily="34" charset="-122"/>
                           <a:cs typeface="Calibri" pitchFamily="34" charset="-120"/>
                         </a:rPr>
-                        <a:t>Einleitung und Agenda, Fazit und Ausblick, Moderation der Fragerunde; Projektleitung</a:t>
+                        <a:t>Einleitung und Agenda, Fazit und Ausblick, Moderation der Fragerunde; Projektleitung, Fertigstellung der Dokumentation</a:t>
                       </a:r>
                       <a:endParaRPr lang="en-US" sz="1100" dirty="0">
                         <a:latin typeface="Calibri" charset="0"/>
@@ -10036,7 +10033,7 @@
                           <a:ea typeface="Calibri" pitchFamily="34" charset="-122"/>
                           <a:cs typeface="Calibri" pitchFamily="34" charset="-120"/>
                         </a:rPr>
-                        <a:t>3, 16</a:t>
+                        <a:t>3, 12</a:t>
                       </a:r>
                       <a:endParaRPr lang="en-US" sz="1100" dirty="0">
                         <a:latin typeface="Calibri" charset="0"/>
@@ -10101,7 +10098,7 @@
                           <a:ea typeface="Calibri" pitchFamily="34" charset="-122"/>
                           <a:cs typeface="Calibri" pitchFamily="34" charset="-120"/>
                         </a:rPr>
-                        <a:t>Ausgangslage und Problem; Vorgehen und Projektmanagement; stellvertretende Projektleitung, Backups</a:t>
+                        <a:t>Ausgangslage und Problem, Use-Case-Diagramm; Überarbeitung des Use-Case-Diagramms, SD2 und SD4 in Visual Paradigm, stellvertretende Projektleitung</a:t>
                       </a:r>
                       <a:endParaRPr lang="en-US" sz="1100" dirty="0">
                         <a:latin typeface="Calibri" charset="0"/>
@@ -10298,7 +10295,7 @@
                           <a:ea typeface="Calibri" pitchFamily="34" charset="-122"/>
                           <a:cs typeface="Calibri" pitchFamily="34" charset="-120"/>
                         </a:rPr>
-                        <a:t>Startup und Markt, Zustandsautomat, KI-Sofortdiagnose; Product Owner</a:t>
+                        <a:t>Startup und Markt, Zustandsautomat, KI-Sofortdiagnose; Product Owner, SD5 und SD6 in Visual Paradigm</a:t>
                       </a:r>
                       <a:endParaRPr lang="en-US" sz="1100" dirty="0">
                         <a:latin typeface="Calibri" charset="0"/>
@@ -10430,7 +10427,7 @@
                           <a:ea typeface="Calibri" pitchFamily="34" charset="-122"/>
                           <a:cs typeface="Calibri" pitchFamily="34" charset="-120"/>
                         </a:rPr>
-                        <a:t>7–10</a:t>
+                        <a:t>7–10, 14</a:t>
                       </a:r>
                       <a:endParaRPr lang="en-US" sz="1100" dirty="0">
                         <a:latin typeface="Calibri" charset="0"/>
@@ -10495,7 +10492,7 @@
                           <a:ea typeface="Calibri" pitchFamily="34" charset="-122"/>
                           <a:cs typeface="Calibri" pitchFamily="34" charset="-120"/>
                         </a:rPr>
-                        <a:t>Geschäftsprozessmodell: Prozesslandkarte, Konventionen, Prozesse 01 und 04; BPMN-Modellierung im Camunda Modeler</a:t>
+                        <a:t>Geschäftsprozessmodell: Prozesslandkarte, Konventionen, Prozesse 01 und 04, Sequenzdiagramm SD1; BPMN im Camunda Modeler, SD1 in Visual Paradigm</a:t>
                       </a:r>
                       <a:endParaRPr lang="en-US" sz="1100" dirty="0">
                         <a:latin typeface="Calibri" charset="0"/>
@@ -10627,7 +10624,7 @@
                           <a:ea typeface="Calibri" pitchFamily="34" charset="-122"/>
                           <a:cs typeface="Calibri" pitchFamily="34" charset="-120"/>
                         </a:rPr>
-                        <a:t>12–14</a:t>
+                        <a:t>13, 16</a:t>
                       </a:r>
                       <a:endParaRPr lang="en-US" sz="1100" dirty="0">
                         <a:latin typeface="Calibri" charset="0"/>
@@ -10692,7 +10689,7 @@
                           <a:ea typeface="Calibri" pitchFamily="34" charset="-122"/>
                           <a:cs typeface="Calibri" pitchFamily="34" charset="-120"/>
                         </a:rPr>
-                        <a:t>Use-Case-Diagramm, Klassendiagramm, Sequenzdiagramm SD1; UML-Modellierung in Visual Paradigm, Scrum Master</a:t>
+                        <a:t>Klassendiagramm, Vorgehen und Projektmanagement; Klassendiagramm und VP-Projekt, Scrum Master</a:t>
                       </a:r>
                       <a:endParaRPr lang="en-US" sz="1100" dirty="0">
                         <a:latin typeface="Calibri" charset="0"/>
@@ -10889,7 +10886,7 @@
                           <a:ea typeface="Calibri" pitchFamily="34" charset="-122"/>
                           <a:cs typeface="Calibri" pitchFamily="34" charset="-120"/>
                         </a:rPr>
-                        <a:t>Sequenzdiagramm SD3, Herausforderungen; Qualitätssicherung und Konsistenz</a:t>
+                        <a:t>Sequenzdiagramm SD3, Herausforderungen; Qualitätssicherung und Konsistenz, SD3 in Visual Paradigm</a:t>
                       </a:r>
                       <a:endParaRPr lang="en-US" sz="1100" dirty="0">
                         <a:latin typeface="Calibri" charset="0"/>
@@ -10975,7 +10972,7 @@
                 <a:ea typeface="Calibri" pitchFamily="34" charset="-122"/>
                 <a:cs typeface="Calibri" pitchFamily="34" charset="-120"/>
               </a:rPr>
-              <a:t>Zuordnung nach der Rollenverteilung vom Gruppentermin 02.09.2026.</a:t>
+              <a:t>Zuordnung nach der Aufgabenverteilung vom Gruppentermin 15.10.2026 (E-23): Jede Person trägt vor, was sie selbst erarbeitet hat.</a:t>
             </a:r>
             <a:endParaRPr lang="en-US" sz="1000" dirty="0"/>
           </a:p>

</xml_diff>

<commit_message>
[T05 2026-10-15] feat: one role per use case (E-24), responsibilities for completion (E-23)
Use-case diagram rebuilt after the lecturer's feedback: 15 employee
roles, each tied to exactly one use case, customer and supplier drawn
several times, UC08 without actor. New grid-layout template
(usecase_layout.py), modell.xmi updated and modell-usecase.xmi added
for re-import into Visual Paradigm. Sequence diagrams use the role
names. Documentation (1, 3.1, 5.3 with role table, 5.5, 5.6, 7.1),
slides 2, 12, 16, 18, 20 and speaker notes, decision log (E-23, E-24),
lecturer feedback and TODO.md (tasks without names) aligned.

Co-Authored-By: Claude Fable 5.1 <noreply@anthropic.com>
Claude-Session: https://claude.ai/code/session_01H2bGsFaySUqsEjJ1PXuxUw
</commit_message>
<xml_diff>
--- a/4_praesentation/Abschlusspraesentation.pptx
+++ b/4_praesentation/Abschlusspraesentation.pptx
@@ -520,10 +520,8 @@
           <a:lstStyle/>
           <a:p>
             <a:r>
-              <a:rPr lang="en-US" dirty="0"/>
               <a:t>Vortragende(r): Nina</a:t>
             </a:r>
-            <a:endParaRPr lang="en-US" dirty="0"/>
           </a:p>
         </p:txBody>
       </p:sp>
@@ -608,11 +606,14 @@
           <a:lstStyle/>
           <a:p>
             <a:r>
-              <a:rPr lang="en-US" dirty="0"/>
-              <a:t>Vortragende(r): Maximilian
-Ereignisbasiertes Gateway: Freigabe, Ablehnung oder Timer. Die Erinnerung protokollieren und den KVA erneut senden; nach der dritten Erinnerung gilt der KVA als abgelehnt. Abgelehnte Aufträge gehen über Prozess 08 mit Diagnosepauschale zur Abholung.</a:t>
-            </a:r>
-            <a:endParaRPr lang="en-US" dirty="0"/>
+              <a:t>Vortragende(r): Maximilian</a:t>
+            </a:r>
+          </a:p>
+          <a:p/>
+          <a:p>
+            <a:r>
+              <a:t>Ereignisbasiertes Gateway: Freigabe, Ablehnung oder Timer. Die Erinnerung protokollieren und den KVA erneut senden; nach der dritten Erinnerung gilt der KVA als abgelehnt. Abgelehnte Aufträge gehen über Prozess 08 mit Diagnosepauschale zur Abholung.</a:t>
+            </a:r>
           </a:p>
         </p:txBody>
       </p:sp>
@@ -697,11 +698,14 @@
           <a:lstStyle/>
           <a:p>
             <a:r>
-              <a:rPr lang="en-US" dirty="0"/>
-              <a:t>Vortragende(r): Adrian
-Rückmeldung des Dozenten: ein Gimmick, das uns abhebt, darf visionär sein. Heute machbar: sichtbare Schäden per Bildanalyse. Vision: Geräuschanalyse, Aufwandsschätzung aus Video. Deshalb: Vorschlag bleibt vorläufig, Techniker bestätigt.</a:t>
-            </a:r>
-            <a:endParaRPr lang="en-US" dirty="0"/>
+              <a:t>Vortragende(r): Adrian</a:t>
+            </a:r>
+          </a:p>
+          <a:p/>
+          <a:p>
+            <a:r>
+              <a:t>Rückmeldung des Dozenten: ein Gimmick, das uns abhebt, darf visionär sein. Heute machbar: sichtbare Schäden per Bildanalyse. Vision: Geräuschanalyse, Aufwandsschätzung aus Video. Deshalb: Vorschlag bleibt vorläufig, Techniker bestätigt.</a:t>
+            </a:r>
           </a:p>
         </p:txBody>
       </p:sp>
@@ -786,10 +790,14 @@
           <a:lstStyle/>
           <a:p>
             <a:r>
-              <a:rPr lang="en-US" dirty="0"/>
               <a:t>Vortragende(r): David</a:t>
             </a:r>
-            <a:endParaRPr lang="en-US" dirty="0"/>
+          </a:p>
+          <a:p/>
+          <a:p>
+            <a:r>
+              <a:t>19 Use Cases in vier Bereichen, 18 Akteure. Seit 15.10. (Hinweis des Dozenten): je Use Case genau eine Rolle, z. B. Diagnoseprüfer, Diagnostiker, Kalkulator, Reparateur und Endkontrolleur statt eines Technikers mit fünf Linien. Das Organigramm ordnet Rollen den Mitarbeiterklassen zu (Tabelle 7 der Doku). Kunde und Lieferant mehrfach dargestellt, UC08 nur per include ohne Akteur. include = immer, extend = bedingt.</a:t>
+            </a:r>
           </a:p>
         </p:txBody>
       </p:sp>
@@ -874,11 +882,14 @@
           <a:lstStyle/>
           <a:p>
             <a:r>
-              <a:rPr lang="en-US" dirty="0"/>
-              <a:t>Vortragende(r): Kilian
-Entwurfsentscheidungen: Reparaturauftrag als Aggregatwurzel, Lagerbestand je Filiale, Reservierung als eigene Klasse, Werkstattbetrieb als Mandant, Rollen als Unterklassen von Mitarbeiter, drei KI-Klassen.</a:t>
-            </a:r>
-            <a:endParaRPr lang="en-US" dirty="0"/>
+              <a:t>Vortragende(r): Kilian</a:t>
+            </a:r>
+          </a:p>
+          <a:p/>
+          <a:p>
+            <a:r>
+              <a:t>Entwurfsentscheidungen: Reparaturauftrag als Aggregatwurzel, Lagerbestand je Filiale, Reservierung als eigene Klasse, Werkstattbetrieb als Mandant, Rollen als Unterklassen von Mitarbeiter, drei KI-Klassen.</a:t>
+            </a:r>
           </a:p>
         </p:txBody>
       </p:sp>
@@ -963,10 +974,14 @@
           <a:lstStyle/>
           <a:p>
             <a:r>
-              <a:rPr lang="en-US" dirty="0"/>
-              <a:t>Vortragende(r): Maximilian</a:t>
-            </a:r>
-            <a:endParaRPr lang="en-US" dirty="0"/>
+              <a:t>Vortragende(r): Kilian</a:t>
+            </a:r>
+          </a:p>
+          <a:p/>
+          <a:p>
+            <a:r>
+              <a:t>BPMN 01: Medien nachreichen oder nach sieben Tagen verwerfen; KI erst nach Medienprüfung. Bestätigung, Terminablehnung und Timeout getrennt. Klassenbotschaften sind Operationen.</a:t>
+            </a:r>
           </a:p>
         </p:txBody>
       </p:sp>
@@ -1051,11 +1066,14 @@
           <a:lstStyle/>
           <a:p>
             <a:r>
-              <a:rPr lang="en-US" dirty="0"/>
-              <a:t>Vortragende(r): Jakob
-BPMN 05: parallele Teileprüfung; Fehlteile zunächst markieren. Reservierungen bestätigen, Meldebestand prüfen, Kunde informieren, erst danach bestellen.</a:t>
-            </a:r>
-            <a:endParaRPr lang="en-US" dirty="0"/>
+              <a:t>Vortragende(r): David</a:t>
+            </a:r>
+          </a:p>
+          <a:p/>
+          <a:p>
+            <a:r>
+              <a:t>BPMN 05: parallele Teileprüfung; Fehlteile zunächst markieren. Reservierungen bestätigen, Meldebestand prüfen, Kunde informieren, erst danach bestellen.</a:t>
+            </a:r>
           </a:p>
         </p:txBody>
       </p:sp>
@@ -1140,10 +1158,14 @@
           <a:lstStyle/>
           <a:p>
             <a:r>
-              <a:rPr lang="en-US" dirty="0"/>
               <a:t>Vortragende(r): Kilian</a:t>
             </a:r>
-            <a:endParaRPr lang="en-US" dirty="0"/>
+          </a:p>
+          <a:p/>
+          <a:p>
+            <a:r>
+              <a:t>Scrum im Takt der Gruppentermine: Review, Retrospektive und Planning je Termin. Jede Änderung über Branch, Pull Request und Review; Merge durch Jakob als Qualitätsmanager. Abstimmung über WhatsApp, Dateien nur über GitHub.</a:t>
+            </a:r>
           </a:p>
         </p:txBody>
       </p:sp>
@@ -1228,11 +1250,14 @@
           <a:lstStyle/>
           <a:p>
             <a:r>
-              <a:rPr lang="en-US" dirty="0"/>
-              <a:t>Vortragende(r): Jakob
-Beispiel für die Konsistenzprüfung: Nach den Korrekturen an Prozess 07 (E-19) musste SD4 nachgezogen werden. Prüfrunden: Gesamtprüfung am 26.09., Komplettcheck am 05.10. mit 39 Befunden, QA-Checkliste mit Q1 bis Q8.</a:t>
-            </a:r>
-            <a:endParaRPr lang="en-US" dirty="0"/>
+              <a:t>Vortragende(r): Jakob</a:t>
+            </a:r>
+          </a:p>
+          <a:p/>
+          <a:p>
+            <a:r>
+              <a:t>Beispiel für die Konsistenzprüfung: Nach den Korrekturen an Prozess 07 (E-19) musste SD4 nachgezogen werden. Prüfrunden: Gesamtprüfung am 26.09., Komplettcheck am 05.10. mit 39 Befunden, QA-Checkliste mit Q1 bis Q8.</a:t>
+            </a:r>
           </a:p>
         </p:txBody>
       </p:sp>
@@ -1317,11 +1342,14 @@
           <a:lstStyle/>
           <a:p>
             <a:r>
-              <a:rPr lang="en-US" dirty="0"/>
-              <a:t>Vortragende(r): Nina
-Kennzahlen kurz nennen, dann die zwei Kernaussagen. Der Ausblick ist Vision, nicht modelliert.</a:t>
-            </a:r>
-            <a:endParaRPr lang="en-US" dirty="0"/>
+              <a:t>Vortragende(r): Nina</a:t>
+            </a:r>
+          </a:p>
+          <a:p/>
+          <a:p>
+            <a:r>
+              <a:t>Kennzahlen kurz nennen, dann die zwei Kernaussagen. Der Ausblick ist Vision, nicht modelliert.</a:t>
+            </a:r>
           </a:p>
         </p:txBody>
       </p:sp>
@@ -1406,10 +1434,8 @@
           <a:lstStyle/>
           <a:p>
             <a:r>
-              <a:rPr lang="en-US" dirty="0"/>
               <a:t>Vortragende(r): Nina</a:t>
             </a:r>
-            <a:endParaRPr lang="en-US" dirty="0"/>
           </a:p>
         </p:txBody>
       </p:sp>
@@ -1494,11 +1520,14 @@
           <a:lstStyle/>
           <a:p>
             <a:r>
-              <a:rPr lang="en-US" dirty="0"/>
-              <a:t>Vortragende(r): Nina
-Kurz die sieben Teile und die Vortragenden nennen; Fragen bitte am Ende.</a:t>
-            </a:r>
-            <a:endParaRPr lang="en-US" dirty="0"/>
+              <a:t>Vortragende(r): Nina</a:t>
+            </a:r>
+          </a:p>
+          <a:p/>
+          <a:p>
+            <a:r>
+              <a:t>Kurz die sieben Teile und die Vortragenden nennen; Fragen bitte am Ende.</a:t>
+            </a:r>
           </a:p>
         </p:txBody>
       </p:sp>
@@ -1583,11 +1612,14 @@
           <a:lstStyle/>
           <a:p>
             <a:r>
-              <a:rPr lang="en-US" dirty="0"/>
-              <a:t>Vortragende(r): -
-Pflichtangabe für den PDF-Export laut Ablauf: welche/r Vortragende welchen Beitrag verantwortet.</a:t>
-            </a:r>
-            <a:endParaRPr lang="en-US" dirty="0"/>
+              <a:t>Vortragende(r): -</a:t>
+            </a:r>
+          </a:p>
+          <a:p/>
+          <a:p>
+            <a:r>
+              <a:t>Pflichtangabe für den PDF-Export laut Ablauf: welche/r Vortragende welchen Beitrag verantwortet.</a:t>
+            </a:r>
           </a:p>
         </p:txBody>
       </p:sp>
@@ -1672,11 +1704,14 @@
           <a:lstStyle/>
           <a:p>
             <a:r>
-              <a:rPr lang="en-US" dirty="0"/>
-              <a:t>Vortragende(r): David
-FixWerk GmbH ist ein fiktiver Pilotkunde mit vier Filialen in der Region Karlsruhe (Fahrrad, E-Bike, Elektronik). Die vier Probleme sind Annahmen unseres Szenarios, keine erhobenen Daten.</a:t>
-            </a:r>
-            <a:endParaRPr lang="en-US" dirty="0"/>
+              <a:t>Vortragende(r): David</a:t>
+            </a:r>
+          </a:p>
+          <a:p/>
+          <a:p>
+            <a:r>
+              <a:t>FixWerk GmbH ist ein fiktiver Pilotkunde mit vier Filialen in der Region Karlsruhe (Fahrrad, E-Bike, Elektronik). Die vier Probleme sind Annahmen unseres Szenarios, keine erhobenen Daten.</a:t>
+            </a:r>
           </a:p>
         </p:txBody>
       </p:sp>
@@ -1761,11 +1796,14 @@
           <a:lstStyle/>
           <a:p>
             <a:r>
-              <a:rPr lang="en-US" dirty="0"/>
-              <a:t>Vortragende(r): Adrian
-Rückfrage des Dozenten bei der Konzeptvorstellung: Betreiber oder Solution Provider? Wir sind der Softwareanbieter, FixWerk ist der Pilotkunde. Systemkontext: Buchhaltung, Lieferantensysteme und die physische Reparatur liegen außerhalb der Systemgrenze.</a:t>
-            </a:r>
-            <a:endParaRPr lang="en-US" dirty="0"/>
+              <a:t>Vortragende(r): Adrian</a:t>
+            </a:r>
+          </a:p>
+          <a:p/>
+          <a:p>
+            <a:r>
+              <a:t>Rückfrage des Dozenten bei der Konzeptvorstellung: Betreiber oder Solution Provider? Wir sind der Softwareanbieter, FixWerk ist der Pilotkunde. Systemkontext: Buchhaltung, Lieferantensysteme und die physische Reparatur liegen außerhalb der Systemgrenze.</a:t>
+            </a:r>
           </a:p>
         </p:txBody>
       </p:sp>
@@ -1850,11 +1888,14 @@
           <a:lstStyle/>
           <a:p>
             <a:r>
-              <a:rPr lang="en-US" dirty="0"/>
-              <a:t>Vortragende(r): Adrian
-Die drei Merkmale beschreiben den Zuschnitt unseres Entwurfs. Einen belegten Funktionsvergleich mit bestehenden Werkstattlösungen haben wir nicht erstellt; deshalb nennen wir keine Wettbewerber.</a:t>
-            </a:r>
-            <a:endParaRPr lang="en-US" dirty="0"/>
+              <a:t>Vortragende(r): Adrian</a:t>
+            </a:r>
+          </a:p>
+          <a:p/>
+          <a:p>
+            <a:r>
+              <a:t>Die drei Merkmale beschreiben den Zuschnitt unseres Entwurfs. Einen belegten Funktionsvergleich mit bestehenden Werkstattlösungen haben wir nicht erstellt; deshalb nennen wir keine Wettbewerber.</a:t>
+            </a:r>
           </a:p>
         </p:txBody>
       </p:sp>
@@ -1939,11 +1980,14 @@
           <a:lstStyle/>
           <a:p>
             <a:r>
-              <a:rPr lang="en-US" dirty="0"/>
-              <a:t>Vortragende(r): Adrian
-Der Automat ist der gemeinsame Nenner aller Modelle: BPMN-Prozesse sind seine Übergänge, das Klassendiagramm führt ihn als Attribut status, die Sequenzdiagramme markieren die Wechsel.</a:t>
-            </a:r>
-            <a:endParaRPr lang="en-US" dirty="0"/>
+              <a:t>Vortragende(r): Adrian</a:t>
+            </a:r>
+          </a:p>
+          <a:p/>
+          <a:p>
+            <a:r>
+              <a:t>Der Automat ist der gemeinsame Nenner aller Modelle: BPMN-Prozesse sind seine Übergänge, das Klassendiagramm führt ihn als Attribut status, die Sequenzdiagramme markieren die Wechsel.</a:t>
+            </a:r>
           </a:p>
         </p:txBody>
       </p:sp>
@@ -2028,11 +2072,14 @@
           <a:lstStyle/>
           <a:p>
             <a:r>
-              <a:rPr lang="en-US" dirty="0"/>
-              <a:t>Vortragende(r): Maximilian
-Prozesse 01 bis 08 sind die Auftragsreise entlang des Zustandsautomaten, 09 und 10 die Folgeprozesse Reklamation und Retoure. Gezählt sind nur die Aktivitäten im Werkstatt-Pool; die 26 Aktivitäten der Kundenabläufe kommen hinzu.</a:t>
-            </a:r>
-            <a:endParaRPr lang="en-US" dirty="0"/>
+              <a:t>Vortragende(r): Maximilian</a:t>
+            </a:r>
+          </a:p>
+          <a:p/>
+          <a:p>
+            <a:r>
+              <a:t>Prozesse 01 bis 08 sind die Auftragsreise entlang des Zustandsautomaten, 09 und 10 die Folgeprozesse Reklamation und Retoure. Gezählt sind nur die Aktivitäten im Werkstatt-Pool; die 26 Aktivitäten der Kundenabläufe kommen hinzu.</a:t>
+            </a:r>
           </a:p>
         </p:txBody>
       </p:sp>
@@ -2117,11 +2164,14 @@
           <a:lstStyle/>
           <a:p>
             <a:r>
-              <a:rPr lang="en-US" dirty="0"/>
-              <a:t>Vortragende(r): Maximilian
-Regeln aus der Vorlesung: Pool = Unternehmen, Lane = Rolle, keine Lane für Software. Automatisierung zeigt der Aktivitätstyp. Der Kunde hat einen eigenen, nicht ausführbaren Ablauf (z. B. Foto aufnehmen, Anfrage senden, KVA freigeben), der Lieferant bleibt Black Box.</a:t>
-            </a:r>
-            <a:endParaRPr lang="en-US" dirty="0"/>
+              <a:t>Vortragende(r): Jakob</a:t>
+            </a:r>
+          </a:p>
+          <a:p/>
+          <a:p>
+            <a:r>
+              <a:t>Regeln aus der Vorlesung: Pool = Unternehmen, Lane = Rolle, keine Lane für Software. Automatisierung zeigt der Aktivitätstyp. Der Kunde hat einen eigenen, nicht ausführbaren Ablauf (z. B. Foto aufnehmen, Anfrage senden, KVA freigeben), der Lieferant bleibt Black Box. Als Qualitätsmanager: Diese Regeln sind die Prüfpunkte der QA-Checkliste.</a:t>
+            </a:r>
           </a:p>
         </p:txBody>
       </p:sp>
@@ -2206,11 +2256,14 @@
           <a:lstStyle/>
           <a:p>
             <a:r>
-              <a:rPr lang="en-US" dirty="0"/>
-              <a:t>Vortragende(r): Maximilian
-Message-Start aus der App, Voranmeldung wird sofort angelegt, Medienprüfung mit Rückfrage (Antwort oder 7-Tage-Timer), KI als Business Rule Task, Vorab-KVA, Verfügbarkeit über alle Filialen, Terminvorschlag, ereignisbasiertes Gateway: Bestätigung, Ablehnung oder 7-Tage-Timer.</a:t>
-            </a:r>
-            <a:endParaRPr lang="en-US" dirty="0"/>
+              <a:t>Vortragende(r): Maximilian</a:t>
+            </a:r>
+          </a:p>
+          <a:p/>
+          <a:p>
+            <a:r>
+              <a:t>Message-Start aus der App, Voranmeldung wird sofort angelegt, Medienprüfung mit Rückfrage (Antwort oder 7-Tage-Timer), KI als Business Rule Task, Vorab-KVA, Verfügbarkeit über alle Filialen, Terminvorschlag, ereignisbasiertes Gateway: Bestätigung, Ablehnung oder 7-Tage-Timer.</a:t>
+            </a:r>
           </a:p>
         </p:txBody>
       </p:sp>
@@ -4541,30 +4594,6 @@
           </a:p>
         </p:txBody>
       </p:sp>
-      <p:pic>
-        <p:nvPicPr>
-          <p:cNvPr id="6" name="Image 0" descr="/tmp/repo/uml/usecase.png">    </p:cNvPr>
-          <p:cNvPicPr>
-            <a:picLocks noChangeAspect="1"/>
-          </p:cNvPicPr>
-          <p:nvPr/>
-        </p:nvPicPr>
-        <p:blipFill>
-          <a:blip r:embed="rId1"/>
-          <a:stretch>
-            <a:fillRect/>
-          </a:stretch>
-        </p:blipFill>
-        <p:spPr>
-          <a:xfrm>
-            <a:off x="1212172" y="960120"/>
-            <a:ext cx="3427817" cy="3749040"/>
-          </a:xfrm>
-          <a:prstGeom prst="rect">
-            <a:avLst/>
-          </a:prstGeom>
-        </p:spPr>
-      </p:pic>
       <p:sp>
         <p:nvSpPr>
           <p:cNvPr id="7" name="Text 3"/>
@@ -4623,7 +4652,7 @@
                 <a:ea typeface="Calibri" pitchFamily="34" charset="-122"/>
                 <a:cs typeface="Calibri" pitchFamily="34" charset="-120"/>
               </a:rPr>
-              <a:t>Primäre Akteure: Kunde, Servicemitarbeiter, Techniker, Disponent, Werkstattleiter, Werkstattinhaber</a:t>
+              <a:t>Je Use Case genau eine Rolle: 15 Mitarbeiterrollen statt vier Akteuren mit bis zu acht Linien (Hinweis des Dozenten)</a:t>
             </a:r>
             <a:endParaRPr lang="en-US" sz="1150" dirty="0"/>
           </a:p>
@@ -4644,7 +4673,7 @@
                 <a:ea typeface="Calibri" pitchFamily="34" charset="-122"/>
                 <a:cs typeface="Calibri" pitchFamily="34" charset="-120"/>
               </a:rPr>
-              <a:t>Sekundär und extern: Lieferant, KI-Diagnosedienst</a:t>
+              <a:t>Kunde und die externen Akteure Lieferant und KI-Diagnosedienst mehrfach dargestellt; Rolle → Klasse und Lane: Tabelle 7 der Doku</a:t>
             </a:r>
             <a:endParaRPr lang="en-US" sz="1150" dirty="0"/>
           </a:p>
@@ -4689,6 +4718,61 @@
               <a:t>«extend» für bedingtes Verhalten, z. B. Voranmeldung bestätigen → Sofortdiagnose anfordern</a:t>
             </a:r>
             <a:endParaRPr lang="en-US" sz="1150" dirty="0"/>
+          </a:p>
+        </p:txBody>
+      </p:sp>
+      <p:pic>
+        <p:nvPicPr>
+          <p:cNvPr id="8" name="Picture 7" descr="uc_ausschnitt.png"/>
+          <p:cNvPicPr>
+            <a:picLocks noChangeAspect="1"/>
+          </p:cNvPicPr>
+          <p:nvPr/>
+        </p:nvPicPr>
+        <p:blipFill>
+          <a:blip r:embed="rId5"/>
+          <a:stretch>
+            <a:fillRect/>
+          </a:stretch>
+        </p:blipFill>
+        <p:spPr>
+          <a:xfrm>
+            <a:off x="912172" y="1460665"/>
+            <a:ext cx="4027817" cy="2747949"/>
+          </a:xfrm>
+          <a:prstGeom prst="rect">
+            <a:avLst/>
+          </a:prstGeom>
+        </p:spPr>
+      </p:pic>
+      <p:sp>
+        <p:nvSpPr>
+          <p:cNvPr id="9" name="TextBox 8"/>
+          <p:cNvSpPr txBox="1"/>
+          <p:nvPr/>
+        </p:nvSpPr>
+        <p:spPr>
+          <a:xfrm>
+            <a:off x="912172" y="4248614"/>
+            <a:ext cx="4027817" cy="250000"/>
+          </a:xfrm>
+          <a:prstGeom prst="rect">
+            <a:avLst/>
+          </a:prstGeom>
+          <a:noFill/>
+        </p:spPr>
+        <p:txBody>
+          <a:bodyPr wrap="square">
+            <a:spAutoFit/>
+          </a:bodyPr>
+          <a:lstStyle/>
+          <a:p>
+            <a:r>
+              <a:rPr sz="900" i="1">
+                <a:latin typeface="Calibri"/>
+              </a:rPr>
+              <a:t>Ausschnitt: Bereich „Auftrag und Werkstatt“ – je Use Case eine Rolle</a:t>
+            </a:r>
           </a:p>
         </p:txBody>
       </p:sp>
@@ -5783,6 +5867,10 @@
             <a:prstDash val="solid"/>
           </a:ln>
         </p:spPr>
+        <p:txBody>
+          <a:bodyPr/>
+          <a:p/>
+        </p:txBody>
       </p:sp>
       <p:sp>
         <p:nvSpPr>
@@ -5847,6 +5935,10 @@
             <a:prstDash val="solid"/>
           </a:ln>
         </p:spPr>
+        <p:txBody>
+          <a:bodyPr/>
+          <a:p/>
+        </p:txBody>
       </p:sp>
       <p:sp>
         <p:nvSpPr>
@@ -5911,6 +6003,10 @@
             <a:prstDash val="solid"/>
           </a:ln>
         </p:spPr>
+        <p:txBody>
+          <a:bodyPr/>
+          <a:p/>
+        </p:txBody>
       </p:sp>
       <p:sp>
         <p:nvSpPr>
@@ -5975,6 +6071,10 @@
             <a:prstDash val="solid"/>
           </a:ln>
         </p:spPr>
+        <p:txBody>
+          <a:bodyPr/>
+          <a:p/>
+        </p:txBody>
       </p:sp>
       <p:sp>
         <p:nvSpPr>
@@ -6039,6 +6139,10 @@
             <a:prstDash val="solid"/>
           </a:ln>
         </p:spPr>
+        <p:txBody>
+          <a:bodyPr/>
+          <a:p/>
+        </p:txBody>
       </p:sp>
       <p:sp>
         <p:nvSpPr>
@@ -6103,6 +6207,10 @@
             <a:prstDash val="solid"/>
           </a:ln>
         </p:spPr>
+        <p:txBody>
+          <a:bodyPr/>
+          <a:p/>
+        </p:txBody>
       </p:sp>
       <p:sp>
         <p:nvSpPr>
@@ -6169,6 +6277,10 @@
             <a:prstDash val="solid"/>
           </a:ln>
         </p:spPr>
+        <p:txBody>
+          <a:bodyPr/>
+          <a:p/>
+        </p:txBody>
       </p:sp>
       <p:sp>
         <p:nvSpPr>
@@ -6194,6 +6306,10 @@
             <a:prstDash val="solid"/>
           </a:ln>
         </p:spPr>
+        <p:txBody>
+          <a:bodyPr/>
+          <a:p/>
+        </p:txBody>
       </p:sp>
       <p:pic>
         <p:nvPicPr>
@@ -6291,7 +6407,7 @@
                 <a:ea typeface="Calibri" pitchFamily="34" charset="-122"/>
                 <a:cs typeface="Calibri" pitchFamily="34" charset="-120"/>
               </a:rPr>
-              <a:t>Projektleitung Nina (Stellvertretung und Backups David), Product Owner Adrian, Scrum Master und UML Kilian, BPMN Maximilian, Qualität Jakob.</a:t>
+              <a:t>Projektleitung Nina (Stellvertretung und Backups David), Product Owner Adrian, Scrum Master Kilian, UML Kilian und David, BPMN Maximilian, Qualität Jakob.</a:t>
             </a:r>
             <a:endParaRPr lang="en-US" sz="1150" dirty="0"/>
           </a:p>
@@ -6323,6 +6439,10 @@
             <a:prstDash val="solid"/>
           </a:ln>
         </p:spPr>
+        <p:txBody>
+          <a:bodyPr/>
+          <a:p/>
+        </p:txBody>
       </p:sp>
       <p:sp>
         <p:nvSpPr>
@@ -6348,6 +6468,10 @@
             <a:prstDash val="solid"/>
           </a:ln>
         </p:spPr>
+        <p:txBody>
+          <a:bodyPr/>
+          <a:p/>
+        </p:txBody>
       </p:sp>
       <p:pic>
         <p:nvPicPr>
@@ -6477,6 +6601,10 @@
             <a:prstDash val="solid"/>
           </a:ln>
         </p:spPr>
+        <p:txBody>
+          <a:bodyPr/>
+          <a:p/>
+        </p:txBody>
       </p:sp>
       <p:sp>
         <p:nvSpPr>
@@ -6502,6 +6630,10 @@
             <a:prstDash val="solid"/>
           </a:ln>
         </p:spPr>
+        <p:txBody>
+          <a:bodyPr/>
+          <a:p/>
+        </p:txBody>
       </p:sp>
       <p:pic>
         <p:nvPicPr>
@@ -7669,7 +7801,7 @@
                 <a:ea typeface="Calibri" pitchFamily="34" charset="-122"/>
                 <a:cs typeface="Calibri" pitchFamily="34" charset="-120"/>
               </a:rPr>
-              <a:t>Use Cases, 8 Akteure</a:t>
+              <a:t>Use Cases, 18 Rollen und Akteure</a:t>
             </a:r>
             <a:endParaRPr lang="en-US" sz="1100" dirty="0"/>
           </a:p>
@@ -8758,7 +8890,7 @@
                 <a:ea typeface="Calibri" pitchFamily="34" charset="-122"/>
                 <a:cs typeface="Calibri" pitchFamily="34" charset="-120"/>
               </a:rPr>
-              <a:t>Maximilian</a:t>
+              <a:t>Maximilian, Jakob</a:t>
             </a:r>
             <a:endParaRPr lang="en-US" sz="1200" dirty="0"/>
           </a:p>
@@ -9042,7 +9174,7 @@
                 <a:ea typeface="Calibri" pitchFamily="34" charset="-122"/>
                 <a:cs typeface="Calibri" pitchFamily="34" charset="-120"/>
               </a:rPr>
-              <a:t>David, Kilian, Maximilian, Jakob</a:t>
+              <a:t>David, Kilian</a:t>
             </a:r>
             <a:endParaRPr lang="en-US" sz="1200" dirty="0"/>
           </a:p>
@@ -9901,7 +10033,7 @@
                           <a:ea typeface="Calibri" pitchFamily="34" charset="-122"/>
                           <a:cs typeface="Calibri" pitchFamily="34" charset="-120"/>
                         </a:rPr>
-                        <a:t>Einleitung und Agenda, Fazit und Ausblick, Moderation der Fragerunde; Projektleitung, Fertigstellung der Dokumentation</a:t>
+                        <a:t>Einleitung und Agenda, Fazit und Ausblick, Moderation der Fragerunde; Projektleitung, Redaktion der Dokumentation, Abgabe-Archiv</a:t>
                       </a:r>
                       <a:endParaRPr lang="en-US" sz="1100" dirty="0">
                         <a:latin typeface="Calibri" charset="0"/>
@@ -10033,7 +10165,7 @@
                           <a:ea typeface="Calibri" pitchFamily="34" charset="-122"/>
                           <a:cs typeface="Calibri" pitchFamily="34" charset="-120"/>
                         </a:rPr>
-                        <a:t>3, 12</a:t>
+                        <a:t>3, 12, 15</a:t>
                       </a:r>
                       <a:endParaRPr lang="en-US" sz="1100" dirty="0">
                         <a:latin typeface="Calibri" charset="0"/>
@@ -10098,7 +10230,7 @@
                           <a:ea typeface="Calibri" pitchFamily="34" charset="-122"/>
                           <a:cs typeface="Calibri" pitchFamily="34" charset="-120"/>
                         </a:rPr>
-                        <a:t>Ausgangslage und Problem, Use-Case-Diagramm; Überarbeitung des Use-Case-Diagramms, SD2 und SD4 in Visual Paradigm, stellvertretende Projektleitung</a:t>
+                        <a:t>Ausgangslage und Problem, Use-Case-Diagramm, Sequenzdiagramm SD3; Use-Case-Diagramm und SD2, SD3, SD5, SD6 in Visual Paradigm, stellvertretende Projektleitung</a:t>
                       </a:r>
                       <a:endParaRPr lang="en-US" sz="1100" dirty="0">
                         <a:latin typeface="Calibri" charset="0"/>
@@ -10295,7 +10427,7 @@
                           <a:ea typeface="Calibri" pitchFamily="34" charset="-122"/>
                           <a:cs typeface="Calibri" pitchFamily="34" charset="-120"/>
                         </a:rPr>
-                        <a:t>Startup und Markt, Zustandsautomat, KI-Sofortdiagnose; Product Owner, SD5 und SD6 in Visual Paradigm</a:t>
+                        <a:t>Startup und Markt, Zustandsautomat, KI-Sofortdiagnose; Product Owner, Fachkonzept und Entscheidungslog</a:t>
                       </a:r>
                       <a:endParaRPr lang="en-US" sz="1100" dirty="0">
                         <a:latin typeface="Calibri" charset="0"/>
@@ -10427,7 +10559,7 @@
                           <a:ea typeface="Calibri" pitchFamily="34" charset="-122"/>
                           <a:cs typeface="Calibri" pitchFamily="34" charset="-120"/>
                         </a:rPr>
-                        <a:t>7–10, 14</a:t>
+                        <a:t>7, 9–10</a:t>
                       </a:r>
                       <a:endParaRPr lang="en-US" sz="1100" dirty="0">
                         <a:latin typeface="Calibri" charset="0"/>
@@ -10492,7 +10624,7 @@
                           <a:ea typeface="Calibri" pitchFamily="34" charset="-122"/>
                           <a:cs typeface="Calibri" pitchFamily="34" charset="-120"/>
                         </a:rPr>
-                        <a:t>Geschäftsprozessmodell: Prozesslandkarte, Konventionen, Prozesse 01 und 04, Sequenzdiagramm SD1; BPMN im Camunda Modeler, SD1 in Visual Paradigm</a:t>
+                        <a:t>Prozesslandkarte, Prozesse 01 und 04; BPMN-Modellierung der zehn Prozesse im Camunda Modeler</a:t>
                       </a:r>
                       <a:endParaRPr lang="en-US" sz="1100" dirty="0">
                         <a:latin typeface="Calibri" charset="0"/>
@@ -10624,7 +10756,7 @@
                           <a:ea typeface="Calibri" pitchFamily="34" charset="-122"/>
                           <a:cs typeface="Calibri" pitchFamily="34" charset="-120"/>
                         </a:rPr>
-                        <a:t>13, 16</a:t>
+                        <a:t>13–14, 16</a:t>
                       </a:r>
                       <a:endParaRPr lang="en-US" sz="1100" dirty="0">
                         <a:latin typeface="Calibri" charset="0"/>
@@ -10689,7 +10821,7 @@
                           <a:ea typeface="Calibri" pitchFamily="34" charset="-122"/>
                           <a:cs typeface="Calibri" pitchFamily="34" charset="-120"/>
                         </a:rPr>
-                        <a:t>Klassendiagramm, Vorgehen und Projektmanagement; Klassendiagramm und VP-Projekt, Scrum Master</a:t>
+                        <a:t>Klassendiagramm, Sequenzdiagramm SD1, Vorgehen und Projektmanagement; Klassendiagramm, SD1, SD4 und VP-Projekt, Scrum Master</a:t>
                       </a:r>
                       <a:endParaRPr lang="en-US" sz="1100" dirty="0">
                         <a:latin typeface="Calibri" charset="0"/>
@@ -10821,7 +10953,7 @@
                           <a:ea typeface="Calibri" pitchFamily="34" charset="-122"/>
                           <a:cs typeface="Calibri" pitchFamily="34" charset="-120"/>
                         </a:rPr>
-                        <a:t>15, 17</a:t>
+                        <a:t>8, 17</a:t>
                       </a:r>
                       <a:endParaRPr lang="en-US" sz="1100" dirty="0">
                         <a:latin typeface="Calibri" charset="0"/>
@@ -10886,7 +11018,7 @@
                           <a:ea typeface="Calibri" pitchFamily="34" charset="-122"/>
                           <a:cs typeface="Calibri" pitchFamily="34" charset="-120"/>
                         </a:rPr>
-                        <a:t>Sequenzdiagramm SD3, Herausforderungen; Qualitätssicherung und Konsistenz, SD3 in Visual Paradigm</a:t>
+                        <a:t>BPMN-Konventionen, Herausforderungen; Qualitätssicherung, Reviews und Konsistenz der Modelle</a:t>
                       </a:r>
                       <a:endParaRPr lang="en-US" sz="1100" dirty="0">
                         <a:latin typeface="Calibri" charset="0"/>
@@ -10972,7 +11104,7 @@
                 <a:ea typeface="Calibri" pitchFamily="34" charset="-122"/>
                 <a:cs typeface="Calibri" pitchFamily="34" charset="-120"/>
               </a:rPr>
-              <a:t>Zuordnung nach der Aufgabenverteilung vom Gruppentermin 15.10.2026 (E-23): Jede Person trägt vor, was sie selbst erarbeitet hat.</a:t>
+              <a:t>Zuordnung nach der Zuständigkeitsverteilung vom Gruppentermin 15.10.2026 (E-23): Jede Person trägt vor, was sie verantwortet.</a:t>
             </a:r>
             <a:endParaRPr lang="en-US" sz="1000" dirty="0"/>
           </a:p>

</xml_diff>

<commit_message>
[T05 2026-10-15] docs: update presentation
</commit_message>
<xml_diff>
--- a/4_praesentation/Abschlusspraesentation.pptx
+++ b/4_praesentation/Abschlusspraesentation.pptx
@@ -12,7 +12,7 @@
     <p:sldId id="257" r:id="rId3"/>
     <p:sldId id="258" r:id="rId4"/>
     <p:sldId id="259" r:id="rId5"/>
-    <p:sldId id="260" r:id="rId6"/>
+    <p:sldId id="274" r:id="rId6"/>
     <p:sldId id="261" r:id="rId7"/>
     <p:sldId id="262" r:id="rId8"/>
     <p:sldId id="263" r:id="rId9"/>
@@ -388,8 +388,8 @@
           <a:p>
             <a:r>
               <a:rPr lang="en-US" dirty="0"/>
-              <a:t>Vortragende(r): Maximilian (80 s)
-Drei Stellen zeigen, was die Prozesse leisten. Erstens der Kostenvoranschlag in Prozess 04: Nach dem Versand wartet ein ereignisbasiertes Gateway auf Freigabe, Ablehnung oder den Ablauf von drei Tagen. Bei Fristablauf erinnert RepairFlow den Kunden, höchstens zweimal. Nach dem dritten Fristablauf ohne Antwort gilt der KVA als abgelehnt und das Gerät geht mit Diagnosepauschale zur Abholung. Kein Auftrag bleibt liegen. Zweitens die Disposition in Prozess 05: Für jedes benötigte Teil läuft parallel eine Prüfung, erst im eigenen Lager, dann in den anderen Filialen. Was lokal liegt, wird reserviert, was anderswo liegt, umgelagert, und nur Fehlteile werden bestellt. Drittens die Reklamation in Prozess 09: Der Techniker prüft den Mangel, RepairFlow entscheidet nach Regel über Gewährleistung, und im Gewährleistungsfall entsteht ein kostenfreier Nacharbeitsauftrag, der wieder durch die normale Auftragsreise läuft. So bleibt das Modell schlank, weil die Reklamation keine eigene Reparaturlogik braucht.</a:t>
+              <a:t>Vortragende(r): David (70 s)
+Das Use-Case-Diagramm beschreibt, was RepairFlow für seine Benutzer leistet. 19 Use Cases in vier Bereichen: das Kundenportal mit Sofortdiagnose, Voranmeldung und KVA-Freigabe; Auftrag und Werkstatt von der Annahme bis zur Reklamation; die Ersatzteil-Disposition von der Reservierung bis zur Retoure; und die Administration des Werkstattbetriebs. Eine Besonderheit geht auf das Coaching zurück: Jeder Use Case hat genau eine Rolle. Statt eines Technikers mit fünf Verbindungen gibt es jetzt Diagnoseprüfer, Diagnostiker, Kalkulator, Reparateur und Endkontrolleur. Welche Person welche Rolle ausfüllt, regelt die Werkstatt selbst; im Datenmodell sind die Rollen den Mitarbeitertypen zugeordnet. Das Diagramm ist dadurch sofort lesbar, und die Rollen tauchen in den Sequenzdiagrammen wieder auf. Dazu kommen der Kunde und zwei externe Akteure, der Lieferant und der KI-Diagnosedienst.</a:t>
             </a:r>
           </a:p>
         </p:txBody>
@@ -411,7 +411,7 @@
           <a:p>
             <a:fld id="{F7021451-1387-4CA6-816F-3879F97B5CBC}" type="slidenum">
               <a:rPr lang="en-US"/>
-              <a:t>10</a:t>
+              <a:t>11</a:t>
             </a:fld>
             <a:endParaRPr lang="en-US"/>
           </a:p>
@@ -476,8 +476,8 @@
           <a:p>
             <a:r>
               <a:rPr lang="en-US" dirty="0"/>
-              <a:t>Vortragende(r): David (70 s)
-Das Use-Case-Diagramm beschreibt, was RepairFlow für seine Benutzer leistet. 19 Use Cases in vier Bereichen: das Kundenportal mit Sofortdiagnose, Voranmeldung und KVA-Freigabe; Auftrag und Werkstatt von der Annahme bis zur Reklamation; die Ersatzteil-Disposition von der Reservierung bis zur Retoure; und die Administration des Werkstattbetriebs. Eine Besonderheit geht auf das Coaching zurück: Jeder Use Case hat genau eine Rolle. Statt eines Technikers mit fünf Verbindungen gibt es jetzt Diagnoseprüfer, Diagnostiker, Kalkulator, Reparateur und Endkontrolleur. Welche Person welche Rolle ausfüllt, regelt die Werkstatt selbst; im Datenmodell sind die Rollen den Mitarbeitertypen zugeordnet. Das Diagramm ist dadurch sofort lesbar, und die Rollen tauchen in den Sequenzdiagrammen wieder auf. Dazu kommen der Kunde und zwei externe Akteure, der Lieferant und der KI-Diagnosedienst.</a:t>
+              <a:t>Vortragende(r): Kilian (80 s)
+Das Klassendiagramm ist ein einziges, vollständiges Modell mit 27 Klassen. Fünf Entscheidungen prägen es. Erstens: Der Reparaturauftrag ist die Aggregatwurzel. Befund und Reparaturschritte existieren nur mit ihrem Auftrag und sind deshalb Kompositionen, Kostenvoranschlag und Gerät sind nur zugeordnet, weil der Vorab-KVA schon vor dem Auftrag entsteht. Zweitens: Der Lagerbestand ist eine eigene Klasse zwischen Ersatzteil und Filiale. Nur so lässt sich die Verfügbarkeit über alle Filialen prüfen. Drittens: Die Reservierung ist eine eigene Klasse mit Lebenszyklus, vorreserviert, reserviert, entnommen, storniert. Viertens: Der Werkstattbetrieb ist der Mandant, und die Mitarbeiter sind nach Typ spezialisiert, Servicemitarbeiter, Techniker, Disponent und Werkstattleiter, passend zu den Lanes in BPMN und zu den Rollen im Use-Case-Diagramm. Fünftens: Voranmeldung, Medienanhang und KI-Diagnosevorschlag tragen die Sofortdiagnose. Die sechs Sequenzdiagramme verwenden ausschließlich Operationen dieser Klassen; jede Botschaft an ein Objekt ist eine Operation des Klassendiagramms.</a:t>
             </a:r>
           </a:p>
         </p:txBody>
@@ -499,7 +499,7 @@
           <a:p>
             <a:fld id="{F7021451-1387-4CA6-816F-3879F97B5CBC}" type="slidenum">
               <a:rPr lang="en-US"/>
-              <a:t>11</a:t>
+              <a:t>12</a:t>
             </a:fld>
             <a:endParaRPr lang="en-US"/>
           </a:p>
@@ -564,8 +564,8 @@
           <a:p>
             <a:r>
               <a:rPr lang="en-US" dirty="0"/>
-              <a:t>Vortragende(r): Kilian (80 s)
-Das Klassendiagramm ist ein einziges, vollständiges Modell mit 27 Klassen. Fünf Entscheidungen prägen es. Erstens: Der Reparaturauftrag ist die Aggregatwurzel. Befund und Reparaturschritte existieren nur mit ihrem Auftrag und sind deshalb Kompositionen, Kostenvoranschlag und Gerät sind nur zugeordnet, weil der Vorab-KVA schon vor dem Auftrag entsteht. Zweitens: Der Lagerbestand ist eine eigene Klasse zwischen Ersatzteil und Filiale. Nur so lässt sich die Verfügbarkeit über alle Filialen prüfen. Drittens: Die Reservierung ist eine eigene Klasse mit Lebenszyklus, vorreserviert, reserviert, entnommen, storniert. Viertens: Der Werkstattbetrieb ist der Mandant, und die Mitarbeiter sind nach Typ spezialisiert, Servicemitarbeiter, Techniker, Disponent und Werkstattleiter, passend zu den Lanes in BPMN und zu den Rollen im Use-Case-Diagramm. Fünftens: Voranmeldung, Medienanhang und KI-Diagnosevorschlag tragen die Sofortdiagnose. Die sechs Sequenzdiagramme verwenden ausschließlich Operationen dieser Klassen; jede Botschaft an ein Objekt ist eine Operation des Klassendiagramms.</a:t>
+              <a:t>Vortragende(r): Kilian (70 s)
+Gearbeitet haben wir in Sprints, die sich am Takt der vier Gruppentermine orientiert haben, mit Review, Retrospektive und Planning je Termin. Nina hat die Projektleitung, David die Stellvertretung und die Sicherungen, Adrian ist Product Owner, ich Scrum Master, Maximilian verantwortet BPMN, Jakob die Qualität. Alles Schriftliche liegt in einem GitHub-Repository; jede Änderung geht über einen eigenen Branch, einen Pull Request und ein Review durch eine zweite Person, bisher zehn gemergte Pull Requests. Das Trello-Board hat eine Liste je Termin und eine Karte je Person und Aufgabe. Jedes Diagramm wurde im Zweierteam geprüft. Die Meilensteine: Am 02.09. standen alle Diagramme im Entwurf, am 05.10. die Korrekturen aus zwei Gesamtprüfungen, am 15.10. haben wir die Rollenstruktur umgesetzt, am 22.10. war die Generalprobe. Die Abgabe folgt am 13.11.</a:t>
             </a:r>
           </a:p>
         </p:txBody>
@@ -587,7 +587,7 @@
           <a:p>
             <a:fld id="{F7021451-1387-4CA6-816F-3879F97B5CBC}" type="slidenum">
               <a:rPr lang="en-US"/>
-              <a:t>12</a:t>
+              <a:t>13</a:t>
             </a:fld>
             <a:endParaRPr lang="en-US"/>
           </a:p>
@@ -652,8 +652,8 @@
           <a:p>
             <a:r>
               <a:rPr lang="en-US" dirty="0"/>
-              <a:t>Vortragende(r): Kilian (70 s)
-Gearbeitet haben wir in Sprints, die sich am Takt der vier Gruppentermine orientiert haben, mit Review, Retrospektive und Planning je Termin. Nina hat die Projektleitung, David die Stellvertretung und die Sicherungen, Adrian ist Product Owner, ich Scrum Master, Maximilian verantwortet BPMN, Jakob die Qualität. Alles Schriftliche liegt in einem GitHub-Repository; jede Änderung geht über einen eigenen Branch, einen Pull Request und ein Review durch eine zweite Person, bisher zehn gemergte Pull Requests. Das Trello-Board hat eine Liste je Termin und eine Karte je Person und Aufgabe. Jedes Diagramm wurde im Zweierteam geprüft. Die Meilensteine: Am 02.09. standen alle Diagramme im Entwurf, am 05.10. die Korrekturen aus zwei Gesamtprüfungen, am 15.10. haben wir die Rollenstruktur umgesetzt, am 22.10. war die Generalprobe. Die Abgabe folgt am 13.11.</a:t>
+              <a:t>Vortragende(r): Jakob (70 s)
+Drei Modelle, die sich auf dieselben Dinge beziehen, laufen schnell auseinander. Dagegen hatten wir drei Mittel. Erstens Konventionen: Datenobjekte in BPMN tragen die Klassennamen, Aktivitäten heißen Verb plus Objekt, jede Rolle ist genau einer Lane und einer Klasse zugeordnet, und die Statuswerte sind in allen Modellen identisch. Zweitens Werkzeuge: Die BPMN-Dateien sind für Camunda 8 angereichert, mit Task-Definitionen, Timern und Bedingungen. Der Camunda-Linter und bpmnlint melden null Befunde. Drittens Prüfrunden: Eine Gesamtprüfung am 26.09., ein Komplettcheck am 05.10. mit 39 Befunden und der QA-Abgleich am 08.10. Jede Änderung wird gegen unsere QA-Checkliste geprüft, bevor sie gemergt wird. Ein Beispiel: Als wir die Nacharbeit in Prozess 07 auf zwei Durchläufe begrenzt haben, musste das Sequenzdiagramm SD4 nachziehen. Genau solche Stellen findet die Checkliste.</a:t>
             </a:r>
           </a:p>
         </p:txBody>
@@ -675,7 +675,7 @@
           <a:p>
             <a:fld id="{F7021451-1387-4CA6-816F-3879F97B5CBC}" type="slidenum">
               <a:rPr lang="en-US"/>
-              <a:t>13</a:t>
+              <a:t>14</a:t>
             </a:fld>
             <a:endParaRPr lang="en-US"/>
           </a:p>
@@ -741,7 +741,7 @@
             <a:r>
               <a:rPr lang="en-US" dirty="0"/>
               <a:t>Vortragende(r): Jakob (70 s)
-Drei Modelle, die sich auf dieselben Dinge beziehen, laufen schnell auseinander. Dagegen hatten wir drei Mittel. Erstens Konventionen: Datenobjekte in BPMN tragen die Klassennamen, Aktivitäten heißen Verb plus Objekt, jede Rolle ist genau einer Lane und einer Klasse zugeordnet, und die Statuswerte sind in allen Modellen identisch. Zweitens Werkzeuge: Die BPMN-Dateien sind für Camunda 8 angereichert, mit Task-Definitionen, Timern und Bedingungen. Der Camunda-Linter und bpmnlint melden null Befunde. Drittens Prüfrunden: Eine Gesamtprüfung am 26.09., ein Komplettcheck am 05.10. mit 39 Befunden und der QA-Abgleich am 08.10. Jede Änderung wird gegen unsere QA-Checkliste geprüft, bevor sie gemergt wird. Ein Beispiel: Als wir die Nacharbeit in Prozess 07 auf zwei Durchläufe begrenzt haben, musste das Sequenzdiagramm SD4 nachziehen. Genau solche Stellen findet die Checkliste.</a:t>
+Vier Dinge haben uns am meisten beschäftigt. Die Perspektive: Werkstatt oder Softwareanbieter? Die Rückfrage des Dozenten hat uns zur klaren Entscheidung gezwungen, und danach mussten Texte und Klassenmodell nachziehen. Das Vokabular: Datenobjekte, Klassen, Lebenslinien und Statuswerte müssen wortgleich sein, sonst zerfällt die Analyse in drei Einzelmodelle. Die Werkzeuge: Der Camunda Modeler meldet für Camunda 8 fehlende technische Details als Fehler, und wir haben die Diagramme so lange angereichert, bis nichts mehr rot war. Und die Vision: Die KI-Sofortdiagnose soll beeindrucken, aber glaubwürdig bleiben, deshalb die Trennung in heute machbar und Vision. Gelernt haben wir, dass Konsistenz keine Prüfung am Ende ist, sondern eine Regel bei jeder Änderung. Und dass ein klarer Hinweis von außen, wie der zum Use-Case-Diagramm, ein Modell deutlich besser machen kann.</a:t>
             </a:r>
           </a:p>
         </p:txBody>
@@ -763,7 +763,7 @@
           <a:p>
             <a:fld id="{F7021451-1387-4CA6-816F-3879F97B5CBC}" type="slidenum">
               <a:rPr lang="en-US"/>
-              <a:t>14</a:t>
+              <a:t>15</a:t>
             </a:fld>
             <a:endParaRPr lang="en-US"/>
           </a:p>
@@ -828,8 +828,8 @@
           <a:p>
             <a:r>
               <a:rPr lang="en-US" dirty="0"/>
-              <a:t>Vortragende(r): Jakob (70 s)
-Vier Dinge haben uns am meisten beschäftigt. Die Perspektive: Werkstatt oder Softwareanbieter? Die Rückfrage des Dozenten hat uns zur klaren Entscheidung gezwungen, und danach mussten Texte und Klassenmodell nachziehen. Das Vokabular: Datenobjekte, Klassen, Lebenslinien und Statuswerte müssen wortgleich sein, sonst zerfällt die Analyse in drei Einzelmodelle. Die Werkzeuge: Der Camunda Modeler meldet für Camunda 8 fehlende technische Details als Fehler, und wir haben die Diagramme so lange angereichert, bis nichts mehr rot war. Und die Vision: Die KI-Sofortdiagnose soll beeindrucken, aber glaubwürdig bleiben, deshalb die Trennung in heute machbar und Vision. Gelernt haben wir, dass Konsistenz keine Prüfung am Ende ist, sondern eine Regel bei jeder Änderung. Und dass ein klarer Hinweis von außen, wie der zum Use-Case-Diagramm, ein Modell deutlich besser machen kann.</a:t>
+              <a:t>Vortragende(r): Nina (70 s)
+Zum Schluss der Blick nach vorn. RepairFlow wird als Abo je Filiale angeboten, in zwei Stufen: Basis mit Auftrags- und Kundenverwaltung, Pro mit filialübergreifender Disposition und KI-Sofortdiagnose. Zielkunden sind unabhängige Werkstätten und kleine Ketten mit zwei bis zehn Filialen im deutschsprachigen Raum. Das sind Betriebe, die heute genau die vier Probleme vom Anfang haben und für die ein großes Werkstattsystem zu schwer ist. Der Ausblick geht in drei Richtungen: Predictive Disposition, also eine Bedarfsprognose je Filiale und Saison, damit Teile vor der Nachfrage im Lager liegen. Ein Techniker-Copilot, der Reparaturschritte aus der Historie vorschlägt. Und eine digitale Geräteakte, in der jedes Gerät seine Reparaturgeschichte behält. Nichts davon ist modelliert, aber alles baut auf dem Datenmodell auf, das wir heute vorgestellt haben.</a:t>
             </a:r>
           </a:p>
         </p:txBody>
@@ -851,7 +851,7 @@
           <a:p>
             <a:fld id="{F7021451-1387-4CA6-816F-3879F97B5CBC}" type="slidenum">
               <a:rPr lang="en-US"/>
-              <a:t>15</a:t>
+              <a:t>16</a:t>
             </a:fld>
             <a:endParaRPr lang="en-US"/>
           </a:p>
@@ -916,8 +916,8 @@
           <a:p>
             <a:r>
               <a:rPr lang="en-US" dirty="0"/>
-              <a:t>Vortragende(r): Nina (70 s)
-Zum Schluss der Blick nach vorn. RepairFlow wird als Abo je Filiale angeboten, in zwei Stufen: Basis mit Auftrags- und Kundenverwaltung, Pro mit filialübergreifender Disposition und KI-Sofortdiagnose. Zielkunden sind unabhängige Werkstätten und kleine Ketten mit zwei bis zehn Filialen im deutschsprachigen Raum. Das sind Betriebe, die heute genau die vier Probleme vom Anfang haben und für die ein großes Werkstattsystem zu schwer ist. Der Ausblick geht in drei Richtungen: Predictive Disposition, also eine Bedarfsprognose je Filiale und Saison, damit Teile vor der Nachfrage im Lager liegen. Ein Techniker-Copilot, der Reparaturschritte aus der Historie vorschlägt. Und eine digitale Geräteakte, in der jedes Gerät seine Reparaturgeschichte behält. Nichts davon ist modelliert, aber alles baut auf dem Datenmodell auf, das wir heute vorgestellt haben.</a:t>
+              <a:t>Vortragende(r): Nina (30 s)
+RepairFlow löst den Medienbruch aus Papier, Excel und Telefon und macht den Reparaturauftrag zum zentralen Zustandsautomaten. Der fachliche Mehrwert liegt in der filialübergreifenden Disposition und in der KI-Sofortdiagnose, die dem Kunden Klarheit gibt, bevor er die Werkstatt betritt. Vielen Dank für Ihre Aufmerksamkeit. Wir freuen uns auf Ihre Fragen.</a:t>
             </a:r>
           </a:p>
         </p:txBody>
@@ -939,7 +939,7 @@
           <a:p>
             <a:fld id="{F7021451-1387-4CA6-816F-3879F97B5CBC}" type="slidenum">
               <a:rPr lang="en-US"/>
-              <a:t>16</a:t>
+              <a:t>17</a:t>
             </a:fld>
             <a:endParaRPr lang="en-US"/>
           </a:p>
@@ -1004,94 +1004,6 @@
           <a:p>
             <a:r>
               <a:rPr lang="en-US" dirty="0"/>
-              <a:t>Vortragende(r): Nina (30 s)
-RepairFlow löst den Medienbruch aus Papier, Excel und Telefon und macht den Reparaturauftrag zum zentralen Zustandsautomaten. Der fachliche Mehrwert liegt in der filialübergreifenden Disposition und in der KI-Sofortdiagnose, die dem Kunden Klarheit gibt, bevor er die Werkstatt betritt. Vielen Dank für Ihre Aufmerksamkeit. Wir freuen uns auf Ihre Fragen.</a:t>
-            </a:r>
-          </a:p>
-        </p:txBody>
-      </p:sp>
-      <p:sp>
-        <p:nvSpPr>
-          <p:cNvPr id="4" name="Slide Number Placeholder 3"/>
-          <p:cNvSpPr>
-            <a:spLocks noGrp="1"/>
-          </p:cNvSpPr>
-          <p:nvPr>
-            <p:ph type="sldNum" sz="quarter" idx="10"/>
-          </p:nvPr>
-        </p:nvSpPr>
-        <p:spPr/>
-        <p:txBody>
-          <a:bodyPr/>
-          <a:lstStyle/>
-          <a:p>
-            <a:fld id="{F7021451-1387-4CA6-816F-3879F97B5CBC}" type="slidenum">
-              <a:rPr lang="en-US"/>
-              <a:t>17</a:t>
-            </a:fld>
-            <a:endParaRPr lang="en-US"/>
-          </a:p>
-        </p:txBody>
-      </p:sp>
-    </p:spTree>
-    <p:extLst>
-      <p:ext uri="{BB962C8B-B14F-4D97-AF65-F5344CB8AC3E}">
-        <p14:creationId xmlns:p14="http://schemas.microsoft.com/office/powerpoint/2010/main" val="1024086991"/>
-      </p:ext>
-    </p:extLst>
-  </p:cSld>
-  <p:clrMapOvr>
-    <a:masterClrMapping/>
-  </p:clrMapOvr>
-</p:notes>
-</file>
-
-<file path=ppt/notesSlides/notesSlide18.xml><?xml version="1.0" encoding="utf-8"?>
-<p:notes xmlns:a="http://schemas.openxmlformats.org/drawingml/2006/main" xmlns:r="http://schemas.openxmlformats.org/officeDocument/2006/relationships" xmlns:p="http://schemas.openxmlformats.org/presentationml/2006/main">
-  <p:cSld>
-    <p:spTree>
-      <p:nvGrpSpPr>
-        <p:cNvPr id="1" name=""/>
-        <p:cNvGrpSpPr/>
-        <p:nvPr/>
-      </p:nvGrpSpPr>
-      <p:grpSpPr>
-        <a:xfrm>
-          <a:off x="0" y="0"/>
-          <a:ext cx="0" cy="0"/>
-          <a:chOff x="0" y="0"/>
-          <a:chExt cx="0" cy="0"/>
-        </a:xfrm>
-      </p:grpSpPr>
-      <p:sp>
-        <p:nvSpPr>
-          <p:cNvPr id="2" name="Slide Image Placeholder 1"/>
-          <p:cNvSpPr>
-            <a:spLocks noGrp="1" noRot="1" noChangeAspect="1"/>
-          </p:cNvSpPr>
-          <p:nvPr>
-            <p:ph type="sldImg"/>
-          </p:nvPr>
-        </p:nvSpPr>
-        <p:spPr/>
-      </p:sp>
-      <p:sp>
-        <p:nvSpPr>
-          <p:cNvPr id="3" name="Notes Placeholder 2"/>
-          <p:cNvSpPr>
-            <a:spLocks noGrp="1"/>
-          </p:cNvSpPr>
-          <p:nvPr>
-            <p:ph type="body" idx="1"/>
-          </p:nvPr>
-        </p:nvSpPr>
-        <p:spPr/>
-        <p:txBody>
-          <a:bodyPr/>
-          <a:lstStyle/>
-          <a:p>
-            <a:r>
-              <a:rPr lang="en-US" dirty="0"/>
               <a:t>Vortragende(r): -
 Pflichtangabe für den PDF-Export laut Ablauf: welche/r Vortragende welchen Beitrag verantwortet.</a:t>
             </a:r>
@@ -1444,8 +1356,8 @@
           <a:p>
             <a:r>
               <a:rPr lang="en-US" dirty="0"/>
-              <a:t>Vortragende(r): Adrian (60 s)
-Was hat die Werkstatt davon? Drei Dinge. Erstens: eine Plattform für alle drei Gerätearten, mit einer Kundenbasis und einem gemeinsamen Ersatzteillager. Zweitens: filialübergreifende Disposition. RepairFlow kennt die Bestände aller Standorte, reserviert dort, wo das Teil liegt, und bestellt nur, was nirgends vorhanden ist. Das spart Lieferzeit und Doppelbestellungen. Drittens: der Kunde bekommt Klarheit, bevor er die Werkstatt betritt. Mit einem Foto aus der App erhält er einen Diagnosevorschlag, einen vorläufigen Kostenvoranschlag und einen Termin. Für die Werkstatt heißt das weniger Telefon, weniger Standzeit im Lager und eine Auslastung, die sie wirklich sieht.</a:t>
+              <a:t>Vortragende(r): David (75 s)
+So sieht eine Reparatur mit RepairFlow aus. Der Kunde schickt per App ein Foto oder Video und bekommt innerhalb einer Minute Vorschlag, vorläufigen Kostenvoranschlag und Terminvorschlag. Bestätigt er, sind die Teile schon vorreserviert. In der Filiale wird das Gerät registriert und der Auftrag angelegt. Der Techniker prüft den Vorschlag, stellt die Diagnose und erstellt den Kostenvoranschlag, den der Kunde wieder in der App freigibt. Dann disponiert RepairFlow die Teile über alle Filialen und bestellt Fehlteile beim Lieferanten. Nach der Reparatur folgt die Endkontrolle, der Kunde wird benachrichtigt, holt ab und zahlt. Jeder dieser Schritte ist ein Status des Reparaturauftrags: angenommen, in Diagnose, KVA offen, freigegeben, Teile bestellt, in Reparatur, fertig, abgeholt. Dieser Zustandsautomat ist der rote Faden durch alle unsere Modelle. Und falls doch etwas nicht passt: Die Reklamation startet einen eigenen Prozess, im Gewährleistungsfall kostenfrei.</a:t>
             </a:r>
           </a:p>
         </p:txBody>
@@ -1467,7 +1379,7 @@
           <a:p>
             <a:fld id="{F7021451-1387-4CA6-816F-3879F97B5CBC}" type="slidenum">
               <a:rPr lang="en-US"/>
-              <a:t>5</a:t>
+              <a:t>6</a:t>
             </a:fld>
             <a:endParaRPr lang="en-US"/>
           </a:p>
@@ -1532,8 +1444,8 @@
           <a:p>
             <a:r>
               <a:rPr lang="en-US" dirty="0"/>
-              <a:t>Vortragende(r): David (75 s)
-So sieht eine Reparatur mit RepairFlow aus. Der Kunde schickt per App ein Foto oder Video und bekommt innerhalb einer Minute Vorschlag, vorläufigen Kostenvoranschlag und Terminvorschlag. Bestätigt er, sind die Teile schon vorreserviert. In der Filiale wird das Gerät registriert und der Auftrag angelegt. Der Techniker prüft den Vorschlag, stellt die Diagnose und erstellt den Kostenvoranschlag, den der Kunde wieder in der App freigibt. Dann disponiert RepairFlow die Teile über alle Filialen und bestellt Fehlteile beim Lieferanten. Nach der Reparatur folgt die Endkontrolle, der Kunde wird benachrichtigt, holt ab und zahlt. Jeder dieser Schritte ist ein Status des Reparaturauftrags: angenommen, in Diagnose, KVA offen, freigegeben, Teile bestellt, in Reparatur, fertig, abgeholt. Dieser Zustandsautomat ist der rote Faden durch alle unsere Modelle. Und falls doch etwas nicht passt: Die Reklamation startet einen eigenen Prozess, im Gewährleistungsfall kostenfrei.</a:t>
+              <a:t>Vortragende(r): Adrian (80 s)
+Unser Alleinstellungsmerkmal ist die KI-Sofortdiagnose, die Sie gerade in der Auftragsreise gesehen haben. Fünf Schritte: Der Kunde nimmt Foto, Video oder Ton auf. Ein KI-Dienst erkennt Gerätetyp, wahrscheinliche Ursache und benötigte Teile. RepairFlow rechnet daraus einen vorläufigen Kostenvoranschlag, prüft die Verfügbarkeit in allen Filialen und reserviert vor. Zum Schluss schlägt es Filiale und Termin vor, und der Kunde bestätigt. Uns war wichtig, das glaubwürdig zu halten. Heute machbar ist die Erkennung sichtbarer Schäden per Bildanalyse, etwa ein gebrochenes Display oder eine gerissene Kette, dazu ein Vorab-KVA aus Teilepreisen und Aufwandsrichtwerten. Vision sind Geräuschanalyse bei E-Bike-Motoren und eine Aufwandsschätzung aus Video. Deshalb bleibt der Vorschlag immer vorläufig: Der Techniker bestätigt oder korrigiert ihn, und erst dann wird daraus ein verbindlicher Kostenvoranschlag. Die Medien werden nur mit Einwilligung verarbeitet und nach Abschluss gelöscht.</a:t>
             </a:r>
           </a:p>
         </p:txBody>
@@ -1555,7 +1467,7 @@
           <a:p>
             <a:fld id="{F7021451-1387-4CA6-816F-3879F97B5CBC}" type="slidenum">
               <a:rPr lang="en-US"/>
-              <a:t>6</a:t>
+              <a:t>7</a:t>
             </a:fld>
             <a:endParaRPr lang="en-US"/>
           </a:p>
@@ -1620,8 +1532,8 @@
           <a:p>
             <a:r>
               <a:rPr lang="en-US" dirty="0"/>
-              <a:t>Vortragende(r): Adrian (80 s)
-Unser Alleinstellungsmerkmal ist die KI-Sofortdiagnose, die Sie gerade in der Auftragsreise gesehen haben. Fünf Schritte: Der Kunde nimmt Foto, Video oder Ton auf. Ein KI-Dienst erkennt Gerätetyp, wahrscheinliche Ursache und benötigte Teile. RepairFlow rechnet daraus einen vorläufigen Kostenvoranschlag, prüft die Verfügbarkeit in allen Filialen und reserviert vor. Zum Schluss schlägt es Filiale und Termin vor, und der Kunde bestätigt. Uns war wichtig, das glaubwürdig zu halten. Heute machbar ist die Erkennung sichtbarer Schäden per Bildanalyse, etwa ein gebrochenes Display oder eine gerissene Kette, dazu ein Vorab-KVA aus Teilepreisen und Aufwandsrichtwerten. Vision sind Geräuschanalyse bei E-Bike-Motoren und eine Aufwandsschätzung aus Video. Deshalb bleibt der Vorschlag immer vorläufig: Der Techniker bestätigt oder korrigiert ihn, und erst dann wird daraus ein verbindlicher Kostenvoranschlag. Die Medien werden nur mit Einwilligung verarbeitet und nach Abschluss gelöscht.</a:t>
+              <a:t>Vortragende(r): Maximilian (50 s)
+Damit zur zweiten Hälfte: Was steckt hinter dieser Geschichte? Wir haben drei Modelle erstellt, die zusammenpassen. Zehn BPMN-Kollaborationsdiagramme mit 131 Aktivitäten im Werkstatt-Pool, dazu die Abläufe des Kunden mit 26 weiteren Aktivitäten. Ein Use-Case-Diagramm mit 19 Use Cases und 18 Akteuren. Ein vollständiges Klassendiagramm mit 27 Klassen und 36 Assoziationen. Sechs Sequenzdiagramme, gefordert waren fünf, und als Zugabe ein Zustandsdiagramm für den Reparaturauftrag. Alle Modelle liegen im Camunda Modeler und in Visual Paradigm und werden mit der Dokumentation abgegeben. Ich beginne mit den Geschäftsprozessen.</a:t>
             </a:r>
           </a:p>
         </p:txBody>
@@ -1643,7 +1555,7 @@
           <a:p>
             <a:fld id="{F7021451-1387-4CA6-816F-3879F97B5CBC}" type="slidenum">
               <a:rPr lang="en-US"/>
-              <a:t>7</a:t>
+              <a:t>8</a:t>
             </a:fld>
             <a:endParaRPr lang="en-US"/>
           </a:p>
@@ -1708,8 +1620,8 @@
           <a:p>
             <a:r>
               <a:rPr lang="en-US" dirty="0"/>
-              <a:t>Vortragende(r): Maximilian (50 s)
-Damit zur zweiten Hälfte: Was steckt hinter dieser Geschichte? Wir haben drei Modelle erstellt, die zusammenpassen. Zehn BPMN-Kollaborationsdiagramme mit 131 Aktivitäten im Werkstatt-Pool, dazu die Abläufe des Kunden mit 26 weiteren Aktivitäten. Ein Use-Case-Diagramm mit 19 Use Cases und 18 Akteuren. Ein vollständiges Klassendiagramm mit 27 Klassen und 36 Assoziationen. Sechs Sequenzdiagramme, gefordert waren fünf, und als Zugabe ein Zustandsdiagramm für den Reparaturauftrag. Alle Modelle liegen im Camunda Modeler und in Visual Paradigm und werden mit der Dokumentation abgegeben. Ich beginne mit den Geschäftsprozessen.</a:t>
+              <a:t>Vortragende(r): Maximilian (70 s)
+Die zehn Prozesse decken den gesamten Lebenszyklus ab. Prozesse 01 bis 08 sind die durchgehende Auftragsreise: Sofortdiagnose, Annahme, Diagnose, Kostenvoranschlag, Ersatzteilreservierung, Bestellung, Reparatur und Abholung. 09 und 10 sind die Folgeprozesse Reklamation und Retoure. Jedes Diagramm ist eine Kollaboration: Der Werkstattbetrieb ist der ausführbare Pool mit den Lanes Service, Techniker, Werkstattleitung und Disposition, der Kunde hat seinen eigenen Ablauf, der Lieferant bleibt eine Black Box. Die wichtigste Zahl: 60 Prozent der Aktivitäten führt RepairFlow ohne manuelle Arbeit aus, also Statuswechsel, Benachrichtigungen, Verfügbarkeitsprüfungen, Berechnungen und Regeln. Was Handwerk ist, bleibt Handwerk: Diagnose, Reparatur und Endkontrolle sind Aktivitäten des Technikers mit Unterstützung durch das System.</a:t>
             </a:r>
           </a:p>
         </p:txBody>
@@ -1731,7 +1643,7 @@
           <a:p>
             <a:fld id="{F7021451-1387-4CA6-816F-3879F97B5CBC}" type="slidenum">
               <a:rPr lang="en-US"/>
-              <a:t>8</a:t>
+              <a:t>9</a:t>
             </a:fld>
             <a:endParaRPr lang="en-US"/>
           </a:p>
@@ -1796,8 +1708,8 @@
           <a:p>
             <a:r>
               <a:rPr lang="en-US" dirty="0"/>
-              <a:t>Vortragende(r): Maximilian (70 s)
-Die zehn Prozesse decken den gesamten Lebenszyklus ab. Prozesse 01 bis 08 sind die durchgehende Auftragsreise: Sofortdiagnose, Annahme, Diagnose, Kostenvoranschlag, Ersatzteilreservierung, Bestellung, Reparatur und Abholung. 09 und 10 sind die Folgeprozesse Reklamation und Retoure. Jedes Diagramm ist eine Kollaboration: Der Werkstattbetrieb ist der ausführbare Pool mit den Lanes Service, Techniker, Werkstattleitung und Disposition, der Kunde hat seinen eigenen Ablauf, der Lieferant bleibt eine Black Box. Die wichtigste Zahl: 60 Prozent der Aktivitäten führt RepairFlow ohne manuelle Arbeit aus, also Statuswechsel, Benachrichtigungen, Verfügbarkeitsprüfungen, Berechnungen und Regeln. Was Handwerk ist, bleibt Handwerk: Diagnose, Reparatur und Endkontrolle sind Aktivitäten des Technikers mit Unterstützung durch das System.</a:t>
+              <a:t>Vortragende(r): Maximilian (80 s)
+Drei Stellen zeigen, was die Prozesse leisten. Erstens der Kostenvoranschlag in Prozess 04: Nach dem Versand wartet ein ereignisbasiertes Gateway auf Freigabe, Ablehnung oder den Ablauf von drei Tagen. Bei Fristablauf erinnert RepairFlow den Kunden, höchstens zweimal. Nach dem dritten Fristablauf ohne Antwort gilt der KVA als abgelehnt und das Gerät geht mit Diagnosepauschale zur Abholung. Kein Auftrag bleibt liegen. Zweitens die Disposition in Prozess 05: Für jedes benötigte Teil läuft parallel eine Prüfung, erst im eigenen Lager, dann in den anderen Filialen. Was lokal liegt, wird reserviert, was anderswo liegt, umgelagert, und nur Fehlteile werden bestellt. Drittens die Reklamation in Prozess 09: Der Techniker prüft den Mangel, RepairFlow entscheidet nach Regel über Gewährleistung, und im Gewährleistungsfall entsteht ein kostenfreier Nacharbeitsauftrag, der wieder durch die normale Auftragsreise läuft. So bleibt das Modell schlank, weil die Reklamation keine eigene Reparaturlogik braucht.</a:t>
             </a:r>
           </a:p>
         </p:txBody>
@@ -1819,7 +1731,7 @@
           <a:p>
             <a:fld id="{F7021451-1387-4CA6-816F-3879F97B5CBC}" type="slidenum">
               <a:rPr lang="en-US"/>
-              <a:t>9</a:t>
+              <a:t>10</a:t>
             </a:fld>
             <a:endParaRPr lang="en-US"/>
           </a:p>
@@ -14385,15 +14297,7 @@
 
 <file path=ppt/slides/slide5.xml><?xml version="1.0" encoding="utf-8"?>
 <p:sld xmlns:a="http://schemas.openxmlformats.org/drawingml/2006/main" xmlns:r="http://schemas.openxmlformats.org/officeDocument/2006/relationships" xmlns:p="http://schemas.openxmlformats.org/presentationml/2006/main">
-  <p:cSld name="Slide 5">
-    <p:bg>
-      <p:bgPr>
-        <a:solidFill>
-          <a:srgbClr val="FFFFFF"/>
-        </a:solidFill>
-        <a:effectLst/>
-      </p:bgPr>
-    </p:bg>
+  <p:cSld>
     <p:spTree>
       <p:nvGrpSpPr>
         <p:cNvPr id="1" name=""/>
@@ -14408,582 +14312,108 @@
           <a:chExt cx="0" cy="0"/>
         </a:xfrm>
       </p:grpSpPr>
-      <p:sp>
-        <p:nvSpPr>
-          <p:cNvPr id="2" name="Text 0"/>
-          <p:cNvSpPr txBox="1"/>
-          <p:nvPr/>
-        </p:nvSpPr>
-        <p:spPr>
-          <a:xfrm>
-            <a:off x="457200" y="274320"/>
-            <a:ext cx="8229600" cy="640080"/>
-          </a:xfrm>
-          <a:prstGeom prst="rect">
-            <a:avLst/>
-          </a:prstGeom>
-          <a:noFill/>
-          <a:ln/>
-        </p:spPr>
-        <p:txBody>
-          <a:bodyPr wrap="square" lIns="0" tIns="0" rIns="0" bIns="0" rtlCol="0" anchor="ctr"/>
-          <a:lstStyle/>
-          <a:p>
-            <a:pPr marL="0" indent="0">
-              <a:buNone/>
-            </a:pPr>
-            <a:r>
-              <a:rPr lang="en-US" sz="2800" b="1" dirty="0">
-                <a:solidFill>
-                  <a:srgbClr val="0E5E5E"/>
-                </a:solidFill>
-                <a:latin typeface="Calibri" pitchFamily="34" charset="0"/>
-                <a:ea typeface="Calibri" pitchFamily="34" charset="-122"/>
-                <a:cs typeface="Calibri" pitchFamily="34" charset="-120"/>
-              </a:rPr>
-              <a:t>Drei Nutzenversprechen</a:t>
-            </a:r>
-            <a:endParaRPr lang="en-US" sz="2800" dirty="0"/>
-          </a:p>
-        </p:txBody>
-      </p:sp>
-      <p:sp>
-        <p:nvSpPr>
-          <p:cNvPr id="3" name="Text 1"/>
-          <p:cNvSpPr txBox="1"/>
-          <p:nvPr/>
-        </p:nvSpPr>
-        <p:spPr>
-          <a:xfrm>
-            <a:off x="457200" y="4754880"/>
-            <a:ext cx="5486400" cy="274320"/>
-          </a:xfrm>
-          <a:prstGeom prst="rect">
-            <a:avLst/>
-          </a:prstGeom>
-          <a:noFill/>
-          <a:ln/>
-        </p:spPr>
-        <p:txBody>
-          <a:bodyPr wrap="square" lIns="0" tIns="0" rIns="0" bIns="0" rtlCol="0" anchor="ctr"/>
-          <a:lstStyle/>
-          <a:p>
-            <a:pPr marL="0" indent="0">
-              <a:buNone/>
-            </a:pPr>
-            <a:r>
-              <a:rPr lang="en-US" sz="900" dirty="0">
-                <a:solidFill>
-                  <a:srgbClr val="5F6B7A"/>
-                </a:solidFill>
-                <a:latin typeface="Calibri" pitchFamily="34" charset="0"/>
-                <a:ea typeface="Calibri" pitchFamily="34" charset="-122"/>
-                <a:cs typeface="Calibri" pitchFamily="34" charset="-120"/>
-              </a:rPr>
-              <a:t>RepairFlow · Fallstudie Systemanalyse · WWI25B4 Gruppe 1</a:t>
-            </a:r>
-            <a:endParaRPr lang="en-US" sz="900" dirty="0"/>
-          </a:p>
-        </p:txBody>
-      </p:sp>
-      <p:sp>
-        <p:nvSpPr>
-          <p:cNvPr id="4" name="Text 2"/>
-          <p:cNvSpPr txBox="1"/>
-          <p:nvPr/>
-        </p:nvSpPr>
-        <p:spPr>
-          <a:xfrm>
-            <a:off x="8229600" y="4754880"/>
-            <a:ext cx="457200" cy="274320"/>
-          </a:xfrm>
-          <a:prstGeom prst="rect">
-            <a:avLst/>
-          </a:prstGeom>
-          <a:noFill/>
-          <a:ln/>
-        </p:spPr>
-        <p:txBody>
-          <a:bodyPr wrap="square" lIns="0" tIns="0" rIns="0" bIns="0" rtlCol="0" anchor="ctr"/>
-          <a:lstStyle/>
-          <a:p>
-            <a:pPr marL="0" indent="0" algn="r">
-              <a:buNone/>
-            </a:pPr>
-            <a:r>
-              <a:rPr lang="en-US" sz="900" dirty="0">
-                <a:solidFill>
-                  <a:srgbClr val="5F6B7A"/>
-                </a:solidFill>
-                <a:latin typeface="Calibri" pitchFamily="34" charset="0"/>
-                <a:ea typeface="Calibri" pitchFamily="34" charset="-122"/>
-                <a:cs typeface="Calibri" pitchFamily="34" charset="-120"/>
-              </a:rPr>
-              <a:t>5</a:t>
-            </a:r>
-            <a:endParaRPr lang="en-US" sz="900" dirty="0"/>
-          </a:p>
-        </p:txBody>
-      </p:sp>
-      <p:sp>
-        <p:nvSpPr>
-          <p:cNvPr id="6" name="Text 3"/>
-          <p:cNvSpPr txBox="1"/>
-          <p:nvPr/>
-        </p:nvSpPr>
-        <p:spPr>
-          <a:xfrm>
-            <a:off x="457200" y="960120"/>
-            <a:ext cx="8229600" cy="365760"/>
-          </a:xfrm>
-          <a:prstGeom prst="rect">
-            <a:avLst/>
-          </a:prstGeom>
-          <a:noFill/>
-          <a:ln/>
-        </p:spPr>
-        <p:txBody>
-          <a:bodyPr wrap="square" lIns="0" tIns="0" rIns="0" bIns="0" rtlCol="0" anchor="ctr"/>
-          <a:lstStyle/>
-          <a:p>
-            <a:pPr marL="0" indent="0">
-              <a:buNone/>
-            </a:pPr>
-            <a:r>
-              <a:rPr lang="en-US" sz="1300" dirty="0">
-                <a:solidFill>
-                  <a:srgbClr val="1B2430"/>
-                </a:solidFill>
-                <a:latin typeface="Calibri" pitchFamily="34" charset="0"/>
-                <a:ea typeface="Calibri" pitchFamily="34" charset="-122"/>
-                <a:cs typeface="Calibri" pitchFamily="34" charset="-120"/>
-              </a:rPr>
-              <a:t>Was die Werkstatt davon hat:</a:t>
-            </a:r>
-            <a:endParaRPr lang="en-US" sz="1300" dirty="0"/>
-          </a:p>
-        </p:txBody>
-      </p:sp>
-      <p:sp>
-        <p:nvSpPr>
-          <p:cNvPr id="7" name="Shape 4"/>
-          <p:cNvSpPr/>
-          <p:nvPr/>
-        </p:nvSpPr>
-        <p:spPr>
-          <a:xfrm>
-            <a:off x="457200" y="1417320"/>
-            <a:ext cx="2651760" cy="2377440"/>
-          </a:xfrm>
-          <a:prstGeom prst="roundRect">
-            <a:avLst>
-              <a:gd name="adj" fmla="val 3077"/>
-            </a:avLst>
-          </a:prstGeom>
-          <a:solidFill>
-            <a:srgbClr val="EEF4F4"/>
-          </a:solidFill>
-          <a:ln w="12700">
-            <a:solidFill>
-              <a:srgbClr val="EEF4F4"/>
-            </a:solidFill>
-            <a:prstDash val="solid"/>
-          </a:ln>
-        </p:spPr>
-        <p:txBody>
-          <a:bodyPr/>
-          <a:lstStyle/>
-          <a:p>
-            <a:endParaRPr lang="de-DE"/>
-          </a:p>
-        </p:txBody>
-      </p:sp>
-      <p:sp>
-        <p:nvSpPr>
-          <p:cNvPr id="8" name="Shape 5"/>
-          <p:cNvSpPr/>
-          <p:nvPr/>
-        </p:nvSpPr>
-        <p:spPr>
-          <a:xfrm>
-            <a:off x="640080" y="1600200"/>
-            <a:ext cx="457200" cy="457200"/>
-          </a:xfrm>
-          <a:prstGeom prst="ellipse">
-            <a:avLst/>
-          </a:prstGeom>
-          <a:solidFill>
-            <a:srgbClr val="0E5E5E"/>
-          </a:solidFill>
-          <a:ln w="12700">
-            <a:solidFill>
-              <a:srgbClr val="0E5E5E"/>
-            </a:solidFill>
-            <a:prstDash val="solid"/>
-          </a:ln>
-        </p:spPr>
-        <p:txBody>
-          <a:bodyPr/>
-          <a:lstStyle/>
-          <a:p>
-            <a:endParaRPr lang="de-DE"/>
-          </a:p>
-        </p:txBody>
-      </p:sp>
       <p:pic>
         <p:nvPicPr>
-          <p:cNvPr id="9" name="Image 0" descr="preencoded.png"/>
+          <p:cNvPr id="3" name="Grafik 2" descr="Übertragen mit einfarbiger Füllung">
+            <a:extLst>
+              <a:ext uri="{FF2B5EF4-FFF2-40B4-BE49-F238E27FC236}">
+                <a16:creationId xmlns:a16="http://schemas.microsoft.com/office/drawing/2014/main" id="{868C1496-D83E-2D10-7F66-DA08FCFCA2C6}"/>
+              </a:ext>
+            </a:extLst>
+          </p:cNvPr>
           <p:cNvPicPr>
             <a:picLocks noChangeAspect="1"/>
           </p:cNvPicPr>
           <p:nvPr/>
         </p:nvPicPr>
         <p:blipFill>
-          <a:blip r:embed="rId3"/>
+          <a:blip>
+            <a:extLst>
+              <a:ext uri="{96DAC541-7B7A-43D3-8B79-37D633B846F1}">
+                <asvg:svgBlip xmlns:asvg="http://schemas.microsoft.com/office/drawing/2016/SVG/main" r:embed="rId2"/>
+              </a:ext>
+            </a:extLst>
+          </a:blip>
           <a:stretch>
             <a:fillRect/>
           </a:stretch>
         </p:blipFill>
         <p:spPr>
           <a:xfrm>
-            <a:off x="754380" y="1714500"/>
-            <a:ext cx="228600" cy="228600"/>
+            <a:off x="4114800" y="1948293"/>
+            <a:ext cx="914400" cy="914400"/>
           </a:xfrm>
           <a:prstGeom prst="rect">
             <a:avLst/>
           </a:prstGeom>
         </p:spPr>
       </p:pic>
-      <p:sp>
-        <p:nvSpPr>
-          <p:cNvPr id="10" name="Text 6"/>
-          <p:cNvSpPr txBox="1"/>
-          <p:nvPr/>
-        </p:nvSpPr>
-        <p:spPr>
-          <a:xfrm>
-            <a:off x="1234440" y="1581912"/>
-            <a:ext cx="1737360" cy="457200"/>
-          </a:xfrm>
-          <a:prstGeom prst="rect">
-            <a:avLst/>
-          </a:prstGeom>
-          <a:noFill/>
-          <a:ln/>
-        </p:spPr>
-        <p:txBody>
-          <a:bodyPr wrap="square" lIns="0" tIns="0" rIns="0" bIns="0" rtlCol="0" anchor="ctr"/>
-          <a:lstStyle/>
-          <a:p>
-            <a:pPr marL="0" indent="0">
-              <a:buNone/>
-            </a:pPr>
-            <a:r>
-              <a:rPr lang="en-US" sz="1400" b="1" dirty="0">
-                <a:solidFill>
-                  <a:srgbClr val="1B2430"/>
-                </a:solidFill>
-                <a:latin typeface="Calibri" pitchFamily="34" charset="0"/>
-                <a:ea typeface="Calibri" pitchFamily="34" charset="-122"/>
-                <a:cs typeface="Calibri" pitchFamily="34" charset="-120"/>
-              </a:rPr>
-              <a:t>Eine Plattform</a:t>
-            </a:r>
-            <a:endParaRPr lang="en-US" sz="1400" dirty="0"/>
-          </a:p>
-        </p:txBody>
-      </p:sp>
-      <p:sp>
-        <p:nvSpPr>
-          <p:cNvPr id="11" name="Text 7"/>
-          <p:cNvSpPr txBox="1"/>
-          <p:nvPr/>
-        </p:nvSpPr>
-        <p:spPr>
-          <a:xfrm>
-            <a:off x="640080" y="2148840"/>
-            <a:ext cx="2286000" cy="1508760"/>
-          </a:xfrm>
-          <a:prstGeom prst="rect">
-            <a:avLst/>
-          </a:prstGeom>
-          <a:noFill/>
-          <a:ln/>
-        </p:spPr>
-        <p:txBody>
-          <a:bodyPr wrap="square" lIns="0" tIns="0" rIns="0" bIns="0" rtlCol="0" anchor="t"/>
-          <a:lstStyle/>
-          <a:p>
-            <a:pPr marL="0" indent="0">
-              <a:buNone/>
-            </a:pPr>
-            <a:r>
-              <a:rPr lang="en-US" sz="1150" dirty="0">
-                <a:solidFill>
-                  <a:srgbClr val="1B2430"/>
-                </a:solidFill>
-                <a:latin typeface="Calibri" pitchFamily="34" charset="0"/>
-                <a:ea typeface="Calibri" pitchFamily="34" charset="-122"/>
-                <a:cs typeface="Calibri" pitchFamily="34" charset="-120"/>
-              </a:rPr>
-              <a:t>Fahrrad, E-Bike und Elektronik mit einer Kundenbasis und einem gemeinsamen Ersatzteillager. Ein Auftragsstatus für alle.</a:t>
-            </a:r>
-            <a:endParaRPr lang="en-US" sz="1150" dirty="0"/>
-          </a:p>
-        </p:txBody>
-      </p:sp>
-      <p:sp>
-        <p:nvSpPr>
-          <p:cNvPr id="12" name="Shape 8"/>
-          <p:cNvSpPr/>
-          <p:nvPr/>
-        </p:nvSpPr>
-        <p:spPr>
-          <a:xfrm>
-            <a:off x="3246120" y="1417320"/>
-            <a:ext cx="2651760" cy="2377440"/>
-          </a:xfrm>
-          <a:prstGeom prst="roundRect">
-            <a:avLst>
-              <a:gd name="adj" fmla="val 3077"/>
-            </a:avLst>
-          </a:prstGeom>
-          <a:solidFill>
-            <a:srgbClr val="EEF4F4"/>
-          </a:solidFill>
-          <a:ln w="12700">
-            <a:solidFill>
-              <a:srgbClr val="EEF4F4"/>
-            </a:solidFill>
-            <a:prstDash val="solid"/>
-          </a:ln>
-        </p:spPr>
-        <p:txBody>
-          <a:bodyPr/>
-          <a:lstStyle/>
-          <a:p>
-            <a:endParaRPr lang="de-DE"/>
-          </a:p>
-        </p:txBody>
-      </p:sp>
-      <p:sp>
-        <p:nvSpPr>
-          <p:cNvPr id="13" name="Shape 9"/>
-          <p:cNvSpPr/>
-          <p:nvPr/>
-        </p:nvSpPr>
-        <p:spPr>
-          <a:xfrm>
-            <a:off x="3429000" y="1600200"/>
-            <a:ext cx="457200" cy="457200"/>
-          </a:xfrm>
-          <a:prstGeom prst="ellipse">
-            <a:avLst/>
-          </a:prstGeom>
-          <a:solidFill>
-            <a:srgbClr val="0E5E5E"/>
-          </a:solidFill>
-          <a:ln w="12700">
-            <a:solidFill>
-              <a:srgbClr val="0E5E5E"/>
-            </a:solidFill>
-            <a:prstDash val="solid"/>
-          </a:ln>
-        </p:spPr>
-        <p:txBody>
-          <a:bodyPr/>
-          <a:lstStyle/>
-          <a:p>
-            <a:endParaRPr lang="de-DE"/>
-          </a:p>
-        </p:txBody>
-      </p:sp>
       <p:pic>
         <p:nvPicPr>
-          <p:cNvPr id="14" name="Image 1" descr="preencoded.png"/>
+          <p:cNvPr id="5" name="Grafik 4" descr="Benutzer mit einfarbiger Füllung">
+            <a:extLst>
+              <a:ext uri="{FF2B5EF4-FFF2-40B4-BE49-F238E27FC236}">
+                <a16:creationId xmlns:a16="http://schemas.microsoft.com/office/drawing/2014/main" id="{F8EF1F55-4B3B-B9BA-6361-929E65DBEA7E}"/>
+              </a:ext>
+            </a:extLst>
+          </p:cNvPr>
           <p:cNvPicPr>
             <a:picLocks noChangeAspect="1"/>
           </p:cNvPicPr>
           <p:nvPr/>
         </p:nvPicPr>
         <p:blipFill>
-          <a:blip r:embed="rId4"/>
+          <a:blip>
+            <a:extLst>
+              <a:ext uri="{96DAC541-7B7A-43D3-8B79-37D633B846F1}">
+                <asvg:svgBlip xmlns:asvg="http://schemas.microsoft.com/office/drawing/2016/SVG/main" r:embed="rId3"/>
+              </a:ext>
+            </a:extLst>
+          </a:blip>
           <a:stretch>
             <a:fillRect/>
           </a:stretch>
         </p:blipFill>
         <p:spPr>
           <a:xfrm>
-            <a:off x="3543300" y="1714500"/>
-            <a:ext cx="228600" cy="228600"/>
+            <a:off x="6889866" y="1948293"/>
+            <a:ext cx="914400" cy="914400"/>
           </a:xfrm>
           <a:prstGeom prst="rect">
             <a:avLst/>
           </a:prstGeom>
         </p:spPr>
       </p:pic>
-      <p:sp>
-        <p:nvSpPr>
-          <p:cNvPr id="15" name="Text 10"/>
-          <p:cNvSpPr txBox="1"/>
-          <p:nvPr/>
-        </p:nvSpPr>
-        <p:spPr>
-          <a:xfrm>
-            <a:off x="4023360" y="1581912"/>
-            <a:ext cx="1737360" cy="457200"/>
-          </a:xfrm>
-          <a:prstGeom prst="rect">
-            <a:avLst/>
-          </a:prstGeom>
-          <a:noFill/>
-          <a:ln/>
-        </p:spPr>
-        <p:txBody>
-          <a:bodyPr wrap="square" lIns="0" tIns="0" rIns="0" bIns="0" rtlCol="0" anchor="ctr"/>
-          <a:lstStyle/>
-          <a:p>
-            <a:pPr marL="0" indent="0">
-              <a:buNone/>
-            </a:pPr>
-            <a:r>
-              <a:rPr lang="en-US" sz="1400" b="1" dirty="0">
-                <a:solidFill>
-                  <a:srgbClr val="1B2430"/>
-                </a:solidFill>
-                <a:latin typeface="Calibri" pitchFamily="34" charset="0"/>
-                <a:ea typeface="Calibri" pitchFamily="34" charset="-122"/>
-                <a:cs typeface="Calibri" pitchFamily="34" charset="-120"/>
-              </a:rPr>
-              <a:t>Filialübergreifend</a:t>
-            </a:r>
-            <a:endParaRPr lang="en-US" sz="1400" dirty="0"/>
-          </a:p>
-        </p:txBody>
-      </p:sp>
-      <p:sp>
-        <p:nvSpPr>
-          <p:cNvPr id="16" name="Text 11"/>
-          <p:cNvSpPr txBox="1"/>
-          <p:nvPr/>
-        </p:nvSpPr>
-        <p:spPr>
-          <a:xfrm>
-            <a:off x="3429000" y="2148840"/>
-            <a:ext cx="2286000" cy="1508760"/>
-          </a:xfrm>
-          <a:prstGeom prst="rect">
-            <a:avLst/>
-          </a:prstGeom>
-          <a:noFill/>
-          <a:ln/>
-        </p:spPr>
-        <p:txBody>
-          <a:bodyPr wrap="square" lIns="0" tIns="0" rIns="0" bIns="0" rtlCol="0" anchor="t"/>
-          <a:lstStyle/>
-          <a:p>
-            <a:pPr marL="0" indent="0">
-              <a:buNone/>
-            </a:pPr>
-            <a:r>
-              <a:rPr lang="en-US" sz="1150" dirty="0">
-                <a:solidFill>
-                  <a:srgbClr val="1B2430"/>
-                </a:solidFill>
-                <a:latin typeface="Calibri" pitchFamily="34" charset="0"/>
-                <a:ea typeface="Calibri" pitchFamily="34" charset="-122"/>
-                <a:cs typeface="Calibri" pitchFamily="34" charset="-120"/>
-              </a:rPr>
-              <a:t>Bestände, Reservierungen und Umlagerungen über alle Standorte. Bestellt wird nur, was nirgends liegt.</a:t>
-            </a:r>
-            <a:endParaRPr lang="en-US" sz="1150" dirty="0"/>
-          </a:p>
-        </p:txBody>
-      </p:sp>
-      <p:sp>
-        <p:nvSpPr>
-          <p:cNvPr id="17" name="Shape 12"/>
-          <p:cNvSpPr/>
-          <p:nvPr/>
-        </p:nvSpPr>
-        <p:spPr>
-          <a:xfrm>
-            <a:off x="6035040" y="1417320"/>
-            <a:ext cx="2651760" cy="2377440"/>
-          </a:xfrm>
-          <a:prstGeom prst="roundRect">
-            <a:avLst>
-              <a:gd name="adj" fmla="val 3077"/>
-            </a:avLst>
-          </a:prstGeom>
-          <a:solidFill>
-            <a:srgbClr val="FFF4D6"/>
-          </a:solidFill>
-          <a:ln w="12700">
-            <a:solidFill>
-              <a:srgbClr val="FFF4D6"/>
-            </a:solidFill>
-            <a:prstDash val="solid"/>
-          </a:ln>
-        </p:spPr>
-        <p:txBody>
-          <a:bodyPr/>
-          <a:lstStyle/>
-          <a:p>
-            <a:endParaRPr lang="de-DE"/>
-          </a:p>
-        </p:txBody>
-      </p:sp>
-      <p:sp>
-        <p:nvSpPr>
-          <p:cNvPr id="18" name="Shape 13"/>
-          <p:cNvSpPr/>
-          <p:nvPr/>
-        </p:nvSpPr>
-        <p:spPr>
-          <a:xfrm>
-            <a:off x="6217920" y="1600200"/>
-            <a:ext cx="457200" cy="457200"/>
-          </a:xfrm>
-          <a:prstGeom prst="ellipse">
-            <a:avLst/>
-          </a:prstGeom>
-          <a:solidFill>
-            <a:srgbClr val="F2A900"/>
-          </a:solidFill>
-          <a:ln w="12700">
-            <a:solidFill>
-              <a:srgbClr val="F2A900"/>
-            </a:solidFill>
-            <a:prstDash val="solid"/>
-          </a:ln>
-        </p:spPr>
-        <p:txBody>
-          <a:bodyPr/>
-          <a:lstStyle/>
-          <a:p>
-            <a:endParaRPr lang="de-DE"/>
-          </a:p>
-        </p:txBody>
-      </p:sp>
       <p:pic>
         <p:nvPicPr>
-          <p:cNvPr id="19" name="Image 2" descr="preencoded.png"/>
+          <p:cNvPr id="7" name="Grafik 6" descr="Tools mit einfarbiger Füllung">
+            <a:extLst>
+              <a:ext uri="{FF2B5EF4-FFF2-40B4-BE49-F238E27FC236}">
+                <a16:creationId xmlns:a16="http://schemas.microsoft.com/office/drawing/2014/main" id="{D67B4893-0DCF-B0A8-560D-3ACD3C9887ED}"/>
+              </a:ext>
+            </a:extLst>
+          </p:cNvPr>
           <p:cNvPicPr>
             <a:picLocks noChangeAspect="1"/>
           </p:cNvPicPr>
           <p:nvPr/>
         </p:nvPicPr>
         <p:blipFill>
-          <a:blip r:embed="rId5"/>
+          <a:blip>
+            <a:extLst>
+              <a:ext uri="{96DAC541-7B7A-43D3-8B79-37D633B846F1}">
+                <asvg:svgBlip xmlns:asvg="http://schemas.microsoft.com/office/drawing/2016/SVG/main" r:embed="rId4"/>
+              </a:ext>
+            </a:extLst>
+          </a:blip>
           <a:stretch>
             <a:fillRect/>
           </a:stretch>
         </p:blipFill>
         <p:spPr>
           <a:xfrm>
-            <a:off x="6332220" y="1714500"/>
-            <a:ext cx="228600" cy="228600"/>
+            <a:off x="1335900" y="1948293"/>
+            <a:ext cx="914400" cy="914400"/>
           </a:xfrm>
           <a:prstGeom prst="rect">
             <a:avLst/>
@@ -14992,14 +14422,20 @@
       </p:pic>
       <p:sp>
         <p:nvSpPr>
-          <p:cNvPr id="20" name="Text 14"/>
+          <p:cNvPr id="8" name="Text 6">
+            <a:extLst>
+              <a:ext uri="{FF2B5EF4-FFF2-40B4-BE49-F238E27FC236}">
+                <a16:creationId xmlns:a16="http://schemas.microsoft.com/office/drawing/2014/main" id="{F891E01B-58C0-995B-B086-1E6CFB514490}"/>
+              </a:ext>
+            </a:extLst>
+          </p:cNvPr>
           <p:cNvSpPr txBox="1"/>
           <p:nvPr/>
         </p:nvSpPr>
         <p:spPr>
           <a:xfrm>
-            <a:off x="6812280" y="1581912"/>
-            <a:ext cx="1737360" cy="457200"/>
+            <a:off x="711752" y="2960437"/>
+            <a:ext cx="2162695" cy="457200"/>
           </a:xfrm>
           <a:prstGeom prst="rect">
             <a:avLst/>
@@ -15011,34 +14447,50 @@
           <a:bodyPr wrap="square" lIns="0" tIns="0" rIns="0" bIns="0" rtlCol="0" anchor="ctr"/>
           <a:lstStyle/>
           <a:p>
-            <a:pPr marL="0" indent="0">
+            <a:pPr marL="0" indent="0" algn="ctr">
               <a:buNone/>
             </a:pPr>
             <a:r>
               <a:rPr lang="en-US" sz="1400" b="1" dirty="0">
                 <a:solidFill>
-                  <a:srgbClr val="1B2430"/>
-                </a:solidFill>
-                <a:latin typeface="Calibri" pitchFamily="34" charset="0"/>
-                <a:ea typeface="Calibri" pitchFamily="34" charset="-122"/>
-                <a:cs typeface="Calibri" pitchFamily="34" charset="-120"/>
-              </a:rPr>
-              <a:t>Klarheit vor dem Besuch</a:t>
-            </a:r>
-            <a:endParaRPr lang="en-US" sz="1400" dirty="0"/>
-          </a:p>
-        </p:txBody>
-      </p:sp>
-      <p:sp>
-        <p:nvSpPr>
-          <p:cNvPr id="21" name="Text 15"/>
+                  <a:schemeClr val="accent2">
+                    <a:lumMod val="50000"/>
+                  </a:schemeClr>
+                </a:solidFill>
+                <a:latin typeface="Segoe UI" panose="020B0502040204020203" pitchFamily="34" charset="0"/>
+                <a:ea typeface="Calibri" pitchFamily="34" charset="-122"/>
+                <a:cs typeface="Segoe UI" panose="020B0502040204020203" pitchFamily="34" charset="0"/>
+              </a:rPr>
+              <a:t>Eine Plattform</a:t>
+            </a:r>
+            <a:endParaRPr lang="en-US" sz="1400" dirty="0">
+              <a:solidFill>
+                <a:schemeClr val="accent2">
+                  <a:lumMod val="50000"/>
+                </a:schemeClr>
+              </a:solidFill>
+              <a:latin typeface="Segoe UI" panose="020B0502040204020203" pitchFamily="34" charset="0"/>
+              <a:cs typeface="Segoe UI" panose="020B0502040204020203" pitchFamily="34" charset="0"/>
+            </a:endParaRPr>
+          </a:p>
+        </p:txBody>
+      </p:sp>
+      <p:sp>
+        <p:nvSpPr>
+          <p:cNvPr id="9" name="Text 10">
+            <a:extLst>
+              <a:ext uri="{FF2B5EF4-FFF2-40B4-BE49-F238E27FC236}">
+                <a16:creationId xmlns:a16="http://schemas.microsoft.com/office/drawing/2014/main" id="{3C8BF763-E02C-9EA3-7BBE-7E240B141903}"/>
+              </a:ext>
+            </a:extLst>
+          </p:cNvPr>
           <p:cNvSpPr txBox="1"/>
           <p:nvPr/>
         </p:nvSpPr>
         <p:spPr>
           <a:xfrm>
-            <a:off x="6217920" y="2148840"/>
-            <a:ext cx="2286000" cy="1508760"/>
+            <a:off x="3490652" y="2960437"/>
+            <a:ext cx="2162695" cy="457200"/>
           </a:xfrm>
           <a:prstGeom prst="rect">
             <a:avLst/>
@@ -15047,71 +14499,53 @@
           <a:ln/>
         </p:spPr>
         <p:txBody>
-          <a:bodyPr wrap="square" lIns="0" tIns="0" rIns="0" bIns="0" rtlCol="0" anchor="t"/>
-          <a:lstStyle/>
-          <a:p>
-            <a:pPr marL="0" indent="0">
-              <a:buNone/>
-            </a:pPr>
-            <a:r>
-              <a:rPr lang="en-US" sz="1150" dirty="0">
-                <a:solidFill>
-                  <a:srgbClr val="1B2430"/>
-                </a:solidFill>
-                <a:latin typeface="Calibri" pitchFamily="34" charset="0"/>
-                <a:ea typeface="Calibri" pitchFamily="34" charset="-122"/>
-                <a:cs typeface="Calibri" pitchFamily="34" charset="-120"/>
-              </a:rPr>
-              <a:t>Foto aus der App, Diagnosevorschlag, vorläufiger Kostenvoranschlag und Termin, bevor der Kunde die Werkstatt betritt.</a:t>
-            </a:r>
-            <a:endParaRPr lang="en-US" sz="1150" dirty="0"/>
-          </a:p>
-        </p:txBody>
-      </p:sp>
-      <p:sp>
-        <p:nvSpPr>
-          <p:cNvPr id="22" name="Shape 16"/>
-          <p:cNvSpPr/>
-          <p:nvPr/>
-        </p:nvSpPr>
-        <p:spPr>
-          <a:xfrm>
-            <a:off x="457200" y="3977640"/>
-            <a:ext cx="8229600" cy="594360"/>
-          </a:xfrm>
-          <a:prstGeom prst="roundRect">
-            <a:avLst>
-              <a:gd name="adj" fmla="val 12308"/>
-            </a:avLst>
-          </a:prstGeom>
-          <a:solidFill>
-            <a:srgbClr val="EEF4F4"/>
-          </a:solidFill>
-          <a:ln w="12700">
-            <a:solidFill>
-              <a:srgbClr val="EEF4F4"/>
-            </a:solidFill>
-            <a:prstDash val="solid"/>
-          </a:ln>
-        </p:spPr>
-        <p:txBody>
-          <a:bodyPr/>
-          <a:lstStyle/>
-          <a:p>
-            <a:endParaRPr lang="de-DE"/>
-          </a:p>
-        </p:txBody>
-      </p:sp>
-      <p:sp>
-        <p:nvSpPr>
-          <p:cNvPr id="23" name="Text 17"/>
+          <a:bodyPr wrap="square" lIns="0" tIns="0" rIns="0" bIns="0" rtlCol="0" anchor="ctr"/>
+          <a:lstStyle/>
+          <a:p>
+            <a:pPr marL="0" indent="0" algn="ctr">
+              <a:buNone/>
+            </a:pPr>
+            <a:r>
+              <a:rPr lang="en-US" sz="1400" b="1" dirty="0">
+                <a:solidFill>
+                  <a:schemeClr val="accent2">
+                    <a:lumMod val="75000"/>
+                  </a:schemeClr>
+                </a:solidFill>
+                <a:latin typeface="Segoe UI" panose="020B0502040204020203" pitchFamily="34" charset="0"/>
+                <a:ea typeface="Calibri" pitchFamily="34" charset="-122"/>
+                <a:cs typeface="Segoe UI" panose="020B0502040204020203" pitchFamily="34" charset="0"/>
+              </a:rPr>
+              <a:t>Filialübergreifend</a:t>
+            </a:r>
+            <a:endParaRPr lang="en-US" sz="1400" dirty="0">
+              <a:solidFill>
+                <a:schemeClr val="accent2">
+                  <a:lumMod val="75000"/>
+                </a:schemeClr>
+              </a:solidFill>
+              <a:latin typeface="Segoe UI" panose="020B0502040204020203" pitchFamily="34" charset="0"/>
+              <a:cs typeface="Segoe UI" panose="020B0502040204020203" pitchFamily="34" charset="0"/>
+            </a:endParaRPr>
+          </a:p>
+        </p:txBody>
+      </p:sp>
+      <p:sp>
+        <p:nvSpPr>
+          <p:cNvPr id="11" name="Text 14">
+            <a:extLst>
+              <a:ext uri="{FF2B5EF4-FFF2-40B4-BE49-F238E27FC236}">
+                <a16:creationId xmlns:a16="http://schemas.microsoft.com/office/drawing/2014/main" id="{57ACD45A-C4AF-3724-FC3A-2FD000A1D529}"/>
+              </a:ext>
+            </a:extLst>
+          </p:cNvPr>
           <p:cNvSpPr txBox="1"/>
           <p:nvPr/>
         </p:nvSpPr>
         <p:spPr>
           <a:xfrm>
-            <a:off x="640080" y="3977640"/>
-            <a:ext cx="7863840" cy="594360"/>
+            <a:off x="6265718" y="2960437"/>
+            <a:ext cx="2162695" cy="457200"/>
           </a:xfrm>
           <a:prstGeom prst="rect">
             <a:avLst/>
@@ -15123,11 +14557,474 @@
           <a:bodyPr wrap="square" lIns="0" tIns="0" rIns="0" bIns="0" rtlCol="0" anchor="ctr"/>
           <a:lstStyle/>
           <a:p>
+            <a:pPr marL="0" indent="0" algn="ctr">
+              <a:buNone/>
+            </a:pPr>
+            <a:r>
+              <a:rPr lang="en-US" sz="1400" b="1" dirty="0">
+                <a:solidFill>
+                  <a:schemeClr val="accent2">
+                    <a:lumMod val="50000"/>
+                  </a:schemeClr>
+                </a:solidFill>
+                <a:latin typeface="Segoe UI" panose="020B0502040204020203" pitchFamily="34" charset="0"/>
+                <a:ea typeface="Calibri" pitchFamily="34" charset="-122"/>
+                <a:cs typeface="Segoe UI" panose="020B0502040204020203" pitchFamily="34" charset="0"/>
+              </a:rPr>
+              <a:t>Klarheit vor dem Besuch</a:t>
+            </a:r>
+            <a:endParaRPr lang="en-US" sz="1400" dirty="0">
+              <a:solidFill>
+                <a:schemeClr val="accent2">
+                  <a:lumMod val="50000"/>
+                </a:schemeClr>
+              </a:solidFill>
+              <a:latin typeface="Segoe UI" panose="020B0502040204020203" pitchFamily="34" charset="0"/>
+              <a:cs typeface="Segoe UI" panose="020B0502040204020203" pitchFamily="34" charset="0"/>
+            </a:endParaRPr>
+          </a:p>
+        </p:txBody>
+      </p:sp>
+      <p:sp>
+        <p:nvSpPr>
+          <p:cNvPr id="12" name="Text 0">
+            <a:extLst>
+              <a:ext uri="{FF2B5EF4-FFF2-40B4-BE49-F238E27FC236}">
+                <a16:creationId xmlns:a16="http://schemas.microsoft.com/office/drawing/2014/main" id="{C6780E2C-0C97-BB2E-EE86-76A772FB7380}"/>
+              </a:ext>
+            </a:extLst>
+          </p:cNvPr>
+          <p:cNvSpPr txBox="1"/>
+          <p:nvPr/>
+        </p:nvSpPr>
+        <p:spPr>
+          <a:xfrm>
+            <a:off x="339437" y="249382"/>
+            <a:ext cx="8229600" cy="914400"/>
+          </a:xfrm>
+          <a:prstGeom prst="rect">
+            <a:avLst/>
+          </a:prstGeom>
+          <a:noFill/>
+          <a:ln/>
+        </p:spPr>
+        <p:txBody>
+          <a:bodyPr wrap="square" lIns="0" tIns="0" rIns="0" bIns="0" rtlCol="0" anchor="ctr"/>
+          <a:lstStyle/>
+          <a:p>
             <a:pPr marL="0" indent="0">
-              <a:buNone/>
-            </a:pPr>
-            <a:r>
-              <a:rPr lang="en-US" sz="1200" dirty="0">
+              <a:spcAft>
+                <a:spcPts val="600"/>
+              </a:spcAft>
+              <a:buNone/>
+            </a:pPr>
+            <a:r>
+              <a:rPr lang="en-US" sz="2800" b="1" dirty="0">
+                <a:solidFill>
+                  <a:schemeClr val="accent2">
+                    <a:lumMod val="75000"/>
+                  </a:schemeClr>
+                </a:solidFill>
+                <a:latin typeface="Segoe UI" panose="020B0502040204020203" pitchFamily="34" charset="0"/>
+                <a:ea typeface="Calibri" pitchFamily="34" charset="-122"/>
+                <a:cs typeface="Segoe UI" panose="020B0502040204020203" pitchFamily="34" charset="0"/>
+              </a:rPr>
+              <a:t>Drei </a:t>
+            </a:r>
+            <a:r>
+              <a:rPr lang="en-US" sz="2800" b="1" dirty="0" err="1">
+                <a:solidFill>
+                  <a:schemeClr val="accent2">
+                    <a:lumMod val="75000"/>
+                  </a:schemeClr>
+                </a:solidFill>
+                <a:latin typeface="Segoe UI" panose="020B0502040204020203" pitchFamily="34" charset="0"/>
+                <a:ea typeface="Calibri" pitchFamily="34" charset="-122"/>
+                <a:cs typeface="Segoe UI" panose="020B0502040204020203" pitchFamily="34" charset="0"/>
+              </a:rPr>
+              <a:t>Nutzenversprechen</a:t>
+            </a:r>
+            <a:endParaRPr lang="en-US" sz="2800" b="1" dirty="0">
+              <a:solidFill>
+                <a:schemeClr val="accent2">
+                  <a:lumMod val="75000"/>
+                </a:schemeClr>
+              </a:solidFill>
+              <a:latin typeface="Segoe UI" panose="020B0502040204020203" pitchFamily="34" charset="0"/>
+              <a:ea typeface="Calibri" pitchFamily="34" charset="-122"/>
+              <a:cs typeface="Segoe UI" panose="020B0502040204020203" pitchFamily="34" charset="0"/>
+            </a:endParaRPr>
+          </a:p>
+          <a:p>
+            <a:r>
+              <a:rPr lang="en-US" sz="1400" dirty="0">
+                <a:solidFill>
+                  <a:schemeClr val="bg1">
+                    <a:lumMod val="50000"/>
+                  </a:schemeClr>
+                </a:solidFill>
+                <a:latin typeface="Segoe UI" panose="020B0502040204020203" pitchFamily="34" charset="0"/>
+                <a:ea typeface="Calibri" pitchFamily="34" charset="-122"/>
+                <a:cs typeface="Segoe UI" panose="020B0502040204020203" pitchFamily="34" charset="0"/>
+              </a:rPr>
+              <a:t>Die </a:t>
+            </a:r>
+            <a:r>
+              <a:rPr lang="en-US" sz="1400" dirty="0" err="1">
+                <a:solidFill>
+                  <a:schemeClr val="bg1">
+                    <a:lumMod val="50000"/>
+                  </a:schemeClr>
+                </a:solidFill>
+                <a:latin typeface="Segoe UI" panose="020B0502040204020203" pitchFamily="34" charset="0"/>
+                <a:ea typeface="Calibri" pitchFamily="34" charset="-122"/>
+                <a:cs typeface="Segoe UI" panose="020B0502040204020203" pitchFamily="34" charset="0"/>
+              </a:rPr>
+              <a:t>Werkstätten</a:t>
+            </a:r>
+            <a:r>
+              <a:rPr lang="en-US" sz="1400" dirty="0">
+                <a:solidFill>
+                  <a:schemeClr val="bg1">
+                    <a:lumMod val="50000"/>
+                  </a:schemeClr>
+                </a:solidFill>
+                <a:latin typeface="Segoe UI" panose="020B0502040204020203" pitchFamily="34" charset="0"/>
+                <a:ea typeface="Calibri" pitchFamily="34" charset="-122"/>
+                <a:cs typeface="Segoe UI" panose="020B0502040204020203" pitchFamily="34" charset="0"/>
+              </a:rPr>
+              <a:t> </a:t>
+            </a:r>
+            <a:r>
+              <a:rPr lang="en-US" sz="1400" dirty="0" err="1">
+                <a:solidFill>
+                  <a:schemeClr val="bg1">
+                    <a:lumMod val="50000"/>
+                  </a:schemeClr>
+                </a:solidFill>
+                <a:latin typeface="Segoe UI" panose="020B0502040204020203" pitchFamily="34" charset="0"/>
+                <a:ea typeface="Calibri" pitchFamily="34" charset="-122"/>
+                <a:cs typeface="Segoe UI" panose="020B0502040204020203" pitchFamily="34" charset="0"/>
+              </a:rPr>
+              <a:t>profitieren</a:t>
+            </a:r>
+            <a:r>
+              <a:rPr lang="en-US" sz="1400" dirty="0">
+                <a:solidFill>
+                  <a:schemeClr val="bg1">
+                    <a:lumMod val="50000"/>
+                  </a:schemeClr>
+                </a:solidFill>
+                <a:latin typeface="Segoe UI" panose="020B0502040204020203" pitchFamily="34" charset="0"/>
+                <a:ea typeface="Calibri" pitchFamily="34" charset="-122"/>
+                <a:cs typeface="Segoe UI" panose="020B0502040204020203" pitchFamily="34" charset="0"/>
+              </a:rPr>
+              <a:t> von </a:t>
+            </a:r>
+            <a:r>
+              <a:rPr lang="en-US" sz="1400" dirty="0" err="1">
+                <a:solidFill>
+                  <a:schemeClr val="bg1">
+                    <a:lumMod val="50000"/>
+                  </a:schemeClr>
+                </a:solidFill>
+                <a:latin typeface="Segoe UI" panose="020B0502040204020203" pitchFamily="34" charset="0"/>
+                <a:ea typeface="Calibri" pitchFamily="34" charset="-122"/>
+                <a:cs typeface="Segoe UI" panose="020B0502040204020203" pitchFamily="34" charset="0"/>
+              </a:rPr>
+              <a:t>weniger</a:t>
+            </a:r>
+            <a:r>
+              <a:rPr lang="en-US" sz="1400" dirty="0">
+                <a:solidFill>
+                  <a:schemeClr val="bg1">
+                    <a:lumMod val="50000"/>
+                  </a:schemeClr>
+                </a:solidFill>
+                <a:latin typeface="Segoe UI" panose="020B0502040204020203" pitchFamily="34" charset="0"/>
+                <a:ea typeface="Calibri" pitchFamily="34" charset="-122"/>
+                <a:cs typeface="Segoe UI" panose="020B0502040204020203" pitchFamily="34" charset="0"/>
+              </a:rPr>
+              <a:t> </a:t>
+            </a:r>
+            <a:r>
+              <a:rPr lang="en-US" sz="1400" dirty="0" err="1">
+                <a:solidFill>
+                  <a:schemeClr val="bg1">
+                    <a:lumMod val="50000"/>
+                  </a:schemeClr>
+                </a:solidFill>
+                <a:latin typeface="Segoe UI" panose="020B0502040204020203" pitchFamily="34" charset="0"/>
+                <a:ea typeface="Calibri" pitchFamily="34" charset="-122"/>
+                <a:cs typeface="Segoe UI" panose="020B0502040204020203" pitchFamily="34" charset="0"/>
+              </a:rPr>
+              <a:t>Telefonaten</a:t>
+            </a:r>
+            <a:r>
+              <a:rPr lang="en-US" sz="1400" dirty="0">
+                <a:solidFill>
+                  <a:schemeClr val="bg1">
+                    <a:lumMod val="50000"/>
+                  </a:schemeClr>
+                </a:solidFill>
+                <a:latin typeface="Segoe UI" panose="020B0502040204020203" pitchFamily="34" charset="0"/>
+                <a:ea typeface="Calibri" pitchFamily="34" charset="-122"/>
+                <a:cs typeface="Segoe UI" panose="020B0502040204020203" pitchFamily="34" charset="0"/>
+              </a:rPr>
+              <a:t>, </a:t>
+            </a:r>
+            <a:r>
+              <a:rPr lang="en-US" sz="1400" dirty="0" err="1">
+                <a:solidFill>
+                  <a:schemeClr val="bg1">
+                    <a:lumMod val="50000"/>
+                  </a:schemeClr>
+                </a:solidFill>
+                <a:latin typeface="Segoe UI" panose="020B0502040204020203" pitchFamily="34" charset="0"/>
+                <a:ea typeface="Calibri" pitchFamily="34" charset="-122"/>
+                <a:cs typeface="Segoe UI" panose="020B0502040204020203" pitchFamily="34" charset="0"/>
+              </a:rPr>
+              <a:t>weniger</a:t>
+            </a:r>
+            <a:r>
+              <a:rPr lang="en-US" sz="1400" dirty="0">
+                <a:solidFill>
+                  <a:schemeClr val="bg1">
+                    <a:lumMod val="50000"/>
+                  </a:schemeClr>
+                </a:solidFill>
+                <a:latin typeface="Segoe UI" panose="020B0502040204020203" pitchFamily="34" charset="0"/>
+                <a:ea typeface="Calibri" pitchFamily="34" charset="-122"/>
+                <a:cs typeface="Segoe UI" panose="020B0502040204020203" pitchFamily="34" charset="0"/>
+              </a:rPr>
+              <a:t> </a:t>
+            </a:r>
+            <a:r>
+              <a:rPr lang="en-US" sz="1400" dirty="0" err="1">
+                <a:solidFill>
+                  <a:schemeClr val="bg1">
+                    <a:lumMod val="50000"/>
+                  </a:schemeClr>
+                </a:solidFill>
+                <a:latin typeface="Segoe UI" panose="020B0502040204020203" pitchFamily="34" charset="0"/>
+                <a:ea typeface="Calibri" pitchFamily="34" charset="-122"/>
+                <a:cs typeface="Segoe UI" panose="020B0502040204020203" pitchFamily="34" charset="0"/>
+              </a:rPr>
+              <a:t>Standzeit</a:t>
+            </a:r>
+            <a:r>
+              <a:rPr lang="en-US" sz="1400" dirty="0">
+                <a:solidFill>
+                  <a:schemeClr val="bg1">
+                    <a:lumMod val="50000"/>
+                  </a:schemeClr>
+                </a:solidFill>
+                <a:latin typeface="Segoe UI" panose="020B0502040204020203" pitchFamily="34" charset="0"/>
+                <a:ea typeface="Calibri" pitchFamily="34" charset="-122"/>
+                <a:cs typeface="Segoe UI" panose="020B0502040204020203" pitchFamily="34" charset="0"/>
+              </a:rPr>
+              <a:t> </a:t>
+            </a:r>
+            <a:r>
+              <a:rPr lang="en-US" sz="1400" dirty="0" err="1">
+                <a:solidFill>
+                  <a:schemeClr val="bg1">
+                    <a:lumMod val="50000"/>
+                  </a:schemeClr>
+                </a:solidFill>
+                <a:latin typeface="Segoe UI" panose="020B0502040204020203" pitchFamily="34" charset="0"/>
+                <a:ea typeface="Calibri" pitchFamily="34" charset="-122"/>
+                <a:cs typeface="Segoe UI" panose="020B0502040204020203" pitchFamily="34" charset="0"/>
+              </a:rPr>
+              <a:t>im</a:t>
+            </a:r>
+            <a:r>
+              <a:rPr lang="en-US" sz="1400" dirty="0">
+                <a:solidFill>
+                  <a:schemeClr val="bg1">
+                    <a:lumMod val="50000"/>
+                  </a:schemeClr>
+                </a:solidFill>
+                <a:latin typeface="Segoe UI" panose="020B0502040204020203" pitchFamily="34" charset="0"/>
+                <a:ea typeface="Calibri" pitchFamily="34" charset="-122"/>
+                <a:cs typeface="Segoe UI" panose="020B0502040204020203" pitchFamily="34" charset="0"/>
+              </a:rPr>
+              <a:t> Lager, </a:t>
+            </a:r>
+            <a:r>
+              <a:rPr lang="en-US" sz="1400" dirty="0" err="1">
+                <a:solidFill>
+                  <a:schemeClr val="bg1">
+                    <a:lumMod val="50000"/>
+                  </a:schemeClr>
+                </a:solidFill>
+                <a:latin typeface="Segoe UI" panose="020B0502040204020203" pitchFamily="34" charset="0"/>
+                <a:ea typeface="Calibri" pitchFamily="34" charset="-122"/>
+                <a:cs typeface="Segoe UI" panose="020B0502040204020203" pitchFamily="34" charset="0"/>
+              </a:rPr>
+              <a:t>sichtbare</a:t>
+            </a:r>
+            <a:r>
+              <a:rPr lang="en-US" sz="1400" dirty="0">
+                <a:solidFill>
+                  <a:schemeClr val="bg1">
+                    <a:lumMod val="50000"/>
+                  </a:schemeClr>
+                </a:solidFill>
+                <a:latin typeface="Segoe UI" panose="020B0502040204020203" pitchFamily="34" charset="0"/>
+                <a:ea typeface="Calibri" pitchFamily="34" charset="-122"/>
+                <a:cs typeface="Segoe UI" panose="020B0502040204020203" pitchFamily="34" charset="0"/>
+              </a:rPr>
+              <a:t> </a:t>
+            </a:r>
+            <a:r>
+              <a:rPr lang="en-US" sz="1400" dirty="0" err="1">
+                <a:solidFill>
+                  <a:schemeClr val="bg1">
+                    <a:lumMod val="50000"/>
+                  </a:schemeClr>
+                </a:solidFill>
+                <a:latin typeface="Segoe UI" panose="020B0502040204020203" pitchFamily="34" charset="0"/>
+                <a:ea typeface="Calibri" pitchFamily="34" charset="-122"/>
+                <a:cs typeface="Segoe UI" panose="020B0502040204020203" pitchFamily="34" charset="0"/>
+              </a:rPr>
+              <a:t>Auslastung</a:t>
+            </a:r>
+            <a:r>
+              <a:rPr lang="en-US" sz="1400" dirty="0">
+                <a:solidFill>
+                  <a:schemeClr val="bg1">
+                    <a:lumMod val="50000"/>
+                  </a:schemeClr>
+                </a:solidFill>
+                <a:latin typeface="Segoe UI" panose="020B0502040204020203" pitchFamily="34" charset="0"/>
+                <a:ea typeface="Calibri" pitchFamily="34" charset="-122"/>
+                <a:cs typeface="Segoe UI" panose="020B0502040204020203" pitchFamily="34" charset="0"/>
+              </a:rPr>
+              <a:t>. Die Kunden </a:t>
+            </a:r>
+            <a:r>
+              <a:rPr lang="en-US" sz="1400" dirty="0" err="1">
+                <a:solidFill>
+                  <a:schemeClr val="bg1">
+                    <a:lumMod val="50000"/>
+                  </a:schemeClr>
+                </a:solidFill>
+                <a:latin typeface="Segoe UI" panose="020B0502040204020203" pitchFamily="34" charset="0"/>
+                <a:ea typeface="Calibri" pitchFamily="34" charset="-122"/>
+                <a:cs typeface="Segoe UI" panose="020B0502040204020203" pitchFamily="34" charset="0"/>
+              </a:rPr>
+              <a:t>profitieren</a:t>
+            </a:r>
+            <a:r>
+              <a:rPr lang="en-US" sz="1400" dirty="0">
+                <a:solidFill>
+                  <a:schemeClr val="bg1">
+                    <a:lumMod val="50000"/>
+                  </a:schemeClr>
+                </a:solidFill>
+                <a:latin typeface="Segoe UI" panose="020B0502040204020203" pitchFamily="34" charset="0"/>
+                <a:ea typeface="Calibri" pitchFamily="34" charset="-122"/>
+                <a:cs typeface="Segoe UI" panose="020B0502040204020203" pitchFamily="34" charset="0"/>
+              </a:rPr>
+              <a:t> von  </a:t>
+            </a:r>
+            <a:r>
+              <a:rPr lang="en-US" sz="1400" dirty="0" err="1">
+                <a:solidFill>
+                  <a:schemeClr val="bg1">
+                    <a:lumMod val="50000"/>
+                  </a:schemeClr>
+                </a:solidFill>
+                <a:latin typeface="Segoe UI" panose="020B0502040204020203" pitchFamily="34" charset="0"/>
+                <a:ea typeface="Calibri" pitchFamily="34" charset="-122"/>
+                <a:cs typeface="Segoe UI" panose="020B0502040204020203" pitchFamily="34" charset="0"/>
+              </a:rPr>
+              <a:t>schnelleren</a:t>
+            </a:r>
+            <a:r>
+              <a:rPr lang="en-US" sz="1400" dirty="0">
+                <a:solidFill>
+                  <a:schemeClr val="bg1">
+                    <a:lumMod val="50000"/>
+                  </a:schemeClr>
+                </a:solidFill>
+                <a:latin typeface="Segoe UI" panose="020B0502040204020203" pitchFamily="34" charset="0"/>
+                <a:ea typeface="Calibri" pitchFamily="34" charset="-122"/>
+                <a:cs typeface="Segoe UI" panose="020B0502040204020203" pitchFamily="34" charset="0"/>
+              </a:rPr>
+              <a:t> </a:t>
+            </a:r>
+            <a:r>
+              <a:rPr lang="en-US" sz="1400" dirty="0" err="1">
+                <a:solidFill>
+                  <a:schemeClr val="bg1">
+                    <a:lumMod val="50000"/>
+                  </a:schemeClr>
+                </a:solidFill>
+                <a:latin typeface="Segoe UI" panose="020B0502040204020203" pitchFamily="34" charset="0"/>
+                <a:ea typeface="Calibri" pitchFamily="34" charset="-122"/>
+                <a:cs typeface="Segoe UI" panose="020B0502040204020203" pitchFamily="34" charset="0"/>
+              </a:rPr>
+              <a:t>Antworten</a:t>
+            </a:r>
+            <a:r>
+              <a:rPr lang="en-US" sz="1400" dirty="0">
+                <a:solidFill>
+                  <a:schemeClr val="bg1">
+                    <a:lumMod val="50000"/>
+                  </a:schemeClr>
+                </a:solidFill>
+                <a:latin typeface="Segoe UI" panose="020B0502040204020203" pitchFamily="34" charset="0"/>
+                <a:ea typeface="Calibri" pitchFamily="34" charset="-122"/>
+                <a:cs typeface="Segoe UI" panose="020B0502040204020203" pitchFamily="34" charset="0"/>
+              </a:rPr>
+              <a:t>.</a:t>
+            </a:r>
+            <a:endParaRPr lang="en-US" sz="1400" dirty="0">
+              <a:solidFill>
+                <a:schemeClr val="bg1">
+                  <a:lumMod val="50000"/>
+                </a:schemeClr>
+              </a:solidFill>
+              <a:latin typeface="Segoe UI" panose="020B0502040204020203" pitchFamily="34" charset="0"/>
+              <a:cs typeface="Segoe UI" panose="020B0502040204020203" pitchFamily="34" charset="0"/>
+            </a:endParaRPr>
+          </a:p>
+        </p:txBody>
+      </p:sp>
+      <p:sp>
+        <p:nvSpPr>
+          <p:cNvPr id="13" name="Text 7">
+            <a:extLst>
+              <a:ext uri="{FF2B5EF4-FFF2-40B4-BE49-F238E27FC236}">
+                <a16:creationId xmlns:a16="http://schemas.microsoft.com/office/drawing/2014/main" id="{AE8BC7E0-7042-995C-22B8-CB1A0E89E2AA}"/>
+              </a:ext>
+            </a:extLst>
+          </p:cNvPr>
+          <p:cNvSpPr txBox="1"/>
+          <p:nvPr/>
+        </p:nvSpPr>
+        <p:spPr>
+          <a:xfrm>
+            <a:off x="653934" y="3515381"/>
+            <a:ext cx="2286000" cy="1508760"/>
+          </a:xfrm>
+          <a:prstGeom prst="rect">
+            <a:avLst/>
+          </a:prstGeom>
+          <a:noFill/>
+          <a:ln/>
+        </p:spPr>
+        <p:txBody>
+          <a:bodyPr wrap="square" lIns="0" tIns="0" rIns="0" bIns="0" rtlCol="0" anchor="t"/>
+          <a:lstStyle/>
+          <a:p>
+            <a:pPr marL="0" indent="0">
+              <a:buNone/>
+            </a:pPr>
+            <a:r>
+              <a:rPr lang="en-US" sz="1150" dirty="0">
                 <a:solidFill>
                   <a:srgbClr val="1B2430"/>
                 </a:solidFill>
@@ -15135,13 +15032,108 @@
                 <a:ea typeface="Calibri" pitchFamily="34" charset="-122"/>
                 <a:cs typeface="Calibri" pitchFamily="34" charset="-120"/>
               </a:rPr>
-              <a:t>Für die Werkstatt: weniger Telefon, weniger Standzeit im Lager, sichtbare Auslastung. Für den Kunden: Antwort in einer Minute statt in einer Woche.</a:t>
-            </a:r>
-            <a:endParaRPr lang="en-US" sz="1200" dirty="0"/>
+              <a:t>Fahrrad, E-Bike und Elektronik mit einer Kundenbasis und einem gemeinsamen Ersatzteillager. Ein Auftragsstatus für alle.</a:t>
+            </a:r>
+            <a:endParaRPr lang="en-US" sz="1150" dirty="0"/>
+          </a:p>
+        </p:txBody>
+      </p:sp>
+      <p:sp>
+        <p:nvSpPr>
+          <p:cNvPr id="14" name="Text 11">
+            <a:extLst>
+              <a:ext uri="{FF2B5EF4-FFF2-40B4-BE49-F238E27FC236}">
+                <a16:creationId xmlns:a16="http://schemas.microsoft.com/office/drawing/2014/main" id="{1DF8A319-71EB-1CC7-D87D-22C625301494}"/>
+              </a:ext>
+            </a:extLst>
+          </p:cNvPr>
+          <p:cNvSpPr txBox="1"/>
+          <p:nvPr/>
+        </p:nvSpPr>
+        <p:spPr>
+          <a:xfrm>
+            <a:off x="3428999" y="3515381"/>
+            <a:ext cx="2286000" cy="1508760"/>
+          </a:xfrm>
+          <a:prstGeom prst="rect">
+            <a:avLst/>
+          </a:prstGeom>
+          <a:noFill/>
+          <a:ln/>
+        </p:spPr>
+        <p:txBody>
+          <a:bodyPr wrap="square" lIns="0" tIns="0" rIns="0" bIns="0" rtlCol="0" anchor="t"/>
+          <a:lstStyle/>
+          <a:p>
+            <a:pPr marL="0" indent="0">
+              <a:buNone/>
+            </a:pPr>
+            <a:r>
+              <a:rPr lang="en-US" sz="1150" dirty="0">
+                <a:solidFill>
+                  <a:srgbClr val="1B2430"/>
+                </a:solidFill>
+                <a:latin typeface="Calibri" pitchFamily="34" charset="0"/>
+                <a:ea typeface="Calibri" pitchFamily="34" charset="-122"/>
+                <a:cs typeface="Calibri" pitchFamily="34" charset="-120"/>
+              </a:rPr>
+              <a:t>Bestände, Reservierungen und Umlagerungen über alle Standorte. Bestellt wird nur, was nirgends liegt.</a:t>
+            </a:r>
+            <a:endParaRPr lang="en-US" sz="1150" dirty="0"/>
+          </a:p>
+        </p:txBody>
+      </p:sp>
+      <p:sp>
+        <p:nvSpPr>
+          <p:cNvPr id="15" name="Text 15">
+            <a:extLst>
+              <a:ext uri="{FF2B5EF4-FFF2-40B4-BE49-F238E27FC236}">
+                <a16:creationId xmlns:a16="http://schemas.microsoft.com/office/drawing/2014/main" id="{D5650E79-427B-9478-372E-604F8C03CE83}"/>
+              </a:ext>
+            </a:extLst>
+          </p:cNvPr>
+          <p:cNvSpPr txBox="1"/>
+          <p:nvPr/>
+        </p:nvSpPr>
+        <p:spPr>
+          <a:xfrm>
+            <a:off x="6204064" y="3515381"/>
+            <a:ext cx="2286000" cy="1508760"/>
+          </a:xfrm>
+          <a:prstGeom prst="rect">
+            <a:avLst/>
+          </a:prstGeom>
+          <a:noFill/>
+          <a:ln/>
+        </p:spPr>
+        <p:txBody>
+          <a:bodyPr wrap="square" lIns="0" tIns="0" rIns="0" bIns="0" rtlCol="0" anchor="t"/>
+          <a:lstStyle/>
+          <a:p>
+            <a:pPr marL="0" indent="0">
+              <a:buNone/>
+            </a:pPr>
+            <a:r>
+              <a:rPr lang="en-US" sz="1150" dirty="0">
+                <a:solidFill>
+                  <a:srgbClr val="1B2430"/>
+                </a:solidFill>
+                <a:latin typeface="Calibri" pitchFamily="34" charset="0"/>
+                <a:ea typeface="Calibri" pitchFamily="34" charset="-122"/>
+                <a:cs typeface="Calibri" pitchFamily="34" charset="-120"/>
+              </a:rPr>
+              <a:t>Foto aus der App, Diagnosevorschlag, vorläufiger Kostenvoranschlag und Termin, bevor der Kunde die Werkstatt betritt.</a:t>
+            </a:r>
+            <a:endParaRPr lang="en-US" sz="1150" dirty="0"/>
           </a:p>
         </p:txBody>
       </p:sp>
     </p:spTree>
+    <p:extLst>
+      <p:ext uri="{BB962C8B-B14F-4D97-AF65-F5344CB8AC3E}">
+        <p14:creationId xmlns:p14="http://schemas.microsoft.com/office/powerpoint/2010/main" val="7463954"/>
+      </p:ext>
+    </p:extLst>
   </p:cSld>
   <p:clrMapOvr>
     <a:masterClrMapping/>

</xml_diff>

<commit_message>
[T05 2026-10-16] docs: update slide figures (133/81/61 %, 17 actors), notes 11/13/14, speaker text
Co-Authored-By: Claude Fable 5.1 <noreply@anthropic.com>
Claude-Session: https://claude.ai/code/session_01H2bGsFaySUqsEjJ1PXuxUw
</commit_message>
<xml_diff>
--- a/4_praesentation/Abschlusspraesentation.pptx
+++ b/4_praesentation/Abschlusspraesentation.pptx
@@ -389,7 +389,7 @@
             <a:r>
               <a:rPr lang="en-US" dirty="0"/>
               <a:t>Vortragende(r): David (70 s)
-Das Use-Case-Diagramm beschreibt, was RepairFlow für seine Benutzer leistet. 19 Use Cases in vier Bereichen: das Kundenportal mit Sofortdiagnose, Voranmeldung und KVA-Freigabe; Auftrag und Werkstatt von der Annahme bis zur Reklamation; die Ersatzteil-Disposition von der Reservierung bis zur Retoure; und die Administration des Werkstattbetriebs. Eine Besonderheit geht auf das Coaching zurück: Jeder Use Case hat genau eine Rolle. Statt eines Technikers mit fünf Verbindungen gibt es jetzt Diagnoseprüfer, Diagnostiker, Kalkulator, Reparateur und Endkontrolleur. Welche Person welche Rolle ausfüllt, regelt die Werkstatt selbst; im Datenmodell sind die Rollen den Mitarbeitertypen zugeordnet. Das Diagramm ist dadurch sofort lesbar, und die Rollen tauchen in den Sequenzdiagrammen wieder auf. Dazu kommen der Kunde und zwei externe Akteure, der Lieferant und der KI-Diagnosedienst.</a:t>
+Das Use-Case-Diagramm beschreibt, was RepairFlow für seine Benutzer leistet. 19 Use Cases in vier Bereichen: das Kundenportal mit Sofortdiagnose, Voranmeldung und KVA-Freigabe; Auftrag und Werkstatt von der Annahme bis zur Reklamation; die Ersatzteil-Disposition von der Reservierung bis zur Retoure; und die Administration des Werkstattbetriebs. Eine Besonderheit geht auf das Coaching zurück: Jeder Use Case hat genau eine Rolle. Statt eines Technikers mit fünf Verbindungen gibt es jetzt Diagnoseprüfer, Diagnostiker, Kalkulator, Reparateur und Endkontrolleur. Welche Person welche Rolle ausfüllt, regelt die Werkstatt selbst; im Datenmodell sind die Rollen den Mitarbeitertypen zugeordnet. Das Diagramm ist dadurch sofort lesbar, und die Rollen tauchen in den Sequenzdiagrammen wieder auf. Dazu kommen der Kunde und der KI-Diagnosedienst als externes System. Der Lieferant ist bewusst kein Akteur: Er hat keinen Zugang zu RepairFlow und bleibt eine Black Box, mit der nur Nachrichten ausgetauscht werden.</a:t>
             </a:r>
           </a:p>
         </p:txBody>
@@ -565,7 +565,7 @@
             <a:r>
               <a:rPr lang="en-US" dirty="0"/>
               <a:t>Vortragende(r): Kilian (70 s)
-Gearbeitet haben wir in Sprints, die sich am Takt der vier Gruppentermine orientiert haben, mit Review, Retrospektive und Planning je Termin. Nina hat die Projektleitung, David die Stellvertretung und die Sicherungen, Adrian ist Product Owner, ich Scrum Master, Maximilian verantwortet BPMN, Jakob die Qualität. Alles Schriftliche liegt in einem GitHub-Repository; jede Änderung geht über einen eigenen Branch, einen Pull Request und ein Review durch eine zweite Person, bisher zehn gemergte Pull Requests. Das Trello-Board hat eine Liste je Termin und eine Karte je Person und Aufgabe. Jedes Diagramm wurde im Zweierteam geprüft. Die Meilensteine: Am 02.09. standen alle Diagramme im Entwurf, am 05.10. die Korrekturen aus zwei Gesamtprüfungen, am 15.10. haben wir die Rollenstruktur umgesetzt, am 22.10. war die Generalprobe. Die Abgabe folgt am 13.11.</a:t>
+Gearbeitet haben wir in Sprints, die sich am Takt der vier Gruppentermine orientiert haben, mit Review, Retrospektive und Planning je Termin. Nina hat die Projektleitung, David die Stellvertretung und die Sicherungen, Adrian ist Product Owner, ich Scrum Master, Maximilian verantwortet BPMN, Jakob die Qualität. Alles Schriftliche liegt in einem GitHub-Repository; jede Änderung geht über einen eigenen Branch, einen Pull Request und ein Review durch eine zweite Person, bisher 27 gemergte Pull Requests. Das Trello-Board hat eine Liste je Termin und eine Karte je Person und Aufgabe. Jedes Diagramm wurde im Zweierteam geprüft. Die Meilensteine: Am 02.09. standen alle Diagramme im Entwurf, am 05.10. die Korrekturen aus zwei Gesamtprüfungen, am 15.10. haben wir die Rollenstruktur umgesetzt, am 22.10. war die Generalprobe. Die Abgabe folgt am 13.11.</a:t>
             </a:r>
           </a:p>
         </p:txBody>
@@ -653,7 +653,7 @@
             <a:r>
               <a:rPr lang="en-US" dirty="0"/>
               <a:t>Vortragende(r): Jakob (70 s)
-Drei Modelle, die sich auf dieselben Dinge beziehen, laufen schnell auseinander. Dagegen hatten wir drei Mittel. Erstens Konventionen: Datenobjekte in BPMN tragen die Klassennamen, Aktivitäten heißen Verb plus Objekt, jede Rolle ist genau einer Lane und einer Klasse zugeordnet, und die Statuswerte sind in allen Modellen identisch. Zweitens Werkzeuge: Die BPMN-Dateien sind für Camunda 8 angereichert, mit Task-Definitionen, Timern und Bedingungen. Der Camunda-Linter und bpmnlint melden null Befunde. Drittens Prüfrunden: Eine Gesamtprüfung am 26.09., ein Komplettcheck am 05.10. mit 39 Befunden und der QA-Abgleich am 08.10. Jede Änderung wird gegen unsere QA-Checkliste geprüft, bevor sie gemergt wird. Ein Beispiel: Als wir die Nacharbeit in Prozess 07 auf zwei Durchläufe begrenzt haben, musste das Sequenzdiagramm SD4 nachziehen. Genau solche Stellen findet die Checkliste.</a:t>
+Drei Modelle, die sich auf dieselben Dinge beziehen, laufen schnell auseinander. Dagegen hatten wir drei Mittel. Erstens Konventionen: Datenobjekte in BPMN tragen die Klassennamen, Aktivitäten heißen Verb plus Objekt, jede Rolle ist genau einer Lane und einer Klasse zugeordnet, und die Statuswerte sind in allen Modellen identisch. Zweitens Werkzeuge: Die BPMN-Dateien sind für Camunda 8 angereichert, mit Task-Definitionen, Timern und Bedingungen. Der Camunda-Linter und bpmnlint melden null Befunde. Drittens Prüfrunden: Eine Gesamtprüfung am 26.09., eine zweite Prüfrunde am 05.10. und der QA-Abgleich am 08.10. Jede Änderung wird gegen unsere QA-Checkliste geprüft, bevor sie gemergt wird. Ein Beispiel: Als wir die Nacharbeit in Prozess 07 auf zwei Durchläufe begrenzt haben, musste das Sequenzdiagramm SD4 nachziehen. Genau solche Stellen findet die Checkliste.</a:t>
             </a:r>
           </a:p>
         </p:txBody>
@@ -1533,7 +1533,7 @@
             <a:r>
               <a:rPr lang="en-US" dirty="0"/>
               <a:t>Vortragende(r): Maximilian (50 s)
-Damit zur zweiten Hälfte: Was steckt hinter dieser Geschichte? Wir haben drei Modelle erstellt, die zusammenpassen. Zehn BPMN-Kollaborationsdiagramme mit 131 Aktivitäten im Werkstatt-Pool, dazu die Abläufe des Kunden mit 26 weiteren Aktivitäten. Ein Use-Case-Diagramm mit 19 Use Cases und 18 Akteuren. Ein vollständiges Klassendiagramm mit 27 Klassen und 36 Assoziationen. Sechs Sequenzdiagramme, gefordert waren fünf, und als Zugabe ein Zustandsdiagramm für den Reparaturauftrag. Alle Modelle liegen im Camunda Modeler und in Visual Paradigm und werden mit der Dokumentation abgegeben. Ich beginne mit den Geschäftsprozessen.</a:t>
+Damit zur zweiten Hälfte: Was steckt hinter dieser Geschichte? Wir haben drei Modelle erstellt, die zusammenpassen. Zehn BPMN-Kollaborationsdiagramme mit 133 Aktivitäten im Werkstatt-Pool, dazu die Abläufe des Kunden mit 26 weiteren Aktivitäten. Ein Use-Case-Diagramm mit 19 Use Cases und 17 Akteuren. Ein vollständiges Klassendiagramm mit 27 Klassen und 36 Assoziationen. Sechs Sequenzdiagramme, gefordert waren fünf, und als Zugabe ein Zustandsdiagramm für den Reparaturauftrag. Alle Modelle liegen im Camunda Modeler und in Visual Paradigm und werden mit der Dokumentation abgegeben. Ich beginne mit den Geschäftsprozessen.</a:t>
             </a:r>
           </a:p>
         </p:txBody>
@@ -1621,7 +1621,7 @@
             <a:r>
               <a:rPr lang="en-US" dirty="0"/>
               <a:t>Vortragende(r): Maximilian (70 s)
-Die zehn Prozesse decken den gesamten Lebenszyklus ab. Prozesse 01 bis 08 sind die durchgehende Auftragsreise: Sofortdiagnose, Annahme, Diagnose, Kostenvoranschlag, Ersatzteilreservierung, Bestellung, Reparatur und Abholung. 09 und 10 sind die Folgeprozesse Reklamation und Retoure. Jedes Diagramm ist eine Kollaboration: Der Werkstattbetrieb ist der ausführbare Pool mit den Lanes Service, Techniker, Werkstattleitung und Disposition, der Kunde hat seinen eigenen Ablauf, der Lieferant bleibt eine Black Box. Die wichtigste Zahl: 60 Prozent der Aktivitäten führt RepairFlow ohne manuelle Arbeit aus, also Statuswechsel, Benachrichtigungen, Verfügbarkeitsprüfungen, Berechnungen und Regeln. Was Handwerk ist, bleibt Handwerk: Diagnose, Reparatur und Endkontrolle sind Aktivitäten des Technikers mit Unterstützung durch das System.</a:t>
+Die zehn Prozesse decken den gesamten Lebenszyklus ab. Prozesse 01 bis 08 sind die durchgehende Auftragsreise: Sofortdiagnose, Annahme, Diagnose, Kostenvoranschlag, Ersatzteilreservierung, Bestellung, Reparatur und Abholung. 09 und 10 sind die Folgeprozesse Reklamation und Retoure. Jedes Diagramm ist eine Kollaboration: Der Werkstattbetrieb ist der ausführbare Pool mit den Lanes Service, Techniker, Werkstattleitung und Disposition, der Kunde hat seinen eigenen Ablauf, der Lieferant bleibt eine Black Box. Die wichtigste Zahl: 61 Prozent der Aktivitäten führt RepairFlow ohne manuelle Arbeit aus, also Statuswechsel, Benachrichtigungen, Verfügbarkeitsprüfungen, Berechnungen und Regeln. Was Handwerk ist, bleibt Handwerk: Diagnose, Reparatur und Endkontrolle sind Aktivitäten des Technikers mit Unterstützung durch das System.</a:t>
             </a:r>
           </a:p>
         </p:txBody>
@@ -7114,7 +7114,7 @@
                 <a:ea typeface="Calibri" pitchFamily="34" charset="-122"/>
                 <a:cs typeface="Calibri" pitchFamily="34" charset="-120"/>
               </a:rPr>
-              <a:t>Gesamtprüfung 26.09., Komplettcheck 05.10. (39 Befunde), QA-Abgleich 08.10. Jeder Pull Request wird gegen die QA-Checkliste geprüft, bevor er gemergt wird.</a:t>
+              <a:t>Gesamtprüfung 26.09., zweite Prüfrunde 05.10., QA-Abgleich 08.10. Jeder Pull Request wird gegen die QA-Checkliste geprüft, bevor er gemergt wird.</a:t>
             </a:r>
             <a:endParaRPr lang="en-US" sz="1050" dirty="0"/>
           </a:p>
@@ -18856,7 +18856,7 @@
                 <a:ea typeface="Calibri" pitchFamily="34" charset="-122"/>
                 <a:cs typeface="Calibri" pitchFamily="34" charset="-120"/>
               </a:rPr>
-              <a:t>131 Aktivitäten im Werkstatt-Pool</a:t>
+              <a:t>133 Aktivitäten im Werkstatt-Pool</a:t>
             </a:r>
             <a:endParaRPr lang="en-US" sz="1100" dirty="0"/>
           </a:p>
@@ -19309,7 +19309,7 @@
                 <a:ea typeface="Calibri" pitchFamily="34" charset="-122"/>
                 <a:cs typeface="Calibri" pitchFamily="34" charset="-120"/>
               </a:rPr>
-              <a:t>Camunda Modeler, BPMN 2.0, angereichert für Camunda 8. Zehn Prozesse vom ersten Foto bis zur Retoure. 41 Nachrichtenflüsse, 48 Datenobjekte, 12 Datenspeicher.</a:t>
+              <a:t>Camunda Modeler, BPMN 2.0, angereichert für Camunda 8. Zehn Prozesse vom ersten Foto bis zur Retoure. 42 Nachrichtenflüsse, 51 Datenobjekte, 12 Datenspeicher.</a:t>
             </a:r>
             <a:endParaRPr lang="en-US" sz="1050" dirty="0"/>
           </a:p>
@@ -19717,7 +19717,7 @@
                 <a:ea typeface="Calibri" pitchFamily="34" charset="-122"/>
                 <a:cs typeface="Calibri" pitchFamily="34" charset="-120"/>
               </a:rPr>
-              <a:t>Zehn Prozesse, 60 Prozent automatisiert</a:t>
+              <a:t>Zehn Prozesse, 61 Prozent automatisiert</a:t>
             </a:r>
             <a:endParaRPr lang="en-US" sz="2800" dirty="0"/>
           </a:p>
@@ -21348,7 +21348,7 @@
                           <a:ea typeface="Calibri" pitchFamily="34" charset="-122"/>
                           <a:cs typeface="Calibri" pitchFamily="34" charset="-120"/>
                         </a:rPr>
-                        <a:t>14</a:t>
+                        <a:t>15</a:t>
                       </a:r>
                       <a:endParaRPr lang="en-US" sz="950" dirty="0">
                         <a:latin typeface="Calibri" charset="0"/>
@@ -21413,7 +21413,7 @@
                           <a:ea typeface="Calibri" pitchFamily="34" charset="-122"/>
                           <a:cs typeface="Calibri" pitchFamily="34" charset="-120"/>
                         </a:rPr>
-                        <a:t>79 %</a:t>
+                        <a:t>80 %</a:t>
                       </a:r>
                       <a:endParaRPr lang="en-US" sz="950" dirty="0">
                         <a:latin typeface="Calibri" charset="0"/>
@@ -21615,7 +21615,7 @@
                           <a:ea typeface="Calibri" pitchFamily="34" charset="-122"/>
                           <a:cs typeface="Calibri" pitchFamily="34" charset="-120"/>
                         </a:rPr>
-                        <a:t>14</a:t>
+                        <a:t>15</a:t>
                       </a:r>
                       <a:endParaRPr lang="en-US" sz="950" dirty="0">
                         <a:latin typeface="Calibri" charset="0"/>
@@ -21680,7 +21680,7 @@
                           <a:ea typeface="Calibri" pitchFamily="34" charset="-122"/>
                           <a:cs typeface="Calibri" pitchFamily="34" charset="-120"/>
                         </a:rPr>
-                        <a:t>57 %</a:t>
+                        <a:t>60 %</a:t>
                       </a:r>
                       <a:endParaRPr lang="en-US" sz="950" dirty="0">
                         <a:latin typeface="Calibri" charset="0"/>
@@ -22839,7 +22839,7 @@
                 <a:ea typeface="Calibri" pitchFamily="34" charset="-122"/>
                 <a:cs typeface="Calibri" pitchFamily="34" charset="-120"/>
               </a:rPr>
-              <a:t>131</a:t>
+              <a:t>133</a:t>
             </a:r>
             <a:endParaRPr lang="en-US" sz="4000" dirty="0"/>
           </a:p>
@@ -22878,7 +22878,7 @@
                 <a:ea typeface="Calibri" pitchFamily="34" charset="-122"/>
                 <a:cs typeface="Calibri" pitchFamily="34" charset="-120"/>
               </a:rPr>
-              <a:t>Aktivitäten im Werkstatt-Pool, im Schnitt 13,1 je Diagramm</a:t>
+              <a:t>Aktivitäten im Werkstatt-Pool, im Schnitt 13,3 je Diagramm</a:t>
             </a:r>
             <a:endParaRPr lang="en-US" sz="1100" dirty="0"/>
           </a:p>
@@ -22917,7 +22917,7 @@
                 <a:ea typeface="Calibri" pitchFamily="34" charset="-122"/>
                 <a:cs typeface="Calibri" pitchFamily="34" charset="-120"/>
               </a:rPr>
-              <a:t>60 %</a:t>
+              <a:t>61 %</a:t>
             </a:r>
             <a:endParaRPr lang="en-US" sz="4000" dirty="0"/>
           </a:p>

</xml_diff>

<commit_message>
[T05 2026-10-20] docs: Folie 8 Live-Demo der Kunden-App
- neue Folie 8 mit drei Screenshots aus dem Mockup und Hinweisen, was die Demo zeigt; Folien 9 bis 19 neu nummeriert, Agenda und Anhang angepasst
- Sprechtext: Folie 8 (Adrian, 60 s) ergänzt, Nummern angeglichen, Redezeit gesamt 19:10
- TODO, Team-Datei und Mockup-README auf die neue Folienfolge

Co-Authored-By: Claude Fable 5.1 <noreply@anthropic.com>
Claude-Session: https://claude.ai/code/session_01H2bGsFaySUqsEjJ1PXuxUw
</commit_message>
<xml_diff>
--- a/4_praesentation/Abschlusspraesentation.pptx
+++ b/4_praesentation/Abschlusspraesentation.pptx
@@ -15,6 +15,7 @@
     <p:sldId id="274" r:id="rId6"/>
     <p:sldId id="276" r:id="rId7"/>
     <p:sldId id="262" r:id="rId8"/>
+    <p:sldId id="277" r:id="rId99"/>
     <p:sldId id="263" r:id="rId9"/>
     <p:sldId id="264" r:id="rId10"/>
     <p:sldId id="265" r:id="rId11"/>
@@ -477,7 +478,7 @@
           <a:p>
             <a:fld id="{F7021451-1387-4CA6-816F-3879F97B5CBC}" type="slidenum">
               <a:rPr lang="en-US"/>
-              <a:t>10</a:t>
+              <a:t>11</a:t>
             </a:fld>
             <a:endParaRPr lang="en-US"/>
           </a:p>
@@ -565,7 +566,7 @@
           <a:p>
             <a:fld id="{F7021451-1387-4CA6-816F-3879F97B5CBC}" type="slidenum">
               <a:rPr lang="en-US"/>
-              <a:t>11</a:t>
+              <a:t>12</a:t>
             </a:fld>
             <a:endParaRPr lang="en-US"/>
           </a:p>
@@ -653,7 +654,7 @@
           <a:p>
             <a:fld id="{F7021451-1387-4CA6-816F-3879F97B5CBC}" type="slidenum">
               <a:rPr lang="en-US"/>
-              <a:t>12</a:t>
+              <a:t>13</a:t>
             </a:fld>
             <a:endParaRPr lang="en-US"/>
           </a:p>
@@ -741,7 +742,7 @@
           <a:p>
             <a:fld id="{F7021451-1387-4CA6-816F-3879F97B5CBC}" type="slidenum">
               <a:rPr lang="en-US"/>
-              <a:t>13</a:t>
+              <a:t>14</a:t>
             </a:fld>
             <a:endParaRPr lang="en-US"/>
           </a:p>
@@ -829,7 +830,7 @@
           <a:p>
             <a:fld id="{F7021451-1387-4CA6-816F-3879F97B5CBC}" type="slidenum">
               <a:rPr lang="en-US"/>
-              <a:t>14</a:t>
+              <a:t>15</a:t>
             </a:fld>
             <a:endParaRPr lang="en-US"/>
           </a:p>
@@ -917,7 +918,7 @@
           <a:p>
             <a:fld id="{F7021451-1387-4CA6-816F-3879F97B5CBC}" type="slidenum">
               <a:rPr lang="en-US"/>
-              <a:t>15</a:t>
+              <a:t>16</a:t>
             </a:fld>
             <a:endParaRPr lang="en-US"/>
           </a:p>
@@ -1005,7 +1006,7 @@
           <a:p>
             <a:fld id="{F7021451-1387-4CA6-816F-3879F97B5CBC}" type="slidenum">
               <a:rPr lang="en-US"/>
-              <a:t>16</a:t>
+              <a:t>17</a:t>
             </a:fld>
             <a:endParaRPr lang="en-US"/>
           </a:p>
@@ -1093,7 +1094,7 @@
           <a:p>
             <a:fld id="{F7021451-1387-4CA6-816F-3879F97B5CBC}" type="slidenum">
               <a:rPr lang="en-US"/>
-              <a:t>17</a:t>
+              <a:t>18</a:t>
             </a:fld>
             <a:endParaRPr lang="en-US"/>
           </a:p>
@@ -1200,6 +1201,94 @@
 </p:notes>
 </file>
 
+<file path=ppt/notesSlides/notesSlide19.xml><?xml version="1.0" encoding="utf-8"?>
+<p:notes xmlns:a="http://schemas.openxmlformats.org/drawingml/2006/main" xmlns:r="http://schemas.openxmlformats.org/officeDocument/2006/relationships" xmlns:p="http://schemas.openxmlformats.org/presentationml/2006/main">
+  <p:cSld>
+    <p:spTree>
+      <p:nvGrpSpPr>
+        <p:cNvPr id="1" name=""/>
+        <p:cNvGrpSpPr/>
+        <p:nvPr/>
+      </p:nvGrpSpPr>
+      <p:grpSpPr>
+        <a:xfrm>
+          <a:off x="0" y="0"/>
+          <a:ext cx="0" cy="0"/>
+          <a:chOff x="0" y="0"/>
+          <a:chExt cx="0" cy="0"/>
+        </a:xfrm>
+      </p:grpSpPr>
+      <p:sp>
+        <p:nvSpPr>
+          <p:cNvPr id="2" name="Slide Image Placeholder 1"/>
+          <p:cNvSpPr>
+            <a:spLocks noGrp="1" noRot="1" noChangeAspect="1"/>
+          </p:cNvSpPr>
+          <p:nvPr>
+            <p:ph type="sldImg"/>
+          </p:nvPr>
+        </p:nvSpPr>
+        <p:spPr/>
+      </p:sp>
+      <p:sp>
+        <p:nvSpPr>
+          <p:cNvPr id="3" name="Notes Placeholder 2"/>
+          <p:cNvSpPr>
+            <a:spLocks noGrp="1"/>
+          </p:cNvSpPr>
+          <p:nvPr>
+            <p:ph type="body" idx="1"/>
+          </p:nvPr>
+        </p:nvSpPr>
+        <p:spPr/>
+        <p:txBody>
+          <a:bodyPr/>
+          <a:lstStyle/>
+          <a:p>
+            <a:r>
+              <a:rPr lang="de-DE" dirty="0"/>
+              <a:t>Vortragende(r): Adrian (60 s)
+Wie sich das für den Kunden anfühlt, zeige ich Ihnen kurz in der App. Der Kunde wählt sein Gerät, beschreibt das Problem und lädt ein Foto hoch; im Modell ist das die Voranmeldung mit dem Medienanhang. Der KI-Dienst antwortet mit Ursache, benötigten Teilen und einer Konfidenz, das ist der KIDiagnosevorschlag. RepairFlow rechnet daraus das Angebot, deutlich als vorläufig markiert, und schlägt Filiale und Termin vor. Bestätigt der Kunde, sind die Teile vorreserviert und die Voranmeldung steht. Der eigentliche Reparaturauftrag entsteht erst, wenn das Gerät in der Filiale abgegeben wird. Zum Schluss sieht der Kunde den Status seines Auftrags entlang derselben Zustände, die David in der Auftragsreise gezeigt hat. Die KI-Antwort ist in der Demo simuliert; Ablauf und Begriffe sind genau die aus unseren Modellen.</a:t>
+            </a:r>
+          </a:p>
+        </p:txBody>
+      </p:sp>
+      <p:sp>
+        <p:nvSpPr>
+          <p:cNvPr id="4" name="Slide Number Placeholder 3"/>
+          <p:cNvSpPr>
+            <a:spLocks noGrp="1"/>
+          </p:cNvSpPr>
+          <p:nvPr>
+            <p:ph type="sldNum" sz="quarter" idx="10"/>
+          </p:nvPr>
+        </p:nvSpPr>
+        <p:spPr/>
+        <p:txBody>
+          <a:bodyPr/>
+          <a:lstStyle/>
+          <a:p>
+            <a:fld id="{F7021451-1387-4CA6-816F-3879F97B5CBC}" type="slidenum">
+              <a:rPr lang="en-US"/>
+              <a:t>8</a:t>
+            </a:fld>
+            <a:endParaRPr lang="en-US"/>
+          </a:p>
+        </p:txBody>
+      </p:sp>
+    </p:spTree>
+    <p:extLst>
+      <p:ext uri="{BB962C8B-B14F-4D97-AF65-F5344CB8AC3E}">
+        <p14:creationId xmlns:p14="http://schemas.microsoft.com/office/powerpoint/2010/main" val="1024087001"/>
+      </p:ext>
+    </p:extLst>
+  </p:cSld>
+  <p:clrMapOvr>
+    <a:masterClrMapping/>
+  </p:clrMapOvr>
+</p:notes>
+</file>
+
 <file path=ppt/notesSlides/notesSlide2.xml><?xml version="1.0" encoding="utf-8"?>
 <p:notes xmlns:a="http://schemas.openxmlformats.org/drawingml/2006/main" xmlns:r="http://schemas.openxmlformats.org/officeDocument/2006/relationships" xmlns:p="http://schemas.openxmlformats.org/presentationml/2006/main">
   <p:cSld>
@@ -1247,7 +1336,7 @@
             <a:r>
               <a:rPr lang="de-DE" dirty="0"/>
               <a:t>Vortragende(r): Nina (40 s)
-Unsere Präsentation hat zwei Hälften. In der ersten erzählen wir RepairFlow so, wie wir es einer Werkstatt vorstellen würden: Problem, Lösung, Nutzen, die Reparatur aus Kundensicht und unser Alleinstellungsmerkmal, die KI-Sofortdiagnose. In der zweiten Hälfte zeigen wir, was dahintersteckt: zehn Geschäftsprozesse, Rollen und Use Cases, das Datenmodell, unser Vorgehen und die Qualitätssicherung. Die Diagramme selbst finden Sie in der Projektdokumentation und im Abgabepaket; hier konzentrieren wir uns auf die Ergebnisse. Fragen gern am Ende.</a:t>
+Unsere Präsentation hat zwei Hälften. In der ersten erzählen wir RepairFlow so, wie wir es einer Werkstatt vorstellen würden: Problem, Lösung, Nutzen, die Reparatur aus Kundensicht und unser Alleinstellungsmerkmal, die KI-Sofortdiagnose, mit einer kurzen Demo der Kunden-App. In der zweiten Hälfte zeigen wir, was dahintersteckt: zehn Geschäftsprozesse, Rollen und Use Cases, das Datenmodell, unser Vorgehen und die Qualitätssicherung. Die Diagramme selbst finden Sie in der Projektdokumentation und im Abgabepaket; hier konzentrieren wir uns auf die Ergebnisse. Fragen gern am Ende.</a:t>
             </a:r>
           </a:p>
         </p:txBody>
@@ -1821,7 +1910,7 @@
           <a:p>
             <a:fld id="{F7021451-1387-4CA6-816F-3879F97B5CBC}" type="slidenum">
               <a:rPr lang="en-US"/>
-              <a:t>8</a:t>
+              <a:t>9</a:t>
             </a:fld>
             <a:endParaRPr lang="en-US"/>
           </a:p>
@@ -1909,7 +1998,7 @@
           <a:p>
             <a:fld id="{F7021451-1387-4CA6-816F-3879F97B5CBC}" type="slidenum">
               <a:rPr lang="en-US"/>
-              <a:t>9</a:t>
+              <a:t>10</a:t>
             </a:fld>
             <a:endParaRPr lang="en-US"/>
           </a:p>
@@ -2770,7 +2859,7 @@
                 <a:ea typeface="Calibri" pitchFamily="34" charset="-122"/>
                 <a:cs typeface="Calibri" pitchFamily="34" charset="-120"/>
               </a:rPr>
-              <a:t>10</a:t>
+              <a:t>11</a:t>
             </a:r>
             <a:endParaRPr lang="en-US" sz="900" dirty="0"/>
           </a:p>
@@ -3562,7 +3651,7 @@
                 <a:ea typeface="Calibri" pitchFamily="34" charset="-122"/>
                 <a:cs typeface="Calibri" pitchFamily="34" charset="-120"/>
               </a:rPr>
-              <a:t>11</a:t>
+              <a:t>12</a:t>
             </a:r>
             <a:endParaRPr lang="en-US" sz="900" dirty="0"/>
           </a:p>
@@ -4628,7 +4717,7 @@
                 <a:ea typeface="Calibri" pitchFamily="34" charset="-122"/>
                 <a:cs typeface="Calibri" pitchFamily="34" charset="-120"/>
               </a:rPr>
-              <a:t>12</a:t>
+              <a:t>13</a:t>
             </a:r>
             <a:endParaRPr lang="en-US" sz="900" dirty="0"/>
           </a:p>
@@ -5708,7 +5797,7 @@
                 <a:ea typeface="Calibri" pitchFamily="34" charset="-122"/>
                 <a:cs typeface="Calibri" pitchFamily="34" charset="-120"/>
               </a:rPr>
-              <a:t>13</a:t>
+              <a:t>14</a:t>
             </a:r>
             <a:endParaRPr lang="en-US" sz="900" dirty="0"/>
           </a:p>
@@ -6788,7 +6877,7 @@
                 <a:ea typeface="Calibri" pitchFamily="34" charset="-122"/>
                 <a:cs typeface="Calibri" pitchFamily="34" charset="-120"/>
               </a:rPr>
-              <a:t>14</a:t>
+              <a:t>15</a:t>
             </a:r>
             <a:endParaRPr lang="en-US" sz="900" dirty="0"/>
           </a:p>
@@ -7582,7 +7671,7 @@
                 <a:ea typeface="Calibri" pitchFamily="34" charset="-122"/>
                 <a:cs typeface="Calibri" pitchFamily="34" charset="-120"/>
               </a:rPr>
-              <a:t>15</a:t>
+              <a:t>16</a:t>
             </a:r>
             <a:endParaRPr lang="en-US" sz="900" dirty="0"/>
           </a:p>
@@ -8404,7 +8493,7 @@
                 <a:ea typeface="Calibri" pitchFamily="34" charset="-122"/>
                 <a:cs typeface="Calibri" pitchFamily="34" charset="-120"/>
               </a:rPr>
-              <a:t>16</a:t>
+              <a:t>17</a:t>
             </a:r>
             <a:endParaRPr lang="en-US" sz="900" dirty="0"/>
           </a:p>
@@ -9433,7 +9522,7 @@
                 <a:ea typeface="Calibri" pitchFamily="34" charset="-122"/>
                 <a:cs typeface="Calibri" pitchFamily="34" charset="-120"/>
               </a:rPr>
-              <a:t>17</a:t>
+              <a:t>18</a:t>
             </a:r>
             <a:endParaRPr lang="en-US" sz="900" dirty="0"/>
           </a:p>
@@ -9818,7 +9907,7 @@
                 <a:ea typeface="Calibri" pitchFamily="34" charset="-122"/>
                 <a:cs typeface="Calibri" pitchFamily="34" charset="-120"/>
               </a:rPr>
-              <a:t>18</a:t>
+              <a:t>19</a:t>
             </a:r>
             <a:endParaRPr lang="en-US" sz="900" dirty="0"/>
           </a:p>
@@ -10163,7 +10252,7 @@
                           <a:ea typeface="Calibri" pitchFamily="34" charset="-122"/>
                           <a:cs typeface="Calibri" pitchFamily="34" charset="-120"/>
                         </a:rPr>
-                        <a:t>1–2, 16–17</a:t>
+                        <a:t>1–2, 17–18</a:t>
                       </a:r>
                       <a:endParaRPr lang="en-US" sz="1050" dirty="0">
                         <a:latin typeface="Calibri" charset="0"/>
@@ -10365,7 +10454,7 @@
                           <a:ea typeface="Calibri" pitchFamily="34" charset="-122"/>
                           <a:cs typeface="Calibri" pitchFamily="34" charset="-120"/>
                         </a:rPr>
-                        <a:t>3, 6, 11</a:t>
+                        <a:t>3, 6, 12</a:t>
                       </a:r>
                       <a:endParaRPr lang="en-US" sz="1050" dirty="0">
                         <a:latin typeface="Calibri" charset="0"/>
@@ -10430,7 +10519,7 @@
                           <a:ea typeface="Calibri" pitchFamily="34" charset="-122"/>
                           <a:cs typeface="Calibri" pitchFamily="34" charset="-120"/>
                         </a:rPr>
-                        <a:t>Das Problem, Auftragsreise, Rollen und Use Cases; Use-Case-Diagramm und Sequenzdiagramme SD2, SD3, SD5, SD6 in Visual Paradigm, stellvertretende Projektleitung</a:t>
+                        <a:t>Das Problem, Auftragsreise, Rollen und Use Cases; Use-Case-Diagramm und Sequenzdiagramme SD5 und SD6 in Visual Paradigm, stellvertretende Projektleitung</a:t>
                       </a:r>
                       <a:endParaRPr lang="en-US" sz="1050" dirty="0">
                         <a:latin typeface="Calibri" charset="0"/>
@@ -10567,7 +10656,7 @@
                           <a:ea typeface="Calibri" pitchFamily="34" charset="-122"/>
                           <a:cs typeface="Calibri" pitchFamily="34" charset="-120"/>
                         </a:rPr>
-                        <a:t>4–5, 7</a:t>
+                        <a:t>4–5, 7–8</a:t>
                       </a:r>
                       <a:endParaRPr lang="en-US" sz="1050" dirty="0">
                         <a:latin typeface="Calibri" charset="0"/>
@@ -10632,7 +10721,7 @@
                           <a:ea typeface="Calibri" pitchFamily="34" charset="-122"/>
                           <a:cs typeface="Calibri" pitchFamily="34" charset="-120"/>
                         </a:rPr>
-                        <a:t>Lösung, Nutzenversprechen, KI-Sofortdiagnose; Product Owner, Fachkonzept und Entscheidungslog</a:t>
+                        <a:t>Lösung, Nutzenversprechen, KI-Sofortdiagnose, Live-Demo; Product Owner, Fachkonzept und Entscheidungslog</a:t>
                       </a:r>
                       <a:endParaRPr lang="en-US" sz="1050" dirty="0">
                         <a:latin typeface="Calibri" charset="0"/>
@@ -10769,7 +10858,7 @@
                           <a:ea typeface="Calibri" pitchFamily="34" charset="-122"/>
                           <a:cs typeface="Calibri" pitchFamily="34" charset="-120"/>
                         </a:rPr>
-                        <a:t>8–10</a:t>
+                        <a:t>9–11</a:t>
                       </a:r>
                       <a:endParaRPr lang="en-US" sz="1050" dirty="0">
                         <a:latin typeface="Calibri" charset="0"/>
@@ -10971,7 +11060,7 @@
                           <a:ea typeface="Calibri" pitchFamily="34" charset="-122"/>
                           <a:cs typeface="Calibri" pitchFamily="34" charset="-120"/>
                         </a:rPr>
-                        <a:t>12–13</a:t>
+                        <a:t>13–14</a:t>
                       </a:r>
                       <a:endParaRPr lang="en-US" sz="1050" dirty="0">
                         <a:latin typeface="Calibri" charset="0"/>
@@ -11036,7 +11125,7 @@
                           <a:ea typeface="Calibri" pitchFamily="34" charset="-122"/>
                           <a:cs typeface="Calibri" pitchFamily="34" charset="-120"/>
                         </a:rPr>
-                        <a:t>Datenmodell, Vorgehen und Projektmanagement; Klassendiagramm, SD1, SD4 und VP-Projekt, Scrum Master</a:t>
+                        <a:t>Datenmodell, Vorgehen und Projektmanagement; Klassendiagramm, SD1 bis SD4 und VP-Projekt, Scrum Master</a:t>
                       </a:r>
                       <a:endParaRPr lang="en-US" sz="1050" dirty="0">
                         <a:latin typeface="Calibri" charset="0"/>
@@ -11173,7 +11262,7 @@
                           <a:ea typeface="Calibri" pitchFamily="34" charset="-122"/>
                           <a:cs typeface="Calibri" pitchFamily="34" charset="-120"/>
                         </a:rPr>
-                        <a:t>14–15</a:t>
+                        <a:t>15–16</a:t>
                       </a:r>
                       <a:endParaRPr lang="en-US" sz="1050" dirty="0">
                         <a:latin typeface="Calibri" charset="0"/>
@@ -11296,6 +11385,614 @@
           </a:graphicData>
         </a:graphic>
       </p:graphicFrame>
+    </p:spTree>
+  </p:cSld>
+  <p:clrMapOvr>
+    <a:masterClrMapping/>
+  </p:clrMapOvr>
+</p:sld>
+</file>
+
+<file path=ppt/slides/slide19.xml><?xml version="1.0" encoding="utf-8"?>
+<p:sld xmlns:a="http://schemas.openxmlformats.org/drawingml/2006/main" xmlns:r="http://schemas.openxmlformats.org/officeDocument/2006/relationships" xmlns:p="http://schemas.openxmlformats.org/presentationml/2006/main">
+  <p:cSld name="Slide 8">
+    <p:bg>
+      <p:bgPr>
+        <a:solidFill>
+          <a:srgbClr val="FFFFFF"/>
+        </a:solidFill>
+        <a:effectLst/>
+      </p:bgPr>
+    </p:bg>
+    <p:spTree>
+      <p:nvGrpSpPr>
+        <p:cNvPr id="1" name=""/>
+        <p:cNvGrpSpPr/>
+        <p:nvPr/>
+      </p:nvGrpSpPr>
+      <p:grpSpPr>
+        <a:xfrm>
+          <a:off x="0" y="0"/>
+          <a:ext cx="0" cy="0"/>
+          <a:chOff x="0" y="0"/>
+          <a:chExt cx="0" cy="0"/>
+        </a:xfrm>
+      </p:grpSpPr>
+      <p:sp>
+        <p:nvSpPr>
+          <p:cNvPr id="2" name="Text 0"/>
+          <p:cNvSpPr txBox="1"/>
+          <p:nvPr/>
+        </p:nvSpPr>
+        <p:spPr>
+          <a:xfrm>
+            <a:off x="457200" y="274320"/>
+            <a:ext cx="8229600" cy="640080"/>
+          </a:xfrm>
+          <a:prstGeom prst="rect">
+            <a:avLst/>
+          </a:prstGeom>
+          <a:noFill/>
+          <a:ln/>
+        </p:spPr>
+        <p:txBody>
+          <a:bodyPr wrap="square" lIns="0" tIns="0" rIns="0" bIns="0" rtlCol="0" anchor="ctr"/>
+          <a:lstStyle/>
+          <a:p>
+            <a:pPr marL="0" indent="0">
+              <a:buNone/>
+            </a:pPr>
+            <a:r>
+              <a:rPr lang="en-US" sz="2800" b="1" dirty="0">
+                <a:solidFill>
+                  <a:srgbClr val="0E5E5E"/>
+                </a:solidFill>
+                <a:latin typeface="Calibri" pitchFamily="34" charset="0"/>
+                <a:ea typeface="Calibri" pitchFamily="34" charset="-122"/>
+                <a:cs typeface="Calibri" pitchFamily="34" charset="-120"/>
+              </a:rPr>
+              <a:t>Live-Demo: die Kunden-App</a:t>
+            </a:r>
+            <a:endParaRPr lang="en-US" sz="2800" dirty="0"/>
+          </a:p>
+        </p:txBody>
+      </p:sp>
+      <p:sp>
+        <p:nvSpPr>
+          <p:cNvPr id="3" name="Text 1"/>
+          <p:cNvSpPr txBox="1"/>
+          <p:nvPr/>
+        </p:nvSpPr>
+        <p:spPr>
+          <a:xfrm>
+            <a:off x="457200" y="4754880"/>
+            <a:ext cx="5486400" cy="274320"/>
+          </a:xfrm>
+          <a:prstGeom prst="rect">
+            <a:avLst/>
+          </a:prstGeom>
+          <a:noFill/>
+          <a:ln/>
+        </p:spPr>
+        <p:txBody>
+          <a:bodyPr wrap="square" lIns="0" tIns="0" rIns="0" bIns="0" rtlCol="0" anchor="ctr"/>
+          <a:lstStyle/>
+          <a:p>
+            <a:pPr marL="0" indent="0">
+              <a:buNone/>
+            </a:pPr>
+            <a:r>
+              <a:rPr lang="en-US" sz="900" dirty="0">
+                <a:solidFill>
+                  <a:srgbClr val="5F6B7A"/>
+                </a:solidFill>
+                <a:latin typeface="Calibri" pitchFamily="34" charset="0"/>
+                <a:ea typeface="Calibri" pitchFamily="34" charset="-122"/>
+                <a:cs typeface="Calibri" pitchFamily="34" charset="-120"/>
+              </a:rPr>
+              <a:t>RepairFlow · Fallstudie Systemanalyse · WWI25B4 Gruppe 1</a:t>
+            </a:r>
+            <a:endParaRPr lang="en-US" sz="900" dirty="0"/>
+          </a:p>
+        </p:txBody>
+      </p:sp>
+      <p:sp>
+        <p:nvSpPr>
+          <p:cNvPr id="4" name="Text 2"/>
+          <p:cNvSpPr txBox="1"/>
+          <p:nvPr/>
+        </p:nvSpPr>
+        <p:spPr>
+          <a:xfrm>
+            <a:off x="8229600" y="4754880"/>
+            <a:ext cx="457200" cy="274320"/>
+          </a:xfrm>
+          <a:prstGeom prst="rect">
+            <a:avLst/>
+          </a:prstGeom>
+          <a:noFill/>
+          <a:ln/>
+        </p:spPr>
+        <p:txBody>
+          <a:bodyPr wrap="square" lIns="0" tIns="0" rIns="0" bIns="0" rtlCol="0" anchor="ctr"/>
+          <a:lstStyle/>
+          <a:p>
+            <a:pPr marL="0" indent="0" algn="r">
+              <a:buNone/>
+            </a:pPr>
+            <a:r>
+              <a:rPr lang="en-US" sz="900" dirty="0">
+                <a:solidFill>
+                  <a:srgbClr val="5F6B7A"/>
+                </a:solidFill>
+                <a:latin typeface="Calibri" pitchFamily="34" charset="0"/>
+                <a:ea typeface="Calibri" pitchFamily="34" charset="-122"/>
+                <a:cs typeface="Calibri" pitchFamily="34" charset="-120"/>
+              </a:rPr>
+              <a:t>8</a:t>
+            </a:r>
+            <a:endParaRPr lang="en-US" sz="900" dirty="0"/>
+          </a:p>
+        </p:txBody>
+      </p:sp>
+      <p:sp>
+        <p:nvSpPr>
+          <p:cNvPr id="101" name="Text 101"/>
+          <p:cNvSpPr txBox="1"/>
+          <p:nvPr/>
+        </p:nvSpPr>
+        <p:spPr>
+          <a:xfrm>
+            <a:off x="457200" y="868680"/>
+            <a:ext cx="8229600" cy="320040"/>
+          </a:xfrm>
+          <a:prstGeom prst="rect">
+            <a:avLst/>
+          </a:prstGeom>
+          <a:noFill/>
+          <a:ln/>
+        </p:spPr>
+        <p:txBody>
+          <a:bodyPr wrap="square" lIns="0" tIns="0" rIns="0" bIns="0" rtlCol="0" anchor="ctr"/>
+          <a:lstStyle/>
+          <a:p>
+            <a:pPr marL="0" indent="0">
+              <a:buNone/>
+            </a:pPr>
+            <a:r>
+              <a:rPr lang="de-DE" sz="1200" dirty="0">
+                <a:solidFill>
+                  <a:srgbClr val="5A6572"/>
+                </a:solidFill>
+                <a:latin typeface="Calibri" pitchFamily="34" charset="0"/>
+                <a:ea typeface="Calibri" pitchFamily="34" charset="-122"/>
+                <a:cs typeface="Calibri" pitchFamily="34" charset="-120"/>
+              </a:rPr>
+              <a:t>Drei Stationen der Sofortdiagnose, wie sie der Kunde in der App erlebt. Die Demo läuft offline im Browser.</a:t>
+            </a:r>
+            <a:endParaRPr lang="de-DE" sz="1200" dirty="0"/>
+          </a:p>
+        </p:txBody>
+      </p:sp>
+      <p:pic>
+        <p:nvPicPr>
+          <p:cNvPr id="102" name="Image 102" descr="Kunden-App"/>
+          <p:cNvPicPr>
+            <a:picLocks noChangeAspect="1"/>
+          </p:cNvPicPr>
+          <p:nvPr/>
+        </p:nvPicPr>
+        <p:blipFill>
+          <a:blip r:embed="rId10"/>
+          <a:stretch>
+            <a:fillRect/>
+          </a:stretch>
+        </p:blipFill>
+        <p:spPr>
+          <a:xfrm>
+            <a:off x="457200" y="1234440"/>
+            <a:ext cx="1391672" cy="2926080"/>
+          </a:xfrm>
+          <a:prstGeom prst="rect">
+            <a:avLst/>
+          </a:prstGeom>
+        </p:spPr>
+      </p:pic>
+      <p:sp>
+        <p:nvSpPr>
+          <p:cNvPr id="103" name="Text 103"/>
+          <p:cNvSpPr txBox="1"/>
+          <p:nvPr/>
+        </p:nvSpPr>
+        <p:spPr>
+          <a:xfrm>
+            <a:off x="411480" y="4221480"/>
+            <a:ext cx="1483112" cy="457200"/>
+          </a:xfrm>
+          <a:prstGeom prst="rect">
+            <a:avLst/>
+          </a:prstGeom>
+          <a:noFill/>
+          <a:ln/>
+        </p:spPr>
+        <p:txBody>
+          <a:bodyPr wrap="square" lIns="0" tIns="0" rIns="0" bIns="0" rtlCol="0" anchor="t"/>
+          <a:lstStyle/>
+          <a:p>
+            <a:pPr marL="0" indent="0" algn="ctr">
+              <a:buNone/>
+            </a:pPr>
+            <a:r>
+              <a:rPr lang="de-DE" sz="1100" b="1" dirty="0">
+                <a:solidFill>
+                  <a:srgbClr val="0E5E5E"/>
+                </a:solidFill>
+                <a:latin typeface="Calibri" pitchFamily="34" charset="0"/>
+                <a:ea typeface="Calibri" pitchFamily="34" charset="-122"/>
+                <a:cs typeface="Calibri" pitchFamily="34" charset="-120"/>
+              </a:rPr>
+              <a:t>1  Problem und Foto</a:t>
+            </a:r>
+            <a:endParaRPr lang="de-DE" sz="1100" dirty="0"/>
+          </a:p>
+          <a:p>
+            <a:pPr marL="0" indent="0" algn="ctr">
+              <a:buNone/>
+            </a:pPr>
+            <a:r>
+              <a:rPr lang="de-DE" sz="950" dirty="0">
+                <a:solidFill>
+                  <a:srgbClr val="1B2430"/>
+                </a:solidFill>
+                <a:latin typeface="Calibri" pitchFamily="34" charset="0"/>
+                <a:ea typeface="Calibri" pitchFamily="34" charset="-122"/>
+                <a:cs typeface="Calibri" pitchFamily="34" charset="-120"/>
+              </a:rPr>
+              <a:t>Voranmeldung mit Medienanhang</a:t>
+            </a:r>
+            <a:endParaRPr lang="de-DE" sz="950" dirty="0"/>
+          </a:p>
+        </p:txBody>
+      </p:sp>
+      <p:pic>
+        <p:nvPicPr>
+          <p:cNvPr id="104" name="Image 104" descr="Kunden-App"/>
+          <p:cNvPicPr>
+            <a:picLocks noChangeAspect="1"/>
+          </p:cNvPicPr>
+          <p:nvPr/>
+        </p:nvPicPr>
+        <p:blipFill>
+          <a:blip r:embed="rId11"/>
+          <a:stretch>
+            <a:fillRect/>
+          </a:stretch>
+        </p:blipFill>
+        <p:spPr>
+          <a:xfrm>
+            <a:off x="2031752" y="1234440"/>
+            <a:ext cx="1391672" cy="2926080"/>
+          </a:xfrm>
+          <a:prstGeom prst="rect">
+            <a:avLst/>
+          </a:prstGeom>
+        </p:spPr>
+      </p:pic>
+      <p:sp>
+        <p:nvSpPr>
+          <p:cNvPr id="105" name="Text 105"/>
+          <p:cNvSpPr txBox="1"/>
+          <p:nvPr/>
+        </p:nvSpPr>
+        <p:spPr>
+          <a:xfrm>
+            <a:off x="1986032" y="4221480"/>
+            <a:ext cx="1483112" cy="457200"/>
+          </a:xfrm>
+          <a:prstGeom prst="rect">
+            <a:avLst/>
+          </a:prstGeom>
+          <a:noFill/>
+          <a:ln/>
+        </p:spPr>
+        <p:txBody>
+          <a:bodyPr wrap="square" lIns="0" tIns="0" rIns="0" bIns="0" rtlCol="0" anchor="t"/>
+          <a:lstStyle/>
+          <a:p>
+            <a:pPr marL="0" indent="0" algn="ctr">
+              <a:buNone/>
+            </a:pPr>
+            <a:r>
+              <a:rPr lang="de-DE" sz="1100" b="1" dirty="0">
+                <a:solidFill>
+                  <a:srgbClr val="0E5E5E"/>
+                </a:solidFill>
+                <a:latin typeface="Calibri" pitchFamily="34" charset="0"/>
+                <a:ea typeface="Calibri" pitchFamily="34" charset="-122"/>
+                <a:cs typeface="Calibri" pitchFamily="34" charset="-120"/>
+              </a:rPr>
+              <a:t>2  KI-Diagnose</a:t>
+            </a:r>
+            <a:endParaRPr lang="de-DE" sz="1100" dirty="0"/>
+          </a:p>
+          <a:p>
+            <a:pPr marL="0" indent="0" algn="ctr">
+              <a:buNone/>
+            </a:pPr>
+            <a:r>
+              <a:rPr lang="de-DE" sz="950" dirty="0">
+                <a:solidFill>
+                  <a:srgbClr val="1B2430"/>
+                </a:solidFill>
+                <a:latin typeface="Calibri" pitchFamily="34" charset="0"/>
+                <a:ea typeface="Calibri" pitchFamily="34" charset="-122"/>
+                <a:cs typeface="Calibri" pitchFamily="34" charset="-120"/>
+              </a:rPr>
+              <a:t>KIDiagnosevorschlag: Ursache, Teile, Konfidenz</a:t>
+            </a:r>
+            <a:endParaRPr lang="de-DE" sz="950" dirty="0"/>
+          </a:p>
+        </p:txBody>
+      </p:sp>
+      <p:pic>
+        <p:nvPicPr>
+          <p:cNvPr id="106" name="Image 106" descr="Kunden-App"/>
+          <p:cNvPicPr>
+            <a:picLocks noChangeAspect="1"/>
+          </p:cNvPicPr>
+          <p:nvPr/>
+        </p:nvPicPr>
+        <p:blipFill>
+          <a:blip r:embed="rId12"/>
+          <a:stretch>
+            <a:fillRect/>
+          </a:stretch>
+        </p:blipFill>
+        <p:spPr>
+          <a:xfrm>
+            <a:off x="3606304" y="1234440"/>
+            <a:ext cx="1391672" cy="2926080"/>
+          </a:xfrm>
+          <a:prstGeom prst="rect">
+            <a:avLst/>
+          </a:prstGeom>
+        </p:spPr>
+      </p:pic>
+      <p:sp>
+        <p:nvSpPr>
+          <p:cNvPr id="107" name="Text 107"/>
+          <p:cNvSpPr txBox="1"/>
+          <p:nvPr/>
+        </p:nvSpPr>
+        <p:spPr>
+          <a:xfrm>
+            <a:off x="3560584" y="4221480"/>
+            <a:ext cx="1483112" cy="457200"/>
+          </a:xfrm>
+          <a:prstGeom prst="rect">
+            <a:avLst/>
+          </a:prstGeom>
+          <a:noFill/>
+          <a:ln/>
+        </p:spPr>
+        <p:txBody>
+          <a:bodyPr wrap="square" lIns="0" tIns="0" rIns="0" bIns="0" rtlCol="0" anchor="t"/>
+          <a:lstStyle/>
+          <a:p>
+            <a:pPr marL="0" indent="0" algn="ctr">
+              <a:buNone/>
+            </a:pPr>
+            <a:r>
+              <a:rPr lang="de-DE" sz="1100" b="1" dirty="0">
+                <a:solidFill>
+                  <a:srgbClr val="0E5E5E"/>
+                </a:solidFill>
+                <a:latin typeface="Calibri" pitchFamily="34" charset="0"/>
+                <a:ea typeface="Calibri" pitchFamily="34" charset="-122"/>
+                <a:cs typeface="Calibri" pitchFamily="34" charset="-120"/>
+              </a:rPr>
+              <a:t>3  Bestätigung</a:t>
+            </a:r>
+            <a:endParaRPr lang="de-DE" sz="1100" dirty="0"/>
+          </a:p>
+          <a:p>
+            <a:pPr marL="0" indent="0" algn="ctr">
+              <a:buNone/>
+            </a:pPr>
+            <a:r>
+              <a:rPr lang="de-DE" sz="950" dirty="0">
+                <a:solidFill>
+                  <a:srgbClr val="1B2430"/>
+                </a:solidFill>
+                <a:latin typeface="Calibri" pitchFamily="34" charset="0"/>
+                <a:ea typeface="Calibri" pitchFamily="34" charset="-122"/>
+                <a:cs typeface="Calibri" pitchFamily="34" charset="-120"/>
+              </a:rPr>
+              <a:t>Voranmeldung, Termin, Teile vorreserviert</a:t>
+            </a:r>
+            <a:endParaRPr lang="de-DE" sz="950" dirty="0"/>
+          </a:p>
+        </p:txBody>
+      </p:sp>
+      <p:sp>
+        <p:nvSpPr>
+          <p:cNvPr id="108" name="Shape 108"/>
+          <p:cNvSpPr/>
+          <p:nvPr/>
+        </p:nvSpPr>
+        <p:spPr>
+          <a:xfrm>
+            <a:off x="5226576" y="1234440"/>
+            <a:ext cx="3460224" cy="2926080"/>
+          </a:xfrm>
+          <a:prstGeom prst="roundRect">
+            <a:avLst>
+              <a:gd name="adj" fmla="val 4706"/>
+            </a:avLst>
+          </a:prstGeom>
+          <a:solidFill>
+            <a:srgbClr val="EEF4F4"/>
+          </a:solidFill>
+          <a:ln w="12700">
+            <a:solidFill>
+              <a:srgbClr val="EEF4F4"/>
+            </a:solidFill>
+            <a:prstDash val="solid"/>
+          </a:ln>
+        </p:spPr>
+        <p:txBody>
+          <a:bodyPr/>
+          <a:lstStyle/>
+          <a:p>
+            <a:endParaRPr lang="de-DE"/>
+          </a:p>
+        </p:txBody>
+      </p:sp>
+      <p:sp>
+        <p:nvSpPr>
+          <p:cNvPr id="109" name="Text 109"/>
+          <p:cNvSpPr txBox="1"/>
+          <p:nvPr/>
+        </p:nvSpPr>
+        <p:spPr>
+          <a:xfrm>
+            <a:off x="5409456" y="1371600"/>
+            <a:ext cx="3094464" cy="320040"/>
+          </a:xfrm>
+          <a:prstGeom prst="rect">
+            <a:avLst/>
+          </a:prstGeom>
+          <a:noFill/>
+          <a:ln/>
+        </p:spPr>
+        <p:txBody>
+          <a:bodyPr wrap="square" lIns="0" tIns="0" rIns="0" bIns="0" rtlCol="0" anchor="ctr"/>
+          <a:lstStyle/>
+          <a:p>
+            <a:pPr marL="0" indent="0">
+              <a:buNone/>
+            </a:pPr>
+            <a:r>
+              <a:rPr lang="de-DE" sz="1300" b="1" dirty="0">
+                <a:solidFill>
+                  <a:srgbClr val="0E5E5E"/>
+                </a:solidFill>
+                <a:latin typeface="Calibri" pitchFamily="34" charset="0"/>
+                <a:ea typeface="Calibri" pitchFamily="34" charset="-122"/>
+                <a:cs typeface="Calibri" pitchFamily="34" charset="-120"/>
+              </a:rPr>
+              <a:t>Was die Demo zeigt</a:t>
+            </a:r>
+            <a:endParaRPr lang="de-DE" sz="1300" dirty="0"/>
+          </a:p>
+        </p:txBody>
+      </p:sp>
+      <p:sp>
+        <p:nvSpPr>
+          <p:cNvPr id="110" name="Text 110"/>
+          <p:cNvSpPr txBox="1"/>
+          <p:nvPr/>
+        </p:nvSpPr>
+        <p:spPr>
+          <a:xfrm>
+            <a:off x="5409456" y="1737360"/>
+            <a:ext cx="3094464" cy="2331720"/>
+          </a:xfrm>
+          <a:prstGeom prst="rect">
+            <a:avLst/>
+          </a:prstGeom>
+          <a:noFill/>
+          <a:ln/>
+        </p:spPr>
+        <p:txBody>
+          <a:bodyPr wrap="square" lIns="0" tIns="0" rIns="0" bIns="0" rtlCol="0" anchor="t"/>
+          <a:lstStyle/>
+          <a:p>
+            <a:pPr marL="228600" indent="-228600">
+              <a:spcAft>
+                <a:spcPts val="600"/>
+              </a:spcAft>
+              <a:buSzPct val="100000"/>
+              <a:buChar char="•"/>
+            </a:pPr>
+            <a:r>
+              <a:rPr lang="de-DE" sz="1050" dirty="0">
+                <a:solidFill>
+                  <a:srgbClr val="1B2430"/>
+                </a:solidFill>
+                <a:latin typeface="Calibri" pitchFamily="34" charset="0"/>
+                <a:ea typeface="Calibri" pitchFamily="34" charset="-122"/>
+                <a:cs typeface="Calibri" pitchFamily="34" charset="-120"/>
+              </a:rPr>
+              <a:t>Acht Schritte von der Geräteauswahl bis zum Auftragsstatus, Bedienung mit Weiter und Zurück.</a:t>
+            </a:r>
+            <a:endParaRPr lang="de-DE" sz="1050" dirty="0"/>
+          </a:p>
+          <a:p>
+            <a:pPr marL="228600" indent="-228600">
+              <a:spcAft>
+                <a:spcPts val="600"/>
+              </a:spcAft>
+              <a:buSzPct val="100000"/>
+              <a:buChar char="•"/>
+            </a:pPr>
+            <a:r>
+              <a:rPr lang="de-DE" sz="1050" dirty="0">
+                <a:solidFill>
+                  <a:srgbClr val="1B2430"/>
+                </a:solidFill>
+                <a:latin typeface="Calibri" pitchFamily="34" charset="0"/>
+                <a:ea typeface="Calibri" pitchFamily="34" charset="-122"/>
+                <a:cs typeface="Calibri" pitchFamily="34" charset="-120"/>
+              </a:rPr>
+              <a:t>Begriffe und Werte wie im Modell: Voranmeldung, KIDiagnosevorschlag, KVA-Status vorläufig, Reservierung vorreserviert.</a:t>
+            </a:r>
+            <a:endParaRPr lang="de-DE" sz="1050" dirty="0"/>
+          </a:p>
+          <a:p>
+            <a:pPr marL="228600" indent="-228600">
+              <a:spcAft>
+                <a:spcPts val="600"/>
+              </a:spcAft>
+              <a:buSzPct val="100000"/>
+              <a:buChar char="•"/>
+            </a:pPr>
+            <a:r>
+              <a:rPr lang="de-DE" sz="1050" dirty="0">
+                <a:solidFill>
+                  <a:srgbClr val="1B2430"/>
+                </a:solidFill>
+                <a:latin typeface="Calibri" pitchFamily="34" charset="0"/>
+                <a:ea typeface="Calibri" pitchFamily="34" charset="-122"/>
+                <a:cs typeface="Calibri" pitchFamily="34" charset="-120"/>
+              </a:rPr>
+              <a:t>Der Reparaturauftrag entsteht erst bei der Abgabe in der Filiale (Prozess 02), die App bestätigt nur die Voranmeldung.</a:t>
+            </a:r>
+            <a:endParaRPr lang="de-DE" sz="1050" dirty="0"/>
+          </a:p>
+          <a:p>
+            <a:pPr marL="228600" indent="-228600">
+              <a:spcAft>
+                <a:spcPts val="600"/>
+              </a:spcAft>
+              <a:buSzPct val="100000"/>
+              <a:buChar char="•"/>
+            </a:pPr>
+            <a:r>
+              <a:rPr lang="de-DE" sz="1050" dirty="0">
+                <a:solidFill>
+                  <a:srgbClr val="1B2430"/>
+                </a:solidFill>
+                <a:latin typeface="Calibri" pitchFamily="34" charset="0"/>
+                <a:ea typeface="Calibri" pitchFamily="34" charset="-122"/>
+                <a:cs typeface="Calibri" pitchFamily="34" charset="-120"/>
+              </a:rPr>
+              <a:t>Die KI-Antwort ist simuliert: keine echte Anbindung, damit die Demo zuverlässig läuft.</a:t>
+            </a:r>
+            <a:endParaRPr lang="de-DE" sz="1050" dirty="0"/>
+          </a:p>
+        </p:txBody>
+      </p:sp>
     </p:spTree>
   </p:cSld>
   <p:clrMapOvr>
@@ -11738,7 +12435,7 @@
                 <a:ea typeface="Calibri" pitchFamily="34" charset="-122"/>
                 <a:cs typeface="Calibri" pitchFamily="34" charset="-120"/>
               </a:rPr>
-              <a:t>RepairFlow: Lösung, Nutzen, Auftragsreise, KI-Sofortdiagnose</a:t>
+              <a:t>RepairFlow: Lösung, Nutzen, Auftragsreise, KI-Sofortdiagnose mit Live-Demo</a:t>
             </a:r>
             <a:endParaRPr lang="en-US" sz="1500" dirty="0"/>
           </a:p>
@@ -18272,7 +18969,7 @@
                 <a:ea typeface="Calibri" pitchFamily="34" charset="-122"/>
                 <a:cs typeface="Calibri" pitchFamily="34" charset="-120"/>
               </a:rPr>
-              <a:t>8</a:t>
+              <a:t>9</a:t>
             </a:r>
             <a:endParaRPr lang="en-US" sz="900" dirty="0"/>
           </a:p>
@@ -19306,7 +20003,7 @@
                 <a:ea typeface="Calibri" pitchFamily="34" charset="-122"/>
                 <a:cs typeface="Calibri" pitchFamily="34" charset="-120"/>
               </a:rPr>
-              <a:t>9</a:t>
+              <a:t>10</a:t>
             </a:r>
             <a:endParaRPr lang="en-US" sz="900" dirty="0"/>
           </a:p>

</xml_diff>

<commit_message>
[T05 2026-10-22] docs: Diagramme, Doku und Praesentation an UI-Umbau angepasst
- Klassendiagramm und sechs Sequenzdiagramme neu exportiert (Oberflaechenklassen, Objektsuche)
- Doku: Abbildungen 5-7 ersetzt, Tippfehler in 5.4, 5.5 und 7.1
- Praesentation: Zahlen 29 Klassen / 40 Assoziationen, Folie 13 Mandant und Oberflaechen, Anhang
- Sprechtexte nach Aufteilung der Agenda, Notizen und Word-Datei gleich
</commit_message>
<xml_diff>
--- a/4_praesentation/Abschlusspraesentation.pptx
+++ b/4_praesentation/Abschlusspraesentation.pptx
@@ -351,9 +351,13 @@
           <a:lstStyle/>
           <a:p>
             <a:r>
-              <a:rPr lang="en-US" dirty="0"/>
-              <a:t>Vortragende(r): Nina (30 s)
-Guten Morgen zusammen. Wir sind Gruppe 1 und stellen Ihnen RepairFlow vor: eine Plattform, mit der Reparaturwerkstätten ihre Aufträge, Ersatzteile und Kunden an einer Stelle steuern. Den Anfang macht David mit dem Problem, das wir lösen wollen. Danach zeigt Adrian die Lösung, Maximilian, Kilian und Jakob fassen zusammen, was wir dafür modelliert haben, und ich schließe mit Geschäftsmodell und Ausblick.</a:t>
+              <a:t>Vortragende(r): Nina (30 s)</a:t>
+            </a:r>
+          </a:p>
+          <a:p/>
+          <a:p>
+            <a:r>
+              <a:t>Guten Morgen zusammen. Wir sind Gruppe 1 und stellen Ihnen RepairFlow vor: eine Plattform, mit der Reparaturwerkstätten ihre Aufträge, Ersatzteile und Kunden an einer Stelle steuern. David beginnt mit dem Problem und unserer Lösung, Kilian und Maximilian zeigen, wie ein Auftrag durch RepairFlow läuft. Danach stellen Adrian, Kilian und Jakob vor, was wir dafür modelliert haben, und ich schließe mit Vorgehen, Geschäftsmodell und Ausblick.</a:t>
             </a:r>
           </a:p>
         </p:txBody>
@@ -439,9 +443,13 @@
           <a:lstStyle/>
           <a:p>
             <a:r>
-              <a:rPr lang="en-US" dirty="0"/>
-              <a:t>Vortragende(r): David (70 s)
-Das Use-Case-Diagramm beschreibt, was RepairFlow für seine Benutzer leistet. 19 Use Cases in vier Bereichen: das Kundenportal mit Sofortdiagnose, Voranmeldung und KVA-Freigabe; Auftrag und Werkstatt von der Annahme bis zur Reklamation; die Ersatzteil-Disposition von der Reservierung bis zur Retoure; und die Administration des Werkstattbetriebs. Eine Besonderheit geht auf das Coaching zurück: Jeder Use Case hat genau eine Rolle. Statt eines Technikers mit fünf Verbindungen gibt es jetzt Diagnoseprüfer, Diagnostiker, Kalkulator, Reparateur und Endkontrolleur. Welche Person welche Rolle ausfüllt, regelt die Werkstatt selbst; im Datenmodell sind die Rollen den Mitarbeitertypen zugeordnet. Das Diagramm ist dadurch sofort lesbar, und die Rollen tauchen in den Sequenzdiagrammen wieder auf. Dazu kommen der Kunde und zwei externe Akteure, der Lieferant und der KI-Diagnosedienst.</a:t>
+              <a:t>Vortragende(r): Kilian (70 s)</a:t>
+            </a:r>
+          </a:p>
+          <a:p/>
+          <a:p>
+            <a:r>
+              <a:t>Das Use-Case-Diagramm beschreibt, was RepairFlow für seine Benutzer leistet. 19 Use Cases in vier Bereichen: das Kundenportal mit Sofortdiagnose, Voranmeldung und KVA-Freigabe; Auftrag und Werkstatt von der Annahme bis zur Reklamation; die Ersatzteil-Disposition von der Reservierung bis zur Retoure; und die Administration des Werkstattbetriebs. Eine Besonderheit geht auf das Coaching zurück: Jeder Use Case hat genau eine Rolle. Statt eines Technikers mit fünf Verbindungen gibt es Diagnoseprüfer, Diagnostiker, Kalkulator, Reparateur und Endkontrolleur. Welche Person welche Rolle ausfüllt, regelt die Werkstatt selbst; im Datenmodell sind die Rollen den Mitarbeitertypen zugeordnet. Dazu kommen der Kunde und der KI-Diagnosedienst als externes System. Der Lieferant ist bewusst kein Akteur: Er hat keinen Zugang zu RepairFlow und bleibt eine Black Box.</a:t>
             </a:r>
           </a:p>
         </p:txBody>
@@ -527,9 +535,13 @@
           <a:lstStyle/>
           <a:p>
             <a:r>
-              <a:rPr lang="en-US" dirty="0"/>
-              <a:t>Vortragende(r): Kilian (80 s)
-Das Klassendiagramm ist ein einziges, vollständiges Modell mit 27 Klassen. Fünf Entscheidungen prägen es. Erstens: Der Reparaturauftrag ist die Aggregatwurzel. Befund und Reparaturschritte existieren nur mit ihrem Auftrag und sind deshalb Kompositionen, Kostenvoranschlag und Gerät sind nur zugeordnet, weil der Vorab-KVA schon vor dem Auftrag entsteht. Zweitens: Der Lagerbestand ist eine eigene Klasse zwischen Ersatzteil und Filiale. Nur so lässt sich die Verfügbarkeit über alle Filialen prüfen. Drittens: Die Reservierung ist eine eigene Klasse mit Lebenszyklus, vorreserviert, reserviert, entnommen, storniert. Viertens: Der Werkstattbetrieb ist der Mandant, und die Mitarbeiter sind nach Typ spezialisiert, Servicemitarbeiter, Techniker, Disponent und Werkstattleiter, passend zu den Lanes in BPMN und zu den Rollen im Use-Case-Diagramm. Fünftens: Voranmeldung, Medienanhang und KI-Diagnosevorschlag tragen die Sofortdiagnose. Die sechs Sequenzdiagramme verwenden ausschließlich Operationen dieser Klassen; jede Botschaft an ein Objekt ist eine Operation des Klassendiagramms.</a:t>
+              <a:t>Vortragende(r): Kilian (100 s)</a:t>
+            </a:r>
+          </a:p>
+          <a:p/>
+          <a:p>
+            <a:r>
+              <a:t>Das Klassendiagramm ist ein einziges, vollständiges Modell mit 29 Klassen. Fünf Entscheidungen prägen es. Erstens: Der Reparaturauftrag ist die Aggregatwurzel. Befund und Reparaturschritte sind Kompositionen, Kostenvoranschlag und Gerät nur zugeordnet, weil der Vorab-KVA schon vor dem Auftrag entsteht. Zweitens: Der Lagerbestand ist eine eigene Klasse zwischen Ersatzteil und Filiale; nur so lässt sich die Verfügbarkeit über alle Filialen prüfen. Drittens: Die Reservierung ist eine eigene Klasse mit Lebenszyklus. Viertens: Der Werkstattbetrieb ist Mandant und Sammelstelle. Er kennt alle Aufträge, Bestellungen und Reklamationen und findet sie über ihre Nummer. Die Mitarbeiter sind nach Typ spezialisiert, passend zu Lanes und Rollen, und arbeiten wie der Kunde nie direkt mit den Fachobjekten, sondern über zwei Oberflächenklassen, die Werkstattoberfläche und die KundenApp. Fünftens: Voranmeldung, Medienanhang und KI-Diagnosevorschlag tragen die Sofortdiagnose. Ein Beispiel aus den Sequenzdiagrammen ist SD4, die Fertigmeldung: Der Endkontrolleur gibt die Auftragsnummer ein, die Werkstattoberfläche sucht den Auftrag und arbeitet mit diesem Objekt; nach jeder Nacharbeit sucht sie ihn neu. Besteht er auch nach der zweiten Nacharbeit die Endkontrolle nicht, ruft sie wechsleStatus mit dem Wert ABGELEHNT auf, genau die Operation, die der Reparaturauftrag im Klassendiagramm anbietet.</a:t>
             </a:r>
           </a:p>
         </p:txBody>
@@ -615,9 +627,13 @@
           <a:lstStyle/>
           <a:p>
             <a:r>
-              <a:rPr lang="en-US" dirty="0"/>
-              <a:t>Vortragende(r): Jakob (70 s)
-Drei Modelle, die sich auf dieselben Dinge beziehen, laufen schnell auseinander. Dagegen hatten wir drei Mittel. Erstens Konventionen: Datenobjekte in BPMN tragen die Klassennamen, Aktivitäten heißen Verb plus Objekt, jede Rolle ist genau einer Lane und einer Klasse zugeordnet, und die Statuswerte sind in allen Modellen identisch. Zweitens Werkzeuge: Die BPMN-Dateien sind für Camunda 8 angereichert, mit Task-Definitionen, Timern und Bedingungen. Der Camunda-Linter und bpmnlint melden null Befunde. Drittens Prüfrunden: Eine Gesamtprüfung am 26.09., ein Komplettcheck am 05.10. mit 39 Befunden und der QA-Abgleich am 08.10. Jede Änderung wird gegen unsere QA-Checkliste geprüft, bevor sie gemergt wird. Ein Beispiel: Als wir die Nacharbeit in Prozess 07 auf zwei Durchläufe begrenzt haben, musste das Sequenzdiagramm SD4 nachziehen. Genau solche Stellen findet die Checkliste.</a:t>
+              <a:t>Vortragende(r): Jakob (65 s)</a:t>
+            </a:r>
+          </a:p>
+          <a:p/>
+          <a:p>
+            <a:r>
+              <a:t>Drei Modelle, die sich auf dieselben Dinge beziehen, laufen schnell auseinander. Dagegen hatten wir drei Mittel. Erstens Konventionen: Datenobjekte in BPMN tragen die Klassennamen, Aktivitäten heißen Verb plus Objekt, jede Rolle ist genau einer Lane und einer Klasse zugeordnet, die Statuswerte sind in allen Modellen identisch, und in jedem Sequenzdiagramm geht der Weg vom Akteur über die Oberfläche zum Objekt. Zweitens Werkzeuge: Die BPMN-Dateien sind für Camunda 8 angereichert, mit Task-Definitionen, Timern und Bedingungen; der Camunda-Linter und bpmnlint melden null Befunde. Drittens Prüfrunden: Jedes Diagramm wurde im Zweierteam geprüft, und jede Änderung wird gegen unsere QA-Checkliste geprüft, bevor sie gemergt wird. Ein Beispiel: Als wir die Nacharbeit in Prozess 07 auf zwei Durchläufe begrenzt haben, musste das Sequenzdiagramm SD4 nachziehen. Genau solche Stellen findet die Checkliste.</a:t>
             </a:r>
           </a:p>
         </p:txBody>
@@ -703,9 +719,13 @@
           <a:lstStyle/>
           <a:p>
             <a:r>
-              <a:rPr lang="en-US" dirty="0"/>
-              <a:t>Vortragende(r): Jakob (70 s)
-Vier Dinge haben uns am meisten beschäftigt. Die Perspektive: Werkstatt oder Softwareanbieter? Die Rückfrage des Dozenten hat uns zur klaren Entscheidung gezwungen, und danach mussten Texte und Klassenmodell nachziehen. Das Vokabular: Datenobjekte, Klassen, Lebenslinien und Statuswerte müssen wortgleich sein, sonst zerfällt die Analyse in drei Einzelmodelle. Die Werkzeuge: Der Camunda Modeler meldet für Camunda 8 fehlende technische Details als Fehler, und wir haben die Diagramme so lange angereichert, bis nichts mehr rot war. Und die Vision: Die KI-Sofortdiagnose soll beeindrucken, aber glaubwürdig bleiben, deshalb die Trennung in heute machbar und Vision. Gelernt haben wir, dass Konsistenz keine Prüfung am Ende ist, sondern eine Regel bei jeder Änderung. Und dass ein klarer Hinweis von außen, wie der zum Use-Case-Diagramm, ein Modell deutlich besser machen kann.</a:t>
+              <a:t>Vortragende(r): Jakob (65 s)</a:t>
+            </a:r>
+          </a:p>
+          <a:p/>
+          <a:p>
+            <a:r>
+              <a:t>Vier Dinge haben uns am meisten beschäftigt. Die Perspektive: Werkstatt oder Softwareanbieter? Die Rückfrage des Dozenten hat uns zur klaren Entscheidung gezwungen, und danach mussten Texte und Klassenmodell nachziehen. Das Vokabular: Datenobjekte, Klassen, Lebenslinien und Statuswerte müssen wortgleich sein, sonst zerfällt die Analyse in drei Einzelmodelle. Die Werkzeuge: Der Camunda Modeler meldet für Camunda 8 fehlende technische Details als Fehler, und wir haben die Diagramme so lange angereichert, bis nichts mehr rot war. Und die Vision: Die KI-Sofortdiagnose soll beeindrucken, aber glaubwürdig bleiben. Gelernt haben wir, dass Konsistenz keine Prüfung am Ende ist, sondern eine Regel bei jeder Änderung, und dass klare Hinweise von außen, etwa zum Use-Case-Diagramm und zu den Oberflächen in den Sequenzdiagrammen, ein Modell deutlich besser machen. Wie wir zusammengearbeitet haben, zeigt Nina.</a:t>
             </a:r>
           </a:p>
         </p:txBody>
@@ -791,9 +811,13 @@
           <a:lstStyle/>
           <a:p>
             <a:r>
-              <a:rPr lang="en-US" dirty="0"/>
-              <a:t>Vortragende(r): Kilian (70 s)
-Gearbeitet haben wir in Sprints, die sich am Takt der vier Gruppentermine orientiert haben, mit Review, Retrospektive und Planning je Termin. Nina hat die Projektleitung, David die Stellvertretung und die Sicherungen, Adrian ist Product Owner, ich Scrum Master, Maximilian verantwortet BPMN, Jakob die Qualität. Alles Schriftliche liegt in einem GitHub-Repository; jede Änderung geht über einen eigenen Branch, einen Pull Request und ein Review durch eine zweite Person, bisher zehn gemergte Pull Requests. Das Trello-Board hat eine Liste je Termin und eine Karte je Person und Aufgabe. Jedes Diagramm wurde im Zweierteam geprüft. Die Meilensteine: Am 02.09. standen alle Diagramme im Entwurf, am 05.10. die Korrekturen aus zwei Gesamtprüfungen, am 15.10. haben wir die Rollenstruktur umgesetzt, am 22.10. war die Generalprobe. Die Abgabe folgt am 13.11.</a:t>
+              <a:t>Vortragende(r): Nina (65 s)</a:t>
+            </a:r>
+          </a:p>
+          <a:p/>
+          <a:p>
+            <a:r>
+              <a:t>Gearbeitet haben wir in Sprints im Takt der vier Gruppentermine, mit Review, Retrospektive und Planning je Termin. Ich habe die Projektleitung, David die Stellvertretung und die Sicherungen, Adrian ist Product Owner, Kilian Scrum Master, Maximilian verantwortet BPMN, Jakob die Qualität. Alles Schriftliche liegt in einem GitHub-Repository; jede Änderung geht über einen eigenen Branch, einen Pull Request und ein Review durch eine zweite Person. Das Trello-Board hat eine Liste je Termin und eine Karte je Person und Aufgabe. Jedes Diagramm ist denselben Weg gegangen: Entwurf im Zweierteam, gegenseitiges Review, Abstimmung im Gruppentermin und erst dann die Umsetzung über einen Pull Request. Entscheidungen, die mehrere betreffen, stehen mit Begründung und Datum im Entscheidungslog; so konnten wir bei jeder Korrektur nachvollziehen, warum ein Modell so aussieht.</a:t>
             </a:r>
           </a:p>
         </p:txBody>
@@ -879,9 +903,13 @@
           <a:lstStyle/>
           <a:p>
             <a:r>
-              <a:rPr lang="en-US" dirty="0"/>
-              <a:t>Vortragende(r): Nina (70 s)
-Zum Schluss der Blick nach vorn. RepairFlow wird als Abo je Filiale angeboten, in zwei Stufen: Basis mit Auftrags- und Kundenverwaltung, Pro mit filialübergreifender Disposition und KI-Sofortdiagnose. Zielkunden sind unabhängige Werkstätten und kleine Ketten mit zwei bis zehn Filialen im deutschsprachigen Raum. Das sind Betriebe, die heute genau die vier Probleme vom Anfang haben und für die ein großes Werkstattsystem zu schwer ist. Der Ausblick geht in drei Richtungen: Predictive Disposition, also eine Bedarfsprognose je Filiale und Saison, damit Teile vor der Nachfrage im Lager liegen. Ein Techniker-Copilot, der Reparaturschritte aus der Historie vorschlägt. Und eine digitale Geräteakte, in der jedes Gerät seine Reparaturgeschichte behält. Nichts davon ist modelliert, aber alles baut auf dem Datenmodell auf, das wir heute vorgestellt haben.</a:t>
+              <a:t>Vortragende(r): Nina (60 s)</a:t>
+            </a:r>
+          </a:p>
+          <a:p/>
+          <a:p>
+            <a:r>
+              <a:t>Zum Schluss der Blick nach vorn. RepairFlow wird als Abo je Filiale angeboten, in zwei Stufen: Basis mit Auftrags- und Kundenverwaltung, Pro mit filialübergreifender Disposition und KI-Sofortdiagnose. Zielkunden sind unabhängige Werkstätten und kleine Ketten mit zwei bis zehn Filialen im deutschsprachigen Raum, also genau die Betriebe mit den vier Problemen vom Anfang. Der Ausblick geht in drei Richtungen: Predictive Disposition, also eine Bedarfsprognose je Filiale und Saison. Ein Techniker-Copilot, der Reparaturschritte aus der Historie vorschlägt. Und eine digitale Geräteakte, in der jedes Gerät seine Reparaturgeschichte behält. Nichts davon ist modelliert, aber alles baut auf dem Datenmodell auf, das wir heute vorgestellt haben.</a:t>
             </a:r>
           </a:p>
         </p:txBody>
@@ -967,9 +995,13 @@
           <a:lstStyle/>
           <a:p>
             <a:r>
-              <a:rPr lang="en-US" dirty="0"/>
-              <a:t>Vortragende(r): Nina (30 s)
-RepairFlow löst den Medienbruch aus Papier, Excel und Telefon und macht den Reparaturauftrag zum zentralen Zustandsautomaten. Der fachliche Mehrwert liegt in der filialübergreifenden Disposition und in der KI-Sofortdiagnose, die dem Kunden Klarheit gibt, bevor er die Werkstatt betritt. Vielen Dank für Ihre Aufmerksamkeit. Wir freuen uns auf Ihre Fragen.</a:t>
+              <a:t>Vortragende(r): Nina (30 s)</a:t>
+            </a:r>
+          </a:p>
+          <a:p/>
+          <a:p>
+            <a:r>
+              <a:t>RepairFlow löst den Medienbruch aus Papier, Excel und Telefon und macht den Reparaturauftrag zum zentralen Zustandsautomaten. Der fachliche Mehrwert liegt in der filialübergreifenden Disposition und in der KI-Sofortdiagnose, die dem Kunden Klarheit gibt, bevor er die Werkstatt betritt. Vielen Dank für Ihre Aufmerksamkeit. Wir freuen uns auf Ihre Fragen.</a:t>
             </a:r>
           </a:p>
         </p:txBody>
@@ -1098,6 +1130,110 @@
 </p:notes>
 </file>
 
+<file path=ppt/notesSlides/notesSlide18.xml><?xml version="1.0" encoding="utf-8"?>
+<p:notes xmlns:a="http://schemas.openxmlformats.org/drawingml/2006/main" xmlns:p="http://schemas.openxmlformats.org/presentationml/2006/main" xmlns:r="http://schemas.openxmlformats.org/officeDocument/2006/relationships">
+  <p:cSld>
+    <p:spTree>
+      <p:nvGrpSpPr>
+        <p:cNvPr id="1" name=""/>
+        <p:cNvGrpSpPr/>
+        <p:nvPr/>
+      </p:nvGrpSpPr>
+      <p:grpSpPr>
+        <a:xfrm>
+          <a:off x="0" y="0"/>
+          <a:ext cx="0" cy="0"/>
+          <a:chOff x="0" y="0"/>
+          <a:chExt cx="0" cy="0"/>
+        </a:xfrm>
+      </p:grpSpPr>
+      <p:sp>
+        <p:nvSpPr>
+          <p:cNvPr id="3" name="Notes Placeholder 2"/>
+          <p:cNvSpPr>
+            <a:spLocks noGrp="1"/>
+          </p:cNvSpPr>
+          <p:nvPr>
+            <p:ph type="body" idx="1"/>
+          </p:nvPr>
+        </p:nvSpPr>
+        <p:spPr/>
+        <p:txBody>
+          <a:bodyPr/>
+          <a:lstStyle/>
+          <a:p>
+            <a:r>
+              <a:t>Vortragende(r): David (55 s)</a:t>
+            </a:r>
+          </a:p>
+          <a:p/>
+          <a:p>
+            <a:r>
+              <a:t>Was hat die Werkstatt davon? Drei Dinge. Erstens: eine Plattform für alle drei Gerätearten, mit einer Kundenbasis und einem gemeinsamen Ersatzteillager. Zweitens: filialübergreifende Disposition. RepairFlow kennt die Bestände aller Standorte, reserviert dort, wo das Teil liegt, und bestellt nur, was nirgends vorhanden ist. Drittens: Der Kunde bekommt Klarheit, bevor er die Werkstatt betritt, mit Diagnosevorschlag, vorläufigem Kostenvoranschlag und Termin. Für die Werkstatt heißt das weniger Telefon, weniger Standzeit im Lager und eine Auslastung, die sie wirklich sieht. Wie das für einen einzelnen Auftrag aussieht, zeigt Kilian.</a:t>
+            </a:r>
+          </a:p>
+        </p:txBody>
+      </p:sp>
+    </p:spTree>
+  </p:cSld>
+  <p:clrMapOvr>
+    <a:masterClrMapping/>
+  </p:clrMapOvr>
+</p:notes>
+</file>
+
+<file path=ppt/notesSlides/notesSlide19.xml><?xml version="1.0" encoding="utf-8"?>
+<p:notes xmlns:a="http://schemas.openxmlformats.org/drawingml/2006/main" xmlns:p="http://schemas.openxmlformats.org/presentationml/2006/main" xmlns:r="http://schemas.openxmlformats.org/officeDocument/2006/relationships">
+  <p:cSld>
+    <p:spTree>
+      <p:nvGrpSpPr>
+        <p:cNvPr id="1" name=""/>
+        <p:cNvGrpSpPr/>
+        <p:nvPr/>
+      </p:nvGrpSpPr>
+      <p:grpSpPr>
+        <a:xfrm>
+          <a:off x="0" y="0"/>
+          <a:ext cx="0" cy="0"/>
+          <a:chOff x="0" y="0"/>
+          <a:chExt cx="0" cy="0"/>
+        </a:xfrm>
+      </p:grpSpPr>
+      <p:sp>
+        <p:nvSpPr>
+          <p:cNvPr id="3" name="Notes Placeholder 2"/>
+          <p:cNvSpPr>
+            <a:spLocks noGrp="1"/>
+          </p:cNvSpPr>
+          <p:nvPr>
+            <p:ph type="body" idx="1"/>
+          </p:nvPr>
+        </p:nvSpPr>
+        <p:spPr/>
+        <p:txBody>
+          <a:bodyPr/>
+          <a:lstStyle/>
+          <a:p>
+            <a:r>
+              <a:t>Vortragende(r): Maximilian (70 s)</a:t>
+            </a:r>
+          </a:p>
+          <a:p/>
+          <a:p>
+            <a:r>
+              <a:t>Wir starten mit der Sofortdiagnose aus Kundensicht. Der Kunde wählt sein Gerät, beschreibt das Problem und lädt ein Foto hoch; im Modell ist das die Voranmeldung mit dem Medienanhang. Der KI-Dienst antwortet mit Ursache, benötigten Teilen und einer Konfidenz, das ist der KIDiagnosevorschlag. RepairFlow rechnet daraus das Angebot, deutlich als vorläufig markiert, und schlägt Filiale und Termin vor. Bestätigt der Kunde, sind die Teile vorreserviert und die Voranmeldung steht. Der eigentliche Reparaturauftrag entsteht erst, wenn das Gerät in der Filiale abgegeben wird. Zum Schluss sieht der Kunde den Status seines Auftrags entlang derselben Zustände, die Kilian in der Auftragsreise gezeigt hat. Die KI-Antwort ist in der Demo simuliert; Ablauf und Begriffe sind genau die aus unseren Modellen.</a:t>
+            </a:r>
+          </a:p>
+        </p:txBody>
+      </p:sp>
+    </p:spTree>
+  </p:cSld>
+  <p:clrMapOvr>
+    <a:masterClrMapping/>
+  </p:clrMapOvr>
+</p:notes>
+</file>
+
 <file path=ppt/notesSlides/notesSlide2.xml><?xml version="1.0" encoding="utf-8"?>
 <p:notes xmlns:a="http://schemas.openxmlformats.org/drawingml/2006/main" xmlns:r="http://schemas.openxmlformats.org/officeDocument/2006/relationships" xmlns:p="http://schemas.openxmlformats.org/presentationml/2006/main">
   <p:cSld>
@@ -1143,9 +1279,13 @@
           <a:lstStyle/>
           <a:p>
             <a:r>
-              <a:rPr lang="de-DE" dirty="0"/>
-              <a:t>Vortragende(r): Nina (40 s)
-Unsere Präsentation hat zwei Hälften. In der ersten erzählen wir RepairFlow so, wie wir es einer Werkstatt vorstellen würden: Problem, Lösung, Nutzen, die Reparatur aus Kundensicht und unser Alleinstellungsmerkmal, die KI-Sofortdiagnose, mit einer kurzen Demo der Kunden-App. In der zweiten Hälfte zeigen wir, was dahintersteckt: zehn Geschäftsprozesse, Rollen und Use Cases, das Datenmodell, unser Vorgehen und die Qualitätssicherung. Die Diagramme selbst finden Sie in der Projektdokumentation und im Abgabepaket; hier konzentrieren wir uns auf die Ergebnisse. Fragen gern am Ende.</a:t>
+              <a:t>Vortragende(r): Nina (40 s)</a:t>
+            </a:r>
+          </a:p>
+          <a:p/>
+          <a:p>
+            <a:r>
+              <a:t>Unsere Präsentation hat zwei Hälften. In der ersten erzählen wir RepairFlow so, wie wir es einer Werkstatt vorstellen würden: Problem, Lösung, Nutzen, die Reparatur aus Kundensicht mit drei Prozess-Highlights und unser Alleinstellungsmerkmal, die KI-Sofortdiagnose, mit einer kurzen Demo der Kunden-App. In der zweiten Hälfte zeigen wir, was dahintersteckt: zehn Geschäftsprozesse, Rollen und Use Cases, das Datenmodell, die Qualitätssicherung und unser Vorgehen. Die Diagramme selbst finden Sie in der Projektdokumentation und im Abgabepaket; hier konzentrieren wir uns auf die Ergebnisse. Fragen gern am Ende.</a:t>
             </a:r>
           </a:p>
         </p:txBody>
@@ -1231,9 +1371,13 @@
           <a:lstStyle/>
           <a:p>
             <a:r>
-              <a:rPr lang="en-US" dirty="0"/>
-              <a:t>Vortragende(r): David (75 s)
-Stellen Sie sich eine Werkstattkette mit vier Filialen vor, die Fahrräder, E-Bikes und Elektronik repariert. In unserem Szenario heißt sie FixWerk. Der Alltag dort läuft über Papierzettel, Excel-Listen und Telefon. Das führt zu vier Problemen. Erstens: Der Kunde gibt sein Gerät ab und hört dann nichts mehr. Ob der Kostenvoranschlag freizugeben ist oder das Gerät fertig ist, erfährt er, wenn er anruft. Zweitens: Niemand weiß ohne Nachfrage, wo ein Auftrag gerade steht, weil Zettel und Listen auseinanderlaufen. Drittens: Jede Filiale bestellt Ersatzteile für sich, obwohl das Teil oft in der Nachbarfiliale liegt. Viertens: Termine werden nach Gefühl zugesagt, weil die Auslastung der Techniker nicht sichtbar ist. Die vier Punkte sind Annahmen unseres Szenarios, aber jeder, der schon einmal ein Gerät zur Reparatur gebracht hat, kennt mindestens eines davon.</a:t>
+              <a:t>Vortragende(r): David (75 s)</a:t>
+            </a:r>
+          </a:p>
+          <a:p/>
+          <a:p>
+            <a:r>
+              <a:t>Stellen Sie sich eine Werkstattkette mit vier Filialen vor, die Fahrräder, E-Bikes und Elektronik repariert. In unserem Szenario heißt sie FixWerk. Der Alltag dort läuft über Papierzettel, Excel-Listen und Telefon. Das führt zu vier Problemen. Erstens: Der Kunde gibt sein Gerät ab und hört dann nichts mehr. Ob der Kostenvoranschlag freizugeben ist oder das Gerät fertig ist, erfährt er, wenn er anruft. Zweitens: Niemand weiß ohne Nachfrage, wo ein Auftrag gerade steht, weil Zettel und Listen auseinanderlaufen. Drittens: Jede Filiale bestellt Ersatzteile für sich, obwohl das Teil oft in der Nachbarfiliale liegt. Viertens: Termine werden nach Gefühl zugesagt, weil die Auslastung der Techniker nicht sichtbar ist. Die vier Punkte sind Annahmen unseres Szenarios, aber jeder, der schon einmal ein Gerät zur Reparatur gebracht hat, kennt mindestens eines davon.</a:t>
             </a:r>
           </a:p>
         </p:txBody>
@@ -1319,9 +1463,13 @@
           <a:lstStyle/>
           <a:p>
             <a:r>
-              <a:rPr lang="en-US" dirty="0"/>
-              <a:t>Vortragende(r): Adrian (70 s)
-RepairFlow ist unsere Antwort darauf. Wichtig für die Einordnung: Wir sind nicht die Werkstatt, wir sind das Software-Startup. FixWerk ist unser Pilotkunde, an dessen Abläufen wir die Plattform entworfen haben. Diese Perspektive haben wir nach der Rückfrage des Dozenten bei der Konzeptvorstellung bewusst festgelegt. RepairFlow ist eine Cloud-Plattform, die den ganzen Reparatur-Lebenszyklus abdeckt, von der ersten Anfrage bis zur Abholung und Reklamation. Sie besteht aus vier Modulen: dem Kundenportal mit App, dem Auftrags- und Werkstattmodul, dem Dispositionsmodul für Ersatzteile und der Abrechnung. Zielkunden sind unabhängige Werkstätten und kleine Ketten mit zwei bis zehn Filialen. Außerhalb der Plattform bleiben die physische Reparatur, die Systeme der Lieferanten und die Buchhaltung; dorthin gibt es Schnittstellen, mehr nicht.</a:t>
+              <a:t>Vortragende(r): David (65 s)</a:t>
+            </a:r>
+          </a:p>
+          <a:p/>
+          <a:p>
+            <a:r>
+              <a:t>RepairFlow ist unsere Antwort darauf. Wichtig für die Einordnung: Wir sind nicht die Werkstatt, wir sind das Software-Startup. FixWerk ist unser Pilotkunde, an dessen Abläufen wir die Plattform entworfen haben. RepairFlow ist eine Cloud-Plattform, die den ganzen Reparatur-Lebenszyklus abdeckt, von der ersten Anfrage bis zur Abholung und Reklamation. Sie besteht aus vier Modulen: dem Kundenportal mit App, dem Auftrags- und Werkstattmodul, dem Dispositionsmodul für Ersatzteile und der Abrechnung. Zielkunden sind unabhängige Werkstätten und kleine Ketten mit zwei bis zehn Filialen. Die physische Reparatur, die Lieferantensysteme und die Buchhaltung bleiben außerhalb; dorthin gibt es nur Schnittstellen.</a:t>
             </a:r>
           </a:p>
         </p:txBody>
@@ -1425,9 +1573,13 @@
           <a:lstStyle/>
           <a:p>
             <a:r>
-              <a:rPr lang="en-US" dirty="0"/>
-              <a:t>Vortragende(r): David (75 s)
-So sieht eine Reparatur mit RepairFlow aus. Der Kunde schickt per App ein Foto oder Video und bekommt innerhalb einer Minute Vorschlag, vorläufigen Kostenvoranschlag und Terminvorschlag. Bestätigt er, sind die Teile schon vorreserviert. In der Filiale wird das Gerät registriert und der Auftrag angelegt. Der Techniker prüft den Vorschlag, stellt die Diagnose und erstellt den Kostenvoranschlag, den der Kunde wieder in der App freigibt. Dann disponiert RepairFlow die Teile über alle Filialen und bestellt Fehlteile beim Lieferanten. Nach der Reparatur folgt die Endkontrolle, der Kunde wird benachrichtigt, holt ab und zahlt. Jeder dieser Schritte ist ein Status des Reparaturauftrags: angenommen, in Diagnose, KVA offen, freigegeben, Teile bestellt, in Reparatur, fertig, abgeholt. Dieser Zustandsautomat ist der rote Faden durch alle unsere Modelle. Und falls doch etwas nicht passt: Die Reklamation startet einen eigenen Prozess, im Gewährleistungsfall kostenfrei.</a:t>
+              <a:t>Vortragende(r): Kilian (65 s)</a:t>
+            </a:r>
+          </a:p>
+          <a:p/>
+          <a:p>
+            <a:r>
+              <a:t>So sieht eine Reparatur mit RepairFlow aus. Der Kunde schickt per App ein Foto oder Video und bekommt innerhalb einer Minute Vorschlag, vorläufigen Kostenvoranschlag und Terminvorschlag. In der Filiale wird das Gerät registriert und der Auftrag angelegt. Der Techniker prüft den Vorschlag, stellt die Diagnose und erstellt den Kostenvoranschlag, den der Kunde in der App freigibt. Dann disponiert RepairFlow die Teile über alle Filialen und bestellt Fehlteile beim Lieferanten. Nach der Reparatur folgt die Endkontrolle, der Kunde wird benachrichtigt, holt ab und zahlt. Jeder dieser Schritte ist ein Status des Reparaturauftrags: angenommen, in Diagnose, KVA offen, freigegeben, Teile bestellt, in Reparatur, fertig, abgeholt. Dieser Zustandsautomat ist der rote Faden durch alle unsere Modelle. Welche Abläufe dahinterstecken, zeigt Maximilian an drei Beispielen.</a:t>
             </a:r>
           </a:p>
         </p:txBody>
@@ -1519,9 +1671,13 @@
           <a:lstStyle/>
           <a:p>
             <a:r>
-              <a:rPr lang="en-US" dirty="0"/>
-              <a:t>Vortragende(r): Maximilian (80 s)
-Drei Stellen zeigen, was die Prozesse leisten. Erstens der Kostenvoranschlag in Prozess 04: Nach dem Versand wartet ein ereignisbasiertes Gateway auf Freigabe, Ablehnung oder den Ablauf von drei Tagen. Bei Fristablauf erinnert RepairFlow den Kunden, höchstens zweimal. Nach dem dritten Fristablauf ohne Antwort gilt der KVA als abgelehnt und das Gerät geht mit Diagnosepauschale zur Abholung. Kein Auftrag bleibt liegen. Zweitens die Disposition in Prozess 05: Für jedes benötigte Teil läuft parallel eine Prüfung, erst im eigenen Lager, dann in den anderen Filialen. Was lokal liegt, wird reserviert, was anderswo liegt, umgelagert, und nur Fehlteile werden bestellt. Drittens die Reklamation in Prozess 09: Der Techniker prüft den Mangel, RepairFlow entscheidet nach Regel über Gewährleistung, und im Gewährleistungsfall entsteht ein kostenfreier Nacharbeitsauftrag, der wieder durch die normale Auftragsreise läuft. So bleibt das Modell schlank, weil die Reklamation keine eigene Reparaturlogik braucht.</a:t>
+              <a:t>Vortragende(r): Maximilian (80 s)</a:t>
+            </a:r>
+          </a:p>
+          <a:p/>
+          <a:p>
+            <a:r>
+              <a:t>Hinter jedem dieser Schritte steht ein Geschäftsprozess. Drei Stellen zeigen, was die Prozesse leisten. Erstens der Kostenvoranschlag in Prozess 04: Nach dem Versand wartet ein ereignisbasiertes Gateway auf Freigabe, Ablehnung oder den Ablauf von drei Tagen. Bei Fristablauf erinnert RepairFlow den Kunden, höchstens zweimal. Nach dem dritten Fristablauf ohne Antwort gilt der KVA als abgelehnt und das Gerät geht mit Diagnosepauschale zur Abholung. Kein Auftrag bleibt liegen. Zweitens die Disposition in Prozess 05: Für jedes benötigte Teil läuft parallel eine Prüfung, erst im eigenen Lager, dann in den anderen Filialen. Was lokal liegt, wird reserviert, was anderswo liegt, umgelagert, und nur Fehlteile werden bestellt. Drittens die Reklamation in Prozess 09: Der Techniker prüft den Mangel, RepairFlow entscheidet nach Regel über Gewährleistung, und im Gewährleistungsfall entsteht ein kostenfreier Nacharbeitsauftrag, der wieder durch die normale Auftragsreise läuft. Wie sich das für den Kunden anfühlt, zeige ich Ihnen jetzt in der App.</a:t>
             </a:r>
           </a:p>
         </p:txBody>
@@ -1607,9 +1763,13 @@
           <a:lstStyle/>
           <a:p>
             <a:r>
-              <a:rPr lang="en-US" dirty="0"/>
-              <a:t>Vortragende(r): Adrian (80 s)
-Unser Alleinstellungsmerkmal ist die KI-Sofortdiagnose, die Sie gerade in der Auftragsreise gesehen haben. Fünf Schritte: Der Kunde nimmt Foto, Video oder Ton auf. Ein KI-Dienst erkennt Gerätetyp, wahrscheinliche Ursache und benötigte Teile. RepairFlow rechnet daraus einen vorläufigen Kostenvoranschlag, prüft die Verfügbarkeit in allen Filialen und reserviert vor. Zum Schluss schlägt es Filiale und Termin vor, und der Kunde bestätigt. Uns war wichtig, das glaubwürdig zu halten. Heute machbar ist die Erkennung sichtbarer Schäden per Bildanalyse, etwa ein gebrochenes Display oder eine gerissene Kette, dazu ein Vorab-KVA aus Teilepreisen und Aufwandsrichtwerten. Vision sind Geräuschanalyse bei E-Bike-Motoren und eine Aufwandsschätzung aus Video. Deshalb bleibt der Vorschlag immer vorläufig: Der Techniker bestätigt oder korrigiert ihn, und erst dann wird daraus ein verbindlicher Kostenvoranschlag. Die Medien werden nur mit Einwilligung verarbeitet und nach Abschluss gelöscht.</a:t>
+              <a:t>Vortragende(r): Maximilian (70 s)</a:t>
+            </a:r>
+          </a:p>
+          <a:p/>
+          <a:p>
+            <a:r>
+              <a:t>Was Sie gerade in der App gesehen haben, ist unser Alleinstellungsmerkmal, die KI-Sofortdiagnose. Fünf Schritte: Der Kunde nimmt Foto, Video oder Ton auf. Ein KI-Dienst erkennt Gerätetyp, wahrscheinliche Ursache und benötigte Teile. RepairFlow rechnet daraus einen vorläufigen Kostenvoranschlag, prüft die Verfügbarkeit in allen Filialen und reserviert vor. Zum Schluss schlägt es Filiale und Termin vor, und der Kunde bestätigt. Heute machbar ist die Erkennung sichtbarer Schäden per Bildanalyse, etwa ein gebrochenes Display oder eine gerissene Kette, dazu ein Vorab-KVA aus Teilepreisen und Aufwandsrichtwerten. Vision sind Geräuschanalyse bei E-Bike-Motoren und eine Aufwandsschätzung aus Video. Deshalb bleibt der Vorschlag immer vorläufig: Der Techniker bestätigt oder korrigiert ihn. Die Medien werden nur mit Einwilligung verarbeitet und nach Abschluss gelöscht. Was hinter all dem steckt, zeigt Adrian.</a:t>
             </a:r>
           </a:p>
         </p:txBody>
@@ -1695,9 +1855,13 @@
           <a:lstStyle/>
           <a:p>
             <a:r>
-              <a:rPr lang="en-US" dirty="0"/>
-              <a:t>Vortragende(r): Maximilian (50 s)
-Damit zur zweiten Hälfte: Was steckt hinter dieser Geschichte? Wir haben drei Modelle erstellt, die zusammenpassen. Zehn BPMN-Kollaborationsdiagramme mit 131 Aktivitäten im Werkstatt-Pool, dazu die Abläufe des Kunden mit 26 weiteren Aktivitäten. Ein Use-Case-Diagramm mit 19 Use Cases und 18 Akteuren. Ein vollständiges Klassendiagramm mit 27 Klassen und 36 Assoziationen. Sechs Sequenzdiagramme, gefordert waren fünf, und als Zugabe ein Zustandsdiagramm für den Reparaturauftrag. Alle Modelle liegen im Camunda Modeler und in Visual Paradigm und werden mit der Dokumentation abgegeben. Ich beginne mit den Geschäftsprozessen.</a:t>
+              <a:t>Vortragende(r): Adrian (50 s)</a:t>
+            </a:r>
+          </a:p>
+          <a:p/>
+          <a:p>
+            <a:r>
+              <a:t>Damit zur zweiten Hälfte: Was steckt hinter dieser Geschichte? Wir haben drei Modelle erstellt, die zusammenpassen. Zehn BPMN-Kollaborationsdiagramme mit 133 Aktivitäten im Werkstatt-Pool, dazu die Abläufe des Kunden. Ein Use-Case-Diagramm mit 19 Use Cases und 17 Rollen und Akteuren. Ein vollständiges Klassendiagramm mit 29 Klassen und 40 Assoziationen. Sechs Sequenzdiagramme, gefordert waren fünf, dazu ein Zustandsdiagramm für den Reparaturauftrag. Alle Modelle liegen im Camunda Modeler und in Visual Paradigm und werden mit der Dokumentation abgegeben.</a:t>
             </a:r>
           </a:p>
         </p:txBody>
@@ -1783,9 +1947,13 @@
           <a:lstStyle/>
           <a:p>
             <a:r>
-              <a:rPr lang="en-US" dirty="0"/>
-              <a:t>Vortragende(r): Maximilian (70 s)
-Die zehn Prozesse decken den gesamten Lebenszyklus ab. Prozesse 01 bis 08 sind die durchgehende Auftragsreise: Sofortdiagnose, Annahme, Diagnose, Kostenvoranschlag, Ersatzteilreservierung, Bestellung, Reparatur und Abholung. 09 und 10 sind die Folgeprozesse Reklamation und Retoure. Jedes Diagramm ist eine Kollaboration: Der Werkstattbetrieb ist der ausführbare Pool mit den Lanes Service, Techniker, Werkstattleitung und Disposition, der Kunde hat seinen eigenen Ablauf, der Lieferant bleibt eine Black Box. Die wichtigste Zahl: 60 Prozent der Aktivitäten führt RepairFlow ohne manuelle Arbeit aus, also Statuswechsel, Benachrichtigungen, Verfügbarkeitsprüfungen, Berechnungen und Regeln. Was Handwerk ist, bleibt Handwerk: Diagnose, Reparatur und Endkontrolle sind Aktivitäten des Technikers mit Unterstützung durch das System.</a:t>
+              <a:t>Vortragende(r): Adrian (60 s)</a:t>
+            </a:r>
+          </a:p>
+          <a:p/>
+          <a:p>
+            <a:r>
+              <a:t>Die zehn Prozesse decken den gesamten Lebenszyklus ab. Prozesse 01 bis 08 sind die durchgehende Auftragsreise, 09 und 10 die Folgeprozesse Reklamation und Retoure; drei Highlights daraus hat Maximilian schon gezeigt. Jedes Diagramm ist eine Kollaboration: Der Werkstattbetrieb ist der ausführbare Pool mit den Lanes Service, Techniker, Werkstattleitung und Disposition, der Kunde hat seinen eigenen Ablauf, der Lieferant bleibt eine Black Box. Die wichtigste Zahl: 61 Prozent der Aktivitäten führt RepairFlow ohne manuelle Arbeit aus, also Statuswechsel, Benachrichtigungen, Prüfungen, Berechnungen und Regeln. Was Handwerk ist, bleibt Handwerk: Diagnose, Reparatur und Endkontrolle macht der Techniker mit Unterstützung durch das System. Wer im System welche Aufgaben hat, zeigt Kilian.</a:t>
             </a:r>
           </a:p>
         </p:txBody>
@@ -2863,7 +3031,7 @@
                 <a:ea typeface="Calibri" pitchFamily="34" charset="-122"/>
                 <a:cs typeface="Segoe UI" panose="020B0502040204020203" pitchFamily="34" charset="0"/>
               </a:rPr>
-              <a:t>27</a:t>
+              <a:t>29</a:t>
             </a:r>
             <a:endParaRPr lang="en-US" sz="4000" dirty="0">
               <a:solidFill>
@@ -2930,7 +3098,7 @@
                 <a:ea typeface="Calibri" pitchFamily="34" charset="-122"/>
                 <a:cs typeface="Segoe UI" panose="020B0502040204020203" pitchFamily="34" charset="0"/>
               </a:rPr>
-              <a:t>36 Assoziationen, 7 Aufzählungen</a:t>
+              <a:t>40 Assoziationen, 7 Aufzählungen</a:t>
             </a:r>
             <a:endParaRPr lang="en-US" sz="1100" dirty="0">
               <a:latin typeface="Segoe UI" panose="020B0502040204020203" pitchFamily="34" charset="0"/>
@@ -3529,7 +3697,7 @@
                 <a:ea typeface="Calibri" pitchFamily="34" charset="-122"/>
                 <a:cs typeface="Segoe UI" panose="020B0502040204020203" pitchFamily="34" charset="0"/>
               </a:rPr>
-              <a:t>Zehn Prozesse, 60 Prozent automatisiert</a:t>
+              <a:t>Zehn Prozesse, 61 Prozent automatisiert</a:t>
             </a:r>
             <a:endParaRPr lang="en-US" sz="2800" dirty="0">
               <a:solidFill>
@@ -8857,7 +9025,7 @@
                 <a:ea typeface="Calibri" pitchFamily="34" charset="-122"/>
                 <a:cs typeface="Segoe UI" panose="020B0502040204020203" pitchFamily="34" charset="0"/>
               </a:rPr>
-              <a:t>Werkstattbetrieb als Mandant; Servicemitarbeiter, Techniker, Disponent, Werkstattleiter als Unterklassen von Mitarbeiter, passend zu Lanes und Rollen.</a:t>
+              <a:t>Werkstattbetrieb als Mandant und Sammelstelle; vier Mitarbeitertypen passend zu Lanes und Rollen; KundenApp und Werkstattoberfläche als Zugang.</a:t>
             </a:r>
             <a:endParaRPr lang="en-US" sz="1000" dirty="0">
               <a:latin typeface="Segoe UI" panose="020B0502040204020203" pitchFamily="34" charset="0"/>
@@ -9086,7 +9254,7 @@
                 <a:ea typeface="Calibri" pitchFamily="34" charset="-122"/>
                 <a:cs typeface="Segoe UI" panose="020B0502040204020203" pitchFamily="34" charset="0"/>
               </a:rPr>
-              <a:t>27 Klassen · 36 Assoziationen · 7 Aufzählungen</a:t>
+              <a:t>29 Klassen · 40 Assoziationen · 7 Aufzählungen</a:t>
             </a:r>
             <a:endParaRPr lang="en-US" sz="1050" dirty="0">
               <a:latin typeface="Segoe UI" panose="020B0502040204020203" pitchFamily="34" charset="0"/>
@@ -9722,7 +9890,7 @@
                 <a:ea typeface="Calibri" pitchFamily="34" charset="-122"/>
                 <a:cs typeface="Segoe UI" panose="020B0502040204020203" pitchFamily="34" charset="0"/>
               </a:rPr>
-              <a:t>Als die Nacharbeit in Prozess 07 auf zwei Durchläufe begrenzt wurde, musste Sequenzdiagramm SD4 nachziehen (loop 0..2, danach Status abgelehnt). Genau solche Stellen findet die Checkliste: Botschaft = Operation, Lebenslinie = Rolle oder Klasse, Zustand = AuftragStatus.</a:t>
+              <a:t>Als die Nacharbeit in Prozess 07 auf zwei Durchläufe begrenzt wurde, musste Sequenzdiagramm SD4 nachziehen (loop 0..2, danach Status abgelehnt). Genau solche Stellen findet die Checkliste: Botschaft = Operation, Akteur → Oberfläche → Objekt, Zustand = AuftragStatus.</a:t>
             </a:r>
             <a:endParaRPr lang="en-US" sz="1100" dirty="0">
               <a:latin typeface="Segoe UI" panose="020B0502040204020203" pitchFamily="34" charset="0"/>
@@ -13620,7 +13788,7 @@
                           <a:ea typeface="Calibri" pitchFamily="34" charset="-122"/>
                           <a:cs typeface="Calibri" pitchFamily="34" charset="-120"/>
                         </a:rPr>
-                        <a:t>1–2, 17–18</a:t>
+                        <a:t>1–2, 16–18</a:t>
                       </a:r>
                       <a:endParaRPr lang="en-US" sz="1050" dirty="0">
                         <a:latin typeface="Calibri" charset="0"/>
@@ -13685,7 +13853,7 @@
                           <a:ea typeface="Calibri" pitchFamily="34" charset="-122"/>
                           <a:cs typeface="Calibri" pitchFamily="34" charset="-120"/>
                         </a:rPr>
-                        <a:t>Einleitung und Agenda, Geschäftsmodell und Ausblick, Fazit, Moderation der Fragerunde; Projektleitung, Redaktion der Dokumentation, Abgabe-Archiv</a:t>
+                        <a:t>Einleitung und Agenda, Vorgehen und Projektmanagement, Geschäftsmodell und Ausblick, Fazit, Moderation der Fragerunde; Projektleitung, Redaktion der Dokumentation, Abgabe-Archiv</a:t>
                       </a:r>
                       <a:endParaRPr lang="en-US" sz="1050" dirty="0">
                         <a:latin typeface="Calibri" charset="0"/>
@@ -13822,7 +13990,7 @@
                           <a:ea typeface="Calibri" pitchFamily="34" charset="-122"/>
                           <a:cs typeface="Calibri" pitchFamily="34" charset="-120"/>
                         </a:rPr>
-                        <a:t>3, 6, 12</a:t>
+                        <a:t>3–5</a:t>
                       </a:r>
                       <a:endParaRPr lang="en-US" sz="1050" dirty="0">
                         <a:latin typeface="Calibri" charset="0"/>
@@ -13887,7 +14055,7 @@
                           <a:ea typeface="Calibri" pitchFamily="34" charset="-122"/>
                           <a:cs typeface="Calibri" pitchFamily="34" charset="-120"/>
                         </a:rPr>
-                        <a:t>Das Problem, Auftragsreise, Rollen und Use Cases; Use-Case-Diagramm und Sequenzdiagramme SD5 und SD6 in Visual Paradigm, stellvertretende Projektleitung</a:t>
+                        <a:t>Das Problem, Lösung, Nutzenversprechen; Use-Case-Diagramm und Sequenzdiagramme SD5 und SD6 in Visual Paradigm, stellvertretende Projektleitung</a:t>
                       </a:r>
                       <a:endParaRPr lang="en-US" sz="1050" dirty="0">
                         <a:latin typeface="Calibri" charset="0"/>
@@ -14024,7 +14192,7 @@
                           <a:ea typeface="Calibri" pitchFamily="34" charset="-122"/>
                           <a:cs typeface="Calibri" pitchFamily="34" charset="-120"/>
                         </a:rPr>
-                        <a:t>4–5, 7–8</a:t>
+                        <a:t>10–11</a:t>
                       </a:r>
                       <a:endParaRPr lang="en-US" sz="1050" dirty="0">
                         <a:latin typeface="Calibri" charset="0"/>
@@ -14089,7 +14257,7 @@
                           <a:ea typeface="Calibri" pitchFamily="34" charset="-122"/>
                           <a:cs typeface="Calibri" pitchFamily="34" charset="-120"/>
                         </a:rPr>
-                        <a:t>Lösung, Nutzenversprechen, KI-Sofortdiagnose, Live-Demo; Product Owner, Fachkonzept und Entscheidungslog</a:t>
+                        <a:t>Ergebnisse in Zahlen, Prozesslandkarte; Product Owner, Fachkonzept und Entscheidungslog</a:t>
                       </a:r>
                       <a:endParaRPr lang="en-US" sz="1050" dirty="0">
                         <a:latin typeface="Calibri" charset="0"/>
@@ -14226,7 +14394,7 @@
                           <a:ea typeface="Calibri" pitchFamily="34" charset="-122"/>
                           <a:cs typeface="Calibri" pitchFamily="34" charset="-120"/>
                         </a:rPr>
-                        <a:t>9–11</a:t>
+                        <a:t>7–9</a:t>
                       </a:r>
                       <a:endParaRPr lang="en-US" sz="1050" dirty="0">
                         <a:latin typeface="Calibri" charset="0"/>
@@ -14291,7 +14459,7 @@
                           <a:ea typeface="Calibri" pitchFamily="34" charset="-122"/>
                           <a:cs typeface="Calibri" pitchFamily="34" charset="-120"/>
                         </a:rPr>
-                        <a:t>Ergebnisse in Zahlen, Prozesslandkarte, Prozess-Highlights; BPMN-Modellierung der zehn Prozesse im Camunda Modeler</a:t>
+                        <a:t>Prozess-Highlights, Live-Demo, KI-Sofortdiagnose; BPMN-Modellierung der zehn Prozesse im Camunda Modeler</a:t>
                       </a:r>
                       <a:endParaRPr lang="en-US" sz="1050" dirty="0">
                         <a:latin typeface="Calibri" charset="0"/>
@@ -14428,7 +14596,7 @@
                           <a:ea typeface="Calibri" pitchFamily="34" charset="-122"/>
                           <a:cs typeface="Calibri" pitchFamily="34" charset="-120"/>
                         </a:rPr>
-                        <a:t>13–14</a:t>
+                        <a:t>6, 12–13</a:t>
                       </a:r>
                       <a:endParaRPr lang="en-US" sz="1050" dirty="0">
                         <a:latin typeface="Calibri" charset="0"/>
@@ -14493,7 +14661,7 @@
                           <a:ea typeface="Calibri" pitchFamily="34" charset="-122"/>
                           <a:cs typeface="Calibri" pitchFamily="34" charset="-120"/>
                         </a:rPr>
-                        <a:t>Datenmodell, Vorgehen und Projektmanagement; Klassendiagramm, SD1 bis SD4 und VP-Projekt, Scrum Master</a:t>
+                        <a:t>Auftragsreise, Rollen und Use Cases, Datenmodell; Klassendiagramm, SD1 bis SD4 und VP-Projekt, Scrum Master</a:t>
                       </a:r>
                       <a:endParaRPr lang="en-US" sz="1050" dirty="0">
                         <a:latin typeface="Calibri" charset="0"/>
@@ -14630,7 +14798,7 @@
                           <a:ea typeface="Calibri" pitchFamily="34" charset="-122"/>
                           <a:cs typeface="Calibri" pitchFamily="34" charset="-120"/>
                         </a:rPr>
-                        <a:t>15–16</a:t>
+                        <a:t>14–15</a:t>
                       </a:r>
                       <a:endParaRPr lang="en-US" sz="1050" dirty="0">
                         <a:latin typeface="Calibri" charset="0"/>
@@ -14695,7 +14863,7 @@
                           <a:ea typeface="Calibri" pitchFamily="34" charset="-122"/>
                           <a:cs typeface="Calibri" pitchFamily="34" charset="-120"/>
                         </a:rPr>
-                        <a:t>Qualität, Herausforderungen; Qualitätssicherung, Reviews und Konsistenz der Modelle</a:t>
+                        <a:t>Qualität, Herausforderungen und Lernerfahrungen; Qualitätssicherung, Reviews und Konsistenz der Modelle</a:t>
                       </a:r>
                       <a:endParaRPr lang="en-US" sz="1050" dirty="0">
                         <a:latin typeface="Calibri" charset="0"/>
@@ -14794,7 +14962,7 @@
                 <a:ea typeface="Calibri" pitchFamily="34" charset="-122"/>
                 <a:cs typeface="Segoe UI" panose="020B0502040204020203" pitchFamily="34" charset="0"/>
               </a:rPr>
-              <a:t>Beiträge</a:t>
+              <a:t>Beiträge der Vortragenden</a:t>
             </a:r>
             <a:r>
               <a:rPr lang="en-US" sz="2800" b="1" dirty="0">
@@ -14807,7 +14975,7 @@
                 <a:ea typeface="Calibri" pitchFamily="34" charset="-122"/>
                 <a:cs typeface="Segoe UI" panose="020B0502040204020203" pitchFamily="34" charset="0"/>
               </a:rPr>
-              <a:t> der </a:t>
+              <a:t/>
             </a:r>
             <a:r>
               <a:rPr lang="en-US" sz="2800" b="1" dirty="0" err="1">
@@ -14820,7 +14988,7 @@
                 <a:ea typeface="Calibri" pitchFamily="34" charset="-122"/>
                 <a:cs typeface="Segoe UI" panose="020B0502040204020203" pitchFamily="34" charset="0"/>
               </a:rPr>
-              <a:t>Vordtragenden</a:t>
+              <a:t/>
             </a:r>
             <a:endParaRPr lang="en-US" sz="2800" dirty="0">
               <a:solidFill>

</xml_diff>

<commit_message>
[T05 2026-10-22] docs: Doku und Präsentation an E-32 angepasst
- Doku 5.1: Kennzahlen (134/13,4/82/61 %, 25 Kundenaktivitäten, 44 Nachrichtenflüsse,
  32 Benutzer-Aktivitäten, 10 Aufrufe), Tabelle 6 Zeilen 06–10, Kurztexte P06/P09/P10
- Abbildung 3 durch aktuelles P04 ersetzt (Stand E-31, gleiche Pixelmaße)
- Folie 10 und 11 (Kennzahlen, Prozesstabelle), Notiz Folie 10 und Sprechtext

Co-Authored-By: Claude Opus 5.5 <noreply@anthropic.com>
</commit_message>
<xml_diff>
--- a/4_praesentation/Abschlusspraesentation.pptx
+++ b/4_praesentation/Abschlusspraesentation.pptx
@@ -1861,7 +1861,7 @@
           <a:p/>
           <a:p>
             <a:r>
-              <a:t>Damit zur zweiten Hälfte: Was steckt hinter dieser Geschichte? Wir haben drei Modelle erstellt, die zusammenpassen. Zehn BPMN-Kollaborationsdiagramme mit 133 Aktivitäten im Werkstatt-Pool, dazu die Abläufe des Kunden. Ein Use-Case-Diagramm mit 19 Use Cases und 17 Rollen und Akteuren. Ein vollständiges Klassendiagramm mit 29 Klassen und 40 Assoziationen. Sechs Sequenzdiagramme, gefordert waren fünf, dazu ein Zustandsdiagramm für den Reparaturauftrag. Alle Modelle liegen im Camunda Modeler und in Visual Paradigm und werden mit der Dokumentation abgegeben.</a:t>
+              <a:t>Damit zur zweiten Hälfte: Was steckt hinter dieser Geschichte? Wir haben drei Modelle erstellt, die zusammenpassen. Zehn BPMN-Kollaborationsdiagramme mit 134 Aktivitäten im Werkstatt-Pool, dazu die Abläufe des Kunden. Ein Use-Case-Diagramm mit 19 Use Cases und 17 Rollen und Akteuren. Ein vollständiges Klassendiagramm mit 29 Klassen und 40 Assoziationen. Sechs Sequenzdiagramme, gefordert waren fünf, dazu ein Zustandsdiagramm für den Reparaturauftrag. Alle Modelle liegen im Camunda Modeler und in Visual Paradigm und werden mit der Dokumentation abgegeben.</a:t>
             </a:r>
           </a:p>
         </p:txBody>
@@ -2876,7 +2876,7 @@
                 <a:ea typeface="Calibri" pitchFamily="34" charset="-122"/>
                 <a:cs typeface="Segoe UI" panose="020B0502040204020203" pitchFamily="34" charset="0"/>
               </a:rPr>
-              <a:t>133 Aktivitäten im Werkstatt-Pool</a:t>
+              <a:t>134 Aktivitäten im Werkstatt-Pool</a:t>
             </a:r>
             <a:endParaRPr lang="en-US" sz="1100" dirty="0">
               <a:latin typeface="Segoe UI" panose="020B0502040204020203" pitchFamily="34" charset="0"/>
@@ -3300,7 +3300,7 @@
                 <a:ea typeface="Calibri" pitchFamily="34" charset="-122"/>
                 <a:cs typeface="Segoe UI" panose="020B0502040204020203" pitchFamily="34" charset="0"/>
               </a:rPr>
-              <a:t>Camunda Modeler, BPMN 2.0, angereichert für Camunda 8. Zehn Prozesse vom ersten Foto bis zur Retoure. 42 Nachrichtenflüsse, 51 Datenobjekte, 12 Datenspeicher.</a:t>
+              <a:t>Camunda Modeler, BPMN 2.0, angereichert für Camunda 8. Zehn Prozesse vom ersten Foto bis zur Retoure. 44 Nachrichtenflüsse, 51 Datenobjekte, 12 Datenspeicher.</a:t>
             </a:r>
             <a:endParaRPr lang="en-US" sz="1050" dirty="0">
               <a:latin typeface="Segoe UI" panose="020B0502040204020203" pitchFamily="34" charset="0"/>
@@ -5533,7 +5533,7 @@
                           <a:ea typeface="Calibri" pitchFamily="34" charset="-122"/>
                           <a:cs typeface="Calibri" pitchFamily="34" charset="-120"/>
                         </a:rPr>
-                        <a:t>15</a:t>
+                        <a:t>17</a:t>
                       </a:r>
                       <a:endParaRPr lang="en-US" sz="950" dirty="0">
                         <a:latin typeface="Calibri" charset="0"/>
@@ -5598,7 +5598,7 @@
                           <a:ea typeface="Calibri" pitchFamily="34" charset="-122"/>
                           <a:cs typeface="Calibri" pitchFamily="34" charset="-120"/>
                         </a:rPr>
-                        <a:t>60 %</a:t>
+                        <a:t>65 %</a:t>
                       </a:r>
                       <a:endParaRPr lang="en-US" sz="950" dirty="0">
                         <a:latin typeface="Calibri" charset="0"/>
@@ -5865,7 +5865,7 @@
                           <a:ea typeface="Calibri" pitchFamily="34" charset="-122"/>
                           <a:cs typeface="Calibri" pitchFamily="34" charset="-120"/>
                         </a:rPr>
-                        <a:t>38 %</a:t>
+                        <a:t>46 %</a:t>
                       </a:r>
                       <a:endParaRPr lang="en-US" sz="950" dirty="0">
                         <a:latin typeface="Calibri" charset="0"/>
@@ -6334,7 +6334,7 @@
                           <a:ea typeface="Calibri" pitchFamily="34" charset="-122"/>
                           <a:cs typeface="Calibri" pitchFamily="34" charset="-120"/>
                         </a:rPr>
-                        <a:t>15</a:t>
+                        <a:t>16</a:t>
                       </a:r>
                       <a:endParaRPr lang="en-US" sz="950" dirty="0">
                         <a:latin typeface="Calibri" charset="0"/>
@@ -6399,7 +6399,7 @@
                           <a:ea typeface="Calibri" pitchFamily="34" charset="-122"/>
                           <a:cs typeface="Calibri" pitchFamily="34" charset="-120"/>
                         </a:rPr>
-                        <a:t>53 %</a:t>
+                        <a:t>50 %</a:t>
                       </a:r>
                       <a:endParaRPr lang="en-US" sz="950" dirty="0">
                         <a:latin typeface="Calibri" charset="0"/>
@@ -6601,7 +6601,7 @@
                           <a:ea typeface="Calibri" pitchFamily="34" charset="-122"/>
                           <a:cs typeface="Calibri" pitchFamily="34" charset="-120"/>
                         </a:rPr>
-                        <a:t>11</a:t>
+                        <a:t>9</a:t>
                       </a:r>
                       <a:endParaRPr lang="en-US" sz="950" dirty="0">
                         <a:latin typeface="Calibri" charset="0"/>
@@ -6666,7 +6666,7 @@
                           <a:ea typeface="Calibri" pitchFamily="34" charset="-122"/>
                           <a:cs typeface="Calibri" pitchFamily="34" charset="-120"/>
                         </a:rPr>
-                        <a:t>73 %</a:t>
+                        <a:t>67 %</a:t>
                       </a:r>
                       <a:endParaRPr lang="en-US" sz="950" dirty="0">
                         <a:latin typeface="Calibri" charset="0"/>
@@ -6759,7 +6759,7 @@
                 <a:ea typeface="Calibri" pitchFamily="34" charset="-122"/>
                 <a:cs typeface="Segoe UI" panose="020B0502040204020203" pitchFamily="34" charset="0"/>
               </a:rPr>
-              <a:t>133</a:t>
+              <a:t>134</a:t>
             </a:r>
             <a:endParaRPr lang="en-US" sz="4000" dirty="0">
               <a:solidFill>
@@ -6828,7 +6828,7 @@
                 <a:ea typeface="Calibri" pitchFamily="34" charset="-122"/>
                 <a:cs typeface="Segoe UI" panose="020B0502040204020203" pitchFamily="34" charset="0"/>
               </a:rPr>
-              <a:t> 13,3 je Diagramm</a:t>
+              <a:t> 13,4 je Diagramm</a:t>
             </a:r>
             <a:endParaRPr lang="en-US" sz="1100" dirty="0">
               <a:latin typeface="Segoe UI" panose="020B0502040204020203" pitchFamily="34" charset="0"/>

</xml_diff>

<commit_message>
[T05 2026-10-22] docs: Zustandsdiagramm aus Präsentation und Sprechtext gestrichen (E-30)
- Folie 10: „+ Zustandsdiagramm“ entfernt
- Folie 13: Halbsatz zum Zustandsdiagramm durch wechsleStatus() ersetzt
- Notiz Folie 10 und Sprechtext: „dazu ein Zustandsdiagramm …“ gestrichen

Co-Authored-By: Claude Opus 5.5 <noreply@anthropic.com>
</commit_message>
<xml_diff>
--- a/4_praesentation/Abschlusspraesentation.pptx
+++ b/4_praesentation/Abschlusspraesentation.pptx
@@ -1861,7 +1861,7 @@
           <a:p/>
           <a:p>
             <a:r>
-              <a:t>Damit zur zweiten Hälfte: Was steckt hinter dieser Geschichte? Wir haben drei Modelle erstellt, die zusammenpassen. Zehn BPMN-Kollaborationsdiagramme mit 134 Aktivitäten im Werkstatt-Pool, dazu die Abläufe des Kunden. Ein Use-Case-Diagramm mit 19 Use Cases und 17 Rollen und Akteuren. Ein vollständiges Klassendiagramm mit 29 Klassen und 40 Assoziationen. Sechs Sequenzdiagramme, gefordert waren fünf, dazu ein Zustandsdiagramm für den Reparaturauftrag. Alle Modelle liegen im Camunda Modeler und in Visual Paradigm und werden mit der Dokumentation abgegeben.</a:t>
+              <a:t>Damit zur zweiten Hälfte: Was steckt hinter dieser Geschichte? Wir haben drei Modelle erstellt, die zusammenpassen. Zehn BPMN-Kollaborationsdiagramme mit 134 Aktivitäten im Werkstatt-Pool, dazu die Abläufe des Kunden. Ein Use-Case-Diagramm mit 19 Use Cases und 17 Rollen und Akteuren. Ein vollständiges Klassendiagramm mit 29 Klassen und 40 Assoziationen. Sechs Sequenzdiagramme, gefordert waren fünf. Alle Modelle liegen im Camunda Modeler und in Visual Paradigm und werden mit der Dokumentation abgegeben.</a:t>
             </a:r>
           </a:p>
         </p:txBody>
@@ -3196,26 +3196,6 @@
               <a:cs typeface="Segoe UI" panose="020B0502040204020203" pitchFamily="34" charset="0"/>
             </a:endParaRPr>
           </a:p>
-          <a:p>
-            <a:pPr marL="0" indent="0" algn="ctr">
-              <a:buNone/>
-            </a:pPr>
-            <a:r>
-              <a:rPr lang="en-US" sz="1100" dirty="0">
-                <a:solidFill>
-                  <a:srgbClr val="1B2430"/>
-                </a:solidFill>
-                <a:latin typeface="Segoe UI" panose="020B0502040204020203" pitchFamily="34" charset="0"/>
-                <a:ea typeface="Calibri" pitchFamily="34" charset="-122"/>
-                <a:cs typeface="Segoe UI" panose="020B0502040204020203" pitchFamily="34" charset="0"/>
-              </a:rPr>
-              <a:t>+ Zustandsdiagramm</a:t>
-            </a:r>
-            <a:endParaRPr lang="en-US" sz="1100" dirty="0">
-              <a:latin typeface="Segoe UI" panose="020B0502040204020203" pitchFamily="34" charset="0"/>
-              <a:cs typeface="Segoe UI" panose="020B0502040204020203" pitchFamily="34" charset="0"/>
-            </a:endParaRPr>
-          </a:p>
         </p:txBody>
       </p:sp>
       <p:sp>
@@ -9274,7 +9254,7 @@
                 <a:ea typeface="Calibri" pitchFamily="34" charset="-122"/>
                 <a:cs typeface="Segoe UI" panose="020B0502040204020203" pitchFamily="34" charset="0"/>
               </a:rPr>
-              <a:t>Botschaft = Operation: Die sechs Sequenzdiagramme verwenden ausschließlich Operationen dieser Klassen. Der Reparaturauftrag führt den Status als Attribut, das Zustandsdiagramm beschreibt seine Übergänge.</a:t>
+              <a:t>Botschaft = Operation: Die sechs Sequenzdiagramme verwenden ausschließlich Operationen dieser Klassen. Der Reparaturauftrag führt den Status als Attribut und wechselt ihn über wechsleStatus().</a:t>
             </a:r>
             <a:endParaRPr lang="en-US" sz="1050" dirty="0">
               <a:latin typeface="Segoe UI" panose="020B0502040204020203" pitchFamily="34" charset="0"/>

</xml_diff>

<commit_message>
docs: Folie 14 Reviews statt Pruefrunden, Notiz und Sprechtext angepasst
</commit_message>
<xml_diff>
--- a/4_praesentation/Abschlusspraesentation.pptx
+++ b/4_praesentation/Abschlusspraesentation.pptx
@@ -633,7 +633,7 @@
           <a:p/>
           <a:p>
             <a:r>
-              <a:t>Drei Modelle, die sich auf dieselben Dinge beziehen, laufen schnell auseinander. Dagegen hatten wir drei Mittel. Erstens Konventionen: Datenobjekte in BPMN tragen die Klassennamen, Aktivitäten heißen Verb plus Objekt, jede Rolle ist genau einer Lane und einer Klasse zugeordnet, die Statuswerte sind in allen Modellen identisch, und in jedem Sequenzdiagramm geht der Weg vom Akteur über die Oberfläche zum Objekt. Zweitens Werkzeuge: Die BPMN-Dateien sind für Camunda 8 angereichert, mit Task-Definitionen, Timern und Bedingungen; der Camunda-Linter und bpmnlint melden null Befunde. Drittens Prüfrunden: Jedes Diagramm wurde im Zweierteam geprüft, und jede Änderung wird gegen unsere QA-Checkliste geprüft, bevor sie gemergt wird. Ein Beispiel: Als wir die Nacharbeit in Prozess 07 auf zwei Durchläufe begrenzt haben, musste das Sequenzdiagramm SD4 nachziehen. Genau solche Stellen findet die Checkliste.</a:t>
+              <a:t>Drei Modelle, die sich auf dieselben Dinge beziehen, laufen schnell auseinander. Dagegen hatten wir drei Mittel. Erstens Konventionen: Datenobjekte in BPMN tragen die Klassennamen, Aktivitäten heißen Verb plus Objekt, jede Rolle ist genau einer Lane und einer Klasse zugeordnet, die Statuswerte sind in allen Modellen identisch, und in jedem Sequenzdiagramm geht der Weg vom Akteur über die Oberfläche zum Objekt. Zweitens Werkzeuge: Die BPMN-Dateien sind für Camunda 8 angereichert, mit Task-Definitionen, Timern und Bedingungen; der Camunda-Linter und bpmnlint melden null Befunde. Drittens Reviews: Jedes Diagramm wurde im Zweierteam geprüft und in den Gruppenterminen abgestimmt, und jede Änderung wird gegen unsere QA-Checkliste geprüft, bevor sie gemergt wird. Ein Beispiel: Als wir die Nacharbeit in Prozess 07 auf zwei Durchläufe begrenzt haben, musste das Sequenzdiagramm SD4 nachziehen. Genau solche Stellen findet die Checkliste.</a:t>
             </a:r>
           </a:p>
         </p:txBody>
@@ -9690,7 +9690,7 @@
                 <a:ea typeface="Calibri" pitchFamily="34" charset="-122"/>
                 <a:cs typeface="Segoe UI" panose="020B0502040204020203" pitchFamily="34" charset="0"/>
               </a:rPr>
-              <a:t>Prüfrunden</a:t>
+              <a:t>Reviews</a:t>
             </a:r>
             <a:endParaRPr lang="en-US" sz="1400" dirty="0">
               <a:solidFill>
@@ -9737,7 +9737,7 @@
                 <a:ea typeface="Calibri" pitchFamily="34" charset="-122"/>
                 <a:cs typeface="Segoe UI" panose="020B0502040204020203" pitchFamily="34" charset="0"/>
               </a:rPr>
-              <a:t>Gesamtprüfung 26.09., Komplettcheck 05.10. (39 Befunde), QA-Abgleich 08.10. Jeder Pull Request wird gegen die QA-Checkliste geprüft, bevor er gemergt wird.</a:t>
+              <a:t>Jedes Diagramm im Zweierteam geprüft, Abstimmung in den Gruppenterminen. Jeder Pull Request wird gegen die QA-Checkliste geprüft, bevor er gemergt wird.</a:t>
             </a:r>
             <a:endParaRPr lang="en-US" sz="1050" dirty="0">
               <a:latin typeface="Segoe UI" panose="020B0502040204020203" pitchFamily="34" charset="0"/>

</xml_diff>

<commit_message>
docs: Praesentation und Sprechtext an Doku und Diagramme angeglichen (Vorreservierung nach Bestaetigung, Freigabe Nacharbeit, Status abgelehnt, Agenda, Coaching-Hinweise)
</commit_message>
<xml_diff>
--- a/4_praesentation/Abschlusspraesentation.pptx
+++ b/4_praesentation/Abschlusspraesentation.pptx
@@ -1573,13 +1573,13 @@
           <a:lstStyle/>
           <a:p>
             <a:r>
-              <a:t>Vortragende(r): Kilian (65 s)</a:t>
+              <a:t>Vortragende(r): Kilian (70 s)</a:t>
             </a:r>
           </a:p>
           <a:p/>
           <a:p>
             <a:r>
-              <a:t>So sieht eine Reparatur mit RepairFlow aus. Der Kunde schickt per App ein Foto oder Video und bekommt innerhalb einer Minute Vorschlag, vorläufigen Kostenvoranschlag und Terminvorschlag. In der Filiale wird das Gerät registriert und der Auftrag angelegt. Der Techniker prüft den Vorschlag, stellt die Diagnose und erstellt den Kostenvoranschlag, den der Kunde in der App freigibt. Dann disponiert RepairFlow die Teile über alle Filialen und bestellt Fehlteile beim Lieferanten. Nach der Reparatur folgt die Endkontrolle, der Kunde wird benachrichtigt, holt ab und zahlt. Jeder dieser Schritte ist ein Status des Reparaturauftrags: angenommen, in Diagnose, KVA offen, freigegeben, Teile bestellt, in Reparatur, fertig, abgeholt. Dieser Zustandsautomat ist der rote Faden durch alle unsere Modelle. Welche Abläufe dahinterstecken, zeigt Maximilian an drei Beispielen.</a:t>
+              <a:t>So sieht eine Reparatur mit RepairFlow aus. Der Kunde schickt per App ein Foto oder Video und bekommt innerhalb einer Minute Vorschlag, vorläufigen Kostenvoranschlag und Terminvorschlag. In der Filiale wird das Gerät registriert und der Auftrag angelegt. Der Techniker prüft den Vorschlag, stellt die Diagnose und erstellt den Kostenvoranschlag, den der Kunde in der App freigibt. Dann disponiert RepairFlow die Teile über alle Filialen und bestellt Fehlteile beim Lieferanten. Nach der Reparatur folgt die Endkontrolle, der Kunde wird benachrichtigt, holt ab und zahlt. Jeder dieser Schritte ist ein Status des Reparaturauftrags: angenommen, in Diagnose, KVA offen, freigegeben, Teile bestellt, in Reparatur, fertig, abgeholt, und abgelehnt, wenn der Kunde den KVA ablehnt oder die Reparatur scheitert. Dieser Zustandsautomat ist der rote Faden durch alle unsere Modelle. Welche Abläufe dahinterstecken, zeigt Maximilian an drei Beispielen.</a:t>
             </a:r>
           </a:p>
         </p:txBody>
@@ -1677,7 +1677,7 @@
           <a:p/>
           <a:p>
             <a:r>
-              <a:t>Hinter jedem dieser Schritte steht ein Geschäftsprozess. Drei Stellen zeigen, was die Prozesse leisten. Erstens der Kostenvoranschlag in Prozess 04: Nach dem Versand wartet ein ereignisbasiertes Gateway auf Freigabe, Ablehnung oder den Ablauf von drei Tagen. Bei Fristablauf erinnert RepairFlow den Kunden, höchstens zweimal. Nach dem dritten Fristablauf ohne Antwort gilt der KVA als abgelehnt und das Gerät geht mit Diagnosepauschale zur Abholung. Kein Auftrag bleibt liegen. Zweitens die Disposition in Prozess 05: Für jedes benötigte Teil läuft parallel eine Prüfung, erst im eigenen Lager, dann in den anderen Filialen. Was lokal liegt, wird reserviert, was anderswo liegt, umgelagert, und nur Fehlteile werden bestellt. Drittens die Reklamation in Prozess 09: Der Techniker prüft den Mangel, RepairFlow entscheidet nach Regel über Gewährleistung, und im Gewährleistungsfall entsteht ein kostenfreier Nacharbeitsauftrag, der wieder durch die normale Auftragsreise läuft. Wie sich das für den Kunden anfühlt, zeige ich Ihnen jetzt in der App.</a:t>
+              <a:t>Hinter jedem dieser Schritte steht ein Geschäftsprozess. Drei Stellen zeigen, was die Prozesse leisten. Erstens der Kostenvoranschlag in Prozess 04: Nach dem Versand wartet ein ereignisbasiertes Gateway auf Freigabe, Ablehnung oder den Ablauf von drei Tagen. Bei Fristablauf erinnert RepairFlow den Kunden, höchstens zweimal. Nach dem dritten Fristablauf ohne Antwort gilt der KVA als abgelehnt und das Gerät geht mit Diagnosepauschale zur Abholung. Kein Auftrag bleibt liegen. Zweitens die Disposition in Prozess 05: Für jedes benötigte Teil läuft parallel eine Prüfung, erst im eigenen Lager, dann in den anderen Filialen. Was lokal liegt, wird reserviert, was anderswo liegt, umgelagert, und nur Fehlteile werden bestellt. Drittens die Reklamation in Prozess 09: Der Techniker prüft den Mangel, RepairFlow entscheidet nach Regel über Gewährleistung, und im Gewährleistungsfall gibt die Werkstattleitung einen kostenfreien Nacharbeitsauftrag frei, der wieder durch die normale Auftragsreise läuft. Wie sich das für den Kunden anfühlt, zeige ich Ihnen jetzt in der App.</a:t>
             </a:r>
           </a:p>
         </p:txBody>
@@ -1769,7 +1769,7 @@
           <a:p/>
           <a:p>
             <a:r>
-              <a:t>Was Sie gerade in der App gesehen haben, ist unser Alleinstellungsmerkmal, die KI-Sofortdiagnose. Fünf Schritte: Der Kunde nimmt Foto, Video oder Ton auf. Ein KI-Dienst erkennt Gerätetyp, wahrscheinliche Ursache und benötigte Teile. RepairFlow rechnet daraus einen vorläufigen Kostenvoranschlag, prüft die Verfügbarkeit in allen Filialen und reserviert vor. Zum Schluss schlägt es Filiale und Termin vor, und der Kunde bestätigt. Heute machbar ist die Erkennung sichtbarer Schäden per Bildanalyse, etwa ein gebrochenes Display oder eine gerissene Kette, dazu ein Vorab-KVA aus Teilepreisen und Aufwandsrichtwerten. Vision sind Geräuschanalyse bei E-Bike-Motoren und eine Aufwandsschätzung aus Video. Deshalb bleibt der Vorschlag immer vorläufig: Der Techniker bestätigt oder korrigiert ihn. Die Medien werden nur mit Einwilligung verarbeitet und nach Abschluss gelöscht. Was hinter all dem steckt, zeigt Adrian.</a:t>
+              <a:t>Was Sie gerade in der App gesehen haben, ist unser Alleinstellungsmerkmal, die KI-Sofortdiagnose. Fünf Schritte: Der Kunde nimmt Foto, Video oder Ton auf. Ein KI-Dienst erkennt Gerätetyp, wahrscheinliche Ursache und benötigte Teile. RepairFlow rechnet daraus einen vorläufigen Kostenvoranschlag, prüft die Verfügbarkeit in allen Filialen und schlägt Filiale und Termin vor. Bestätigt der Kunde den Termin, werden die Teile vorreserviert. Heute machbar ist die Erkennung sichtbarer Schäden per Bildanalyse, etwa ein gebrochenes Display oder eine gerissene Kette, dazu ein Vorab-KVA aus Teilepreisen und Aufwandsrichtwerten. Vision sind Geräuschanalyse bei E-Bike-Motoren und eine Aufwandsschätzung aus Video. Deshalb bleibt der Vorschlag immer vorläufig: Der Techniker bestätigt oder korrigiert ihn. Die Medien werden nur mit Einwilligung verarbeitet und nach Abschluss gelöscht. Was hinter all dem steckt, zeigt Adrian.</a:t>
             </a:r>
           </a:p>
         </p:txBody>
@@ -10681,7 +10681,7 @@
                 <a:ea typeface="Calibri" pitchFamily="34" charset="-122"/>
                 <a:cs typeface="Calibri" pitchFamily="34" charset="-120"/>
               </a:rPr>
-              <a:t>Die KI-Vision glaubwürdig halten (heute machbar vs. Vision) und das Use-Case-Diagramm nach dem Coaching auf eine Rolle je Use Case umbauen: Beides hat die Arbeit deutlich besser gemacht.</a:t>
+              <a:t>Die KI-Vision glaubwürdig halten (heute machbar vs. Vision), nach den Coachings eine Rolle je Use Case und Oberflächen in den Sequenzdiagrammen: Das hat die Arbeit deutlich besser gemacht.</a:t>
             </a:r>
             <a:endParaRPr lang="en-US" sz="1150" dirty="0"/>
           </a:p>
@@ -15425,7 +15425,7 @@
                 <a:ea typeface="Calibri" pitchFamily="34" charset="-122"/>
                 <a:cs typeface="Calibri" pitchFamily="34" charset="-120"/>
               </a:rPr>
-              <a:t>Maximilian, Adrian</a:t>
+              <a:t>Adrian</a:t>
             </a:r>
             <a:endParaRPr lang="en-US" sz="1200" dirty="0"/>
           </a:p>
@@ -21075,7 +21075,7 @@
                 <a:ea typeface="Calibri" pitchFamily="34" charset="-122"/>
                 <a:cs typeface="Segoe UI" panose="020B0502040204020203" pitchFamily="34" charset="0"/>
               </a:rPr>
-              <a:t>Gewährleistung: kostenfreier Nacharbeitsauftrag, der durch die normale Auftragsreise läuft. Sonst: kostenpflichtiges Angebot.</a:t>
+              <a:t>Gewährleistung: Die Werkstattleitung gibt die kostenfreie Nacharbeit frei, der Auftrag läuft durch die normale Auftragsreise. Sonst: kostenpflichtiges Angebot.</a:t>
             </a:r>
             <a:endParaRPr lang="en-US" sz="1150" dirty="0">
               <a:latin typeface="Segoe UI" panose="020B0502040204020203" pitchFamily="34" charset="0"/>
@@ -21948,7 +21948,7 @@
                 <a:ea typeface="Calibri" pitchFamily="34" charset="-122"/>
                 <a:cs typeface="Segoe UI" panose="020B0502040204020203" pitchFamily="34" charset="0"/>
               </a:rPr>
-              <a:t>Reservieren</a:t>
+              <a:t>Prüfen</a:t>
             </a:r>
             <a:endParaRPr lang="en-US" sz="1300" dirty="0">
               <a:solidFill>
@@ -21995,7 +21995,7 @@
                 <a:ea typeface="Calibri" pitchFamily="34" charset="-122"/>
                 <a:cs typeface="Segoe UI" panose="020B0502040204020203" pitchFamily="34" charset="0"/>
               </a:rPr>
-              <a:t>Verfügbarkeit in allen Filialen, Teile vorreserviert</a:t>
+              <a:t>Verfügbarkeit in allen Filialen geprüft</a:t>
             </a:r>
             <a:endParaRPr lang="en-US" sz="1000" dirty="0">
               <a:latin typeface="Segoe UI" panose="020B0502040204020203" pitchFamily="34" charset="0"/>
@@ -22086,7 +22086,7 @@
                 <a:ea typeface="Calibri" pitchFamily="34" charset="-122"/>
                 <a:cs typeface="Segoe UI" panose="020B0502040204020203" pitchFamily="34" charset="0"/>
               </a:rPr>
-              <a:t>Filiale und Termin vorgeschlagen, Kunde bestätigt</a:t>
+              <a:t>Kunde bestätigt Termin, Teile vorreserviert</a:t>
             </a:r>
             <a:endParaRPr lang="en-US" sz="1000" dirty="0">
               <a:latin typeface="Segoe UI" panose="020B0502040204020203" pitchFamily="34" charset="0"/>

</xml_diff>

<commit_message>
fix: P01 von Adrian nach 1_bpmn uebernommen, Kennzahlen in Doku, Praesentation und Sprechtext nachgezogen (E-33)
</commit_message>
<xml_diff>
--- a/4_praesentation/Abschlusspraesentation.pptx
+++ b/4_praesentation/Abschlusspraesentation.pptx
@@ -1861,7 +1861,7 @@
           <a:p/>
           <a:p>
             <a:r>
-              <a:t>Damit zur zweiten Hälfte: Was steckt hinter dieser Geschichte? Wir haben drei Modelle erstellt, die zusammenpassen. Zehn BPMN-Kollaborationsdiagramme mit 134 Aktivitäten im Werkstatt-Pool, dazu die Abläufe des Kunden. Ein Use-Case-Diagramm mit 19 Use Cases und 17 Rollen und Akteuren. Ein vollständiges Klassendiagramm mit 29 Klassen und 40 Assoziationen. Sechs Sequenzdiagramme, gefordert waren fünf. Alle Modelle liegen im Camunda Modeler und in Visual Paradigm und werden mit der Dokumentation abgegeben.</a:t>
+              <a:t>Damit zur zweiten Hälfte: Was steckt hinter dieser Geschichte? Wir haben drei Modelle erstellt, die zusammenpassen. Zehn BPMN-Kollaborationsdiagramme mit 136 Aktivitäten im Werkstatt-Pool, dazu die Abläufe des Kunden. Ein Use-Case-Diagramm mit 19 Use Cases und 17 Rollen und Akteuren. Ein vollständiges Klassendiagramm mit 29 Klassen und 40 Assoziationen. Sechs Sequenzdiagramme, gefordert waren fünf. Alle Modelle liegen im Camunda Modeler und in Visual Paradigm und werden mit der Dokumentation abgegeben.</a:t>
             </a:r>
           </a:p>
         </p:txBody>
@@ -1953,7 +1953,7 @@
           <a:p/>
           <a:p>
             <a:r>
-              <a:t>Die zehn Prozesse decken den gesamten Lebenszyklus ab. Prozesse 01 bis 08 sind die durchgehende Auftragsreise, 09 und 10 die Folgeprozesse Reklamation und Retoure; drei Highlights daraus hat Maximilian schon gezeigt. Jedes Diagramm ist eine Kollaboration: Der Werkstattbetrieb ist der ausführbare Pool mit den Lanes Service, Techniker, Werkstattleitung und Disposition, der Kunde hat seinen eigenen Ablauf, der Lieferant bleibt eine Black Box. Die wichtigste Zahl: 61 Prozent der Aktivitäten führt RepairFlow ohne manuelle Arbeit aus, also Statuswechsel, Benachrichtigungen, Prüfungen, Berechnungen und Regeln. Was Handwerk ist, bleibt Handwerk: Diagnose, Reparatur und Endkontrolle macht der Techniker mit Unterstützung durch das System. Wer im System welche Aufgaben hat, zeigt Kilian.</a:t>
+              <a:t>Die zehn Prozesse decken den gesamten Lebenszyklus ab. Prozesse 01 bis 08 sind die durchgehende Auftragsreise, 09 und 10 die Folgeprozesse Reklamation und Retoure; drei Highlights daraus hat Maximilian schon gezeigt. Jedes Diagramm ist eine Kollaboration: Der Werkstattbetrieb ist der ausführbare Pool mit den Lanes Service, Techniker, Werkstattleitung und Disposition, der Kunde hat seinen eigenen Ablauf, der Lieferant bleibt eine Black Box. Die wichtigste Zahl: 62 Prozent der Aktivitäten führt RepairFlow ohne manuelle Arbeit aus, also Statuswechsel, Benachrichtigungen, Prüfungen, Berechnungen und Regeln. Was Handwerk ist, bleibt Handwerk: Diagnose, Reparatur und Endkontrolle macht der Techniker mit Unterstützung durch das System. Wer im System welche Aufgaben hat, zeigt Kilian.</a:t>
             </a:r>
           </a:p>
         </p:txBody>
@@ -2876,7 +2876,7 @@
                 <a:ea typeface="Calibri" pitchFamily="34" charset="-122"/>
                 <a:cs typeface="Segoe UI" panose="020B0502040204020203" pitchFamily="34" charset="0"/>
               </a:rPr>
-              <a:t>134 Aktivitäten im Werkstatt-Pool</a:t>
+              <a:t>136 Aktivitäten im Werkstatt-Pool</a:t>
             </a:r>
             <a:endParaRPr lang="en-US" sz="1100" dirty="0">
               <a:latin typeface="Segoe UI" panose="020B0502040204020203" pitchFamily="34" charset="0"/>
@@ -3280,7 +3280,7 @@
                 <a:ea typeface="Calibri" pitchFamily="34" charset="-122"/>
                 <a:cs typeface="Segoe UI" panose="020B0502040204020203" pitchFamily="34" charset="0"/>
               </a:rPr>
-              <a:t>Camunda Modeler, BPMN 2.0, angereichert für Camunda 8. Zehn Prozesse vom ersten Foto bis zur Retoure. 44 Nachrichtenflüsse, 51 Datenobjekte, 12 Datenspeicher.</a:t>
+              <a:t>Camunda Modeler, BPMN 2.0, angereichert für Camunda 8. Zehn Prozesse vom ersten Foto bis zur Retoure. 45 Nachrichtenflüsse, 53 Datenobjekte, 12 Datenspeicher.</a:t>
             </a:r>
             <a:endParaRPr lang="en-US" sz="1050" dirty="0">
               <a:latin typeface="Segoe UI" panose="020B0502040204020203" pitchFamily="34" charset="0"/>
@@ -3677,7 +3677,7 @@
                 <a:ea typeface="Calibri" pitchFamily="34" charset="-122"/>
                 <a:cs typeface="Segoe UI" panose="020B0502040204020203" pitchFamily="34" charset="0"/>
               </a:rPr>
-              <a:t>Zehn Prozesse, 61 Prozent automatisiert</a:t>
+              <a:t>Zehn Prozesse, 62 Prozent automatisiert</a:t>
             </a:r>
             <a:endParaRPr lang="en-US" sz="2800" dirty="0">
               <a:solidFill>
@@ -4178,7 +4178,7 @@
                           <a:ea typeface="Calibri" pitchFamily="34" charset="-122"/>
                           <a:cs typeface="Calibri" pitchFamily="34" charset="-120"/>
                         </a:rPr>
-                        <a:t>12</a:t>
+                        <a:t>14</a:t>
                       </a:r>
                       <a:endParaRPr lang="en-US" sz="950" dirty="0">
                         <a:latin typeface="Calibri" charset="0"/>
@@ -6739,7 +6739,7 @@
                 <a:ea typeface="Calibri" pitchFamily="34" charset="-122"/>
                 <a:cs typeface="Segoe UI" panose="020B0502040204020203" pitchFamily="34" charset="0"/>
               </a:rPr>
-              <a:t>134</a:t>
+              <a:t>136</a:t>
             </a:r>
             <a:endParaRPr lang="en-US" sz="4000" dirty="0">
               <a:solidFill>
@@ -6808,7 +6808,7 @@
                 <a:ea typeface="Calibri" pitchFamily="34" charset="-122"/>
                 <a:cs typeface="Segoe UI" panose="020B0502040204020203" pitchFamily="34" charset="0"/>
               </a:rPr>
-              <a:t> 13,4 je Diagramm</a:t>
+              <a:t> 13,6 je Diagramm</a:t>
             </a:r>
             <a:endParaRPr lang="en-US" sz="1100" dirty="0">
               <a:latin typeface="Segoe UI" panose="020B0502040204020203" pitchFamily="34" charset="0"/>
@@ -6852,7 +6852,7 @@
                 <a:ea typeface="Calibri" pitchFamily="34" charset="-122"/>
                 <a:cs typeface="Segoe UI" panose="020B0502040204020203" pitchFamily="34" charset="0"/>
               </a:rPr>
-              <a:t>61 %</a:t>
+              <a:t>62 %</a:t>
             </a:r>
             <a:endParaRPr lang="en-US" sz="4000" dirty="0">
               <a:solidFill>

</xml_diff>

<commit_message>
docs: Sprechtexte nach Abschnitten verteilt, Folie 9 an Adrian, Folie 19 angepasst
</commit_message>
<xml_diff>
--- a/4_praesentation/Abschlusspraesentation.pptx
+++ b/4_praesentation/Abschlusspraesentation.pptx
@@ -143,11 +143,11 @@
             <p14:sldId id="276"/>
             <p14:sldId id="265"/>
             <p14:sldId id="280"/>
-            <p14:sldId id="262"/>
           </p14:sldIdLst>
         </p14:section>
         <p14:section name="Adrian" id="{C59C4432-FF7E-A14B-8A5D-46FD719FCE68}">
           <p14:sldIdLst>
+            <p14:sldId id="262"/>
             <p14:sldId id="263"/>
             <p14:sldId id="264"/>
           </p14:sldIdLst>
@@ -179,6 +179,161 @@
     </p:ext>
   </p:extLst>
 </p:presentation>
+</file>
+
+<file path=ppt/changesInfos/changesInfo1.xml><?xml version="1.0" encoding="utf-8"?>
+<pc:chgInfo xmlns:a="http://schemas.openxmlformats.org/drawingml/2006/main" xmlns:r="http://schemas.openxmlformats.org/officeDocument/2006/relationships" xmlns:ac="http://schemas.microsoft.com/office/drawing/2013/main/command" xmlns:pc="http://schemas.microsoft.com/office/powerpoint/2013/main/command">
+  <pc:docChgLst>
+    <pc:chgData name="Kilian Platter" userId="c49eb2881fa751ca" providerId="LiveId" clId="{FDA102BF-EFD5-549B-81DE-49FC5087B7E9}"/>
+    <pc:docChg chg="modSld sldOrd modSection">
+      <pc:chgData name="Kilian Platter" userId="c49eb2881fa751ca" providerId="LiveId" clId="{FDA102BF-EFD5-549B-81DE-49FC5087B7E9}" dt="2026-10-24T10:30:11.968" v="53" actId="20577"/>
+      <pc:docMkLst>
+        <pc:docMk/>
+      </pc:docMkLst>
+      <pc:sldChg chg="modSp mod modNotesTx">
+        <pc:chgData name="Kilian Platter" userId="c49eb2881fa751ca" providerId="LiveId" clId="{FDA102BF-EFD5-549B-81DE-49FC5087B7E9}" dt="2026-10-24T10:29:43.816" v="37" actId="20577"/>
+        <pc:sldMkLst>
+          <pc:docMk/>
+          <pc:sldMk cId="0" sldId="256"/>
+        </pc:sldMkLst>
+        <pc:spChg chg="mod">
+          <ac:chgData name="Kilian Platter" userId="c49eb2881fa751ca" providerId="LiveId" clId="{FDA102BF-EFD5-549B-81DE-49FC5087B7E9}" dt="2026-10-24T10:20:16.757" v="5" actId="20577"/>
+          <ac:spMkLst>
+            <pc:docMk/>
+            <pc:sldMk cId="0" sldId="256"/>
+            <ac:spMk id="10" creationId="{00000000-0000-0000-0000-000000000000}"/>
+          </ac:spMkLst>
+        </pc:spChg>
+      </pc:sldChg>
+      <pc:sldChg chg="modNotesTx">
+        <pc:chgData name="Kilian Platter" userId="c49eb2881fa751ca" providerId="LiveId" clId="{FDA102BF-EFD5-549B-81DE-49FC5087B7E9}" dt="2026-10-24T10:24:46.532" v="15" actId="20577"/>
+        <pc:sldMkLst>
+          <pc:docMk/>
+          <pc:sldMk cId="0" sldId="258"/>
+        </pc:sldMkLst>
+      </pc:sldChg>
+      <pc:sldChg chg="modNotesTx">
+        <pc:chgData name="Kilian Platter" userId="c49eb2881fa751ca" providerId="LiveId" clId="{FDA102BF-EFD5-549B-81DE-49FC5087B7E9}" dt="2026-10-24T10:24:51.620" v="16" actId="20577"/>
+        <pc:sldMkLst>
+          <pc:docMk/>
+          <pc:sldMk cId="0" sldId="259"/>
+        </pc:sldMkLst>
+      </pc:sldChg>
+      <pc:sldChg chg="ord modNotesTx">
+        <pc:chgData name="Kilian Platter" userId="c49eb2881fa751ca" providerId="LiveId" clId="{FDA102BF-EFD5-549B-81DE-49FC5087B7E9}" dt="2026-10-24T10:30:11.968" v="53" actId="20577"/>
+        <pc:sldMkLst>
+          <pc:docMk/>
+          <pc:sldMk cId="0" sldId="262"/>
+        </pc:sldMkLst>
+      </pc:sldChg>
+      <pc:sldChg chg="modNotesTx">
+        <pc:chgData name="Kilian Platter" userId="c49eb2881fa751ca" providerId="LiveId" clId="{FDA102BF-EFD5-549B-81DE-49FC5087B7E9}" dt="2026-10-24T10:25:34.341" v="22" actId="20577"/>
+        <pc:sldMkLst>
+          <pc:docMk/>
+          <pc:sldMk cId="0" sldId="263"/>
+        </pc:sldMkLst>
+      </pc:sldChg>
+      <pc:sldChg chg="modNotesTx">
+        <pc:chgData name="Kilian Platter" userId="c49eb2881fa751ca" providerId="LiveId" clId="{FDA102BF-EFD5-549B-81DE-49FC5087B7E9}" dt="2026-10-24T10:25:40.161" v="23" actId="20577"/>
+        <pc:sldMkLst>
+          <pc:docMk/>
+          <pc:sldMk cId="0" sldId="264"/>
+        </pc:sldMkLst>
+      </pc:sldChg>
+      <pc:sldChg chg="modNotesTx">
+        <pc:chgData name="Kilian Platter" userId="c49eb2881fa751ca" providerId="LiveId" clId="{FDA102BF-EFD5-549B-81DE-49FC5087B7E9}" dt="2026-10-24T10:25:11.456" v="19" actId="20577"/>
+        <pc:sldMkLst>
+          <pc:docMk/>
+          <pc:sldMk cId="0" sldId="265"/>
+        </pc:sldMkLst>
+      </pc:sldChg>
+      <pc:sldChg chg="modNotesTx">
+        <pc:chgData name="Kilian Platter" userId="c49eb2881fa751ca" providerId="LiveId" clId="{FDA102BF-EFD5-549B-81DE-49FC5087B7E9}" dt="2026-10-24T10:25:49.504" v="24" actId="20577"/>
+        <pc:sldMkLst>
+          <pc:docMk/>
+          <pc:sldMk cId="0" sldId="266"/>
+        </pc:sldMkLst>
+      </pc:sldChg>
+      <pc:sldChg chg="modNotesTx">
+        <pc:chgData name="Kilian Platter" userId="c49eb2881fa751ca" providerId="LiveId" clId="{FDA102BF-EFD5-549B-81DE-49FC5087B7E9}" dt="2026-10-24T10:25:55.597" v="25" actId="20577"/>
+        <pc:sldMkLst>
+          <pc:docMk/>
+          <pc:sldMk cId="0" sldId="267"/>
+        </pc:sldMkLst>
+      </pc:sldChg>
+      <pc:sldChg chg="modNotesTx">
+        <pc:chgData name="Kilian Platter" userId="c49eb2881fa751ca" providerId="LiveId" clId="{FDA102BF-EFD5-549B-81DE-49FC5087B7E9}" dt="2026-10-24T10:26:18.025" v="28" actId="20577"/>
+        <pc:sldMkLst>
+          <pc:docMk/>
+          <pc:sldMk cId="1220583403" sldId="268"/>
+        </pc:sldMkLst>
+      </pc:sldChg>
+      <pc:sldChg chg="modNotesTx">
+        <pc:chgData name="Kilian Platter" userId="c49eb2881fa751ca" providerId="LiveId" clId="{FDA102BF-EFD5-549B-81DE-49FC5087B7E9}" dt="2026-10-24T10:26:00.512" v="26" actId="20577"/>
+        <pc:sldMkLst>
+          <pc:docMk/>
+          <pc:sldMk cId="0" sldId="269"/>
+        </pc:sldMkLst>
+      </pc:sldChg>
+      <pc:sldChg chg="modNotesTx">
+        <pc:chgData name="Kilian Platter" userId="c49eb2881fa751ca" providerId="LiveId" clId="{FDA102BF-EFD5-549B-81DE-49FC5087B7E9}" dt="2026-10-24T10:26:07.444" v="27" actId="20577"/>
+        <pc:sldMkLst>
+          <pc:docMk/>
+          <pc:sldMk cId="8933715" sldId="270"/>
+        </pc:sldMkLst>
+      </pc:sldChg>
+      <pc:sldChg chg="modNotesTx">
+        <pc:chgData name="Kilian Platter" userId="c49eb2881fa751ca" providerId="LiveId" clId="{FDA102BF-EFD5-549B-81DE-49FC5087B7E9}" dt="2026-10-24T10:26:23.614" v="29" actId="20577"/>
+        <pc:sldMkLst>
+          <pc:docMk/>
+          <pc:sldMk cId="0" sldId="271"/>
+        </pc:sldMkLst>
+      </pc:sldChg>
+      <pc:sldChg chg="modNotesTx">
+        <pc:chgData name="Kilian Platter" userId="c49eb2881fa751ca" providerId="LiveId" clId="{FDA102BF-EFD5-549B-81DE-49FC5087B7E9}" dt="2026-10-24T10:26:29.054" v="31" actId="20577"/>
+        <pc:sldMkLst>
+          <pc:docMk/>
+          <pc:sldMk cId="0" sldId="272"/>
+        </pc:sldMkLst>
+      </pc:sldChg>
+      <pc:sldChg chg="modNotesTx">
+        <pc:chgData name="Kilian Platter" userId="c49eb2881fa751ca" providerId="LiveId" clId="{FDA102BF-EFD5-549B-81DE-49FC5087B7E9}" dt="2026-10-24T10:26:35.628" v="32" actId="20577"/>
+        <pc:sldMkLst>
+          <pc:docMk/>
+          <pc:sldMk cId="0" sldId="273"/>
+        </pc:sldMkLst>
+      </pc:sldChg>
+      <pc:sldChg chg="modNotesTx">
+        <pc:chgData name="Kilian Platter" userId="c49eb2881fa751ca" providerId="LiveId" clId="{FDA102BF-EFD5-549B-81DE-49FC5087B7E9}" dt="2026-10-24T10:29:55.216" v="43" actId="20577"/>
+        <pc:sldMkLst>
+          <pc:docMk/>
+          <pc:sldMk cId="7463954" sldId="274"/>
+        </pc:sldMkLst>
+      </pc:sldChg>
+      <pc:sldChg chg="modNotesTx">
+        <pc:chgData name="Kilian Platter" userId="c49eb2881fa751ca" providerId="LiveId" clId="{FDA102BF-EFD5-549B-81DE-49FC5087B7E9}" dt="2026-10-24T10:30:00.119" v="46" actId="20577"/>
+        <pc:sldMkLst>
+          <pc:docMk/>
+          <pc:sldMk cId="967035767" sldId="276"/>
+        </pc:sldMkLst>
+      </pc:sldChg>
+      <pc:sldChg chg="modNotesTx">
+        <pc:chgData name="Kilian Platter" userId="c49eb2881fa751ca" providerId="LiveId" clId="{FDA102BF-EFD5-549B-81DE-49FC5087B7E9}" dt="2026-10-24T10:24:35.859" v="13" actId="20577"/>
+        <pc:sldMkLst>
+          <pc:docMk/>
+          <pc:sldMk cId="0" sldId="279"/>
+        </pc:sldMkLst>
+      </pc:sldChg>
+      <pc:sldChg chg="modNotesTx">
+        <pc:chgData name="Kilian Platter" userId="c49eb2881fa751ca" providerId="LiveId" clId="{FDA102BF-EFD5-549B-81DE-49FC5087B7E9}" dt="2026-10-24T10:25:17.161" v="20" actId="20577"/>
+        <pc:sldMkLst>
+          <pc:docMk/>
+          <pc:sldMk cId="3044169480" sldId="280"/>
+        </pc:sldMkLst>
+      </pc:sldChg>
+    </pc:docChg>
+  </pc:docChgLst>
+</pc:chgInfo>
 </file>
 
 <file path=ppt/notesMasters/notesMaster1.xml><?xml version="1.0" encoding="utf-8"?>
@@ -351,14 +506,18 @@
           <a:lstStyle/>
           <a:p>
             <a:r>
-              <a:t>Vortragende(r): Nina (30 s)</a:t>
-            </a:r>
-          </a:p>
-          <a:p/>
-          <a:p>
-            <a:r>
-              <a:t>Guten Morgen zusammen. Wir sind Gruppe 1 und stellen Ihnen RepairFlow vor: eine Plattform, mit der Reparaturwerkstätten ihre Aufträge, Ersatzteile und Kunden an einer Stelle steuern. David beginnt mit dem Problem und unserer Lösung, Kilian und Maximilian zeigen, wie ein Auftrag durch RepairFlow läuft. Danach stellen Adrian, Kilian und Jakob vor, was wir dafür modelliert haben, und ich schließe mit Vorgehen, Geschäftsmodell und Ausblick.</a:t>
-            </a:r>
+              <a:rPr dirty="0" err="1"/>
+              <a:t>Vortragende</a:t>
+            </a:r>
+            <a:r>
+              <a:rPr dirty="0"/>
+              <a:t>(r): </a:t>
+            </a:r>
+            <a:r>
+              <a:rPr lang="de-DE" dirty="0"/>
+              <a:t>David</a:t>
+            </a:r>
+            <a:endParaRPr dirty="0"/>
           </a:p>
         </p:txBody>
       </p:sp>
@@ -443,13 +602,12 @@
           <a:lstStyle/>
           <a:p>
             <a:r>
-              <a:t>Vortragende(r): Kilian (70 s)</a:t>
-            </a:r>
-          </a:p>
-          <a:p/>
-          <a:p>
-            <a:r>
-              <a:t>Das Use-Case-Diagramm beschreibt, was RepairFlow für seine Benutzer leistet. 19 Use Cases in vier Bereichen: das Kundenportal mit Sofortdiagnose, Voranmeldung und KVA-Freigabe; Auftrag und Werkstatt von der Annahme bis zur Reklamation; die Ersatzteil-Disposition von der Reservierung bis zur Retoure; und die Administration des Werkstattbetriebs. Eine Besonderheit geht auf das Coaching zurück: Jeder Use Case hat genau eine Rolle. Statt eines Technikers mit fünf Verbindungen gibt es Diagnoseprüfer, Diagnostiker, Kalkulator, Reparateur und Endkontrolleur. Welche Person welche Rolle ausfüllt, regelt die Werkstatt selbst; im Datenmodell sind die Rollen den Mitarbeitertypen zugeordnet. Dazu kommen der Kunde und der KI-Diagnosedienst als externes System. Der Lieferant ist bewusst kein Akteur: Er hat keinen Zugang zu RepairFlow und bleibt eine Black Box.</a:t>
+              <a:rPr dirty="0" err="1"/>
+              <a:t>Vortragende</a:t>
+            </a:r>
+            <a:r>
+              <a:rPr dirty="0"/>
+              <a:t>(r): Adrian</a:t>
             </a:r>
           </a:p>
         </p:txBody>
@@ -471,7 +629,7 @@
           <a:p>
             <a:fld id="{F7021451-1387-4CA6-816F-3879F97B5CBC}" type="slidenum">
               <a:rPr lang="en-US"/>
-              <a:t>12</a:t>
+              <a:t>10</a:t>
             </a:fld>
             <a:endParaRPr lang="en-US"/>
           </a:p>
@@ -535,13 +693,12 @@
           <a:lstStyle/>
           <a:p>
             <a:r>
-              <a:t>Vortragende(r): Kilian (100 s)</a:t>
-            </a:r>
-          </a:p>
-          <a:p/>
-          <a:p>
-            <a:r>
-              <a:t>Das Klassendiagramm ist ein einziges, vollständiges Modell mit 29 Klassen. Fünf Entscheidungen prägen es. Erstens: Der Reparaturauftrag ist die Aggregatwurzel. Befund und Reparaturschritte sind Kompositionen, Kostenvoranschlag und Gerät nur zugeordnet, weil der Vorab-KVA schon vor dem Auftrag entsteht. Zweitens: Der Lagerbestand ist eine eigene Klasse zwischen Ersatzteil und Filiale; nur so lässt sich die Verfügbarkeit über alle Filialen prüfen. Drittens: Die Reservierung ist eine eigene Klasse mit Lebenszyklus. Viertens: Der Werkstattbetrieb ist Mandant und Sammelstelle. Er kennt alle Aufträge, Bestellungen und Reklamationen und findet sie über ihre Nummer. Die Mitarbeiter sind nach Typ spezialisiert, passend zu Lanes und Rollen, und arbeiten wie der Kunde nie direkt mit den Fachobjekten, sondern über zwei Oberflächenklassen, die Werkstattoberfläche und die KundenApp. Fünftens: Voranmeldung, Medienanhang und KI-Diagnosevorschlag tragen die Sofortdiagnose. Ein Beispiel aus den Sequenzdiagrammen ist SD4, die Fertigmeldung: Der Endkontrolleur gibt die Auftragsnummer ein, die Werkstattoberfläche sucht den Auftrag und arbeitet mit diesem Objekt; nach jeder Nacharbeit sucht sie ihn neu. Besteht er auch nach der zweiten Nacharbeit die Endkontrolle nicht, ruft sie wechsleStatus mit dem Wert ABGELEHNT auf, genau die Operation, die der Reparaturauftrag im Klassendiagramm anbietet.</a:t>
+              <a:rPr dirty="0" err="1"/>
+              <a:t>Vortragende</a:t>
+            </a:r>
+            <a:r>
+              <a:rPr dirty="0"/>
+              <a:t>(r): Adrian</a:t>
             </a:r>
           </a:p>
         </p:txBody>
@@ -563,7 +720,7 @@
           <a:p>
             <a:fld id="{F7021451-1387-4CA6-816F-3879F97B5CBC}" type="slidenum">
               <a:rPr lang="en-US"/>
-              <a:t>13</a:t>
+              <a:t>11</a:t>
             </a:fld>
             <a:endParaRPr lang="en-US"/>
           </a:p>
@@ -627,13 +784,12 @@
           <a:lstStyle/>
           <a:p>
             <a:r>
-              <a:t>Vortragende(r): Jakob (65 s)</a:t>
-            </a:r>
-          </a:p>
-          <a:p/>
-          <a:p>
-            <a:r>
-              <a:t>Drei Modelle, die sich auf dieselben Dinge beziehen, laufen schnell auseinander. Dagegen hatten wir drei Mittel. Erstens Konventionen: Datenobjekte in BPMN tragen die Klassennamen, Aktivitäten heißen Verb plus Objekt, jede Rolle ist genau einer Lane und einer Klasse zugeordnet, die Statuswerte sind in allen Modellen identisch, und in jedem Sequenzdiagramm geht der Weg vom Akteur über die Oberfläche zum Objekt. Zweitens Werkzeuge: Die BPMN-Dateien sind für Camunda 8 angereichert, mit Task-Definitionen, Timern und Bedingungen; der Camunda-Linter und bpmnlint melden null Befunde. Drittens Reviews: Jedes Diagramm wurde im Zweierteam geprüft und in den Gruppenterminen abgestimmt, und jede Änderung wird gegen unsere QA-Checkliste geprüft, bevor sie gemergt wird. Ein Beispiel: Als wir die Nacharbeit in Prozess 07 auf zwei Durchläufe begrenzt haben, musste das Sequenzdiagramm SD4 nachziehen. Genau solche Stellen findet die Checkliste.</a:t>
+              <a:rPr dirty="0" err="1"/>
+              <a:t>Vortragende</a:t>
+            </a:r>
+            <a:r>
+              <a:rPr dirty="0"/>
+              <a:t>(r): Kilian</a:t>
             </a:r>
           </a:p>
         </p:txBody>
@@ -655,7 +811,7 @@
           <a:p>
             <a:fld id="{F7021451-1387-4CA6-816F-3879F97B5CBC}" type="slidenum">
               <a:rPr lang="en-US"/>
-              <a:t>14</a:t>
+              <a:t>12</a:t>
             </a:fld>
             <a:endParaRPr lang="en-US"/>
           </a:p>
@@ -719,13 +875,12 @@
           <a:lstStyle/>
           <a:p>
             <a:r>
-              <a:t>Vortragende(r): Jakob (65 s)</a:t>
-            </a:r>
-          </a:p>
-          <a:p/>
-          <a:p>
-            <a:r>
-              <a:t>Vier Dinge haben uns am meisten beschäftigt. Die Perspektive: Werkstatt oder Softwareanbieter? Die Rückfrage des Dozenten hat uns zur klaren Entscheidung gezwungen, und danach mussten Texte und Klassenmodell nachziehen. Das Vokabular: Datenobjekte, Klassen, Lebenslinien und Statuswerte müssen wortgleich sein, sonst zerfällt die Analyse in drei Einzelmodelle. Die Werkzeuge: Der Camunda Modeler meldet für Camunda 8 fehlende technische Details als Fehler, und wir haben die Diagramme so lange angereichert, bis nichts mehr rot war. Und die Vision: Die KI-Sofortdiagnose soll beeindrucken, aber glaubwürdig bleiben. Gelernt haben wir, dass Konsistenz keine Prüfung am Ende ist, sondern eine Regel bei jeder Änderung, und dass klare Hinweise von außen, etwa zum Use-Case-Diagramm und zu den Oberflächen in den Sequenzdiagrammen, ein Modell deutlich besser machen. Wie wir zusammengearbeitet haben, zeigt Nina.</a:t>
+              <a:rPr dirty="0" err="1"/>
+              <a:t>Vortragende</a:t>
+            </a:r>
+            <a:r>
+              <a:rPr dirty="0"/>
+              <a:t>(r): Kilian</a:t>
             </a:r>
           </a:p>
         </p:txBody>
@@ -747,7 +902,7 @@
           <a:p>
             <a:fld id="{F7021451-1387-4CA6-816F-3879F97B5CBC}" type="slidenum">
               <a:rPr lang="en-US"/>
-              <a:t>15</a:t>
+              <a:t>13</a:t>
             </a:fld>
             <a:endParaRPr lang="en-US"/>
           </a:p>
@@ -756,7 +911,7 @@
     </p:spTree>
     <p:extLst>
       <p:ext uri="{BB962C8B-B14F-4D97-AF65-F5344CB8AC3E}">
-        <p14:creationId xmlns:p14="http://schemas.microsoft.com/office/powerpoint/2010/main" val="1285418441"/>
+        <p14:creationId xmlns:p14="http://schemas.microsoft.com/office/powerpoint/2010/main" val="1024086991"/>
       </p:ext>
     </p:extLst>
   </p:cSld>
@@ -811,13 +966,12 @@
           <a:lstStyle/>
           <a:p>
             <a:r>
-              <a:t>Vortragende(r): Nina (65 s)</a:t>
-            </a:r>
-          </a:p>
-          <a:p/>
-          <a:p>
-            <a:r>
-              <a:t>Gearbeitet haben wir in Sprints im Takt der vier Gruppentermine, mit Review, Retrospektive und Planning je Termin. Ich habe die Projektleitung, David die Stellvertretung und die Sicherungen, Adrian ist Product Owner, Kilian Scrum Master, Maximilian verantwortet BPMN, Jakob die Qualität. Alles Schriftliche liegt in einem GitHub-Repository; jede Änderung geht über einen eigenen Branch, einen Pull Request und ein Review durch eine zweite Person. Das Trello-Board hat eine Liste je Termin und eine Karte je Person und Aufgabe. Jedes Diagramm ist denselben Weg gegangen: Entwurf im Zweierteam, gegenseitiges Review, Abstimmung im Gruppentermin und erst dann die Umsetzung über einen Pull Request. Entscheidungen, die mehrere betreffen, stehen mit Begründung und Datum im Entscheidungslog; so konnten wir bei jeder Korrektur nachvollziehen, warum ein Modell so aussieht.</a:t>
+              <a:rPr dirty="0" err="1"/>
+              <a:t>Vortragende</a:t>
+            </a:r>
+            <a:r>
+              <a:rPr dirty="0"/>
+              <a:t>(r): Jakob</a:t>
             </a:r>
           </a:p>
         </p:txBody>
@@ -839,7 +993,7 @@
           <a:p>
             <a:fld id="{F7021451-1387-4CA6-816F-3879F97B5CBC}" type="slidenum">
               <a:rPr lang="en-US"/>
-              <a:t>16</a:t>
+              <a:t>14</a:t>
             </a:fld>
             <a:endParaRPr lang="en-US"/>
           </a:p>
@@ -848,7 +1002,7 @@
     </p:spTree>
     <p:extLst>
       <p:ext uri="{BB962C8B-B14F-4D97-AF65-F5344CB8AC3E}">
-        <p14:creationId xmlns:p14="http://schemas.microsoft.com/office/powerpoint/2010/main" val="373804386"/>
+        <p14:creationId xmlns:p14="http://schemas.microsoft.com/office/powerpoint/2010/main" val="1024086991"/>
       </p:ext>
     </p:extLst>
   </p:cSld>
@@ -903,13 +1057,12 @@
           <a:lstStyle/>
           <a:p>
             <a:r>
-              <a:t>Vortragende(r): Nina (60 s)</a:t>
-            </a:r>
-          </a:p>
-          <a:p/>
-          <a:p>
-            <a:r>
-              <a:t>Zum Schluss der Blick nach vorn. RepairFlow wird als Abo je Filiale angeboten, in zwei Stufen: Basis mit Auftrags- und Kundenverwaltung, Pro mit filialübergreifender Disposition und KI-Sofortdiagnose. Zielkunden sind unabhängige Werkstätten und kleine Ketten mit zwei bis zehn Filialen im deutschsprachigen Raum, also genau die Betriebe mit den vier Problemen vom Anfang. Der Ausblick geht in drei Richtungen: Predictive Disposition, also eine Bedarfsprognose je Filiale und Saison. Ein Techniker-Copilot, der Reparaturschritte aus der Historie vorschlägt. Und eine digitale Geräteakte, in der jedes Gerät seine Reparaturgeschichte behält. Nichts davon ist modelliert, aber alles baut auf dem Datenmodell auf, das wir heute vorgestellt haben.</a:t>
+              <a:rPr dirty="0" err="1"/>
+              <a:t>Vortragende</a:t>
+            </a:r>
+            <a:r>
+              <a:rPr dirty="0"/>
+              <a:t>(r): Jakob</a:t>
             </a:r>
           </a:p>
         </p:txBody>
@@ -931,7 +1084,7 @@
           <a:p>
             <a:fld id="{F7021451-1387-4CA6-816F-3879F97B5CBC}" type="slidenum">
               <a:rPr lang="en-US"/>
-              <a:t>17</a:t>
+              <a:t>15</a:t>
             </a:fld>
             <a:endParaRPr lang="en-US"/>
           </a:p>
@@ -940,7 +1093,7 @@
     </p:spTree>
     <p:extLst>
       <p:ext uri="{BB962C8B-B14F-4D97-AF65-F5344CB8AC3E}">
-        <p14:creationId xmlns:p14="http://schemas.microsoft.com/office/powerpoint/2010/main" val="1024086991"/>
+        <p14:creationId xmlns:p14="http://schemas.microsoft.com/office/powerpoint/2010/main" val="1285418441"/>
       </p:ext>
     </p:extLst>
   </p:cSld>
@@ -995,13 +1148,12 @@
           <a:lstStyle/>
           <a:p>
             <a:r>
-              <a:t>Vortragende(r): Nina (30 s)</a:t>
-            </a:r>
-          </a:p>
-          <a:p/>
-          <a:p>
-            <a:r>
-              <a:t>RepairFlow löst den Medienbruch aus Papier, Excel und Telefon und macht den Reparaturauftrag zum zentralen Zustandsautomaten. Der fachliche Mehrwert liegt in der filialübergreifenden Disposition und in der KI-Sofortdiagnose, die dem Kunden Klarheit gibt, bevor er die Werkstatt betritt. Vielen Dank für Ihre Aufmerksamkeit. Wir freuen uns auf Ihre Fragen.</a:t>
+              <a:rPr dirty="0" err="1"/>
+              <a:t>Vortragende</a:t>
+            </a:r>
+            <a:r>
+              <a:rPr dirty="0"/>
+              <a:t>(r): Nina</a:t>
             </a:r>
           </a:p>
         </p:txBody>
@@ -1023,7 +1175,7 @@
           <a:p>
             <a:fld id="{F7021451-1387-4CA6-816F-3879F97B5CBC}" type="slidenum">
               <a:rPr lang="en-US"/>
-              <a:t>18</a:t>
+              <a:t>16</a:t>
             </a:fld>
             <a:endParaRPr lang="en-US"/>
           </a:p>
@@ -1032,7 +1184,7 @@
     </p:spTree>
     <p:extLst>
       <p:ext uri="{BB962C8B-B14F-4D97-AF65-F5344CB8AC3E}">
-        <p14:creationId xmlns:p14="http://schemas.microsoft.com/office/powerpoint/2010/main" val="1024086991"/>
+        <p14:creationId xmlns:p14="http://schemas.microsoft.com/office/powerpoint/2010/main" val="373804386"/>
       </p:ext>
     </p:extLst>
   </p:cSld>
@@ -1087,9 +1239,12 @@
           <a:lstStyle/>
           <a:p>
             <a:r>
-              <a:rPr lang="en-US" dirty="0"/>
-              <a:t>Vortragende(r): -
-Pflichtangabe für den PDF-Export laut Ablauf: welche/r Vortragende welchen Beitrag verantwortet.</a:t>
+              <a:rPr dirty="0" err="1"/>
+              <a:t>Vortragende</a:t>
+            </a:r>
+            <a:r>
+              <a:rPr dirty="0"/>
+              <a:t>(r): Nina</a:t>
             </a:r>
           </a:p>
         </p:txBody>
@@ -1111,7 +1266,7 @@
           <a:p>
             <a:fld id="{F7021451-1387-4CA6-816F-3879F97B5CBC}" type="slidenum">
               <a:rPr lang="en-US"/>
-              <a:t>19</a:t>
+              <a:t>17</a:t>
             </a:fld>
             <a:endParaRPr lang="en-US"/>
           </a:p>
@@ -1131,7 +1286,7 @@
 </file>
 
 <file path=ppt/notesSlides/notesSlide18.xml><?xml version="1.0" encoding="utf-8"?>
-<p:notes xmlns:a="http://schemas.openxmlformats.org/drawingml/2006/main" xmlns:p="http://schemas.openxmlformats.org/presentationml/2006/main" xmlns:r="http://schemas.openxmlformats.org/officeDocument/2006/relationships">
+<p:notes xmlns:a="http://schemas.openxmlformats.org/drawingml/2006/main" xmlns:r="http://schemas.openxmlformats.org/officeDocument/2006/relationships" xmlns:p="http://schemas.openxmlformats.org/presentationml/2006/main">
   <p:cSld>
     <p:spTree>
       <p:nvGrpSpPr>
@@ -1149,6 +1304,18 @@
       </p:grpSpPr>
       <p:sp>
         <p:nvSpPr>
+          <p:cNvPr id="2" name="Slide Image Placeholder 1"/>
+          <p:cNvSpPr>
+            <a:spLocks noGrp="1" noRot="1" noChangeAspect="1"/>
+          </p:cNvSpPr>
+          <p:nvPr>
+            <p:ph type="sldImg"/>
+          </p:nvPr>
+        </p:nvSpPr>
+        <p:spPr/>
+      </p:sp>
+      <p:sp>
+        <p:nvSpPr>
           <p:cNvPr id="3" name="Notes Placeholder 2"/>
           <p:cNvSpPr>
             <a:spLocks noGrp="1"/>
@@ -1163,18 +1330,45 @@
           <a:lstStyle/>
           <a:p>
             <a:r>
-              <a:t>Vortragende(r): David (55 s)</a:t>
-            </a:r>
-          </a:p>
-          <a:p/>
-          <a:p>
-            <a:r>
-              <a:t>Was hat die Werkstatt davon? Drei Dinge. Erstens: eine Plattform für alle drei Gerätearten, mit einer Kundenbasis und einem gemeinsamen Ersatzteillager. Zweitens: filialübergreifende Disposition. RepairFlow kennt die Bestände aller Standorte, reserviert dort, wo das Teil liegt, und bestellt nur, was nirgends vorhanden ist. Drittens: Der Kunde bekommt Klarheit, bevor er die Werkstatt betritt, mit Diagnosevorschlag, vorläufigem Kostenvoranschlag und Termin. Für die Werkstatt heißt das weniger Telefon, weniger Standzeit im Lager und eine Auslastung, die sie wirklich sieht. Wie das für einen einzelnen Auftrag aussieht, zeigt Kilian.</a:t>
-            </a:r>
+              <a:rPr dirty="0" err="1"/>
+              <a:t>Vortragende</a:t>
+            </a:r>
+            <a:r>
+              <a:rPr dirty="0"/>
+              <a:t>(r): Nina </a:t>
+            </a:r>
+          </a:p>
+        </p:txBody>
+      </p:sp>
+      <p:sp>
+        <p:nvSpPr>
+          <p:cNvPr id="4" name="Slide Number Placeholder 3"/>
+          <p:cNvSpPr>
+            <a:spLocks noGrp="1"/>
+          </p:cNvSpPr>
+          <p:nvPr>
+            <p:ph type="sldNum" sz="quarter" idx="10"/>
+          </p:nvPr>
+        </p:nvSpPr>
+        <p:spPr/>
+        <p:txBody>
+          <a:bodyPr/>
+          <a:lstStyle/>
+          <a:p>
+            <a:fld id="{F7021451-1387-4CA6-816F-3879F97B5CBC}" type="slidenum">
+              <a:rPr lang="en-US"/>
+              <a:t>18</a:t>
+            </a:fld>
+            <a:endParaRPr lang="en-US"/>
           </a:p>
         </p:txBody>
       </p:sp>
     </p:spTree>
+    <p:extLst>
+      <p:ext uri="{BB962C8B-B14F-4D97-AF65-F5344CB8AC3E}">
+        <p14:creationId xmlns:p14="http://schemas.microsoft.com/office/powerpoint/2010/main" val="1024086991"/>
+      </p:ext>
+    </p:extLst>
   </p:cSld>
   <p:clrMapOvr>
     <a:masterClrMapping/>
@@ -1183,7 +1377,7 @@
 </file>
 
 <file path=ppt/notesSlides/notesSlide19.xml><?xml version="1.0" encoding="utf-8"?>
-<p:notes xmlns:a="http://schemas.openxmlformats.org/drawingml/2006/main" xmlns:p="http://schemas.openxmlformats.org/presentationml/2006/main" xmlns:r="http://schemas.openxmlformats.org/officeDocument/2006/relationships">
+<p:notes xmlns:a="http://schemas.openxmlformats.org/drawingml/2006/main" xmlns:r="http://schemas.openxmlformats.org/officeDocument/2006/relationships" xmlns:p="http://schemas.openxmlformats.org/presentationml/2006/main">
   <p:cSld>
     <p:spTree>
       <p:nvGrpSpPr>
@@ -1201,6 +1395,18 @@
       </p:grpSpPr>
       <p:sp>
         <p:nvSpPr>
+          <p:cNvPr id="2" name="Slide Image Placeholder 1"/>
+          <p:cNvSpPr>
+            <a:spLocks noGrp="1" noRot="1" noChangeAspect="1"/>
+          </p:cNvSpPr>
+          <p:nvPr>
+            <p:ph type="sldImg"/>
+          </p:nvPr>
+        </p:nvSpPr>
+        <p:spPr/>
+      </p:sp>
+      <p:sp>
+        <p:nvSpPr>
           <p:cNvPr id="3" name="Notes Placeholder 2"/>
           <p:cNvSpPr>
             <a:spLocks noGrp="1"/>
@@ -1214,19 +1420,39 @@
           <a:bodyPr/>
           <a:lstStyle/>
           <a:p>
-            <a:r>
-              <a:t>Vortragende(r): Maximilian (70 s)</a:t>
-            </a:r>
-          </a:p>
-          <a:p/>
-          <a:p>
-            <a:r>
-              <a:t>Wir starten mit der Sofortdiagnose aus Kundensicht. Der Kunde wählt sein Gerät, beschreibt das Problem und lädt ein Foto hoch; im Modell ist das die Voranmeldung mit dem Medienanhang. Der KI-Dienst antwortet mit Ursache, benötigten Teilen und einer Konfidenz, das ist der KIDiagnosevorschlag. RepairFlow rechnet daraus das Angebot, deutlich als vorläufig markiert, und schlägt Filiale und Termin vor. Bestätigt der Kunde, sind die Teile vorreserviert und die Voranmeldung steht. Der eigentliche Reparaturauftrag entsteht erst, wenn das Gerät in der Filiale abgegeben wird. Zum Schluss sieht der Kunde den Status seines Auftrags entlang derselben Zustände, die Kilian in der Auftragsreise gezeigt hat. Die KI-Antwort ist in der Demo simuliert; Ablauf und Begriffe sind genau die aus unseren Modellen.</a:t>
-            </a:r>
+            <a:endParaRPr lang="en-US" dirty="0"/>
+          </a:p>
+        </p:txBody>
+      </p:sp>
+      <p:sp>
+        <p:nvSpPr>
+          <p:cNvPr id="4" name="Slide Number Placeholder 3"/>
+          <p:cNvSpPr>
+            <a:spLocks noGrp="1"/>
+          </p:cNvSpPr>
+          <p:nvPr>
+            <p:ph type="sldNum" sz="quarter" idx="10"/>
+          </p:nvPr>
+        </p:nvSpPr>
+        <p:spPr/>
+        <p:txBody>
+          <a:bodyPr/>
+          <a:lstStyle/>
+          <a:p>
+            <a:fld id="{F7021451-1387-4CA6-816F-3879F97B5CBC}" type="slidenum">
+              <a:rPr lang="en-US"/>
+              <a:t>19</a:t>
+            </a:fld>
+            <a:endParaRPr lang="en-US"/>
           </a:p>
         </p:txBody>
       </p:sp>
     </p:spTree>
+    <p:extLst>
+      <p:ext uri="{BB962C8B-B14F-4D97-AF65-F5344CB8AC3E}">
+        <p14:creationId xmlns:p14="http://schemas.microsoft.com/office/powerpoint/2010/main" val="1024086991"/>
+      </p:ext>
+    </p:extLst>
   </p:cSld>
   <p:clrMapOvr>
     <a:masterClrMapping/>
@@ -1279,13 +1505,20 @@
           <a:lstStyle/>
           <a:p>
             <a:r>
-              <a:t>Vortragende(r): Nina (40 s)</a:t>
-            </a:r>
-          </a:p>
-          <a:p/>
-          <a:p>
-            <a:r>
-              <a:t>Unsere Präsentation hat zwei Hälften. In der ersten erzählen wir RepairFlow so, wie wir es einer Werkstatt vorstellen würden: Problem, Lösung, Nutzen, die Reparatur aus Kundensicht mit drei Prozess-Highlights und unser Alleinstellungsmerkmal, die KI-Sofortdiagnose, mit einer kurzen Demo der Kunden-App. In der zweiten Hälfte zeigen wir, was dahintersteckt: zehn Geschäftsprozesse, Rollen und Use Cases, das Datenmodell, die Qualitätssicherung und unser Vorgehen. Die Diagramme selbst finden Sie in der Projektdokumentation und im Abgabepaket; hier konzentrieren wir uns auf die Ergebnisse. Fragen gern am Ende.</a:t>
+              <a:rPr dirty="0" err="1"/>
+              <a:t>Vortragende</a:t>
+            </a:r>
+            <a:r>
+              <a:rPr dirty="0"/>
+              <a:t>(r): </a:t>
+            </a:r>
+            <a:r>
+              <a:rPr lang="de-DE" dirty="0"/>
+              <a:t>David</a:t>
+            </a:r>
+            <a:r>
+              <a:rPr dirty="0"/>
+              <a:t> </a:t>
             </a:r>
           </a:p>
         </p:txBody>
@@ -1371,13 +1604,12 @@
           <a:lstStyle/>
           <a:p>
             <a:r>
-              <a:t>Vortragende(r): David (75 s)</a:t>
-            </a:r>
-          </a:p>
-          <a:p/>
-          <a:p>
-            <a:r>
-              <a:t>Stellen Sie sich eine Werkstattkette mit vier Filialen vor, die Fahrräder, E-Bikes und Elektronik repariert. In unserem Szenario heißt sie FixWerk. Der Alltag dort läuft über Papierzettel, Excel-Listen und Telefon. Das führt zu vier Problemen. Erstens: Der Kunde gibt sein Gerät ab und hört dann nichts mehr. Ob der Kostenvoranschlag freizugeben ist oder das Gerät fertig ist, erfährt er, wenn er anruft. Zweitens: Niemand weiß ohne Nachfrage, wo ein Auftrag gerade steht, weil Zettel und Listen auseinanderlaufen. Drittens: Jede Filiale bestellt Ersatzteile für sich, obwohl das Teil oft in der Nachbarfiliale liegt. Viertens: Termine werden nach Gefühl zugesagt, weil die Auslastung der Techniker nicht sichtbar ist. Die vier Punkte sind Annahmen unseres Szenarios, aber jeder, der schon einmal ein Gerät zur Reparatur gebracht hat, kennt mindestens eines davon.</a:t>
+              <a:rPr dirty="0" err="1"/>
+              <a:t>Vortragende</a:t>
+            </a:r>
+            <a:r>
+              <a:rPr dirty="0"/>
+              <a:t>(r): David</a:t>
             </a:r>
           </a:p>
         </p:txBody>
@@ -1463,13 +1695,12 @@
           <a:lstStyle/>
           <a:p>
             <a:r>
-              <a:t>Vortragende(r): David (65 s)</a:t>
-            </a:r>
-          </a:p>
-          <a:p/>
-          <a:p>
-            <a:r>
-              <a:t>RepairFlow ist unsere Antwort darauf. Wichtig für die Einordnung: Wir sind nicht die Werkstatt, wir sind das Software-Startup. FixWerk ist unser Pilotkunde, an dessen Abläufen wir die Plattform entworfen haben. RepairFlow ist eine Cloud-Plattform, die den ganzen Reparatur-Lebenszyklus abdeckt, von der ersten Anfrage bis zur Abholung und Reklamation. Sie besteht aus vier Modulen: dem Kundenportal mit App, dem Auftrags- und Werkstattmodul, dem Dispositionsmodul für Ersatzteile und der Abrechnung. Zielkunden sind unabhängige Werkstätten und kleine Ketten mit zwei bis zehn Filialen. Die physische Reparatur, die Lieferantensysteme und die Buchhaltung bleiben außerhalb; dorthin gibt es nur Schnittstellen.</a:t>
+              <a:rPr dirty="0" err="1"/>
+              <a:t>Vortragende</a:t>
+            </a:r>
+            <a:r>
+              <a:rPr dirty="0"/>
+              <a:t>(r): David</a:t>
             </a:r>
           </a:p>
         </p:txBody>
@@ -1511,6 +1742,62 @@
 </file>
 
 <file path=ppt/notesSlides/notesSlide5.xml><?xml version="1.0" encoding="utf-8"?>
+<p:notes xmlns:a="http://schemas.openxmlformats.org/drawingml/2006/main" xmlns:r="http://schemas.openxmlformats.org/officeDocument/2006/relationships" xmlns:p="http://schemas.openxmlformats.org/presentationml/2006/main">
+  <p:cSld>
+    <p:spTree>
+      <p:nvGrpSpPr>
+        <p:cNvPr id="1" name=""/>
+        <p:cNvGrpSpPr/>
+        <p:nvPr/>
+      </p:nvGrpSpPr>
+      <p:grpSpPr>
+        <a:xfrm>
+          <a:off x="0" y="0"/>
+          <a:ext cx="0" cy="0"/>
+          <a:chOff x="0" y="0"/>
+          <a:chExt cx="0" cy="0"/>
+        </a:xfrm>
+      </p:grpSpPr>
+      <p:sp>
+        <p:nvSpPr>
+          <p:cNvPr id="3" name="Notes Placeholder 2"/>
+          <p:cNvSpPr>
+            <a:spLocks noGrp="1"/>
+          </p:cNvSpPr>
+          <p:nvPr>
+            <p:ph type="body" idx="1"/>
+          </p:nvPr>
+        </p:nvSpPr>
+        <p:spPr/>
+        <p:txBody>
+          <a:bodyPr/>
+          <a:lstStyle/>
+          <a:p>
+            <a:r>
+              <a:rPr dirty="0" err="1"/>
+              <a:t>Vortragende</a:t>
+            </a:r>
+            <a:r>
+              <a:rPr dirty="0"/>
+              <a:t>(r): </a:t>
+            </a:r>
+            <a:r>
+              <a:rPr lang="de-DE" dirty="0"/>
+              <a:t>Kilian</a:t>
+            </a:r>
+            <a:endParaRPr dirty="0"/>
+          </a:p>
+        </p:txBody>
+      </p:sp>
+    </p:spTree>
+  </p:cSld>
+  <p:clrMapOvr>
+    <a:masterClrMapping/>
+  </p:clrMapOvr>
+</p:notes>
+</file>
+
+<file path=ppt/notesSlides/notesSlide6.xml><?xml version="1.0" encoding="utf-8"?>
 <p:notes xmlns:a="http://schemas.openxmlformats.org/drawingml/2006/main" xmlns:r="http://schemas.openxmlformats.org/officeDocument/2006/relationships" xmlns:p="http://schemas.openxmlformats.org/presentationml/2006/main">
   <p:cSld>
     <p:spTree>
@@ -1573,14 +1860,18 @@
           <a:lstStyle/>
           <a:p>
             <a:r>
-              <a:t>Vortragende(r): Kilian (70 s)</a:t>
-            </a:r>
-          </a:p>
-          <a:p/>
-          <a:p>
-            <a:r>
-              <a:t>So sieht eine Reparatur mit RepairFlow aus. Der Kunde schickt per App ein Foto oder Video und bekommt innerhalb einer Minute Vorschlag, vorläufigen Kostenvoranschlag und Terminvorschlag. In der Filiale wird das Gerät registriert und der Auftrag angelegt. Der Techniker prüft den Vorschlag, stellt die Diagnose und erstellt den Kostenvoranschlag, den der Kunde in der App freigibt. Dann disponiert RepairFlow die Teile über alle Filialen und bestellt Fehlteile beim Lieferanten. Nach der Reparatur folgt die Endkontrolle, der Kunde wird benachrichtigt, holt ab und zahlt. Jeder dieser Schritte ist ein Status des Reparaturauftrags: angenommen, in Diagnose, KVA offen, freigegeben, Teile bestellt, in Reparatur, fertig, abgeholt, und abgelehnt, wenn der Kunde den KVA ablehnt oder die Reparatur scheitert. Dieser Zustandsautomat ist der rote Faden durch alle unsere Modelle. Welche Abläufe dahinterstecken, zeigt Maximilian an drei Beispielen.</a:t>
-            </a:r>
+              <a:rPr dirty="0" err="1"/>
+              <a:t>Vortragende</a:t>
+            </a:r>
+            <a:r>
+              <a:rPr dirty="0"/>
+              <a:t>(r): </a:t>
+            </a:r>
+            <a:r>
+              <a:rPr lang="de-DE" dirty="0"/>
+              <a:t>Max</a:t>
+            </a:r>
+            <a:endParaRPr dirty="0"/>
           </a:p>
         </p:txBody>
       </p:sp>
@@ -1617,98 +1908,6 @@
     <p:extLst>
       <p:ext uri="{BB962C8B-B14F-4D97-AF65-F5344CB8AC3E}">
         <p14:creationId xmlns:p14="http://schemas.microsoft.com/office/powerpoint/2010/main" val="3615067622"/>
-      </p:ext>
-    </p:extLst>
-  </p:cSld>
-  <p:clrMapOvr>
-    <a:masterClrMapping/>
-  </p:clrMapOvr>
-</p:notes>
-</file>
-
-<file path=ppt/notesSlides/notesSlide6.xml><?xml version="1.0" encoding="utf-8"?>
-<p:notes xmlns:a="http://schemas.openxmlformats.org/drawingml/2006/main" xmlns:r="http://schemas.openxmlformats.org/officeDocument/2006/relationships" xmlns:p="http://schemas.openxmlformats.org/presentationml/2006/main">
-  <p:cSld>
-    <p:spTree>
-      <p:nvGrpSpPr>
-        <p:cNvPr id="1" name=""/>
-        <p:cNvGrpSpPr/>
-        <p:nvPr/>
-      </p:nvGrpSpPr>
-      <p:grpSpPr>
-        <a:xfrm>
-          <a:off x="0" y="0"/>
-          <a:ext cx="0" cy="0"/>
-          <a:chOff x="0" y="0"/>
-          <a:chExt cx="0" cy="0"/>
-        </a:xfrm>
-      </p:grpSpPr>
-      <p:sp>
-        <p:nvSpPr>
-          <p:cNvPr id="2" name="Slide Image Placeholder 1"/>
-          <p:cNvSpPr>
-            <a:spLocks noGrp="1" noRot="1" noChangeAspect="1"/>
-          </p:cNvSpPr>
-          <p:nvPr>
-            <p:ph type="sldImg"/>
-          </p:nvPr>
-        </p:nvSpPr>
-        <p:spPr/>
-      </p:sp>
-      <p:sp>
-        <p:nvSpPr>
-          <p:cNvPr id="3" name="Notes Placeholder 2"/>
-          <p:cNvSpPr>
-            <a:spLocks noGrp="1"/>
-          </p:cNvSpPr>
-          <p:nvPr>
-            <p:ph type="body" idx="1"/>
-          </p:nvPr>
-        </p:nvSpPr>
-        <p:spPr/>
-        <p:txBody>
-          <a:bodyPr/>
-          <a:lstStyle/>
-          <a:p>
-            <a:r>
-              <a:t>Vortragende(r): Maximilian (80 s)</a:t>
-            </a:r>
-          </a:p>
-          <a:p/>
-          <a:p>
-            <a:r>
-              <a:t>Hinter jedem dieser Schritte steht ein Geschäftsprozess. Drei Stellen zeigen, was die Prozesse leisten. Erstens der Kostenvoranschlag in Prozess 04: Nach dem Versand wartet ein ereignisbasiertes Gateway auf Freigabe, Ablehnung oder den Ablauf von drei Tagen. Bei Fristablauf erinnert RepairFlow den Kunden, höchstens zweimal. Nach dem dritten Fristablauf ohne Antwort gilt der KVA als abgelehnt und das Gerät geht mit Diagnosepauschale zur Abholung. Kein Auftrag bleibt liegen. Zweitens die Disposition in Prozess 05: Für jedes benötigte Teil läuft parallel eine Prüfung, erst im eigenen Lager, dann in den anderen Filialen. Was lokal liegt, wird reserviert, was anderswo liegt, umgelagert, und nur Fehlteile werden bestellt. Drittens die Reklamation in Prozess 09: Der Techniker prüft den Mangel, RepairFlow entscheidet nach Regel über Gewährleistung, und im Gewährleistungsfall gibt die Werkstattleitung einen kostenfreien Nacharbeitsauftrag frei, der wieder durch die normale Auftragsreise läuft. Wie sich das für den Kunden anfühlt, zeige ich Ihnen jetzt in der App.</a:t>
-            </a:r>
-          </a:p>
-        </p:txBody>
-      </p:sp>
-      <p:sp>
-        <p:nvSpPr>
-          <p:cNvPr id="4" name="Slide Number Placeholder 3"/>
-          <p:cNvSpPr>
-            <a:spLocks noGrp="1"/>
-          </p:cNvSpPr>
-          <p:nvPr>
-            <p:ph type="sldNum" sz="quarter" idx="10"/>
-          </p:nvPr>
-        </p:nvSpPr>
-        <p:spPr/>
-        <p:txBody>
-          <a:bodyPr/>
-          <a:lstStyle/>
-          <a:p>
-            <a:fld id="{F7021451-1387-4CA6-816F-3879F97B5CBC}" type="slidenum">
-              <a:rPr lang="en-US"/>
-              <a:t>7</a:t>
-            </a:fld>
-            <a:endParaRPr lang="en-US"/>
-          </a:p>
-        </p:txBody>
-      </p:sp>
-    </p:spTree>
-    <p:extLst>
-      <p:ext uri="{BB962C8B-B14F-4D97-AF65-F5344CB8AC3E}">
-        <p14:creationId xmlns:p14="http://schemas.microsoft.com/office/powerpoint/2010/main" val="1024086991"/>
       </p:ext>
     </p:extLst>
   </p:cSld>
@@ -1763,14 +1962,18 @@
           <a:lstStyle/>
           <a:p>
             <a:r>
-              <a:t>Vortragende(r): Maximilian (70 s)</a:t>
-            </a:r>
-          </a:p>
-          <a:p/>
-          <a:p>
-            <a:r>
-              <a:t>Was Sie gerade in der App gesehen haben, ist unser Alleinstellungsmerkmal, die KI-Sofortdiagnose. Fünf Schritte: Der Kunde nimmt Foto, Video oder Ton auf. Ein KI-Dienst erkennt Gerätetyp, wahrscheinliche Ursache und benötigte Teile. RepairFlow rechnet daraus einen vorläufigen Kostenvoranschlag, prüft die Verfügbarkeit in allen Filialen und schlägt Filiale und Termin vor. Bestätigt der Kunde den Termin, werden die Teile vorreserviert. Heute machbar ist die Erkennung sichtbarer Schäden per Bildanalyse, etwa ein gebrochenes Display oder eine gerissene Kette, dazu ein Vorab-KVA aus Teilepreisen und Aufwandsrichtwerten. Vision sind Geräuschanalyse bei E-Bike-Motoren und eine Aufwandsschätzung aus Video. Deshalb bleibt der Vorschlag immer vorläufig: Der Techniker bestätigt oder korrigiert ihn. Die Medien werden nur mit Einwilligung verarbeitet und nach Abschluss gelöscht. Was hinter all dem steckt, zeigt Adrian.</a:t>
-            </a:r>
+              <a:rPr dirty="0" err="1"/>
+              <a:t>Vortragende</a:t>
+            </a:r>
+            <a:r>
+              <a:rPr dirty="0"/>
+              <a:t>(r): </a:t>
+            </a:r>
+            <a:r>
+              <a:rPr lang="de-DE" dirty="0"/>
+              <a:t>Max</a:t>
+            </a:r>
+            <a:endParaRPr dirty="0"/>
           </a:p>
         </p:txBody>
       </p:sp>
@@ -1791,7 +1994,7 @@
           <a:p>
             <a:fld id="{F7021451-1387-4CA6-816F-3879F97B5CBC}" type="slidenum">
               <a:rPr lang="en-US"/>
-              <a:t>9</a:t>
+              <a:t>7</a:t>
             </a:fld>
             <a:endParaRPr lang="en-US"/>
           </a:p>
@@ -1829,18 +2032,6 @@
       </p:grpSpPr>
       <p:sp>
         <p:nvSpPr>
-          <p:cNvPr id="2" name="Slide Image Placeholder 1"/>
-          <p:cNvSpPr>
-            <a:spLocks noGrp="1" noRot="1" noChangeAspect="1"/>
-          </p:cNvSpPr>
-          <p:nvPr>
-            <p:ph type="sldImg"/>
-          </p:nvPr>
-        </p:nvSpPr>
-        <p:spPr/>
-      </p:sp>
-      <p:sp>
-        <p:nvSpPr>
           <p:cNvPr id="3" name="Notes Placeholder 2"/>
           <p:cNvSpPr>
             <a:spLocks noGrp="1"/>
@@ -1855,46 +2046,22 @@
           <a:lstStyle/>
           <a:p>
             <a:r>
-              <a:t>Vortragende(r): Adrian (50 s)</a:t>
-            </a:r>
-          </a:p>
-          <a:p/>
-          <a:p>
-            <a:r>
-              <a:t>Damit zur zweiten Hälfte: Was steckt hinter dieser Geschichte? Wir haben drei Modelle erstellt, die zusammenpassen. Zehn BPMN-Kollaborationsdiagramme mit 136 Aktivitäten im Werkstatt-Pool, dazu die Abläufe des Kunden. Ein Use-Case-Diagramm mit 19 Use Cases und 17 Rollen und Akteuren. Ein vollständiges Klassendiagramm mit 29 Klassen und 40 Assoziationen. Sechs Sequenzdiagramme, gefordert waren fünf. Alle Modelle liegen im Camunda Modeler und in Visual Paradigm und werden mit der Dokumentation abgegeben.</a:t>
-            </a:r>
-          </a:p>
-        </p:txBody>
-      </p:sp>
-      <p:sp>
-        <p:nvSpPr>
-          <p:cNvPr id="4" name="Slide Number Placeholder 3"/>
-          <p:cNvSpPr>
-            <a:spLocks noGrp="1"/>
-          </p:cNvSpPr>
-          <p:nvPr>
-            <p:ph type="sldNum" sz="quarter" idx="10"/>
-          </p:nvPr>
-        </p:nvSpPr>
-        <p:spPr/>
-        <p:txBody>
-          <a:bodyPr/>
-          <a:lstStyle/>
-          <a:p>
-            <a:fld id="{F7021451-1387-4CA6-816F-3879F97B5CBC}" type="slidenum">
-              <a:rPr lang="en-US"/>
-              <a:t>10</a:t>
-            </a:fld>
-            <a:endParaRPr lang="en-US"/>
+              <a:rPr dirty="0" err="1"/>
+              <a:t>Vortragende</a:t>
+            </a:r>
+            <a:r>
+              <a:rPr dirty="0"/>
+              <a:t>(r): </a:t>
+            </a:r>
+            <a:r>
+              <a:rPr lang="de-DE" dirty="0"/>
+              <a:t>Max</a:t>
+            </a:r>
+            <a:endParaRPr dirty="0"/>
           </a:p>
         </p:txBody>
       </p:sp>
     </p:spTree>
-    <p:extLst>
-      <p:ext uri="{BB962C8B-B14F-4D97-AF65-F5344CB8AC3E}">
-        <p14:creationId xmlns:p14="http://schemas.microsoft.com/office/powerpoint/2010/main" val="1024086991"/>
-      </p:ext>
-    </p:extLst>
   </p:cSld>
   <p:clrMapOvr>
     <a:masterClrMapping/>
@@ -1947,14 +2114,18 @@
           <a:lstStyle/>
           <a:p>
             <a:r>
-              <a:t>Vortragende(r): Adrian (60 s)</a:t>
-            </a:r>
-          </a:p>
-          <a:p/>
-          <a:p>
-            <a:r>
-              <a:t>Die zehn Prozesse decken den gesamten Lebenszyklus ab. Prozesse 01 bis 08 sind die durchgehende Auftragsreise, 09 und 10 die Folgeprozesse Reklamation und Retoure; drei Highlights daraus hat Maximilian schon gezeigt. Jedes Diagramm ist eine Kollaboration: Der Werkstattbetrieb ist der ausführbare Pool mit den Lanes Service, Techniker, Werkstattleitung und Disposition, der Kunde hat seinen eigenen Ablauf, der Lieferant bleibt eine Black Box. Die wichtigste Zahl: 62 Prozent der Aktivitäten führt RepairFlow ohne manuelle Arbeit aus, also Statuswechsel, Benachrichtigungen, Prüfungen, Berechnungen und Regeln. Was Handwerk ist, bleibt Handwerk: Diagnose, Reparatur und Endkontrolle macht der Techniker mit Unterstützung durch das System. Wer im System welche Aufgaben hat, zeigt Kilian.</a:t>
-            </a:r>
+              <a:rPr dirty="0" err="1"/>
+              <a:t>Vortragende</a:t>
+            </a:r>
+            <a:r>
+              <a:rPr dirty="0"/>
+              <a:t>(r): </a:t>
+            </a:r>
+            <a:r>
+              <a:rPr lang="de-DE" dirty="0"/>
+              <a:t>Adrian</a:t>
+            </a:r>
+            <a:endParaRPr dirty="0"/>
           </a:p>
         </p:txBody>
       </p:sp>
@@ -1975,7 +2146,7 @@
           <a:p>
             <a:fld id="{F7021451-1387-4CA6-816F-3879F97B5CBC}" type="slidenum">
               <a:rPr lang="en-US"/>
-              <a:t>11</a:t>
+              <a:t>9</a:t>
             </a:fld>
             <a:endParaRPr lang="en-US"/>
           </a:p>
@@ -2630,7 +2801,7 @@
                 <a:ea typeface="Calibri" pitchFamily="34" charset="-122"/>
                 <a:cs typeface="Calibri" pitchFamily="34" charset="-120"/>
               </a:rPr>
-              <a:t>Abschlusspräsentation · 27.10.2026, 09:00 Uhr · Raum B458</a:t>
+              <a:t>Abschlusspräsentation · 27.10.2026</a:t>
             </a:r>
             <a:endParaRPr lang="en-US" sz="1200" dirty="0"/>
           </a:p>
@@ -14944,32 +15115,6 @@
               </a:rPr>
               <a:t>Beiträge der Vortragenden</a:t>
             </a:r>
-            <a:r>
-              <a:rPr lang="en-US" sz="2800" b="1" dirty="0">
-                <a:solidFill>
-                  <a:schemeClr val="accent2">
-                    <a:lumMod val="75000"/>
-                  </a:schemeClr>
-                </a:solidFill>
-                <a:latin typeface="Segoe UI" panose="020B0502040204020203" pitchFamily="34" charset="0"/>
-                <a:ea typeface="Calibri" pitchFamily="34" charset="-122"/>
-                <a:cs typeface="Segoe UI" panose="020B0502040204020203" pitchFamily="34" charset="0"/>
-              </a:rPr>
-              <a:t/>
-            </a:r>
-            <a:r>
-              <a:rPr lang="en-US" sz="2800" b="1" dirty="0" err="1">
-                <a:solidFill>
-                  <a:schemeClr val="accent2">
-                    <a:lumMod val="75000"/>
-                  </a:schemeClr>
-                </a:solidFill>
-                <a:latin typeface="Segoe UI" panose="020B0502040204020203" pitchFamily="34" charset="0"/>
-                <a:ea typeface="Calibri" pitchFamily="34" charset="-122"/>
-                <a:cs typeface="Segoe UI" panose="020B0502040204020203" pitchFamily="34" charset="0"/>
-              </a:rPr>
-              <a:t/>
-            </a:r>
             <a:endParaRPr lang="en-US" sz="2800" dirty="0">
               <a:solidFill>
                 <a:schemeClr val="accent2">
@@ -18049,7 +18194,7 @@
           <a:blip>
             <a:extLst>
               <a:ext uri="{96DAC541-7B7A-43D3-8B79-37D633B846F1}">
-                <asvg:svgBlip xmlns:asvg="http://schemas.microsoft.com/office/drawing/2016/SVG/main" r:embed="rId2"/>
+                <asvg:svgBlip xmlns:asvg="http://schemas.microsoft.com/office/drawing/2016/SVG/main" r:embed="rId3"/>
               </a:ext>
             </a:extLst>
           </a:blip>
@@ -18085,7 +18230,7 @@
           <a:blip>
             <a:extLst>
               <a:ext uri="{96DAC541-7B7A-43D3-8B79-37D633B846F1}">
-                <asvg:svgBlip xmlns:asvg="http://schemas.microsoft.com/office/drawing/2016/SVG/main" r:embed="rId3"/>
+                <asvg:svgBlip xmlns:asvg="http://schemas.microsoft.com/office/drawing/2016/SVG/main" r:embed="rId4"/>
               </a:ext>
             </a:extLst>
           </a:blip>
@@ -18121,7 +18266,7 @@
           <a:blip>
             <a:extLst>
               <a:ext uri="{96DAC541-7B7A-43D3-8B79-37D633B846F1}">
-                <asvg:svgBlip xmlns:asvg="http://schemas.microsoft.com/office/drawing/2016/SVG/main" r:embed="rId4"/>
+                <asvg:svgBlip xmlns:asvg="http://schemas.microsoft.com/office/drawing/2016/SVG/main" r:embed="rId5"/>
               </a:ext>
             </a:extLst>
           </a:blip>

</xml_diff>

<commit_message>
docs: Sprechtexte und Folien vereinfacht + mockup
</commit_message>
<xml_diff>
--- a/4_praesentation/Abschlusspraesentation.pptx
+++ b/4_praesentation/Abschlusspraesentation.pptx
@@ -10,19 +10,19 @@
   <p:sldIdLst>
     <p:sldId id="256" r:id="rId2"/>
     <p:sldId id="279" r:id="rId3"/>
-    <p:sldId id="258" r:id="rId4"/>
-    <p:sldId id="259" r:id="rId5"/>
-    <p:sldId id="274" r:id="rId6"/>
+    <p:sldId id="284" r:id="rId4"/>
+    <p:sldId id="285" r:id="rId5"/>
+    <p:sldId id="281" r:id="rId6"/>
     <p:sldId id="276" r:id="rId7"/>
     <p:sldId id="265" r:id="rId8"/>
     <p:sldId id="280" r:id="rId9"/>
     <p:sldId id="262" r:id="rId10"/>
     <p:sldId id="263" r:id="rId11"/>
     <p:sldId id="264" r:id="rId12"/>
-    <p:sldId id="266" r:id="rId13"/>
-    <p:sldId id="267" r:id="rId14"/>
-    <p:sldId id="269" r:id="rId15"/>
-    <p:sldId id="270" r:id="rId16"/>
+    <p:sldId id="282" r:id="rId13"/>
+    <p:sldId id="283" r:id="rId14"/>
+    <p:sldId id="286" r:id="rId15"/>
+    <p:sldId id="287" r:id="rId16"/>
     <p:sldId id="268" r:id="rId17"/>
     <p:sldId id="271" r:id="rId18"/>
     <p:sldId id="272" r:id="rId19"/>
@@ -129,13 +129,13 @@
           <p14:sldIdLst>
             <p14:sldId id="256"/>
             <p14:sldId id="279"/>
-            <p14:sldId id="258"/>
-            <p14:sldId id="259"/>
+            <p14:sldId id="284"/>
+            <p14:sldId id="285"/>
           </p14:sldIdLst>
         </p14:section>
         <p14:section name="Kilian" id="{1139A1D9-944E-3441-9BD8-35E9CEF6D225}">
           <p14:sldIdLst>
-            <p14:sldId id="274"/>
+            <p14:sldId id="281"/>
           </p14:sldIdLst>
         </p14:section>
         <p14:section name="Maximilian" id="{0B64C47C-C681-8643-8A72-028DC518B57D}">
@@ -154,14 +154,14 @@
         </p14:section>
         <p14:section name="Kilian" id="{2F11BAA1-0B73-6D4F-B882-B2353546D24B}">
           <p14:sldIdLst>
-            <p14:sldId id="266"/>
-            <p14:sldId id="267"/>
+            <p14:sldId id="282"/>
+            <p14:sldId id="283"/>
           </p14:sldIdLst>
         </p14:section>
         <p14:section name="Jakob" id="{7DC776A1-7D7D-F548-992F-CA5AB6B455F2}">
           <p14:sldIdLst>
-            <p14:sldId id="269"/>
-            <p14:sldId id="270"/>
+            <p14:sldId id="286"/>
+            <p14:sldId id="287"/>
           </p14:sldIdLst>
         </p14:section>
         <p14:section name="Nina" id="{0D502D7A-3C1B-1F4A-BB67-E47EF2FFD626}">
@@ -185,8 +185,8 @@
 <pc:chgInfo xmlns:a="http://schemas.openxmlformats.org/drawingml/2006/main" xmlns:r="http://schemas.openxmlformats.org/officeDocument/2006/relationships" xmlns:ac="http://schemas.microsoft.com/office/drawing/2013/main/command" xmlns:pc="http://schemas.microsoft.com/office/powerpoint/2013/main/command">
   <pc:docChgLst>
     <pc:chgData name="Kilian Platter" userId="c49eb2881fa751ca" providerId="LiveId" clId="{FDA102BF-EFD5-549B-81DE-49FC5087B7E9}"/>
-    <pc:docChg chg="modSld sldOrd modSection">
-      <pc:chgData name="Kilian Platter" userId="c49eb2881fa751ca" providerId="LiveId" clId="{FDA102BF-EFD5-549B-81DE-49FC5087B7E9}" dt="2026-10-24T10:30:11.968" v="53" actId="20577"/>
+    <pc:docChg chg="addSld delSld modSld sldOrd modSection">
+      <pc:chgData name="Kilian Platter" userId="c49eb2881fa751ca" providerId="LiveId" clId="{FDA102BF-EFD5-549B-81DE-49FC5087B7E9}" dt="2026-10-24T11:35:00.904" v="69" actId="2696"/>
       <pc:docMkLst>
         <pc:docMk/>
       </pc:docMkLst>
@@ -205,15 +205,15 @@
           </ac:spMkLst>
         </pc:spChg>
       </pc:sldChg>
-      <pc:sldChg chg="modNotesTx">
-        <pc:chgData name="Kilian Platter" userId="c49eb2881fa751ca" providerId="LiveId" clId="{FDA102BF-EFD5-549B-81DE-49FC5087B7E9}" dt="2026-10-24T10:24:46.532" v="15" actId="20577"/>
+      <pc:sldChg chg="del modNotesTx">
+        <pc:chgData name="Kilian Platter" userId="c49eb2881fa751ca" providerId="LiveId" clId="{FDA102BF-EFD5-549B-81DE-49FC5087B7E9}" dt="2026-10-24T11:34:28.793" v="63" actId="2696"/>
         <pc:sldMkLst>
           <pc:docMk/>
           <pc:sldMk cId="0" sldId="258"/>
         </pc:sldMkLst>
       </pc:sldChg>
-      <pc:sldChg chg="modNotesTx">
-        <pc:chgData name="Kilian Platter" userId="c49eb2881fa751ca" providerId="LiveId" clId="{FDA102BF-EFD5-549B-81DE-49FC5087B7E9}" dt="2026-10-24T10:24:51.620" v="16" actId="20577"/>
+      <pc:sldChg chg="del modNotesTx">
+        <pc:chgData name="Kilian Platter" userId="c49eb2881fa751ca" providerId="LiveId" clId="{FDA102BF-EFD5-549B-81DE-49FC5087B7E9}" dt="2026-10-24T11:34:36.314" v="65" actId="2696"/>
         <pc:sldMkLst>
           <pc:docMk/>
           <pc:sldMk cId="0" sldId="259"/>
@@ -247,15 +247,15 @@
           <pc:sldMk cId="0" sldId="265"/>
         </pc:sldMkLst>
       </pc:sldChg>
-      <pc:sldChg chg="modNotesTx">
-        <pc:chgData name="Kilian Platter" userId="c49eb2881fa751ca" providerId="LiveId" clId="{FDA102BF-EFD5-549B-81DE-49FC5087B7E9}" dt="2026-10-24T10:25:49.504" v="24" actId="20577"/>
+      <pc:sldChg chg="del modNotesTx">
+        <pc:chgData name="Kilian Platter" userId="c49eb2881fa751ca" providerId="LiveId" clId="{FDA102BF-EFD5-549B-81DE-49FC5087B7E9}" dt="2026-10-24T11:32:30.127" v="57" actId="2696"/>
         <pc:sldMkLst>
           <pc:docMk/>
           <pc:sldMk cId="0" sldId="266"/>
         </pc:sldMkLst>
       </pc:sldChg>
-      <pc:sldChg chg="modNotesTx">
-        <pc:chgData name="Kilian Platter" userId="c49eb2881fa751ca" providerId="LiveId" clId="{FDA102BF-EFD5-549B-81DE-49FC5087B7E9}" dt="2026-10-24T10:25:55.597" v="25" actId="20577"/>
+      <pc:sldChg chg="del modNotesTx">
+        <pc:chgData name="Kilian Platter" userId="c49eb2881fa751ca" providerId="LiveId" clId="{FDA102BF-EFD5-549B-81DE-49FC5087B7E9}" dt="2026-10-24T11:32:58.384" v="59" actId="2696"/>
         <pc:sldMkLst>
           <pc:docMk/>
           <pc:sldMk cId="0" sldId="267"/>
@@ -268,15 +268,15 @@
           <pc:sldMk cId="1220583403" sldId="268"/>
         </pc:sldMkLst>
       </pc:sldChg>
-      <pc:sldChg chg="modNotesTx">
-        <pc:chgData name="Kilian Platter" userId="c49eb2881fa751ca" providerId="LiveId" clId="{FDA102BF-EFD5-549B-81DE-49FC5087B7E9}" dt="2026-10-24T10:26:00.512" v="26" actId="20577"/>
+      <pc:sldChg chg="del modNotesTx">
+        <pc:chgData name="Kilian Platter" userId="c49eb2881fa751ca" providerId="LiveId" clId="{FDA102BF-EFD5-549B-81DE-49FC5087B7E9}" dt="2026-10-24T11:34:54.600" v="67" actId="2696"/>
         <pc:sldMkLst>
           <pc:docMk/>
           <pc:sldMk cId="0" sldId="269"/>
         </pc:sldMkLst>
       </pc:sldChg>
-      <pc:sldChg chg="modNotesTx">
-        <pc:chgData name="Kilian Platter" userId="c49eb2881fa751ca" providerId="LiveId" clId="{FDA102BF-EFD5-549B-81DE-49FC5087B7E9}" dt="2026-10-24T10:26:07.444" v="27" actId="20577"/>
+      <pc:sldChg chg="del modNotesTx">
+        <pc:chgData name="Kilian Platter" userId="c49eb2881fa751ca" providerId="LiveId" clId="{FDA102BF-EFD5-549B-81DE-49FC5087B7E9}" dt="2026-10-24T11:35:00.904" v="69" actId="2696"/>
         <pc:sldMkLst>
           <pc:docMk/>
           <pc:sldMk cId="8933715" sldId="270"/>
@@ -303,8 +303,8 @@
           <pc:sldMk cId="0" sldId="273"/>
         </pc:sldMkLst>
       </pc:sldChg>
-      <pc:sldChg chg="modNotesTx">
-        <pc:chgData name="Kilian Platter" userId="c49eb2881fa751ca" providerId="LiveId" clId="{FDA102BF-EFD5-549B-81DE-49FC5087B7E9}" dt="2026-10-24T10:29:55.216" v="43" actId="20577"/>
+      <pc:sldChg chg="del modNotesTx">
+        <pc:chgData name="Kilian Platter" userId="c49eb2881fa751ca" providerId="LiveId" clId="{FDA102BF-EFD5-549B-81DE-49FC5087B7E9}" dt="2026-10-24T11:32:07.142" v="55" actId="2696"/>
         <pc:sldMkLst>
           <pc:docMk/>
           <pc:sldMk cId="7463954" sldId="274"/>
@@ -329,6 +329,55 @@
         <pc:sldMkLst>
           <pc:docMk/>
           <pc:sldMk cId="3044169480" sldId="280"/>
+        </pc:sldMkLst>
+      </pc:sldChg>
+      <pc:sldChg chg="add">
+        <pc:chgData name="Kilian Platter" userId="c49eb2881fa751ca" providerId="LiveId" clId="{FDA102BF-EFD5-549B-81DE-49FC5087B7E9}" dt="2026-10-24T11:32:02.070" v="54"/>
+        <pc:sldMkLst>
+          <pc:docMk/>
+          <pc:sldMk cId="866893269" sldId="281"/>
+        </pc:sldMkLst>
+      </pc:sldChg>
+      <pc:sldChg chg="add setBg">
+        <pc:chgData name="Kilian Platter" userId="c49eb2881fa751ca" providerId="LiveId" clId="{FDA102BF-EFD5-549B-81DE-49FC5087B7E9}" dt="2026-10-24T11:32:26.169" v="56"/>
+        <pc:sldMkLst>
+          <pc:docMk/>
+          <pc:sldMk cId="0" sldId="282"/>
+        </pc:sldMkLst>
+      </pc:sldChg>
+      <pc:sldChg chg="add setBg">
+        <pc:chgData name="Kilian Platter" userId="c49eb2881fa751ca" providerId="LiveId" clId="{FDA102BF-EFD5-549B-81DE-49FC5087B7E9}" dt="2026-10-24T11:32:53.375" v="58"/>
+        <pc:sldMkLst>
+          <pc:docMk/>
+          <pc:sldMk cId="0" sldId="283"/>
+        </pc:sldMkLst>
+      </pc:sldChg>
+      <pc:sldChg chg="add del setBg">
+        <pc:chgData name="Kilian Platter" userId="c49eb2881fa751ca" providerId="LiveId" clId="{FDA102BF-EFD5-549B-81DE-49FC5087B7E9}" dt="2026-10-24T11:34:27.546" v="62"/>
+        <pc:sldMkLst>
+          <pc:docMk/>
+          <pc:sldMk cId="0" sldId="284"/>
+        </pc:sldMkLst>
+      </pc:sldChg>
+      <pc:sldChg chg="add setBg">
+        <pc:chgData name="Kilian Platter" userId="c49eb2881fa751ca" providerId="LiveId" clId="{FDA102BF-EFD5-549B-81DE-49FC5087B7E9}" dt="2026-10-24T11:34:33.716" v="64"/>
+        <pc:sldMkLst>
+          <pc:docMk/>
+          <pc:sldMk cId="0" sldId="285"/>
+        </pc:sldMkLst>
+      </pc:sldChg>
+      <pc:sldChg chg="add setBg">
+        <pc:chgData name="Kilian Platter" userId="c49eb2881fa751ca" providerId="LiveId" clId="{FDA102BF-EFD5-549B-81DE-49FC5087B7E9}" dt="2026-10-24T11:34:51.179" v="66"/>
+        <pc:sldMkLst>
+          <pc:docMk/>
+          <pc:sldMk cId="0" sldId="286"/>
+        </pc:sldMkLst>
+      </pc:sldChg>
+      <pc:sldChg chg="add">
+        <pc:chgData name="Kilian Platter" userId="c49eb2881fa751ca" providerId="LiveId" clId="{FDA102BF-EFD5-549B-81DE-49FC5087B7E9}" dt="2026-10-24T11:34:58.692" v="68"/>
+        <pc:sldMkLst>
+          <pc:docMk/>
+          <pc:sldMk cId="1146934768" sldId="287"/>
         </pc:sldMkLst>
       </pc:sldChg>
     </pc:docChg>
@@ -7089,15 +7138,7 @@
 
 <file path=ppt/slides/slide12.xml><?xml version="1.0" encoding="utf-8"?>
 <p:sld xmlns:a="http://schemas.openxmlformats.org/drawingml/2006/main" xmlns:r="http://schemas.openxmlformats.org/officeDocument/2006/relationships" xmlns:p="http://schemas.openxmlformats.org/presentationml/2006/main">
-  <p:cSld name="Slide 11">
-    <p:bg>
-      <p:bgPr>
-        <a:solidFill>
-          <a:srgbClr val="FFFFFF"/>
-        </a:solidFill>
-        <a:effectLst/>
-      </p:bgPr>
-    </p:bg>
+  <p:cSld>
     <p:spTree>
       <p:nvGrpSpPr>
         <p:cNvPr id="1" name=""/>
@@ -7120,8 +7161,8 @@
         </p:nvSpPr>
         <p:spPr>
           <a:xfrm>
-            <a:off x="457200" y="274320"/>
-            <a:ext cx="8229600" cy="640080"/>
+            <a:off x="457200" y="249382"/>
+            <a:ext cx="8229600" cy="914400"/>
           </a:xfrm>
           <a:prstGeom prst="rect">
             <a:avLst/>
@@ -7130,14 +7171,14 @@
           <a:ln/>
         </p:spPr>
         <p:txBody>
-          <a:bodyPr wrap="square" lIns="0" tIns="0" rIns="0" bIns="0" rtlCol="0" anchor="ctr"/>
+          <a:bodyPr wrap="square" lIns="0" tIns="0" rIns="0" bIns="0" rtlCol="0" anchor="t"/>
           <a:lstStyle/>
           <a:p>
             <a:pPr marL="0" indent="0">
               <a:buNone/>
             </a:pPr>
             <a:r>
-              <a:rPr lang="en-US" sz="2800" b="1" dirty="0">
+              <a:rPr lang="de-DE" sz="2800" b="1" dirty="0">
                 <a:solidFill>
                   <a:schemeClr val="accent2">
                     <a:lumMod val="75000"/>
@@ -7147,17 +7188,24 @@
                 <a:ea typeface="Calibri" pitchFamily="34" charset="-122"/>
                 <a:cs typeface="Segoe UI" panose="020B0502040204020203" pitchFamily="34" charset="0"/>
               </a:rPr>
-              <a:t>Wer macht was im System: Rollen und Use Cases</a:t>
-            </a:r>
-            <a:endParaRPr lang="en-US" sz="2800" dirty="0">
-              <a:solidFill>
-                <a:schemeClr val="accent2">
-                  <a:lumMod val="75000"/>
-                </a:schemeClr>
-              </a:solidFill>
-              <a:latin typeface="Segoe UI" panose="020B0502040204020203" pitchFamily="34" charset="0"/>
-              <a:cs typeface="Segoe UI" panose="020B0502040204020203" pitchFamily="34" charset="0"/>
-            </a:endParaRPr>
+              <a:t>Wer macht was im System?</a:t>
+            </a:r>
+            <a:endParaRPr lang="de-DE" sz="2800"/>
+          </a:p>
+          <a:p>
+            <a:r>
+              <a:rPr lang="de-DE" sz="1400" dirty="0">
+                <a:solidFill>
+                  <a:schemeClr val="bg1">
+                    <a:lumMod val="50000"/>
+                  </a:schemeClr>
+                </a:solidFill>
+                <a:latin typeface="Segoe UI" panose="020B0502040204020203" pitchFamily="34" charset="0"/>
+                <a:ea typeface="Calibri" pitchFamily="34" charset="-122"/>
+                <a:cs typeface="Segoe UI" panose="020B0502040204020203" pitchFamily="34" charset="0"/>
+              </a:rPr>
+              <a:t>19 Use Cases in vier Bereichen. Jeder Use Case hat genau eine Rolle.</a:t>
+            </a:r>
           </a:p>
         </p:txBody>
       </p:sp>
@@ -7232,7 +7280,7 @@
           <a:lstStyle/>
           <a:p>
             <a:r>
-              <a:rPr lang="en-US" sz="1200" dirty="0">
+              <a:rPr lang="de-DE" sz="1400" b="1" dirty="0">
                 <a:solidFill>
                   <a:srgbClr val="1B2430"/>
                 </a:solidFill>
@@ -7242,14 +7290,14 @@
               </a:rPr>
               <a:t>3 Use Cases</a:t>
             </a:r>
-            <a:endParaRPr lang="en-US" sz="1200" dirty="0"/>
-          </a:p>
-          <a:p>
-            <a:endParaRPr lang="en-US" sz="1200" dirty="0"/>
-          </a:p>
-          <a:p>
-            <a:r>
-              <a:rPr lang="en-US" sz="1200" dirty="0">
+            <a:endParaRPr lang="de-DE" sz="1400"/>
+          </a:p>
+          <a:p>
+            <a:endParaRPr lang="de-DE" sz="1400"/>
+          </a:p>
+          <a:p>
+            <a:r>
+              <a:rPr lang="de-DE" sz="1400" dirty="0">
                 <a:solidFill>
                   <a:srgbClr val="1B2430"/>
                 </a:solidFill>
@@ -7257,10 +7305,13 @@
                 <a:ea typeface="Calibri" pitchFamily="34" charset="-122"/>
                 <a:cs typeface="Calibri" pitchFamily="34" charset="-120"/>
               </a:rPr>
-              <a:t>Kunde: </a:t>
-            </a:r>
-            <a:r>
-              <a:rPr lang="en-US" sz="1200" dirty="0" err="1">
+              <a:t>Kunde</a:t>
+            </a:r>
+            <a:endParaRPr lang="de-DE" sz="1400"/>
+          </a:p>
+          <a:p>
+            <a:r>
+              <a:rPr lang="de-DE" sz="1400" dirty="0">
                 <a:solidFill>
                   <a:srgbClr val="1B2430"/>
                 </a:solidFill>
@@ -7268,153 +7319,9 @@
                 <a:ea typeface="Calibri" pitchFamily="34" charset="-122"/>
                 <a:cs typeface="Calibri" pitchFamily="34" charset="-120"/>
               </a:rPr>
-              <a:t>Sofortdiagnose</a:t>
-            </a:r>
-            <a:r>
-              <a:rPr lang="en-US" sz="1200" dirty="0">
-                <a:solidFill>
-                  <a:srgbClr val="1B2430"/>
-                </a:solidFill>
-                <a:latin typeface="Calibri" pitchFamily="34" charset="0"/>
-                <a:ea typeface="Calibri" pitchFamily="34" charset="-122"/>
-                <a:cs typeface="Calibri" pitchFamily="34" charset="-120"/>
-              </a:rPr>
-              <a:t> </a:t>
-            </a:r>
-            <a:r>
-              <a:rPr lang="en-US" sz="1200" dirty="0" err="1">
-                <a:solidFill>
-                  <a:srgbClr val="1B2430"/>
-                </a:solidFill>
-                <a:latin typeface="Calibri" pitchFamily="34" charset="0"/>
-                <a:ea typeface="Calibri" pitchFamily="34" charset="-122"/>
-                <a:cs typeface="Calibri" pitchFamily="34" charset="-120"/>
-              </a:rPr>
-              <a:t>anfordern</a:t>
-            </a:r>
-            <a:r>
-              <a:rPr lang="en-US" sz="1200" dirty="0">
-                <a:solidFill>
-                  <a:srgbClr val="1B2430"/>
-                </a:solidFill>
-                <a:latin typeface="Calibri" pitchFamily="34" charset="0"/>
-                <a:ea typeface="Calibri" pitchFamily="34" charset="-122"/>
-                <a:cs typeface="Calibri" pitchFamily="34" charset="-120"/>
-              </a:rPr>
-              <a:t>, </a:t>
-            </a:r>
-            <a:r>
-              <a:rPr lang="en-US" sz="1200" dirty="0" err="1">
-                <a:solidFill>
-                  <a:srgbClr val="1B2430"/>
-                </a:solidFill>
-                <a:latin typeface="Calibri" pitchFamily="34" charset="0"/>
-                <a:ea typeface="Calibri" pitchFamily="34" charset="-122"/>
-                <a:cs typeface="Calibri" pitchFamily="34" charset="-120"/>
-              </a:rPr>
-              <a:t>Voranmeldung</a:t>
-            </a:r>
-            <a:r>
-              <a:rPr lang="en-US" sz="1200" dirty="0">
-                <a:solidFill>
-                  <a:srgbClr val="1B2430"/>
-                </a:solidFill>
-                <a:latin typeface="Calibri" pitchFamily="34" charset="0"/>
-                <a:ea typeface="Calibri" pitchFamily="34" charset="-122"/>
-                <a:cs typeface="Calibri" pitchFamily="34" charset="-120"/>
-              </a:rPr>
-              <a:t> </a:t>
-            </a:r>
-            <a:r>
-              <a:rPr lang="en-US" sz="1200" dirty="0" err="1">
-                <a:solidFill>
-                  <a:srgbClr val="1B2430"/>
-                </a:solidFill>
-                <a:latin typeface="Calibri" pitchFamily="34" charset="0"/>
-                <a:ea typeface="Calibri" pitchFamily="34" charset="-122"/>
-                <a:cs typeface="Calibri" pitchFamily="34" charset="-120"/>
-              </a:rPr>
-              <a:t>bestätigen</a:t>
-            </a:r>
-            <a:r>
-              <a:rPr lang="en-US" sz="1200" dirty="0">
-                <a:solidFill>
-                  <a:srgbClr val="1B2430"/>
-                </a:solidFill>
-                <a:latin typeface="Calibri" pitchFamily="34" charset="0"/>
-                <a:ea typeface="Calibri" pitchFamily="34" charset="-122"/>
-                <a:cs typeface="Calibri" pitchFamily="34" charset="-120"/>
-              </a:rPr>
-              <a:t>, KVA </a:t>
-            </a:r>
-            <a:r>
-              <a:rPr lang="en-US" sz="1200" dirty="0" err="1">
-                <a:solidFill>
-                  <a:srgbClr val="1B2430"/>
-                </a:solidFill>
-                <a:latin typeface="Calibri" pitchFamily="34" charset="0"/>
-                <a:ea typeface="Calibri" pitchFamily="34" charset="-122"/>
-                <a:cs typeface="Calibri" pitchFamily="34" charset="-120"/>
-              </a:rPr>
-              <a:t>freigeben</a:t>
-            </a:r>
-            <a:r>
-              <a:rPr lang="en-US" sz="1200" dirty="0">
-                <a:solidFill>
-                  <a:srgbClr val="1B2430"/>
-                </a:solidFill>
-                <a:latin typeface="Calibri" pitchFamily="34" charset="0"/>
-                <a:ea typeface="Calibri" pitchFamily="34" charset="-122"/>
-                <a:cs typeface="Calibri" pitchFamily="34" charset="-120"/>
-              </a:rPr>
-              <a:t> / </a:t>
-            </a:r>
-            <a:r>
-              <a:rPr lang="en-US" sz="1200" dirty="0" err="1">
-                <a:solidFill>
-                  <a:srgbClr val="1B2430"/>
-                </a:solidFill>
-                <a:latin typeface="Calibri" pitchFamily="34" charset="0"/>
-                <a:ea typeface="Calibri" pitchFamily="34" charset="-122"/>
-                <a:cs typeface="Calibri" pitchFamily="34" charset="-120"/>
-              </a:rPr>
-              <a:t>ablehnen</a:t>
-            </a:r>
-            <a:endParaRPr lang="en-US" sz="1200" dirty="0"/>
-          </a:p>
-          <a:p>
-            <a:endParaRPr lang="en-US" sz="1200" dirty="0"/>
-          </a:p>
-          <a:p>
-            <a:r>
-              <a:rPr lang="en-US" sz="1200" dirty="0">
-                <a:solidFill>
-                  <a:srgbClr val="1B2430"/>
-                </a:solidFill>
-                <a:latin typeface="Calibri" pitchFamily="34" charset="0"/>
-                <a:ea typeface="Calibri" pitchFamily="34" charset="-122"/>
-                <a:cs typeface="Calibri" pitchFamily="34" charset="-120"/>
-              </a:rPr>
-              <a:t>extern: KI-</a:t>
-            </a:r>
-            <a:r>
-              <a:rPr lang="en-US" sz="1200" dirty="0" err="1">
-                <a:solidFill>
-                  <a:srgbClr val="1B2430"/>
-                </a:solidFill>
-                <a:latin typeface="Calibri" pitchFamily="34" charset="0"/>
-                <a:ea typeface="Calibri" pitchFamily="34" charset="-122"/>
-                <a:cs typeface="Calibri" pitchFamily="34" charset="-120"/>
-              </a:rPr>
-              <a:t>Diagnosedienst</a:t>
-            </a:r>
-            <a:endParaRPr lang="en-US" sz="1200" dirty="0"/>
-          </a:p>
-          <a:p>
-            <a:endParaRPr lang="en-US" sz="1150" dirty="0">
-              <a:latin typeface="Segoe UI" panose="020B0502040204020203" pitchFamily="34" charset="0"/>
-              <a:cs typeface="Segoe UI" panose="020B0502040204020203" pitchFamily="34" charset="0"/>
-            </a:endParaRPr>
+              <a:t>KI-Diagnosedienst (extern)</a:t>
+            </a:r>
+            <a:endParaRPr lang="de-DE" sz="1400"/>
           </a:p>
         </p:txBody>
       </p:sp>
@@ -7489,7 +7396,7 @@
           <a:lstStyle/>
           <a:p>
             <a:r>
-              <a:rPr lang="en-US" sz="1200" dirty="0">
+              <a:rPr lang="de-DE" sz="1400" b="1" dirty="0">
                 <a:solidFill>
                   <a:srgbClr val="1B2430"/>
                 </a:solidFill>
@@ -7499,14 +7406,14 @@
               </a:rPr>
               <a:t>9 Use Cases</a:t>
             </a:r>
-            <a:endParaRPr lang="en-US" sz="1200" dirty="0"/>
-          </a:p>
-          <a:p>
-            <a:endParaRPr lang="en-US" sz="1200" dirty="0"/>
-          </a:p>
-          <a:p>
-            <a:r>
-              <a:rPr lang="en-US" sz="1200" dirty="0" err="1">
+            <a:endParaRPr lang="de-DE" sz="1400"/>
+          </a:p>
+          <a:p>
+            <a:endParaRPr lang="de-DE" sz="1400"/>
+          </a:p>
+          <a:p>
+            <a:r>
+              <a:rPr lang="de-DE" sz="1400" dirty="0">
                 <a:solidFill>
                   <a:srgbClr val="1B2430"/>
                 </a:solidFill>
@@ -7514,191 +7421,9 @@
                 <a:ea typeface="Calibri" pitchFamily="34" charset="-122"/>
                 <a:cs typeface="Calibri" pitchFamily="34" charset="-120"/>
               </a:rPr>
-              <a:t>Serviceannahme</a:t>
-            </a:r>
-            <a:r>
-              <a:rPr lang="en-US" sz="1200" dirty="0">
-                <a:solidFill>
-                  <a:srgbClr val="1B2430"/>
-                </a:solidFill>
-                <a:latin typeface="Calibri" pitchFamily="34" charset="0"/>
-                <a:ea typeface="Calibri" pitchFamily="34" charset="-122"/>
-                <a:cs typeface="Calibri" pitchFamily="34" charset="-120"/>
-              </a:rPr>
-              <a:t>, </a:t>
-            </a:r>
-            <a:r>
-              <a:rPr lang="en-US" sz="1200" dirty="0" err="1">
-                <a:solidFill>
-                  <a:srgbClr val="1B2430"/>
-                </a:solidFill>
-                <a:latin typeface="Calibri" pitchFamily="34" charset="0"/>
-                <a:ea typeface="Calibri" pitchFamily="34" charset="-122"/>
-                <a:cs typeface="Calibri" pitchFamily="34" charset="-120"/>
-              </a:rPr>
-              <a:t>Diagnoseprüfer</a:t>
-            </a:r>
-            <a:r>
-              <a:rPr lang="en-US" sz="1200" dirty="0">
-                <a:solidFill>
-                  <a:srgbClr val="1B2430"/>
-                </a:solidFill>
-                <a:latin typeface="Calibri" pitchFamily="34" charset="0"/>
-                <a:ea typeface="Calibri" pitchFamily="34" charset="-122"/>
-                <a:cs typeface="Calibri" pitchFamily="34" charset="-120"/>
-              </a:rPr>
-              <a:t>, </a:t>
-            </a:r>
-            <a:r>
-              <a:rPr lang="en-US" sz="1200" dirty="0" err="1">
-                <a:solidFill>
-                  <a:srgbClr val="1B2430"/>
-                </a:solidFill>
-                <a:latin typeface="Calibri" pitchFamily="34" charset="0"/>
-                <a:ea typeface="Calibri" pitchFamily="34" charset="-122"/>
-                <a:cs typeface="Calibri" pitchFamily="34" charset="-120"/>
-              </a:rPr>
-              <a:t>Diagnostiker</a:t>
-            </a:r>
-            <a:r>
-              <a:rPr lang="en-US" sz="1200" dirty="0">
-                <a:solidFill>
-                  <a:srgbClr val="1B2430"/>
-                </a:solidFill>
-                <a:latin typeface="Calibri" pitchFamily="34" charset="0"/>
-                <a:ea typeface="Calibri" pitchFamily="34" charset="-122"/>
-                <a:cs typeface="Calibri" pitchFamily="34" charset="-120"/>
-              </a:rPr>
-              <a:t>, </a:t>
-            </a:r>
-            <a:r>
-              <a:rPr lang="en-US" sz="1200" dirty="0" err="1">
-                <a:solidFill>
-                  <a:srgbClr val="1B2430"/>
-                </a:solidFill>
-                <a:latin typeface="Calibri" pitchFamily="34" charset="0"/>
-                <a:ea typeface="Calibri" pitchFamily="34" charset="-122"/>
-                <a:cs typeface="Calibri" pitchFamily="34" charset="-120"/>
-              </a:rPr>
-              <a:t>Kalkulator</a:t>
-            </a:r>
-            <a:r>
-              <a:rPr lang="en-US" sz="1200" dirty="0">
-                <a:solidFill>
-                  <a:srgbClr val="1B2430"/>
-                </a:solidFill>
-                <a:latin typeface="Calibri" pitchFamily="34" charset="0"/>
-                <a:ea typeface="Calibri" pitchFamily="34" charset="-122"/>
-                <a:cs typeface="Calibri" pitchFamily="34" charset="-120"/>
-              </a:rPr>
-              <a:t>, </a:t>
-            </a:r>
-            <a:r>
-              <a:rPr lang="en-US" sz="1200" dirty="0" err="1">
-                <a:solidFill>
-                  <a:srgbClr val="1B2430"/>
-                </a:solidFill>
-                <a:latin typeface="Calibri" pitchFamily="34" charset="0"/>
-                <a:ea typeface="Calibri" pitchFamily="34" charset="-122"/>
-                <a:cs typeface="Calibri" pitchFamily="34" charset="-120"/>
-              </a:rPr>
-              <a:t>Werkstattplaner</a:t>
-            </a:r>
-            <a:r>
-              <a:rPr lang="en-US" sz="1200" dirty="0">
-                <a:solidFill>
-                  <a:srgbClr val="1B2430"/>
-                </a:solidFill>
-                <a:latin typeface="Calibri" pitchFamily="34" charset="0"/>
-                <a:ea typeface="Calibri" pitchFamily="34" charset="-122"/>
-                <a:cs typeface="Calibri" pitchFamily="34" charset="-120"/>
-              </a:rPr>
-              <a:t>, </a:t>
-            </a:r>
-            <a:r>
-              <a:rPr lang="en-US" sz="1200" dirty="0" err="1">
-                <a:solidFill>
-                  <a:srgbClr val="1B2430"/>
-                </a:solidFill>
-                <a:latin typeface="Calibri" pitchFamily="34" charset="0"/>
-                <a:ea typeface="Calibri" pitchFamily="34" charset="-122"/>
-                <a:cs typeface="Calibri" pitchFamily="34" charset="-120"/>
-              </a:rPr>
-              <a:t>Reparateur</a:t>
-            </a:r>
-            <a:r>
-              <a:rPr lang="en-US" sz="1200" dirty="0">
-                <a:solidFill>
-                  <a:srgbClr val="1B2430"/>
-                </a:solidFill>
-                <a:latin typeface="Calibri" pitchFamily="34" charset="0"/>
-                <a:ea typeface="Calibri" pitchFamily="34" charset="-122"/>
-                <a:cs typeface="Calibri" pitchFamily="34" charset="-120"/>
-              </a:rPr>
-              <a:t>, </a:t>
-            </a:r>
-            <a:r>
-              <a:rPr lang="en-US" sz="1200" dirty="0" err="1">
-                <a:solidFill>
-                  <a:srgbClr val="1B2430"/>
-                </a:solidFill>
-                <a:latin typeface="Calibri" pitchFamily="34" charset="0"/>
-                <a:ea typeface="Calibri" pitchFamily="34" charset="-122"/>
-                <a:cs typeface="Calibri" pitchFamily="34" charset="-120"/>
-              </a:rPr>
-              <a:t>Endkontrolleur</a:t>
-            </a:r>
-            <a:r>
-              <a:rPr lang="en-US" sz="1200" dirty="0">
-                <a:solidFill>
-                  <a:srgbClr val="1B2430"/>
-                </a:solidFill>
-                <a:latin typeface="Calibri" pitchFamily="34" charset="0"/>
-                <a:ea typeface="Calibri" pitchFamily="34" charset="-122"/>
-                <a:cs typeface="Calibri" pitchFamily="34" charset="-120"/>
-              </a:rPr>
-              <a:t>, </a:t>
-            </a:r>
-            <a:r>
-              <a:rPr lang="en-US" sz="1200" dirty="0" err="1">
-                <a:solidFill>
-                  <a:srgbClr val="1B2430"/>
-                </a:solidFill>
-                <a:latin typeface="Calibri" pitchFamily="34" charset="0"/>
-                <a:ea typeface="Calibri" pitchFamily="34" charset="-122"/>
-                <a:cs typeface="Calibri" pitchFamily="34" charset="-120"/>
-              </a:rPr>
-              <a:t>Geräteausgabe</a:t>
-            </a:r>
-            <a:r>
-              <a:rPr lang="en-US" sz="1200" dirty="0">
-                <a:solidFill>
-                  <a:srgbClr val="1B2430"/>
-                </a:solidFill>
-                <a:latin typeface="Calibri" pitchFamily="34" charset="0"/>
-                <a:ea typeface="Calibri" pitchFamily="34" charset="-122"/>
-                <a:cs typeface="Calibri" pitchFamily="34" charset="-120"/>
-              </a:rPr>
-              <a:t>, </a:t>
-            </a:r>
-            <a:r>
-              <a:rPr lang="en-US" sz="1200" dirty="0" err="1">
-                <a:solidFill>
-                  <a:srgbClr val="1B2430"/>
-                </a:solidFill>
-                <a:latin typeface="Calibri" pitchFamily="34" charset="0"/>
-                <a:ea typeface="Calibri" pitchFamily="34" charset="-122"/>
-                <a:cs typeface="Calibri" pitchFamily="34" charset="-120"/>
-              </a:rPr>
-              <a:t>Reklamationsbearbeiter</a:t>
-            </a:r>
-            <a:endParaRPr lang="en-US" sz="1200" dirty="0"/>
-          </a:p>
-          <a:p>
-            <a:endParaRPr lang="en-US" sz="1150" dirty="0">
-              <a:latin typeface="Segoe UI" panose="020B0502040204020203" pitchFamily="34" charset="0"/>
-              <a:cs typeface="Segoe UI" panose="020B0502040204020203" pitchFamily="34" charset="0"/>
-            </a:endParaRPr>
+              <a:t>9 Rollen, von der Annahme bis zur Reklamation</a:t>
+            </a:r>
+            <a:endParaRPr lang="de-DE" sz="1400"/>
           </a:p>
         </p:txBody>
       </p:sp>
@@ -7773,7 +7498,7 @@
           <a:lstStyle/>
           <a:p>
             <a:r>
-              <a:rPr lang="en-US" sz="1200" dirty="0">
+              <a:rPr lang="de-DE" sz="1400" b="1" dirty="0">
                 <a:solidFill>
                   <a:srgbClr val="1B2430"/>
                 </a:solidFill>
@@ -7783,14 +7508,14 @@
               </a:rPr>
               <a:t>6 Use Cases</a:t>
             </a:r>
-            <a:endParaRPr lang="en-US" sz="1200" dirty="0"/>
-          </a:p>
-          <a:p>
-            <a:endParaRPr lang="en-US" sz="1200" dirty="0"/>
-          </a:p>
-          <a:p>
-            <a:r>
-              <a:rPr lang="en-US" sz="1200" dirty="0" err="1">
+            <a:endParaRPr lang="de-DE" sz="1400"/>
+          </a:p>
+          <a:p>
+            <a:endParaRPr lang="de-DE" sz="1400"/>
+          </a:p>
+          <a:p>
+            <a:r>
+              <a:rPr lang="de-DE" sz="1400" dirty="0">
                 <a:solidFill>
                   <a:srgbClr val="1B2430"/>
                 </a:solidFill>
@@ -7798,10 +7523,13 @@
                 <a:ea typeface="Calibri" pitchFamily="34" charset="-122"/>
                 <a:cs typeface="Calibri" pitchFamily="34" charset="-120"/>
               </a:rPr>
-              <a:t>Teiledisponent</a:t>
-            </a:r>
-            <a:r>
-              <a:rPr lang="en-US" sz="1200" dirty="0">
+              <a:t>5 Rollen</a:t>
+            </a:r>
+            <a:endParaRPr lang="de-DE" sz="1400"/>
+          </a:p>
+          <a:p>
+            <a:r>
+              <a:rPr lang="de-DE" sz="1400" dirty="0">
                 <a:solidFill>
                   <a:srgbClr val="1B2430"/>
                 </a:solidFill>
@@ -7809,153 +7537,9 @@
                 <a:ea typeface="Calibri" pitchFamily="34" charset="-122"/>
                 <a:cs typeface="Calibri" pitchFamily="34" charset="-120"/>
               </a:rPr>
-              <a:t>, </a:t>
-            </a:r>
-            <a:r>
-              <a:rPr lang="en-US" sz="1200" dirty="0" err="1">
-                <a:solidFill>
-                  <a:srgbClr val="1B2430"/>
-                </a:solidFill>
-                <a:latin typeface="Calibri" pitchFamily="34" charset="0"/>
-                <a:ea typeface="Calibri" pitchFamily="34" charset="-122"/>
-                <a:cs typeface="Calibri" pitchFamily="34" charset="-120"/>
-              </a:rPr>
-              <a:t>Bestandsplaner</a:t>
-            </a:r>
-            <a:r>
-              <a:rPr lang="en-US" sz="1200" dirty="0">
-                <a:solidFill>
-                  <a:srgbClr val="1B2430"/>
-                </a:solidFill>
-                <a:latin typeface="Calibri" pitchFamily="34" charset="0"/>
-                <a:ea typeface="Calibri" pitchFamily="34" charset="-122"/>
-                <a:cs typeface="Calibri" pitchFamily="34" charset="-120"/>
-              </a:rPr>
-              <a:t>, </a:t>
-            </a:r>
-            <a:r>
-              <a:rPr lang="en-US" sz="1200" dirty="0" err="1">
-                <a:solidFill>
-                  <a:srgbClr val="1B2430"/>
-                </a:solidFill>
-                <a:latin typeface="Calibri" pitchFamily="34" charset="0"/>
-                <a:ea typeface="Calibri" pitchFamily="34" charset="-122"/>
-                <a:cs typeface="Calibri" pitchFamily="34" charset="-120"/>
-              </a:rPr>
-              <a:t>Einkäufer</a:t>
-            </a:r>
-            <a:r>
-              <a:rPr lang="en-US" sz="1200" dirty="0">
-                <a:solidFill>
-                  <a:srgbClr val="1B2430"/>
-                </a:solidFill>
-                <a:latin typeface="Calibri" pitchFamily="34" charset="0"/>
-                <a:ea typeface="Calibri" pitchFamily="34" charset="-122"/>
-                <a:cs typeface="Calibri" pitchFamily="34" charset="-120"/>
-              </a:rPr>
-              <a:t>, </a:t>
-            </a:r>
-            <a:r>
-              <a:rPr lang="en-US" sz="1200" dirty="0" err="1">
-                <a:solidFill>
-                  <a:srgbClr val="1B2430"/>
-                </a:solidFill>
-                <a:latin typeface="Calibri" pitchFamily="34" charset="0"/>
-                <a:ea typeface="Calibri" pitchFamily="34" charset="-122"/>
-                <a:cs typeface="Calibri" pitchFamily="34" charset="-120"/>
-              </a:rPr>
-              <a:t>Wareneingang</a:t>
-            </a:r>
-            <a:r>
-              <a:rPr lang="en-US" sz="1200" dirty="0">
-                <a:solidFill>
-                  <a:srgbClr val="1B2430"/>
-                </a:solidFill>
-                <a:latin typeface="Calibri" pitchFamily="34" charset="0"/>
-                <a:ea typeface="Calibri" pitchFamily="34" charset="-122"/>
-                <a:cs typeface="Calibri" pitchFamily="34" charset="-120"/>
-              </a:rPr>
-              <a:t>, </a:t>
-            </a:r>
-            <a:r>
-              <a:rPr lang="en-US" sz="1200" dirty="0" err="1">
-                <a:solidFill>
-                  <a:srgbClr val="1B2430"/>
-                </a:solidFill>
-                <a:latin typeface="Calibri" pitchFamily="34" charset="0"/>
-                <a:ea typeface="Calibri" pitchFamily="34" charset="-122"/>
-                <a:cs typeface="Calibri" pitchFamily="34" charset="-120"/>
-              </a:rPr>
-              <a:t>Retourenbearbeiter</a:t>
-            </a:r>
-            <a:endParaRPr lang="en-US" sz="1200" dirty="0"/>
-          </a:p>
-          <a:p>
-            <a:endParaRPr lang="en-US" sz="1200" dirty="0"/>
-          </a:p>
-          <a:p>
-            <a:r>
-              <a:rPr lang="en-US" sz="1200" dirty="0" err="1">
-                <a:solidFill>
-                  <a:srgbClr val="1B2430"/>
-                </a:solidFill>
-                <a:latin typeface="Calibri" pitchFamily="34" charset="0"/>
-                <a:ea typeface="Calibri" pitchFamily="34" charset="-122"/>
-                <a:cs typeface="Calibri" pitchFamily="34" charset="-120"/>
-              </a:rPr>
-              <a:t>Lieferant</a:t>
-            </a:r>
-            <a:r>
-              <a:rPr lang="en-US" sz="1200" dirty="0">
-                <a:solidFill>
-                  <a:srgbClr val="1B2430"/>
-                </a:solidFill>
-                <a:latin typeface="Calibri" pitchFamily="34" charset="0"/>
-                <a:ea typeface="Calibri" pitchFamily="34" charset="-122"/>
-                <a:cs typeface="Calibri" pitchFamily="34" charset="-120"/>
-              </a:rPr>
-              <a:t>: Black Box, </a:t>
-            </a:r>
-            <a:r>
-              <a:rPr lang="en-US" sz="1200" dirty="0" err="1">
-                <a:solidFill>
-                  <a:srgbClr val="1B2430"/>
-                </a:solidFill>
-                <a:latin typeface="Calibri" pitchFamily="34" charset="0"/>
-                <a:ea typeface="Calibri" pitchFamily="34" charset="-122"/>
-                <a:cs typeface="Calibri" pitchFamily="34" charset="-120"/>
-              </a:rPr>
-              <a:t>kein</a:t>
-            </a:r>
-            <a:r>
-              <a:rPr lang="en-US" sz="1200" dirty="0">
-                <a:solidFill>
-                  <a:srgbClr val="1B2430"/>
-                </a:solidFill>
-                <a:latin typeface="Calibri" pitchFamily="34" charset="0"/>
-                <a:ea typeface="Calibri" pitchFamily="34" charset="-122"/>
-                <a:cs typeface="Calibri" pitchFamily="34" charset="-120"/>
-              </a:rPr>
-              <a:t> </a:t>
-            </a:r>
-            <a:r>
-              <a:rPr lang="en-US" sz="1200" dirty="0" err="1">
-                <a:solidFill>
-                  <a:srgbClr val="1B2430"/>
-                </a:solidFill>
-                <a:latin typeface="Calibri" pitchFamily="34" charset="0"/>
-                <a:ea typeface="Calibri" pitchFamily="34" charset="-122"/>
-                <a:cs typeface="Calibri" pitchFamily="34" charset="-120"/>
-              </a:rPr>
-              <a:t>Akteur</a:t>
-            </a:r>
-            <a:endParaRPr lang="en-US" sz="1200" dirty="0"/>
-          </a:p>
-          <a:p>
-            <a:endParaRPr lang="en-US" sz="1150" dirty="0">
-              <a:latin typeface="Segoe UI" panose="020B0502040204020203" pitchFamily="34" charset="0"/>
-              <a:cs typeface="Segoe UI" panose="020B0502040204020203" pitchFamily="34" charset="0"/>
-            </a:endParaRPr>
+              <a:t>Lieferant: Black Box</a:t>
+            </a:r>
+            <a:endParaRPr lang="de-DE" sz="1400"/>
           </a:p>
         </p:txBody>
       </p:sp>
@@ -8030,7 +7614,7 @@
           <a:lstStyle/>
           <a:p>
             <a:r>
-              <a:rPr lang="en-US" sz="1200" dirty="0">
+              <a:rPr lang="de-DE" sz="1400" b="1" dirty="0">
                 <a:solidFill>
                   <a:srgbClr val="1B2430"/>
                 </a:solidFill>
@@ -8040,14 +7624,14 @@
               </a:rPr>
               <a:t>1 Use Case</a:t>
             </a:r>
-            <a:endParaRPr lang="en-US" sz="1200" dirty="0"/>
-          </a:p>
-          <a:p>
-            <a:endParaRPr lang="en-US" sz="1200" dirty="0"/>
-          </a:p>
-          <a:p>
-            <a:r>
-              <a:rPr lang="en-US" sz="1200" dirty="0" err="1">
+            <a:endParaRPr lang="de-DE" sz="1400"/>
+          </a:p>
+          <a:p>
+            <a:endParaRPr lang="de-DE" sz="1400"/>
+          </a:p>
+          <a:p>
+            <a:r>
+              <a:rPr lang="de-DE" sz="1400" dirty="0">
                 <a:solidFill>
                   <a:srgbClr val="1B2430"/>
                 </a:solidFill>
@@ -8057,167 +7641,7 @@
               </a:rPr>
               <a:t>Betriebsadministrator</a:t>
             </a:r>
-            <a:r>
-              <a:rPr lang="en-US" sz="1200" dirty="0">
-                <a:solidFill>
-                  <a:srgbClr val="1B2430"/>
-                </a:solidFill>
-                <a:latin typeface="Calibri" pitchFamily="34" charset="0"/>
-                <a:ea typeface="Calibri" pitchFamily="34" charset="-122"/>
-                <a:cs typeface="Calibri" pitchFamily="34" charset="-120"/>
-              </a:rPr>
-              <a:t>: </a:t>
-            </a:r>
-            <a:r>
-              <a:rPr lang="en-US" sz="1200" dirty="0" err="1">
-                <a:solidFill>
-                  <a:srgbClr val="1B2430"/>
-                </a:solidFill>
-                <a:latin typeface="Calibri" pitchFamily="34" charset="0"/>
-                <a:ea typeface="Calibri" pitchFamily="34" charset="-122"/>
-                <a:cs typeface="Calibri" pitchFamily="34" charset="-120"/>
-              </a:rPr>
-              <a:t>Werkstattbetrieb</a:t>
-            </a:r>
-            <a:r>
-              <a:rPr lang="en-US" sz="1200" dirty="0">
-                <a:solidFill>
-                  <a:srgbClr val="1B2430"/>
-                </a:solidFill>
-                <a:latin typeface="Calibri" pitchFamily="34" charset="0"/>
-                <a:ea typeface="Calibri" pitchFamily="34" charset="-122"/>
-                <a:cs typeface="Calibri" pitchFamily="34" charset="-120"/>
-              </a:rPr>
-              <a:t> und </a:t>
-            </a:r>
-            <a:r>
-              <a:rPr lang="en-US" sz="1200" dirty="0" err="1">
-                <a:solidFill>
-                  <a:srgbClr val="1B2430"/>
-                </a:solidFill>
-                <a:latin typeface="Calibri" pitchFamily="34" charset="0"/>
-                <a:ea typeface="Calibri" pitchFamily="34" charset="-122"/>
-                <a:cs typeface="Calibri" pitchFamily="34" charset="-120"/>
-              </a:rPr>
-              <a:t>Filialen</a:t>
-            </a:r>
-            <a:r>
-              <a:rPr lang="en-US" sz="1200" dirty="0">
-                <a:solidFill>
-                  <a:srgbClr val="1B2430"/>
-                </a:solidFill>
-                <a:latin typeface="Calibri" pitchFamily="34" charset="0"/>
-                <a:ea typeface="Calibri" pitchFamily="34" charset="-122"/>
-                <a:cs typeface="Calibri" pitchFamily="34" charset="-120"/>
-              </a:rPr>
-              <a:t> </a:t>
-            </a:r>
-            <a:r>
-              <a:rPr lang="en-US" sz="1200" dirty="0" err="1">
-                <a:solidFill>
-                  <a:srgbClr val="1B2430"/>
-                </a:solidFill>
-                <a:latin typeface="Calibri" pitchFamily="34" charset="0"/>
-                <a:ea typeface="Calibri" pitchFamily="34" charset="-122"/>
-                <a:cs typeface="Calibri" pitchFamily="34" charset="-120"/>
-              </a:rPr>
-              <a:t>verwalten</a:t>
-            </a:r>
-            <a:r>
-              <a:rPr lang="en-US" sz="1200" dirty="0">
-                <a:solidFill>
-                  <a:srgbClr val="1B2430"/>
-                </a:solidFill>
-                <a:latin typeface="Calibri" pitchFamily="34" charset="0"/>
-                <a:ea typeface="Calibri" pitchFamily="34" charset="-122"/>
-                <a:cs typeface="Calibri" pitchFamily="34" charset="-120"/>
-              </a:rPr>
-              <a:t> (</a:t>
-            </a:r>
-            <a:r>
-              <a:rPr lang="en-US" sz="1200" dirty="0" err="1">
-                <a:solidFill>
-                  <a:srgbClr val="1B2430"/>
-                </a:solidFill>
-                <a:latin typeface="Calibri" pitchFamily="34" charset="0"/>
-                <a:ea typeface="Calibri" pitchFamily="34" charset="-122"/>
-                <a:cs typeface="Calibri" pitchFamily="34" charset="-120"/>
-              </a:rPr>
-              <a:t>Mandant</a:t>
-            </a:r>
-            <a:r>
-              <a:rPr lang="en-US" sz="1200" dirty="0">
-                <a:solidFill>
-                  <a:srgbClr val="1B2430"/>
-                </a:solidFill>
-                <a:latin typeface="Calibri" pitchFamily="34" charset="0"/>
-                <a:ea typeface="Calibri" pitchFamily="34" charset="-122"/>
-                <a:cs typeface="Calibri" pitchFamily="34" charset="-120"/>
-              </a:rPr>
-              <a:t>)</a:t>
-            </a:r>
-            <a:endParaRPr lang="en-US" sz="1200" dirty="0"/>
-          </a:p>
-          <a:p>
-            <a:endParaRPr lang="en-US" sz="1200" dirty="0"/>
-          </a:p>
-          <a:p>
-            <a:r>
-              <a:rPr lang="en-US" sz="1200" dirty="0">
-                <a:solidFill>
-                  <a:srgbClr val="1B2430"/>
-                </a:solidFill>
-                <a:latin typeface="Calibri" pitchFamily="34" charset="0"/>
-                <a:ea typeface="Calibri" pitchFamily="34" charset="-122"/>
-                <a:cs typeface="Calibri" pitchFamily="34" charset="-120"/>
-              </a:rPr>
-              <a:t>Rolle → </a:t>
-            </a:r>
-            <a:r>
-              <a:rPr lang="en-US" sz="1200" dirty="0" err="1">
-                <a:solidFill>
-                  <a:srgbClr val="1B2430"/>
-                </a:solidFill>
-                <a:latin typeface="Calibri" pitchFamily="34" charset="0"/>
-                <a:ea typeface="Calibri" pitchFamily="34" charset="-122"/>
-                <a:cs typeface="Calibri" pitchFamily="34" charset="-120"/>
-              </a:rPr>
-              <a:t>Mitarbeitertyp</a:t>
-            </a:r>
-            <a:r>
-              <a:rPr lang="en-US" sz="1200" dirty="0">
-                <a:solidFill>
-                  <a:srgbClr val="1B2430"/>
-                </a:solidFill>
-                <a:latin typeface="Calibri" pitchFamily="34" charset="0"/>
-                <a:ea typeface="Calibri" pitchFamily="34" charset="-122"/>
-                <a:cs typeface="Calibri" pitchFamily="34" charset="-120"/>
-              </a:rPr>
-              <a:t> → Lane: </a:t>
-            </a:r>
-            <a:r>
-              <a:rPr lang="en-US" sz="1200" dirty="0" err="1">
-                <a:solidFill>
-                  <a:srgbClr val="1B2430"/>
-                </a:solidFill>
-                <a:latin typeface="Calibri" pitchFamily="34" charset="0"/>
-                <a:ea typeface="Calibri" pitchFamily="34" charset="-122"/>
-                <a:cs typeface="Calibri" pitchFamily="34" charset="-120"/>
-              </a:rPr>
-              <a:t>Tabelle</a:t>
-            </a:r>
-            <a:r>
-              <a:rPr lang="en-US" sz="1200" dirty="0">
-                <a:solidFill>
-                  <a:srgbClr val="1B2430"/>
-                </a:solidFill>
-                <a:latin typeface="Calibri" pitchFamily="34" charset="0"/>
-                <a:ea typeface="Calibri" pitchFamily="34" charset="-122"/>
-                <a:cs typeface="Calibri" pitchFamily="34" charset="-120"/>
-              </a:rPr>
-              <a:t> 7 der Doku</a:t>
-            </a:r>
-            <a:endParaRPr lang="en-US" sz="1200" dirty="0"/>
+            <a:endParaRPr lang="de-DE" sz="1400"/>
           </a:p>
         </p:txBody>
       </p:sp>
@@ -8513,15 +7937,7 @@
 
 <file path=ppt/slides/slide13.xml><?xml version="1.0" encoding="utf-8"?>
 <p:sld xmlns:a="http://schemas.openxmlformats.org/drawingml/2006/main" xmlns:r="http://schemas.openxmlformats.org/officeDocument/2006/relationships" xmlns:p="http://schemas.openxmlformats.org/presentationml/2006/main">
-  <p:cSld name="Slide 12">
-    <p:bg>
-      <p:bgPr>
-        <a:solidFill>
-          <a:srgbClr val="FFFFFF"/>
-        </a:solidFill>
-        <a:effectLst/>
-      </p:bgPr>
-    </p:bg>
+  <p:cSld>
     <p:spTree>
       <p:nvGrpSpPr>
         <p:cNvPr id="1" name=""/>
@@ -8561,7 +7977,7 @@
               <a:buNone/>
             </a:pPr>
             <a:r>
-              <a:rPr lang="en-US" sz="2800" b="1" dirty="0">
+              <a:rPr lang="de-DE" sz="2800" b="1" dirty="0">
                 <a:solidFill>
                   <a:schemeClr val="accent2">
                     <a:lumMod val="75000"/>
@@ -8571,17 +7987,9 @@
                 <a:ea typeface="Calibri" pitchFamily="34" charset="-122"/>
                 <a:cs typeface="Segoe UI" panose="020B0502040204020203" pitchFamily="34" charset="0"/>
               </a:rPr>
-              <a:t>Das Datenmodell: fünf Entwurfsentscheidungen</a:t>
-            </a:r>
-            <a:endParaRPr lang="en-US" sz="2800" dirty="0">
-              <a:solidFill>
-                <a:schemeClr val="accent2">
-                  <a:lumMod val="75000"/>
-                </a:schemeClr>
-              </a:solidFill>
-              <a:latin typeface="Segoe UI" panose="020B0502040204020203" pitchFamily="34" charset="0"/>
-              <a:cs typeface="Segoe UI" panose="020B0502040204020203" pitchFamily="34" charset="0"/>
-            </a:endParaRPr>
+              <a:t>Das Datenmodell: fünf Entscheidungen</a:t>
+            </a:r>
+            <a:endParaRPr lang="de-DE" sz="2800"/>
           </a:p>
         </p:txBody>
       </p:sp>
@@ -8669,7 +8077,7 @@
               <a:buNone/>
             </a:pPr>
             <a:r>
-              <a:rPr lang="en-US" sz="1400" b="1" dirty="0">
+              <a:rPr lang="de-DE" sz="1400" b="1" dirty="0">
                 <a:solidFill>
                   <a:schemeClr val="accent2">
                     <a:lumMod val="50000"/>
@@ -8679,7 +8087,146 @@
                 <a:ea typeface="Calibri" pitchFamily="34" charset="-122"/>
                 <a:cs typeface="Segoe UI" panose="020B0502040204020203" pitchFamily="34" charset="0"/>
               </a:rPr>
-              <a:t>Reparaturauftrag als Aggregatwurzel</a:t>
+              <a:t>Reparaturauftrag im Mittelpunkt</a:t>
+            </a:r>
+            <a:endParaRPr lang="de-DE" sz="1400"/>
+          </a:p>
+        </p:txBody>
+      </p:sp>
+      <p:sp>
+        <p:nvSpPr>
+          <p:cNvPr id="10" name="Text 6"/>
+          <p:cNvSpPr txBox="1"/>
+          <p:nvPr/>
+        </p:nvSpPr>
+        <p:spPr>
+          <a:xfrm>
+            <a:off x="640080" y="1737360"/>
+            <a:ext cx="3657600" cy="246888"/>
+          </a:xfrm>
+          <a:prstGeom prst="rect">
+            <a:avLst/>
+          </a:prstGeom>
+          <a:noFill/>
+          <a:ln/>
+        </p:spPr>
+        <p:txBody>
+          <a:bodyPr wrap="square" lIns="0" tIns="0" rIns="0" bIns="0" rtlCol="0" anchor="t"/>
+          <a:lstStyle/>
+          <a:p>
+            <a:pPr marL="0" indent="0">
+              <a:buNone/>
+            </a:pPr>
+            <a:r>
+              <a:rPr lang="de-DE" sz="1200" dirty="0">
+                <a:solidFill>
+                  <a:srgbClr val="1B2430"/>
+                </a:solidFill>
+                <a:latin typeface="Segoe UI" panose="020B0502040204020203" pitchFamily="34" charset="0"/>
+                <a:ea typeface="Calibri" pitchFamily="34" charset="-122"/>
+                <a:cs typeface="Segoe UI" panose="020B0502040204020203" pitchFamily="34" charset="0"/>
+              </a:rPr>
+              <a:t>Befund und Reparaturschritte gehören fest zum Auftrag.</a:t>
+            </a:r>
+            <a:endParaRPr lang="de-DE" sz="1200"/>
+          </a:p>
+        </p:txBody>
+      </p:sp>
+      <p:sp>
+        <p:nvSpPr>
+          <p:cNvPr id="12" name="Shape 8"/>
+          <p:cNvSpPr/>
+          <p:nvPr/>
+        </p:nvSpPr>
+        <p:spPr>
+          <a:xfrm>
+            <a:off x="4892040" y="1188720"/>
+            <a:ext cx="457200" cy="457200"/>
+          </a:xfrm>
+          <a:prstGeom prst="ellipse">
+            <a:avLst/>
+          </a:prstGeom>
+          <a:solidFill>
+            <a:schemeClr val="accent2">
+              <a:lumMod val="50000"/>
+            </a:schemeClr>
+          </a:solidFill>
+          <a:ln w="12700">
+            <a:noFill/>
+            <a:prstDash val="solid"/>
+          </a:ln>
+        </p:spPr>
+        <p:txBody>
+          <a:bodyPr/>
+          <a:lstStyle/>
+          <a:p>
+            <a:endParaRPr lang="de-DE">
+              <a:latin typeface="Segoe UI" panose="020B0502040204020203" pitchFamily="34" charset="0"/>
+              <a:cs typeface="Segoe UI" panose="020B0502040204020203" pitchFamily="34" charset="0"/>
+            </a:endParaRPr>
+          </a:p>
+        </p:txBody>
+      </p:sp>
+      <p:pic>
+        <p:nvPicPr>
+          <p:cNvPr id="13" name="Image 1" descr="preencoded.png"/>
+          <p:cNvPicPr>
+            <a:picLocks noChangeAspect="1"/>
+          </p:cNvPicPr>
+          <p:nvPr/>
+        </p:nvPicPr>
+        <p:blipFill>
+          <a:blip r:embed="rId4"/>
+          <a:stretch>
+            <a:fillRect/>
+          </a:stretch>
+        </p:blipFill>
+        <p:spPr>
+          <a:xfrm>
+            <a:off x="5006340" y="1303020"/>
+            <a:ext cx="228600" cy="228600"/>
+          </a:xfrm>
+          <a:prstGeom prst="rect">
+            <a:avLst/>
+          </a:prstGeom>
+        </p:spPr>
+      </p:pic>
+      <p:sp>
+        <p:nvSpPr>
+          <p:cNvPr id="14" name="Text 9"/>
+          <p:cNvSpPr txBox="1"/>
+          <p:nvPr/>
+        </p:nvSpPr>
+        <p:spPr>
+          <a:xfrm>
+            <a:off x="5486400" y="1170432"/>
+            <a:ext cx="3108960" cy="457200"/>
+          </a:xfrm>
+          <a:prstGeom prst="rect">
+            <a:avLst/>
+          </a:prstGeom>
+          <a:noFill/>
+          <a:ln/>
+        </p:spPr>
+        <p:txBody>
+          <a:bodyPr wrap="square" lIns="0" tIns="0" rIns="0" bIns="0" rtlCol="0" anchor="ctr"/>
+          <a:lstStyle/>
+          <a:p>
+            <a:pPr marL="0" indent="0">
+              <a:buNone/>
+            </a:pPr>
+            <a:r>
+              <a:rPr lang="en-US" sz="1400" b="1" dirty="0">
+                <a:solidFill>
+                  <a:schemeClr val="accent2">
+                    <a:lumMod val="50000"/>
+                  </a:schemeClr>
+                </a:solidFill>
+                <a:latin typeface="Segoe UI" panose="020B0502040204020203" pitchFamily="34" charset="0"/>
+                <a:ea typeface="Calibri" pitchFamily="34" charset="-122"/>
+                <a:cs typeface="Segoe UI" panose="020B0502040204020203" pitchFamily="34" charset="0"/>
+              </a:rPr>
+              <a:t>Lagerbestand je Filiale</a:t>
             </a:r>
             <a:endParaRPr lang="en-US" sz="1400" dirty="0">
               <a:solidFill>
@@ -8695,13 +8242,13 @@
       </p:sp>
       <p:sp>
         <p:nvSpPr>
-          <p:cNvPr id="10" name="Text 6"/>
+          <p:cNvPr id="15" name="Text 10"/>
           <p:cNvSpPr txBox="1"/>
           <p:nvPr/>
         </p:nvSpPr>
         <p:spPr>
           <a:xfrm>
-            <a:off x="640080" y="1737360"/>
+            <a:off x="4892040" y="1737360"/>
             <a:ext cx="3657600" cy="246888"/>
           </a:xfrm>
           <a:prstGeom prst="rect">
@@ -8718,7 +8265,7 @@
               <a:buNone/>
             </a:pPr>
             <a:r>
-              <a:rPr lang="en-US" sz="1000" dirty="0">
+              <a:rPr lang="de-DE" sz="1200" dirty="0">
                 <a:solidFill>
                   <a:srgbClr val="1B2430"/>
                 </a:solidFill>
@@ -8726,24 +8273,21 @@
                 <a:ea typeface="Calibri" pitchFamily="34" charset="-122"/>
                 <a:cs typeface="Segoe UI" panose="020B0502040204020203" pitchFamily="34" charset="0"/>
               </a:rPr>
-              <a:t>Befund und Reparaturschritte sind Kompositionen; KVA und Gerät nur zugeordnet, weil der Vorab-KVA vor dem Auftrag entsteht.</a:t>
-            </a:r>
-            <a:endParaRPr lang="en-US" sz="1000" dirty="0">
-              <a:latin typeface="Segoe UI" panose="020B0502040204020203" pitchFamily="34" charset="0"/>
-              <a:cs typeface="Segoe UI" panose="020B0502040204020203" pitchFamily="34" charset="0"/>
-            </a:endParaRPr>
-          </a:p>
-        </p:txBody>
-      </p:sp>
-      <p:sp>
-        <p:nvSpPr>
-          <p:cNvPr id="12" name="Shape 8"/>
+              <a:t>Verfügbarkeit über alle Filialen prüfbar.</a:t>
+            </a:r>
+            <a:endParaRPr lang="de-DE" sz="1200"/>
+          </a:p>
+        </p:txBody>
+      </p:sp>
+      <p:sp>
+        <p:nvSpPr>
+          <p:cNvPr id="17" name="Shape 12"/>
           <p:cNvSpPr/>
           <p:nvPr/>
         </p:nvSpPr>
         <p:spPr>
           <a:xfrm>
-            <a:off x="4892040" y="1188720"/>
+            <a:off x="640080" y="2404872"/>
             <a:ext cx="457200" cy="457200"/>
           </a:xfrm>
           <a:prstGeom prst="ellipse">
@@ -8772,21 +8316,21 @@
       </p:sp>
       <p:pic>
         <p:nvPicPr>
-          <p:cNvPr id="13" name="Image 1" descr="preencoded.png"/>
+          <p:cNvPr id="18" name="Image 2" descr="preencoded.png"/>
           <p:cNvPicPr>
             <a:picLocks noChangeAspect="1"/>
           </p:cNvPicPr>
           <p:nvPr/>
         </p:nvPicPr>
         <p:blipFill>
-          <a:blip r:embed="rId4"/>
+          <a:blip r:embed="rId5"/>
           <a:stretch>
             <a:fillRect/>
           </a:stretch>
         </p:blipFill>
         <p:spPr>
           <a:xfrm>
-            <a:off x="5006340" y="1303020"/>
+            <a:off x="754380" y="2519172"/>
             <a:ext cx="228600" cy="228600"/>
           </a:xfrm>
           <a:prstGeom prst="rect">
@@ -8796,13 +8340,13 @@
       </p:pic>
       <p:sp>
         <p:nvSpPr>
-          <p:cNvPr id="14" name="Text 9"/>
+          <p:cNvPr id="19" name="Text 13"/>
           <p:cNvSpPr txBox="1"/>
           <p:nvPr/>
         </p:nvSpPr>
         <p:spPr>
           <a:xfrm>
-            <a:off x="5486400" y="1170432"/>
+            <a:off x="1234440" y="2386584"/>
             <a:ext cx="3108960" cy="457200"/>
           </a:xfrm>
           <a:prstGeom prst="rect">
@@ -8829,7 +8373,7 @@
                 <a:ea typeface="Calibri" pitchFamily="34" charset="-122"/>
                 <a:cs typeface="Segoe UI" panose="020B0502040204020203" pitchFamily="34" charset="0"/>
               </a:rPr>
-              <a:t>Lagerbestand je Filiale</a:t>
+              <a:t>Reservierung mit Lebenszyklus</a:t>
             </a:r>
             <a:endParaRPr lang="en-US" sz="1400" dirty="0">
               <a:solidFill>
@@ -8845,13 +8389,13 @@
       </p:sp>
       <p:sp>
         <p:nvSpPr>
-          <p:cNvPr id="15" name="Text 10"/>
+          <p:cNvPr id="20" name="Text 14"/>
           <p:cNvSpPr txBox="1"/>
           <p:nvPr/>
         </p:nvSpPr>
         <p:spPr>
           <a:xfrm>
-            <a:off x="4892040" y="1737360"/>
+            <a:off x="640080" y="2953512"/>
             <a:ext cx="3657600" cy="246888"/>
           </a:xfrm>
           <a:prstGeom prst="rect">
@@ -8868,7 +8412,7 @@
               <a:buNone/>
             </a:pPr>
             <a:r>
-              <a:rPr lang="en-US" sz="1000" dirty="0">
+              <a:rPr lang="de-DE" sz="1200" dirty="0">
                 <a:solidFill>
                   <a:srgbClr val="1B2430"/>
                 </a:solidFill>
@@ -8876,24 +8420,21 @@
                 <a:ea typeface="Calibri" pitchFamily="34" charset="-122"/>
                 <a:cs typeface="Segoe UI" panose="020B0502040204020203" pitchFamily="34" charset="0"/>
               </a:rPr>
-              <a:t>Eigene Klasse zwischen Ersatzteil und Filiale. Nur so lässt sich die Verfügbarkeit über alle Filialen prüfen.</a:t>
-            </a:r>
-            <a:endParaRPr lang="en-US" sz="1000" dirty="0">
-              <a:latin typeface="Segoe UI" panose="020B0502040204020203" pitchFamily="34" charset="0"/>
-              <a:cs typeface="Segoe UI" panose="020B0502040204020203" pitchFamily="34" charset="0"/>
-            </a:endParaRPr>
-          </a:p>
-        </p:txBody>
-      </p:sp>
-      <p:sp>
-        <p:nvSpPr>
-          <p:cNvPr id="17" name="Shape 12"/>
+              <a:t>vorreserviert → reserviert → entnommen oder storniert</a:t>
+            </a:r>
+            <a:endParaRPr lang="de-DE" sz="1200"/>
+          </a:p>
+        </p:txBody>
+      </p:sp>
+      <p:sp>
+        <p:nvSpPr>
+          <p:cNvPr id="22" name="Shape 16"/>
           <p:cNvSpPr/>
           <p:nvPr/>
         </p:nvSpPr>
         <p:spPr>
           <a:xfrm>
-            <a:off x="640080" y="2404872"/>
+            <a:off x="4892040" y="2404872"/>
             <a:ext cx="457200" cy="457200"/>
           </a:xfrm>
           <a:prstGeom prst="ellipse">
@@ -8922,21 +8463,21 @@
       </p:sp>
       <p:pic>
         <p:nvPicPr>
-          <p:cNvPr id="18" name="Image 2" descr="preencoded.png"/>
+          <p:cNvPr id="23" name="Image 3" descr="preencoded.png"/>
           <p:cNvPicPr>
             <a:picLocks noChangeAspect="1"/>
           </p:cNvPicPr>
           <p:nvPr/>
         </p:nvPicPr>
         <p:blipFill>
-          <a:blip r:embed="rId5"/>
+          <a:blip r:embed="rId6"/>
           <a:stretch>
             <a:fillRect/>
           </a:stretch>
         </p:blipFill>
         <p:spPr>
           <a:xfrm>
-            <a:off x="754380" y="2519172"/>
+            <a:off x="5006340" y="2519172"/>
             <a:ext cx="228600" cy="228600"/>
           </a:xfrm>
           <a:prstGeom prst="rect">
@@ -8946,13 +8487,13 @@
       </p:pic>
       <p:sp>
         <p:nvSpPr>
-          <p:cNvPr id="19" name="Text 13"/>
+          <p:cNvPr id="24" name="Text 17"/>
           <p:cNvSpPr txBox="1"/>
           <p:nvPr/>
         </p:nvSpPr>
         <p:spPr>
           <a:xfrm>
-            <a:off x="1234440" y="2386584"/>
+            <a:off x="5486400" y="2386584"/>
             <a:ext cx="3108960" cy="457200"/>
           </a:xfrm>
           <a:prstGeom prst="rect">
@@ -8969,7 +8510,7 @@
               <a:buNone/>
             </a:pPr>
             <a:r>
-              <a:rPr lang="en-US" sz="1400" b="1" dirty="0">
+              <a:rPr lang="de-DE" sz="1400" b="1" dirty="0">
                 <a:solidFill>
                   <a:schemeClr val="accent2">
                     <a:lumMod val="50000"/>
@@ -8979,7 +8520,146 @@
                 <a:ea typeface="Calibri" pitchFamily="34" charset="-122"/>
                 <a:cs typeface="Segoe UI" panose="020B0502040204020203" pitchFamily="34" charset="0"/>
               </a:rPr>
-              <a:t>Reservierung mit Lebenszyklus</a:t>
+              <a:t>Werkstattbetrieb als Zentrale</a:t>
+            </a:r>
+            <a:endParaRPr lang="de-DE" sz="1400"/>
+          </a:p>
+        </p:txBody>
+      </p:sp>
+      <p:sp>
+        <p:nvSpPr>
+          <p:cNvPr id="25" name="Text 18"/>
+          <p:cNvSpPr txBox="1"/>
+          <p:nvPr/>
+        </p:nvSpPr>
+        <p:spPr>
+          <a:xfrm>
+            <a:off x="4892040" y="2953512"/>
+            <a:ext cx="3657600" cy="246888"/>
+          </a:xfrm>
+          <a:prstGeom prst="rect">
+            <a:avLst/>
+          </a:prstGeom>
+          <a:noFill/>
+          <a:ln/>
+        </p:spPr>
+        <p:txBody>
+          <a:bodyPr wrap="square" lIns="0" tIns="0" rIns="0" bIns="0" rtlCol="0" anchor="t"/>
+          <a:lstStyle/>
+          <a:p>
+            <a:pPr marL="0" indent="0">
+              <a:buNone/>
+            </a:pPr>
+            <a:r>
+              <a:rPr lang="de-DE" sz="1200" dirty="0">
+                <a:solidFill>
+                  <a:srgbClr val="1B2430"/>
+                </a:solidFill>
+                <a:latin typeface="Segoe UI" panose="020B0502040204020203" pitchFamily="34" charset="0"/>
+                <a:ea typeface="Calibri" pitchFamily="34" charset="-122"/>
+                <a:cs typeface="Segoe UI" panose="020B0502040204020203" pitchFamily="34" charset="0"/>
+              </a:rPr>
+              <a:t>Kennt alle Aufträge. Zugriff nur über KundenApp und Werkstattoberfläche.</a:t>
+            </a:r>
+            <a:endParaRPr lang="de-DE" sz="1200"/>
+          </a:p>
+        </p:txBody>
+      </p:sp>
+      <p:sp>
+        <p:nvSpPr>
+          <p:cNvPr id="27" name="Shape 20"/>
+          <p:cNvSpPr/>
+          <p:nvPr/>
+        </p:nvSpPr>
+        <p:spPr>
+          <a:xfrm>
+            <a:off x="640080" y="3621024"/>
+            <a:ext cx="457200" cy="457200"/>
+          </a:xfrm>
+          <a:prstGeom prst="ellipse">
+            <a:avLst/>
+          </a:prstGeom>
+          <a:solidFill>
+            <a:schemeClr val="accent2">
+              <a:lumMod val="50000"/>
+            </a:schemeClr>
+          </a:solidFill>
+          <a:ln w="12700">
+            <a:noFill/>
+            <a:prstDash val="solid"/>
+          </a:ln>
+        </p:spPr>
+        <p:txBody>
+          <a:bodyPr/>
+          <a:lstStyle/>
+          <a:p>
+            <a:endParaRPr lang="de-DE">
+              <a:latin typeface="Segoe UI" panose="020B0502040204020203" pitchFamily="34" charset="0"/>
+              <a:cs typeface="Segoe UI" panose="020B0502040204020203" pitchFamily="34" charset="0"/>
+            </a:endParaRPr>
+          </a:p>
+        </p:txBody>
+      </p:sp>
+      <p:pic>
+        <p:nvPicPr>
+          <p:cNvPr id="28" name="Image 4" descr="preencoded.png"/>
+          <p:cNvPicPr>
+            <a:picLocks noChangeAspect="1"/>
+          </p:cNvPicPr>
+          <p:nvPr/>
+        </p:nvPicPr>
+        <p:blipFill>
+          <a:blip r:embed="rId7"/>
+          <a:stretch>
+            <a:fillRect/>
+          </a:stretch>
+        </p:blipFill>
+        <p:spPr>
+          <a:xfrm>
+            <a:off x="754380" y="3735324"/>
+            <a:ext cx="228600" cy="228600"/>
+          </a:xfrm>
+          <a:prstGeom prst="rect">
+            <a:avLst/>
+          </a:prstGeom>
+        </p:spPr>
+      </p:pic>
+      <p:sp>
+        <p:nvSpPr>
+          <p:cNvPr id="29" name="Text 21"/>
+          <p:cNvSpPr txBox="1"/>
+          <p:nvPr/>
+        </p:nvSpPr>
+        <p:spPr>
+          <a:xfrm>
+            <a:off x="1234440" y="3602736"/>
+            <a:ext cx="3108960" cy="457200"/>
+          </a:xfrm>
+          <a:prstGeom prst="rect">
+            <a:avLst/>
+          </a:prstGeom>
+          <a:noFill/>
+          <a:ln/>
+        </p:spPr>
+        <p:txBody>
+          <a:bodyPr wrap="square" lIns="0" tIns="0" rIns="0" bIns="0" rtlCol="0" anchor="ctr"/>
+          <a:lstStyle/>
+          <a:p>
+            <a:pPr marL="0" indent="0">
+              <a:buNone/>
+            </a:pPr>
+            <a:r>
+              <a:rPr lang="en-US" sz="1400" b="1" dirty="0">
+                <a:solidFill>
+                  <a:schemeClr val="accent2">
+                    <a:lumMod val="50000"/>
+                  </a:schemeClr>
+                </a:solidFill>
+                <a:latin typeface="Segoe UI" panose="020B0502040204020203" pitchFamily="34" charset="0"/>
+                <a:ea typeface="Calibri" pitchFamily="34" charset="-122"/>
+                <a:cs typeface="Segoe UI" panose="020B0502040204020203" pitchFamily="34" charset="0"/>
+              </a:rPr>
+              <a:t>Drei Klassen für die Sofortdiagnose</a:t>
             </a:r>
             <a:endParaRPr lang="en-US" sz="1400" dirty="0">
               <a:solidFill>
@@ -8995,13 +8675,13 @@
       </p:sp>
       <p:sp>
         <p:nvSpPr>
-          <p:cNvPr id="20" name="Text 14"/>
+          <p:cNvPr id="30" name="Text 22"/>
           <p:cNvSpPr txBox="1"/>
           <p:nvPr/>
         </p:nvSpPr>
         <p:spPr>
           <a:xfrm>
-            <a:off x="640080" y="2953512"/>
+            <a:off x="640080" y="4169664"/>
             <a:ext cx="3657600" cy="246888"/>
           </a:xfrm>
           <a:prstGeom prst="rect">
@@ -9018,7 +8698,7 @@
               <a:buNone/>
             </a:pPr>
             <a:r>
-              <a:rPr lang="en-US" sz="1000" dirty="0">
+              <a:rPr lang="de-DE" sz="1200" dirty="0">
                 <a:solidFill>
                   <a:srgbClr val="1B2430"/>
                 </a:solidFill>
@@ -9026,312 +8706,9 @@
                 <a:ea typeface="Calibri" pitchFamily="34" charset="-122"/>
                 <a:cs typeface="Segoe UI" panose="020B0502040204020203" pitchFamily="34" charset="0"/>
               </a:rPr>
-              <a:t>vorreserviert, reserviert, entnommen, storniert: eine Beziehung mit eigenen Daten wird zur Klasse.</a:t>
-            </a:r>
-            <a:endParaRPr lang="en-US" sz="1000" dirty="0">
-              <a:latin typeface="Segoe UI" panose="020B0502040204020203" pitchFamily="34" charset="0"/>
-              <a:cs typeface="Segoe UI" panose="020B0502040204020203" pitchFamily="34" charset="0"/>
-            </a:endParaRPr>
-          </a:p>
-        </p:txBody>
-      </p:sp>
-      <p:sp>
-        <p:nvSpPr>
-          <p:cNvPr id="22" name="Shape 16"/>
-          <p:cNvSpPr/>
-          <p:nvPr/>
-        </p:nvSpPr>
-        <p:spPr>
-          <a:xfrm>
-            <a:off x="4892040" y="2404872"/>
-            <a:ext cx="457200" cy="457200"/>
-          </a:xfrm>
-          <a:prstGeom prst="ellipse">
-            <a:avLst/>
-          </a:prstGeom>
-          <a:solidFill>
-            <a:schemeClr val="accent2">
-              <a:lumMod val="50000"/>
-            </a:schemeClr>
-          </a:solidFill>
-          <a:ln w="12700">
-            <a:noFill/>
-            <a:prstDash val="solid"/>
-          </a:ln>
-        </p:spPr>
-        <p:txBody>
-          <a:bodyPr/>
-          <a:lstStyle/>
-          <a:p>
-            <a:endParaRPr lang="de-DE">
-              <a:latin typeface="Segoe UI" panose="020B0502040204020203" pitchFamily="34" charset="0"/>
-              <a:cs typeface="Segoe UI" panose="020B0502040204020203" pitchFamily="34" charset="0"/>
-            </a:endParaRPr>
-          </a:p>
-        </p:txBody>
-      </p:sp>
-      <p:pic>
-        <p:nvPicPr>
-          <p:cNvPr id="23" name="Image 3" descr="preencoded.png"/>
-          <p:cNvPicPr>
-            <a:picLocks noChangeAspect="1"/>
-          </p:cNvPicPr>
-          <p:nvPr/>
-        </p:nvPicPr>
-        <p:blipFill>
-          <a:blip r:embed="rId6"/>
-          <a:stretch>
-            <a:fillRect/>
-          </a:stretch>
-        </p:blipFill>
-        <p:spPr>
-          <a:xfrm>
-            <a:off x="5006340" y="2519172"/>
-            <a:ext cx="228600" cy="228600"/>
-          </a:xfrm>
-          <a:prstGeom prst="rect">
-            <a:avLst/>
-          </a:prstGeom>
-        </p:spPr>
-      </p:pic>
-      <p:sp>
-        <p:nvSpPr>
-          <p:cNvPr id="24" name="Text 17"/>
-          <p:cNvSpPr txBox="1"/>
-          <p:nvPr/>
-        </p:nvSpPr>
-        <p:spPr>
-          <a:xfrm>
-            <a:off x="5486400" y="2386584"/>
-            <a:ext cx="3108960" cy="457200"/>
-          </a:xfrm>
-          <a:prstGeom prst="rect">
-            <a:avLst/>
-          </a:prstGeom>
-          <a:noFill/>
-          <a:ln/>
-        </p:spPr>
-        <p:txBody>
-          <a:bodyPr wrap="square" lIns="0" tIns="0" rIns="0" bIns="0" rtlCol="0" anchor="ctr"/>
-          <a:lstStyle/>
-          <a:p>
-            <a:pPr marL="0" indent="0">
-              <a:buNone/>
-            </a:pPr>
-            <a:r>
-              <a:rPr lang="en-US" sz="1400" b="1" dirty="0">
-                <a:solidFill>
-                  <a:schemeClr val="accent2">
-                    <a:lumMod val="50000"/>
-                  </a:schemeClr>
-                </a:solidFill>
-                <a:latin typeface="Segoe UI" panose="020B0502040204020203" pitchFamily="34" charset="0"/>
-                <a:ea typeface="Calibri" pitchFamily="34" charset="-122"/>
-                <a:cs typeface="Segoe UI" panose="020B0502040204020203" pitchFamily="34" charset="0"/>
-              </a:rPr>
-              <a:t>Mandant und Mitarbeitertypen</a:t>
-            </a:r>
-            <a:endParaRPr lang="en-US" sz="1400" dirty="0">
-              <a:solidFill>
-                <a:schemeClr val="accent2">
-                  <a:lumMod val="50000"/>
-                </a:schemeClr>
-              </a:solidFill>
-              <a:latin typeface="Segoe UI" panose="020B0502040204020203" pitchFamily="34" charset="0"/>
-              <a:cs typeface="Segoe UI" panose="020B0502040204020203" pitchFamily="34" charset="0"/>
-            </a:endParaRPr>
-          </a:p>
-        </p:txBody>
-      </p:sp>
-      <p:sp>
-        <p:nvSpPr>
-          <p:cNvPr id="25" name="Text 18"/>
-          <p:cNvSpPr txBox="1"/>
-          <p:nvPr/>
-        </p:nvSpPr>
-        <p:spPr>
-          <a:xfrm>
-            <a:off x="4892040" y="2953512"/>
-            <a:ext cx="3657600" cy="246888"/>
-          </a:xfrm>
-          <a:prstGeom prst="rect">
-            <a:avLst/>
-          </a:prstGeom>
-          <a:noFill/>
-          <a:ln/>
-        </p:spPr>
-        <p:txBody>
-          <a:bodyPr wrap="square" lIns="0" tIns="0" rIns="0" bIns="0" rtlCol="0" anchor="t"/>
-          <a:lstStyle/>
-          <a:p>
-            <a:pPr marL="0" indent="0">
-              <a:buNone/>
-            </a:pPr>
-            <a:r>
-              <a:rPr lang="en-US" sz="1000" dirty="0">
-                <a:solidFill>
-                  <a:srgbClr val="1B2430"/>
-                </a:solidFill>
-                <a:latin typeface="Segoe UI" panose="020B0502040204020203" pitchFamily="34" charset="0"/>
-                <a:ea typeface="Calibri" pitchFamily="34" charset="-122"/>
-                <a:cs typeface="Segoe UI" panose="020B0502040204020203" pitchFamily="34" charset="0"/>
-              </a:rPr>
-              <a:t>Werkstattbetrieb als Mandant und Sammelstelle; vier Mitarbeitertypen passend zu Lanes und Rollen; KundenApp und Werkstattoberfläche als Zugang.</a:t>
-            </a:r>
-            <a:endParaRPr lang="en-US" sz="1000" dirty="0">
-              <a:latin typeface="Segoe UI" panose="020B0502040204020203" pitchFamily="34" charset="0"/>
-              <a:cs typeface="Segoe UI" panose="020B0502040204020203" pitchFamily="34" charset="0"/>
-            </a:endParaRPr>
-          </a:p>
-        </p:txBody>
-      </p:sp>
-      <p:sp>
-        <p:nvSpPr>
-          <p:cNvPr id="27" name="Shape 20"/>
-          <p:cNvSpPr/>
-          <p:nvPr/>
-        </p:nvSpPr>
-        <p:spPr>
-          <a:xfrm>
-            <a:off x="640080" y="3621024"/>
-            <a:ext cx="457200" cy="457200"/>
-          </a:xfrm>
-          <a:prstGeom prst="ellipse">
-            <a:avLst/>
-          </a:prstGeom>
-          <a:solidFill>
-            <a:schemeClr val="accent2">
-              <a:lumMod val="50000"/>
-            </a:schemeClr>
-          </a:solidFill>
-          <a:ln w="12700">
-            <a:noFill/>
-            <a:prstDash val="solid"/>
-          </a:ln>
-        </p:spPr>
-        <p:txBody>
-          <a:bodyPr/>
-          <a:lstStyle/>
-          <a:p>
-            <a:endParaRPr lang="de-DE">
-              <a:latin typeface="Segoe UI" panose="020B0502040204020203" pitchFamily="34" charset="0"/>
-              <a:cs typeface="Segoe UI" panose="020B0502040204020203" pitchFamily="34" charset="0"/>
-            </a:endParaRPr>
-          </a:p>
-        </p:txBody>
-      </p:sp>
-      <p:pic>
-        <p:nvPicPr>
-          <p:cNvPr id="28" name="Image 4" descr="preencoded.png"/>
-          <p:cNvPicPr>
-            <a:picLocks noChangeAspect="1"/>
-          </p:cNvPicPr>
-          <p:nvPr/>
-        </p:nvPicPr>
-        <p:blipFill>
-          <a:blip r:embed="rId7"/>
-          <a:stretch>
-            <a:fillRect/>
-          </a:stretch>
-        </p:blipFill>
-        <p:spPr>
-          <a:xfrm>
-            <a:off x="754380" y="3735324"/>
-            <a:ext cx="228600" cy="228600"/>
-          </a:xfrm>
-          <a:prstGeom prst="rect">
-            <a:avLst/>
-          </a:prstGeom>
-        </p:spPr>
-      </p:pic>
-      <p:sp>
-        <p:nvSpPr>
-          <p:cNvPr id="29" name="Text 21"/>
-          <p:cNvSpPr txBox="1"/>
-          <p:nvPr/>
-        </p:nvSpPr>
-        <p:spPr>
-          <a:xfrm>
-            <a:off x="1234440" y="3602736"/>
-            <a:ext cx="3108960" cy="457200"/>
-          </a:xfrm>
-          <a:prstGeom prst="rect">
-            <a:avLst/>
-          </a:prstGeom>
-          <a:noFill/>
-          <a:ln/>
-        </p:spPr>
-        <p:txBody>
-          <a:bodyPr wrap="square" lIns="0" tIns="0" rIns="0" bIns="0" rtlCol="0" anchor="ctr"/>
-          <a:lstStyle/>
-          <a:p>
-            <a:pPr marL="0" indent="0">
-              <a:buNone/>
-            </a:pPr>
-            <a:r>
-              <a:rPr lang="en-US" sz="1400" b="1" dirty="0">
-                <a:solidFill>
-                  <a:schemeClr val="accent2">
-                    <a:lumMod val="50000"/>
-                  </a:schemeClr>
-                </a:solidFill>
-                <a:latin typeface="Segoe UI" panose="020B0502040204020203" pitchFamily="34" charset="0"/>
-                <a:ea typeface="Calibri" pitchFamily="34" charset="-122"/>
-                <a:cs typeface="Segoe UI" panose="020B0502040204020203" pitchFamily="34" charset="0"/>
-              </a:rPr>
-              <a:t>Drei Klassen für die Sofortdiagnose</a:t>
-            </a:r>
-            <a:endParaRPr lang="en-US" sz="1400" dirty="0">
-              <a:solidFill>
-                <a:schemeClr val="accent2">
-                  <a:lumMod val="50000"/>
-                </a:schemeClr>
-              </a:solidFill>
-              <a:latin typeface="Segoe UI" panose="020B0502040204020203" pitchFamily="34" charset="0"/>
-              <a:cs typeface="Segoe UI" panose="020B0502040204020203" pitchFamily="34" charset="0"/>
-            </a:endParaRPr>
-          </a:p>
-        </p:txBody>
-      </p:sp>
-      <p:sp>
-        <p:nvSpPr>
-          <p:cNvPr id="30" name="Text 22"/>
-          <p:cNvSpPr txBox="1"/>
-          <p:nvPr/>
-        </p:nvSpPr>
-        <p:spPr>
-          <a:xfrm>
-            <a:off x="640080" y="4169664"/>
-            <a:ext cx="3657600" cy="246888"/>
-          </a:xfrm>
-          <a:prstGeom prst="rect">
-            <a:avLst/>
-          </a:prstGeom>
-          <a:noFill/>
-          <a:ln/>
-        </p:spPr>
-        <p:txBody>
-          <a:bodyPr wrap="square" lIns="0" tIns="0" rIns="0" bIns="0" rtlCol="0" anchor="t"/>
-          <a:lstStyle/>
-          <a:p>
-            <a:pPr marL="0" indent="0">
-              <a:buNone/>
-            </a:pPr>
-            <a:r>
-              <a:rPr lang="en-US" sz="1000" dirty="0">
-                <a:solidFill>
-                  <a:srgbClr val="1B2430"/>
-                </a:solidFill>
-                <a:latin typeface="Segoe UI" panose="020B0502040204020203" pitchFamily="34" charset="0"/>
-                <a:ea typeface="Calibri" pitchFamily="34" charset="-122"/>
-                <a:cs typeface="Segoe UI" panose="020B0502040204020203" pitchFamily="34" charset="0"/>
-              </a:rPr>
-              <a:t>Voranmeldung, Medienanhang und KIDiagnosevorschlag tragen das Alleinstellungsmerkmal im Modell.</a:t>
-            </a:r>
-            <a:endParaRPr lang="en-US" sz="1000" dirty="0">
-              <a:latin typeface="Segoe UI" panose="020B0502040204020203" pitchFamily="34" charset="0"/>
-              <a:cs typeface="Segoe UI" panose="020B0502040204020203" pitchFamily="34" charset="0"/>
-            </a:endParaRPr>
+              <a:t>Voranmeldung, Medienanhang, KIDiagnosevorschlag</a:t>
+            </a:r>
+            <a:endParaRPr lang="de-DE" sz="1200"/>
           </a:p>
         </p:txBody>
       </p:sp>
@@ -9343,8 +8720,8 @@
         </p:nvSpPr>
         <p:spPr>
           <a:xfrm>
-            <a:off x="4753550" y="3563414"/>
-            <a:ext cx="3657600" cy="1025810"/>
+            <a:off x="4753550" y="3621024"/>
+            <a:ext cx="3657600" cy="457200"/>
           </a:xfrm>
           <a:prstGeom prst="roundRect">
             <a:avLst>
@@ -9380,8 +8757,8 @@
         </p:nvSpPr>
         <p:spPr>
           <a:xfrm>
-            <a:off x="4892040" y="3536866"/>
-            <a:ext cx="3657600" cy="1051560"/>
+            <a:off x="4753550" y="3621024"/>
+            <a:ext cx="3657600" cy="457200"/>
           </a:xfrm>
           <a:prstGeom prst="rect">
             <a:avLst/>
@@ -9393,11 +8770,11 @@
           <a:bodyPr wrap="square" lIns="0" tIns="0" rIns="0" bIns="0" rtlCol="0" anchor="ctr"/>
           <a:lstStyle/>
           <a:p>
-            <a:pPr marL="0" indent="0">
+            <a:pPr marL="0" indent="0" algn="ctr">
               <a:buNone/>
             </a:pPr>
             <a:r>
-              <a:rPr lang="en-US" sz="1050" b="1" dirty="0">
+              <a:rPr lang="de-DE" sz="1200" b="1" dirty="0">
                 <a:solidFill>
                   <a:srgbClr val="FFFFFF"/>
                 </a:solidFill>
@@ -9407,30 +8784,7 @@
               </a:rPr>
               <a:t>29 Klassen · 40 Assoziationen · 7 Aufzählungen</a:t>
             </a:r>
-            <a:endParaRPr lang="en-US" sz="1050" dirty="0">
-              <a:latin typeface="Segoe UI" panose="020B0502040204020203" pitchFamily="34" charset="0"/>
-              <a:cs typeface="Segoe UI" panose="020B0502040204020203" pitchFamily="34" charset="0"/>
-            </a:endParaRPr>
-          </a:p>
-          <a:p>
-            <a:pPr marL="0" indent="0">
-              <a:buNone/>
-            </a:pPr>
-            <a:r>
-              <a:rPr lang="en-US" sz="1050" dirty="0">
-                <a:solidFill>
-                  <a:srgbClr val="FFFFFF"/>
-                </a:solidFill>
-                <a:latin typeface="Segoe UI" panose="020B0502040204020203" pitchFamily="34" charset="0"/>
-                <a:ea typeface="Calibri" pitchFamily="34" charset="-122"/>
-                <a:cs typeface="Segoe UI" panose="020B0502040204020203" pitchFamily="34" charset="0"/>
-              </a:rPr>
-              <a:t>Botschaft = Operation: Die sechs Sequenzdiagramme verwenden ausschließlich Operationen dieser Klassen. Der Reparaturauftrag führt den Status als Attribut und wechselt ihn über wechsleStatus().</a:t>
-            </a:r>
-            <a:endParaRPr lang="en-US" sz="1050" dirty="0">
-              <a:latin typeface="Segoe UI" panose="020B0502040204020203" pitchFamily="34" charset="0"/>
-              <a:cs typeface="Segoe UI" panose="020B0502040204020203" pitchFamily="34" charset="0"/>
-            </a:endParaRPr>
+            <a:endParaRPr lang="de-DE" sz="1200"/>
           </a:p>
         </p:txBody>
       </p:sp>
@@ -9444,15 +8798,7 @@
 
 <file path=ppt/slides/slide14.xml><?xml version="1.0" encoding="utf-8"?>
 <p:sld xmlns:a="http://schemas.openxmlformats.org/drawingml/2006/main" xmlns:r="http://schemas.openxmlformats.org/officeDocument/2006/relationships" xmlns:p="http://schemas.openxmlformats.org/presentationml/2006/main">
-  <p:cSld name="Slide 14">
-    <p:bg>
-      <p:bgPr>
-        <a:solidFill>
-          <a:srgbClr val="FFFFFF"/>
-        </a:solidFill>
-        <a:effectLst/>
-      </p:bgPr>
-    </p:bg>
+  <p:cSld>
     <p:spTree>
       <p:nvGrpSpPr>
         <p:cNvPr id="1" name=""/>
@@ -9551,7 +8897,7 @@
               <a:buNone/>
             </a:pPr>
             <a:r>
-              <a:rPr lang="en-US" sz="1400" b="1" dirty="0">
+              <a:rPr lang="de-DE" sz="1400" b="1" dirty="0">
                 <a:solidFill>
                   <a:schemeClr val="accent2">
                     <a:lumMod val="50000"/>
@@ -9561,7 +8907,146 @@
                 <a:ea typeface="Calibri" pitchFamily="34" charset="-122"/>
                 <a:cs typeface="Segoe UI" panose="020B0502040204020203" pitchFamily="34" charset="0"/>
               </a:rPr>
-              <a:t>Konventionen</a:t>
+              <a:t>Regeln</a:t>
+            </a:r>
+            <a:endParaRPr lang="de-DE" sz="1400"/>
+          </a:p>
+        </p:txBody>
+      </p:sp>
+      <p:sp>
+        <p:nvSpPr>
+          <p:cNvPr id="10" name="Text 6"/>
+          <p:cNvSpPr txBox="1"/>
+          <p:nvPr/>
+        </p:nvSpPr>
+        <p:spPr>
+          <a:xfrm>
+            <a:off x="640080" y="1901952"/>
+            <a:ext cx="2286000" cy="1417320"/>
+          </a:xfrm>
+          <a:prstGeom prst="rect">
+            <a:avLst/>
+          </a:prstGeom>
+          <a:noFill/>
+          <a:ln/>
+        </p:spPr>
+        <p:txBody>
+          <a:bodyPr wrap="square" lIns="0" tIns="0" rIns="0" bIns="0" rtlCol="0" anchor="t"/>
+          <a:lstStyle/>
+          <a:p>
+            <a:pPr marL="0" indent="0">
+              <a:buNone/>
+            </a:pPr>
+            <a:r>
+              <a:rPr lang="de-DE" sz="1200" dirty="0">
+                <a:solidFill>
+                  <a:srgbClr val="1B2430"/>
+                </a:solidFill>
+                <a:latin typeface="Segoe UI" panose="020B0502040204020203" pitchFamily="34" charset="0"/>
+                <a:ea typeface="Calibri" pitchFamily="34" charset="-122"/>
+                <a:cs typeface="Segoe UI" panose="020B0502040204020203" pitchFamily="34" charset="0"/>
+              </a:rPr>
+              <a:t>Gleiche Namen in allen Modellen. Jede Rolle hat genau eine Lane und eine Klasse.</a:t>
+            </a:r>
+            <a:endParaRPr lang="de-DE" sz="1200"/>
+          </a:p>
+        </p:txBody>
+      </p:sp>
+      <p:sp>
+        <p:nvSpPr>
+          <p:cNvPr id="12" name="Shape 8"/>
+          <p:cNvSpPr/>
+          <p:nvPr/>
+        </p:nvSpPr>
+        <p:spPr>
+          <a:xfrm>
+            <a:off x="3429000" y="1353312"/>
+            <a:ext cx="457200" cy="457200"/>
+          </a:xfrm>
+          <a:prstGeom prst="ellipse">
+            <a:avLst/>
+          </a:prstGeom>
+          <a:solidFill>
+            <a:schemeClr val="accent2">
+              <a:lumMod val="50000"/>
+            </a:schemeClr>
+          </a:solidFill>
+          <a:ln w="12700">
+            <a:noFill/>
+            <a:prstDash val="solid"/>
+          </a:ln>
+        </p:spPr>
+        <p:txBody>
+          <a:bodyPr/>
+          <a:lstStyle/>
+          <a:p>
+            <a:endParaRPr lang="de-DE">
+              <a:latin typeface="Segoe UI" panose="020B0502040204020203" pitchFamily="34" charset="0"/>
+              <a:cs typeface="Segoe UI" panose="020B0502040204020203" pitchFamily="34" charset="0"/>
+            </a:endParaRPr>
+          </a:p>
+        </p:txBody>
+      </p:sp>
+      <p:pic>
+        <p:nvPicPr>
+          <p:cNvPr id="13" name="Image 1" descr="preencoded.png"/>
+          <p:cNvPicPr>
+            <a:picLocks noChangeAspect="1"/>
+          </p:cNvPicPr>
+          <p:nvPr/>
+        </p:nvPicPr>
+        <p:blipFill>
+          <a:blip r:embed="rId4"/>
+          <a:stretch>
+            <a:fillRect/>
+          </a:stretch>
+        </p:blipFill>
+        <p:spPr>
+          <a:xfrm>
+            <a:off x="3543300" y="1467612"/>
+            <a:ext cx="228600" cy="228600"/>
+          </a:xfrm>
+          <a:prstGeom prst="rect">
+            <a:avLst/>
+          </a:prstGeom>
+        </p:spPr>
+      </p:pic>
+      <p:sp>
+        <p:nvSpPr>
+          <p:cNvPr id="14" name="Text 9"/>
+          <p:cNvSpPr txBox="1"/>
+          <p:nvPr/>
+        </p:nvSpPr>
+        <p:spPr>
+          <a:xfrm>
+            <a:off x="4023360" y="1335024"/>
+            <a:ext cx="1737360" cy="457200"/>
+          </a:xfrm>
+          <a:prstGeom prst="rect">
+            <a:avLst/>
+          </a:prstGeom>
+          <a:noFill/>
+          <a:ln/>
+        </p:spPr>
+        <p:txBody>
+          <a:bodyPr wrap="square" lIns="0" tIns="0" rIns="0" bIns="0" rtlCol="0" anchor="ctr"/>
+          <a:lstStyle/>
+          <a:p>
+            <a:pPr marL="0" indent="0">
+              <a:buNone/>
+            </a:pPr>
+            <a:r>
+              <a:rPr lang="en-US" sz="1400" b="1" dirty="0">
+                <a:solidFill>
+                  <a:schemeClr val="accent2">
+                    <a:lumMod val="50000"/>
+                  </a:schemeClr>
+                </a:solidFill>
+                <a:latin typeface="Segoe UI" panose="020B0502040204020203" pitchFamily="34" charset="0"/>
+                <a:ea typeface="Calibri" pitchFamily="34" charset="-122"/>
+                <a:cs typeface="Segoe UI" panose="020B0502040204020203" pitchFamily="34" charset="0"/>
+              </a:rPr>
+              <a:t>Werkzeuge</a:t>
             </a:r>
             <a:endParaRPr lang="en-US" sz="1400" dirty="0">
               <a:solidFill>
@@ -9577,13 +9062,13 @@
       </p:sp>
       <p:sp>
         <p:nvSpPr>
-          <p:cNvPr id="10" name="Text 6"/>
+          <p:cNvPr id="15" name="Text 10"/>
           <p:cNvSpPr txBox="1"/>
           <p:nvPr/>
         </p:nvSpPr>
         <p:spPr>
           <a:xfrm>
-            <a:off x="640080" y="1901952"/>
+            <a:off x="3429000" y="1901952"/>
             <a:ext cx="2286000" cy="1417320"/>
           </a:xfrm>
           <a:prstGeom prst="rect">
@@ -9600,7 +9085,7 @@
               <a:buNone/>
             </a:pPr>
             <a:r>
-              <a:rPr lang="en-US" sz="1050" dirty="0">
+              <a:rPr lang="de-DE" sz="1200" dirty="0">
                 <a:solidFill>
                   <a:srgbClr val="1B2430"/>
                 </a:solidFill>
@@ -9608,24 +9093,21 @@
                 <a:ea typeface="Calibri" pitchFamily="34" charset="-122"/>
                 <a:cs typeface="Segoe UI" panose="020B0502040204020203" pitchFamily="34" charset="0"/>
               </a:rPr>
-              <a:t>Datenobjekte tragen Klassennamen. Aktivität = Verb + Objekt, Ereignis im Partizip Perfekt. Jede Rolle gehört zu genau einer Lane und einer Klasse. Statuswerte in allen Modellen identisch.</a:t>
-            </a:r>
-            <a:endParaRPr lang="en-US" sz="1050" dirty="0">
-              <a:latin typeface="Segoe UI" panose="020B0502040204020203" pitchFamily="34" charset="0"/>
-              <a:cs typeface="Segoe UI" panose="020B0502040204020203" pitchFamily="34" charset="0"/>
-            </a:endParaRPr>
-          </a:p>
-        </p:txBody>
-      </p:sp>
-      <p:sp>
-        <p:nvSpPr>
-          <p:cNvPr id="12" name="Shape 8"/>
+              <a:t>Prozesse für Camunda 8 ergänzt. Zwei Prüfprogramme: 0 Fehler.</a:t>
+            </a:r>
+            <a:endParaRPr lang="de-DE" sz="1200"/>
+          </a:p>
+        </p:txBody>
+      </p:sp>
+      <p:sp>
+        <p:nvSpPr>
+          <p:cNvPr id="17" name="Shape 12"/>
           <p:cNvSpPr/>
           <p:nvPr/>
         </p:nvSpPr>
         <p:spPr>
           <a:xfrm>
-            <a:off x="3429000" y="1353312"/>
+            <a:off x="6217920" y="1353312"/>
             <a:ext cx="457200" cy="457200"/>
           </a:xfrm>
           <a:prstGeom prst="ellipse">
@@ -9654,21 +9136,21 @@
       </p:sp>
       <p:pic>
         <p:nvPicPr>
-          <p:cNvPr id="13" name="Image 1" descr="preencoded.png"/>
+          <p:cNvPr id="18" name="Image 2" descr="preencoded.png"/>
           <p:cNvPicPr>
             <a:picLocks noChangeAspect="1"/>
           </p:cNvPicPr>
           <p:nvPr/>
         </p:nvPicPr>
         <p:blipFill>
-          <a:blip r:embed="rId4"/>
+          <a:blip r:embed="rId5"/>
           <a:stretch>
             <a:fillRect/>
           </a:stretch>
         </p:blipFill>
         <p:spPr>
           <a:xfrm>
-            <a:off x="3543300" y="1467612"/>
+            <a:off x="6332220" y="1467612"/>
             <a:ext cx="228600" cy="228600"/>
           </a:xfrm>
           <a:prstGeom prst="rect">
@@ -9678,13 +9160,13 @@
       </p:pic>
       <p:sp>
         <p:nvSpPr>
-          <p:cNvPr id="14" name="Text 9"/>
+          <p:cNvPr id="19" name="Text 13"/>
           <p:cNvSpPr txBox="1"/>
           <p:nvPr/>
         </p:nvSpPr>
         <p:spPr>
           <a:xfrm>
-            <a:off x="4023360" y="1335024"/>
+            <a:off x="6812280" y="1335024"/>
             <a:ext cx="1737360" cy="457200"/>
           </a:xfrm>
           <a:prstGeom prst="rect">
@@ -9711,7 +9193,7 @@
                 <a:ea typeface="Calibri" pitchFamily="34" charset="-122"/>
                 <a:cs typeface="Segoe UI" panose="020B0502040204020203" pitchFamily="34" charset="0"/>
               </a:rPr>
-              <a:t>Werkzeuge</a:t>
+              <a:t>Reviews</a:t>
             </a:r>
             <a:endParaRPr lang="en-US" sz="1400" dirty="0">
               <a:solidFill>
@@ -9727,13 +9209,13 @@
       </p:sp>
       <p:sp>
         <p:nvSpPr>
-          <p:cNvPr id="15" name="Text 10"/>
+          <p:cNvPr id="20" name="Text 14"/>
           <p:cNvSpPr txBox="1"/>
           <p:nvPr/>
         </p:nvSpPr>
         <p:spPr>
           <a:xfrm>
-            <a:off x="3429000" y="1901952"/>
+            <a:off x="6217920" y="1901952"/>
             <a:ext cx="2286000" cy="1417320"/>
           </a:xfrm>
           <a:prstGeom prst="rect">
@@ -9750,7 +9232,7 @@
               <a:buNone/>
             </a:pPr>
             <a:r>
-              <a:rPr lang="en-US" sz="1050" dirty="0">
+              <a:rPr lang="de-DE" sz="1200" dirty="0">
                 <a:solidFill>
                   <a:srgbClr val="1B2430"/>
                 </a:solidFill>
@@ -9758,162 +9240,9 @@
                 <a:ea typeface="Calibri" pitchFamily="34" charset="-122"/>
                 <a:cs typeface="Segoe UI" panose="020B0502040204020203" pitchFamily="34" charset="0"/>
               </a:rPr>
-              <a:t>BPMN-Dateien angereichert für Camunda 8: Task-Definitionen, Subscriptions, Timer, FEEL-Bedingungen. Camunda-Linter und bpmnlint: 0 Befunde.</a:t>
-            </a:r>
-            <a:endParaRPr lang="en-US" sz="1050" dirty="0">
-              <a:latin typeface="Segoe UI" panose="020B0502040204020203" pitchFamily="34" charset="0"/>
-              <a:cs typeface="Segoe UI" panose="020B0502040204020203" pitchFamily="34" charset="0"/>
-            </a:endParaRPr>
-          </a:p>
-        </p:txBody>
-      </p:sp>
-      <p:sp>
-        <p:nvSpPr>
-          <p:cNvPr id="17" name="Shape 12"/>
-          <p:cNvSpPr/>
-          <p:nvPr/>
-        </p:nvSpPr>
-        <p:spPr>
-          <a:xfrm>
-            <a:off x="6217920" y="1353312"/>
-            <a:ext cx="457200" cy="457200"/>
-          </a:xfrm>
-          <a:prstGeom prst="ellipse">
-            <a:avLst/>
-          </a:prstGeom>
-          <a:solidFill>
-            <a:schemeClr val="accent2">
-              <a:lumMod val="50000"/>
-            </a:schemeClr>
-          </a:solidFill>
-          <a:ln w="12700">
-            <a:noFill/>
-            <a:prstDash val="solid"/>
-          </a:ln>
-        </p:spPr>
-        <p:txBody>
-          <a:bodyPr/>
-          <a:lstStyle/>
-          <a:p>
-            <a:endParaRPr lang="de-DE">
-              <a:latin typeface="Segoe UI" panose="020B0502040204020203" pitchFamily="34" charset="0"/>
-              <a:cs typeface="Segoe UI" panose="020B0502040204020203" pitchFamily="34" charset="0"/>
-            </a:endParaRPr>
-          </a:p>
-        </p:txBody>
-      </p:sp>
-      <p:pic>
-        <p:nvPicPr>
-          <p:cNvPr id="18" name="Image 2" descr="preencoded.png"/>
-          <p:cNvPicPr>
-            <a:picLocks noChangeAspect="1"/>
-          </p:cNvPicPr>
-          <p:nvPr/>
-        </p:nvPicPr>
-        <p:blipFill>
-          <a:blip r:embed="rId5"/>
-          <a:stretch>
-            <a:fillRect/>
-          </a:stretch>
-        </p:blipFill>
-        <p:spPr>
-          <a:xfrm>
-            <a:off x="6332220" y="1467612"/>
-            <a:ext cx="228600" cy="228600"/>
-          </a:xfrm>
-          <a:prstGeom prst="rect">
-            <a:avLst/>
-          </a:prstGeom>
-        </p:spPr>
-      </p:pic>
-      <p:sp>
-        <p:nvSpPr>
-          <p:cNvPr id="19" name="Text 13"/>
-          <p:cNvSpPr txBox="1"/>
-          <p:nvPr/>
-        </p:nvSpPr>
-        <p:spPr>
-          <a:xfrm>
-            <a:off x="6812280" y="1335024"/>
-            <a:ext cx="1737360" cy="457200"/>
-          </a:xfrm>
-          <a:prstGeom prst="rect">
-            <a:avLst/>
-          </a:prstGeom>
-          <a:noFill/>
-          <a:ln/>
-        </p:spPr>
-        <p:txBody>
-          <a:bodyPr wrap="square" lIns="0" tIns="0" rIns="0" bIns="0" rtlCol="0" anchor="ctr"/>
-          <a:lstStyle/>
-          <a:p>
-            <a:pPr marL="0" indent="0">
-              <a:buNone/>
-            </a:pPr>
-            <a:r>
-              <a:rPr lang="en-US" sz="1400" b="1" dirty="0">
-                <a:solidFill>
-                  <a:schemeClr val="accent2">
-                    <a:lumMod val="50000"/>
-                  </a:schemeClr>
-                </a:solidFill>
-                <a:latin typeface="Segoe UI" panose="020B0502040204020203" pitchFamily="34" charset="0"/>
-                <a:ea typeface="Calibri" pitchFamily="34" charset="-122"/>
-                <a:cs typeface="Segoe UI" panose="020B0502040204020203" pitchFamily="34" charset="0"/>
-              </a:rPr>
-              <a:t>Reviews</a:t>
-            </a:r>
-            <a:endParaRPr lang="en-US" sz="1400" dirty="0">
-              <a:solidFill>
-                <a:schemeClr val="accent2">
-                  <a:lumMod val="50000"/>
-                </a:schemeClr>
-              </a:solidFill>
-              <a:latin typeface="Segoe UI" panose="020B0502040204020203" pitchFamily="34" charset="0"/>
-              <a:cs typeface="Segoe UI" panose="020B0502040204020203" pitchFamily="34" charset="0"/>
-            </a:endParaRPr>
-          </a:p>
-        </p:txBody>
-      </p:sp>
-      <p:sp>
-        <p:nvSpPr>
-          <p:cNvPr id="20" name="Text 14"/>
-          <p:cNvSpPr txBox="1"/>
-          <p:nvPr/>
-        </p:nvSpPr>
-        <p:spPr>
-          <a:xfrm>
-            <a:off x="6217920" y="1901952"/>
-            <a:ext cx="2286000" cy="1417320"/>
-          </a:xfrm>
-          <a:prstGeom prst="rect">
-            <a:avLst/>
-          </a:prstGeom>
-          <a:noFill/>
-          <a:ln/>
-        </p:spPr>
-        <p:txBody>
-          <a:bodyPr wrap="square" lIns="0" tIns="0" rIns="0" bIns="0" rtlCol="0" anchor="t"/>
-          <a:lstStyle/>
-          <a:p>
-            <a:pPr marL="0" indent="0">
-              <a:buNone/>
-            </a:pPr>
-            <a:r>
-              <a:rPr lang="en-US" sz="1050" dirty="0">
-                <a:solidFill>
-                  <a:srgbClr val="1B2430"/>
-                </a:solidFill>
-                <a:latin typeface="Segoe UI" panose="020B0502040204020203" pitchFamily="34" charset="0"/>
-                <a:ea typeface="Calibri" pitchFamily="34" charset="-122"/>
-                <a:cs typeface="Segoe UI" panose="020B0502040204020203" pitchFamily="34" charset="0"/>
-              </a:rPr>
-              <a:t>Jedes Diagramm im Zweierteam geprüft, Abstimmung in den Gruppenterminen. Jeder Pull Request wird gegen die QA-Checkliste geprüft, bevor er gemergt wird.</a:t>
-            </a:r>
-            <a:endParaRPr lang="en-US" sz="1050" dirty="0">
-              <a:latin typeface="Segoe UI" panose="020B0502040204020203" pitchFamily="34" charset="0"/>
-              <a:cs typeface="Segoe UI" panose="020B0502040204020203" pitchFamily="34" charset="0"/>
-            </a:endParaRPr>
+              <a:t>Jedes Diagramm von einer zweiten Person geprüft. Jede Änderung gegen eine Checkliste.</a:t>
+            </a:r>
+            <a:endParaRPr lang="de-DE" sz="1200"/>
           </a:p>
         </p:txBody>
       </p:sp>
@@ -10022,7 +9351,7 @@
               <a:buNone/>
             </a:pPr>
             <a:r>
-              <a:rPr lang="en-US" sz="1100" b="1" dirty="0">
+              <a:rPr lang="de-DE" sz="1200" b="1" dirty="0">
                 <a:solidFill>
                   <a:srgbClr val="1B2430"/>
                 </a:solidFill>
@@ -10033,7 +9362,7 @@
               <a:t>Beispiel: </a:t>
             </a:r>
             <a:r>
-              <a:rPr lang="en-US" sz="1100" dirty="0">
+              <a:rPr lang="de-DE" sz="1200" dirty="0">
                 <a:solidFill>
                   <a:srgbClr val="1B2430"/>
                 </a:solidFill>
@@ -10041,12 +9370,9 @@
                 <a:ea typeface="Calibri" pitchFamily="34" charset="-122"/>
                 <a:cs typeface="Segoe UI" panose="020B0502040204020203" pitchFamily="34" charset="0"/>
               </a:rPr>
-              <a:t>Als die Nacharbeit in Prozess 07 auf zwei Durchläufe begrenzt wurde, musste Sequenzdiagramm SD4 nachziehen (loop 0..2, danach Status abgelehnt). Genau solche Stellen findet die Checkliste: Botschaft = Operation, Akteur → Oberfläche → Objekt, Zustand = AuftragStatus.</a:t>
-            </a:r>
-            <a:endParaRPr lang="en-US" sz="1100" dirty="0">
-              <a:latin typeface="Segoe UI" panose="020B0502040204020203" pitchFamily="34" charset="0"/>
-              <a:cs typeface="Segoe UI" panose="020B0502040204020203" pitchFamily="34" charset="0"/>
-            </a:endParaRPr>
+              <a:t>Nacharbeit höchstens zweimal. Diese Regel muss in allen Modellen gleich stehen.</a:t>
+            </a:r>
+            <a:endParaRPr lang="de-DE" sz="1200"/>
           </a:p>
         </p:txBody>
       </p:sp>
@@ -10127,7 +9453,7 @@
               <a:buNone/>
             </a:pPr>
             <a:r>
-              <a:rPr lang="en-US" sz="2800" b="1" dirty="0" err="1">
+              <a:rPr lang="de-DE" sz="2800" b="1" dirty="0">
                 <a:solidFill>
                   <a:schemeClr val="accent2">
                     <a:lumMod val="75000"/>
@@ -10137,69 +9463,9 @@
                 <a:ea typeface="Calibri" pitchFamily="34" charset="-122"/>
                 <a:cs typeface="Segoe UI" panose="020B0502040204020203" pitchFamily="34" charset="0"/>
               </a:rPr>
-              <a:t>Qualität</a:t>
-            </a:r>
-            <a:r>
-              <a:rPr lang="en-US" sz="2800" b="1" dirty="0">
-                <a:solidFill>
-                  <a:schemeClr val="accent2">
-                    <a:lumMod val="75000"/>
-                  </a:schemeClr>
-                </a:solidFill>
-                <a:latin typeface="Segoe UI" panose="020B0502040204020203" pitchFamily="34" charset="0"/>
-                <a:ea typeface="Calibri" pitchFamily="34" charset="-122"/>
-                <a:cs typeface="Segoe UI" panose="020B0502040204020203" pitchFamily="34" charset="0"/>
-              </a:rPr>
-              <a:t>: </a:t>
-            </a:r>
-            <a:r>
-              <a:rPr lang="en-US" sz="2800" b="1" dirty="0" err="1">
-                <a:solidFill>
-                  <a:schemeClr val="accent2">
-                    <a:lumMod val="75000"/>
-                  </a:schemeClr>
-                </a:solidFill>
-                <a:latin typeface="Segoe UI" panose="020B0502040204020203" pitchFamily="34" charset="0"/>
-                <a:ea typeface="Calibri" pitchFamily="34" charset="-122"/>
-                <a:cs typeface="Segoe UI" panose="020B0502040204020203" pitchFamily="34" charset="0"/>
-              </a:rPr>
-              <a:t>Konventionen</a:t>
-            </a:r>
-            <a:r>
-              <a:rPr lang="en-US" sz="2800" b="1" dirty="0">
-                <a:solidFill>
-                  <a:schemeClr val="accent2">
-                    <a:lumMod val="75000"/>
-                  </a:schemeClr>
-                </a:solidFill>
-                <a:latin typeface="Segoe UI" panose="020B0502040204020203" pitchFamily="34" charset="0"/>
-                <a:ea typeface="Calibri" pitchFamily="34" charset="-122"/>
-                <a:cs typeface="Segoe UI" panose="020B0502040204020203" pitchFamily="34" charset="0"/>
-              </a:rPr>
-              <a:t>, Linter, </a:t>
-            </a:r>
-            <a:r>
-              <a:rPr lang="en-US" sz="2800" b="1" dirty="0" err="1">
-                <a:solidFill>
-                  <a:schemeClr val="accent2">
-                    <a:lumMod val="75000"/>
-                  </a:schemeClr>
-                </a:solidFill>
-                <a:latin typeface="Segoe UI" panose="020B0502040204020203" pitchFamily="34" charset="0"/>
-                <a:ea typeface="Calibri" pitchFamily="34" charset="-122"/>
-                <a:cs typeface="Segoe UI" panose="020B0502040204020203" pitchFamily="34" charset="0"/>
-              </a:rPr>
-              <a:t>Konsistenz</a:t>
-            </a:r>
-            <a:endParaRPr lang="en-US" sz="2800" dirty="0">
-              <a:solidFill>
-                <a:schemeClr val="accent2">
-                  <a:lumMod val="75000"/>
-                </a:schemeClr>
-              </a:solidFill>
-              <a:latin typeface="Segoe UI" panose="020B0502040204020203" pitchFamily="34" charset="0"/>
-              <a:cs typeface="Segoe UI" panose="020B0502040204020203" pitchFamily="34" charset="0"/>
-            </a:endParaRPr>
+              <a:t>Qualität: Regeln, Werkzeuge, Reviews</a:t>
+            </a:r>
+            <a:endParaRPr lang="de-DE" sz="2800"/>
           </a:p>
         </p:txBody>
       </p:sp>
@@ -10402,7 +9668,7 @@
               <a:buNone/>
             </a:pPr>
             <a:r>
-              <a:rPr lang="en-US" sz="1150" dirty="0">
+              <a:rPr lang="de-DE" sz="1400" dirty="0">
                 <a:solidFill>
                   <a:srgbClr val="1B2430"/>
                 </a:solidFill>
@@ -10410,9 +9676,9 @@
                 <a:ea typeface="Calibri" pitchFamily="34" charset="-122"/>
                 <a:cs typeface="Calibri" pitchFamily="34" charset="-120"/>
               </a:rPr>
-              <a:t>Werkstatt oder Softwareanbieter? Die Rückfrage des Dozenten hat uns zur klaren Entscheidung gezwungen: Solution Provider, FixWerk als Pilotkunde. Prozesse blieben, Texte und Klassenmodell zogen nach.</a:t>
-            </a:r>
-            <a:endParaRPr lang="en-US" sz="1150" dirty="0"/>
+              <a:t>Werkstatt oder Softwareanbieter? Wir sind der Anbieter, FixWerk ist Pilotkunde.</a:t>
+            </a:r>
+            <a:endParaRPr lang="de-DE" sz="1400"/>
           </a:p>
         </p:txBody>
       </p:sp>
@@ -10552,7 +9818,7 @@
               <a:buNone/>
             </a:pPr>
             <a:r>
-              <a:rPr lang="en-US" sz="1150" dirty="0">
+              <a:rPr lang="de-DE" sz="1400" dirty="0">
                 <a:solidFill>
                   <a:srgbClr val="1B2430"/>
                 </a:solidFill>
@@ -10560,9 +9826,9 @@
                 <a:ea typeface="Calibri" pitchFamily="34" charset="-122"/>
                 <a:cs typeface="Calibri" pitchFamily="34" charset="-120"/>
               </a:rPr>
-              <a:t>Datenobjekte, Klassen, Lebenslinien und Statuswerte müssen wortgleich sein. Gemeinsame Namensregeln und ein Abgleich nach jeder Änderung halten die Modelle zusammen.</a:t>
-            </a:r>
-            <a:endParaRPr lang="en-US" sz="1150" dirty="0"/>
+              <a:t>Klassen, Datenobjekte und Statuswerte heißen überall gleich.</a:t>
+            </a:r>
+            <a:endParaRPr lang="de-DE" sz="1400"/>
           </a:p>
         </p:txBody>
       </p:sp>
@@ -10655,7 +9921,7 @@
               <a:buNone/>
             </a:pPr>
             <a:r>
-              <a:rPr lang="en-US" sz="1400" b="1" dirty="0">
+              <a:rPr lang="de-DE" sz="1400" b="1" dirty="0">
                 <a:solidFill>
                   <a:schemeClr val="accent2">
                     <a:lumMod val="75000"/>
@@ -10665,15 +9931,9 @@
                 <a:ea typeface="Calibri" pitchFamily="34" charset="-122"/>
                 <a:cs typeface="Calibri" pitchFamily="34" charset="-120"/>
               </a:rPr>
-              <a:t>Engine-ready statt Fehlerliste</a:t>
-            </a:r>
-            <a:endParaRPr lang="en-US" sz="1400" dirty="0">
-              <a:solidFill>
-                <a:schemeClr val="accent2">
-                  <a:lumMod val="75000"/>
-                </a:schemeClr>
-              </a:solidFill>
-            </a:endParaRPr>
+              <a:t>Keine Fehler im Camunda Modeler</a:t>
+            </a:r>
+            <a:endParaRPr lang="de-DE" sz="1400"/>
           </a:p>
         </p:txBody>
       </p:sp>
@@ -10702,7 +9962,7 @@
               <a:buNone/>
             </a:pPr>
             <a:r>
-              <a:rPr lang="en-US" sz="1150" dirty="0">
+              <a:rPr lang="de-DE" sz="1400" dirty="0">
                 <a:solidFill>
                   <a:srgbClr val="1B2430"/>
                 </a:solidFill>
@@ -10710,9 +9970,9 @@
                 <a:ea typeface="Calibri" pitchFamily="34" charset="-122"/>
                 <a:cs typeface="Calibri" pitchFamily="34" charset="-120"/>
               </a:rPr>
-              <a:t>Der Camunda Modeler meldet für Camunda 8 fehlende technische Details als Fehler. Wir haben die Diagramme angereichert, bis der Linter keine Befunde mehr meldete.</a:t>
-            </a:r>
-            <a:endParaRPr lang="en-US" sz="1150" dirty="0"/>
+              <a:t>Diagramme so lange ergänzt, bis keine Fehler mehr kamen.</a:t>
+            </a:r>
+            <a:endParaRPr lang="de-DE" sz="1400"/>
           </a:p>
         </p:txBody>
       </p:sp>
@@ -10797,7 +10057,7 @@
               <a:buNone/>
             </a:pPr>
             <a:r>
-              <a:rPr lang="en-US" sz="1400" b="1" dirty="0">
+              <a:rPr lang="de-DE" sz="1400" b="1" dirty="0">
                 <a:solidFill>
                   <a:schemeClr val="accent2">
                     <a:lumMod val="50000"/>
@@ -10807,15 +10067,9 @@
                 <a:ea typeface="Calibri" pitchFamily="34" charset="-122"/>
                 <a:cs typeface="Calibri" pitchFamily="34" charset="-120"/>
               </a:rPr>
-              <a:t>Hinweise von außen nutzen</a:t>
-            </a:r>
-            <a:endParaRPr lang="en-US" sz="1400" dirty="0">
-              <a:solidFill>
-                <a:schemeClr val="accent2">
-                  <a:lumMod val="50000"/>
-                </a:schemeClr>
-              </a:solidFill>
-            </a:endParaRPr>
+              <a:t>Feedback aus den Coachings</a:t>
+            </a:r>
+            <a:endParaRPr lang="de-DE" sz="1400"/>
           </a:p>
         </p:txBody>
       </p:sp>
@@ -10844,7 +10098,7 @@
               <a:buNone/>
             </a:pPr>
             <a:r>
-              <a:rPr lang="en-US" sz="1150" dirty="0">
+              <a:rPr lang="de-DE" sz="1400" dirty="0">
                 <a:solidFill>
                   <a:srgbClr val="1B2430"/>
                 </a:solidFill>
@@ -10852,9 +10106,9 @@
                 <a:ea typeface="Calibri" pitchFamily="34" charset="-122"/>
                 <a:cs typeface="Calibri" pitchFamily="34" charset="-120"/>
               </a:rPr>
-              <a:t>Die KI-Vision glaubwürdig halten (heute machbar vs. Vision), nach den Coachings eine Rolle je Use Case und Oberflächen in den Sequenzdiagrammen: Das hat die Arbeit deutlich besser gemacht.</a:t>
-            </a:r>
-            <a:endParaRPr lang="en-US" sz="1150" dirty="0"/>
+              <a:t>Eine Rolle je Use Case, eigene Oberflächenklassen, KI-Vision realistisch halten.</a:t>
+            </a:r>
+            <a:endParaRPr lang="de-DE" sz="1400"/>
           </a:p>
         </p:txBody>
       </p:sp>
@@ -10942,7 +10196,7 @@
     </p:spTree>
     <p:extLst>
       <p:ext uri="{BB962C8B-B14F-4D97-AF65-F5344CB8AC3E}">
-        <p14:creationId xmlns:p14="http://schemas.microsoft.com/office/powerpoint/2010/main" val="8933715"/>
+        <p14:creationId xmlns:p14="http://schemas.microsoft.com/office/powerpoint/2010/main" val="1146934768"/>
       </p:ext>
     </p:extLst>
   </p:cSld>
@@ -16242,15 +15496,7 @@
 
 <file path=ppt/slides/slide3.xml><?xml version="1.0" encoding="utf-8"?>
 <p:sld xmlns:a="http://schemas.openxmlformats.org/drawingml/2006/main" xmlns:r="http://schemas.openxmlformats.org/officeDocument/2006/relationships" xmlns:p="http://schemas.openxmlformats.org/presentationml/2006/main">
-  <p:cSld name="Slide 3">
-    <p:bg>
-      <p:bgPr>
-        <a:solidFill>
-          <a:srgbClr val="FFFFFF"/>
-        </a:solidFill>
-        <a:effectLst/>
-      </p:bgPr>
-    </p:bg>
+  <p:cSld>
     <p:spTree>
       <p:nvGrpSpPr>
         <p:cNvPr id="1" name=""/>
@@ -16339,7 +15585,7 @@
               <a:buNone/>
             </a:pPr>
             <a:r>
-              <a:rPr lang="en-US" sz="1300" dirty="0">
+              <a:rPr lang="de-DE" sz="1300" dirty="0">
                 <a:solidFill>
                   <a:srgbClr val="1B2430"/>
                 </a:solidFill>
@@ -16347,12 +15593,9 @@
                 <a:ea typeface="Calibri" pitchFamily="34" charset="-122"/>
                 <a:cs typeface="Segoe UI" panose="020B0502040204020203" pitchFamily="34" charset="0"/>
               </a:rPr>
-              <a:t>Unser Szenario: Die Werkstattkette FixWerk GmbH (vier Filialen, Fahrrad, E-Bike und Elektronik) arbeitet mit Papier, Excel-Listen und Telefon. Daraus folgen vier Probleme:</a:t>
-            </a:r>
-            <a:endParaRPr lang="en-US" sz="1300" dirty="0">
-              <a:latin typeface="Segoe UI" panose="020B0502040204020203" pitchFamily="34" charset="0"/>
-              <a:cs typeface="Segoe UI" panose="020B0502040204020203" pitchFamily="34" charset="0"/>
-            </a:endParaRPr>
+              <a:t>Unser Szenario: die Werkstattkette FixWerk mit vier Filialen. Sie arbeitet mit Papier, Excel-Listen und Telefon.</a:t>
+            </a:r>
+            <a:endParaRPr lang="de-DE" sz="1300"/>
           </a:p>
         </p:txBody>
       </p:sp>
@@ -16489,7 +15732,7 @@
               <a:buNone/>
             </a:pPr>
             <a:r>
-              <a:rPr lang="en-US" sz="1150" dirty="0">
+              <a:rPr lang="de-DE" sz="1200" dirty="0">
                 <a:solidFill>
                   <a:srgbClr val="1B2430"/>
                 </a:solidFill>
@@ -16497,12 +15740,9 @@
                 <a:ea typeface="Calibri" pitchFamily="34" charset="-122"/>
                 <a:cs typeface="Segoe UI" panose="020B0502040204020203" pitchFamily="34" charset="0"/>
               </a:rPr>
-              <a:t>Keine zuverlässige Info, wann ein Kostenvoranschlag freizugeben oder das Gerät abholbereit ist. Rückfragen per Telefon, Geräte stehen wochenlang im Lager.</a:t>
-            </a:r>
-            <a:endParaRPr lang="en-US" sz="1150" dirty="0">
-              <a:latin typeface="Segoe UI" panose="020B0502040204020203" pitchFamily="34" charset="0"/>
-              <a:cs typeface="Segoe UI" panose="020B0502040204020203" pitchFamily="34" charset="0"/>
-            </a:endParaRPr>
+              <a:t>Ob der KVA da ist oder das Gerät fertig ist, erfährt der Kunde nur am Telefon.</a:t>
+            </a:r>
+            <a:endParaRPr lang="de-DE" sz="1200"/>
           </a:p>
         </p:txBody>
       </p:sp>
@@ -16639,7 +15879,7 @@
               <a:buNone/>
             </a:pPr>
             <a:r>
-              <a:rPr lang="en-US" sz="1150" dirty="0">
+              <a:rPr lang="de-DE" sz="1200" dirty="0">
                 <a:solidFill>
                   <a:srgbClr val="1B2430"/>
                 </a:solidFill>
@@ -16647,12 +15887,9 @@
                 <a:ea typeface="Calibri" pitchFamily="34" charset="-122"/>
                 <a:cs typeface="Segoe UI" panose="020B0502040204020203" pitchFamily="34" charset="0"/>
               </a:rPr>
-              <a:t>Wer wissen will, wo ein Gerät steht, fragt in der Werkstatt nach. Papierzettel und Excel-Listen laufen auseinander.</a:t>
-            </a:r>
-            <a:endParaRPr lang="en-US" sz="1150" dirty="0">
-              <a:latin typeface="Segoe UI" panose="020B0502040204020203" pitchFamily="34" charset="0"/>
-              <a:cs typeface="Segoe UI" panose="020B0502040204020203" pitchFamily="34" charset="0"/>
-            </a:endParaRPr>
+              <a:t>Zettel und Excel-Listen passen nicht zusammen. Wo ein Gerät steht, weiß niemand sofort.</a:t>
+            </a:r>
+            <a:endParaRPr lang="de-DE" sz="1200"/>
           </a:p>
         </p:txBody>
       </p:sp>
@@ -16789,7 +16026,7 @@
               <a:buNone/>
             </a:pPr>
             <a:r>
-              <a:rPr lang="en-US" sz="1150" dirty="0">
+              <a:rPr lang="de-DE" sz="1200" dirty="0">
                 <a:solidFill>
                   <a:srgbClr val="1B2430"/>
                 </a:solidFill>
@@ -16797,12 +16034,9 @@
                 <a:ea typeface="Calibri" pitchFamily="34" charset="-122"/>
                 <a:cs typeface="Segoe UI" panose="020B0502040204020203" pitchFamily="34" charset="0"/>
               </a:rPr>
-              <a:t>Jede Filiale bestellt für sich, obwohl das Teil in der Nachbarfiliale liegt. Das kostet Lieferzeit und Geld.</a:t>
-            </a:r>
-            <a:endParaRPr lang="en-US" sz="1150" dirty="0">
-              <a:latin typeface="Segoe UI" panose="020B0502040204020203" pitchFamily="34" charset="0"/>
-              <a:cs typeface="Segoe UI" panose="020B0502040204020203" pitchFamily="34" charset="0"/>
-            </a:endParaRPr>
+              <a:t>Jede Filiale bestellt selbst, obwohl das Teil oft nebenan liegt.</a:t>
+            </a:r>
+            <a:endParaRPr lang="de-DE" sz="1200"/>
           </a:p>
         </p:txBody>
       </p:sp>
@@ -16939,7 +16173,7 @@
               <a:buNone/>
             </a:pPr>
             <a:r>
-              <a:rPr lang="en-US" sz="1150" dirty="0">
+              <a:rPr lang="de-DE" sz="1200" dirty="0">
                 <a:solidFill>
                   <a:srgbClr val="1B2430"/>
                 </a:solidFill>
@@ -16947,12 +16181,9 @@
                 <a:ea typeface="Calibri" pitchFamily="34" charset="-122"/>
                 <a:cs typeface="Segoe UI" panose="020B0502040204020203" pitchFamily="34" charset="0"/>
               </a:rPr>
-              <a:t>Termine werden nach Gefühl zugesagt, die Kapazität der Techniker kennt niemand genau.</a:t>
-            </a:r>
-            <a:endParaRPr lang="en-US" sz="1150" dirty="0">
-              <a:latin typeface="Segoe UI" panose="020B0502040204020203" pitchFamily="34" charset="0"/>
-              <a:cs typeface="Segoe UI" panose="020B0502040204020203" pitchFamily="34" charset="0"/>
-            </a:endParaRPr>
+              <a:t>Termine werden nach Gefühl zugesagt.</a:t>
+            </a:r>
+            <a:endParaRPr lang="de-DE" sz="1200"/>
           </a:p>
         </p:txBody>
       </p:sp>
@@ -16966,15 +16197,7 @@
 
 <file path=ppt/slides/slide4.xml><?xml version="1.0" encoding="utf-8"?>
 <p:sld xmlns:a="http://schemas.openxmlformats.org/drawingml/2006/main" xmlns:r="http://schemas.openxmlformats.org/officeDocument/2006/relationships" xmlns:p="http://schemas.openxmlformats.org/presentationml/2006/main">
-  <p:cSld name="Slide 4">
-    <p:bg>
-      <p:bgPr>
-        <a:solidFill>
-          <a:srgbClr val="FFFFFF"/>
-        </a:solidFill>
-        <a:effectLst/>
-      </p:bgPr>
-    </p:bg>
+  <p:cSld>
     <p:spTree>
       <p:nvGrpSpPr>
         <p:cNvPr id="1" name=""/>
@@ -17100,7 +16323,7 @@
               <a:buNone/>
             </a:pPr>
             <a:r>
-              <a:rPr lang="en-US" sz="1400" b="1" dirty="0">
+              <a:rPr lang="de-DE" sz="1400" b="1" dirty="0">
                 <a:solidFill>
                   <a:srgbClr val="FFFFFF"/>
                 </a:solidFill>
@@ -17108,12 +16331,9 @@
                 <a:ea typeface="Calibri" pitchFamily="34" charset="-122"/>
                 <a:cs typeface="Segoe UI" panose="020B0502040204020203" pitchFamily="34" charset="0"/>
               </a:rPr>
-              <a:t>Eine Cloud-Plattform für den gesamten Reparatur-Lebenszyklus: von der Anfrage per App bis zur Abholung und Reklamation. Wir sind das Software-Startup, FixWerk ist unser Pilotkunde.</a:t>
-            </a:r>
-            <a:endParaRPr lang="en-US" sz="1400" dirty="0">
-              <a:latin typeface="Segoe UI" panose="020B0502040204020203" pitchFamily="34" charset="0"/>
-              <a:cs typeface="Segoe UI" panose="020B0502040204020203" pitchFamily="34" charset="0"/>
-            </a:endParaRPr>
+              <a:t>Eine Plattform für die ganze Reparatur, von der Anfrage per App bis zur Abholung. Wir sind das Software-Startup, FixWerk ist unser Pilotkunde.</a:t>
+            </a:r>
+            <a:endParaRPr lang="de-DE" sz="1400"/>
           </a:p>
         </p:txBody>
       </p:sp>
@@ -17185,7 +16405,7 @@
         <p:spPr>
           <a:xfrm>
             <a:off x="1234440" y="2084832"/>
-            <a:ext cx="1165860" cy="457200"/>
+            <a:ext cx="1490000" cy="457200"/>
           </a:xfrm>
           <a:prstGeom prst="rect">
             <a:avLst/>
@@ -17243,7 +16463,7 @@
               <a:buNone/>
             </a:pPr>
             <a:r>
-              <a:rPr lang="en-US" sz="1050" dirty="0">
+              <a:rPr lang="de-DE" sz="1200" dirty="0">
                 <a:solidFill>
                   <a:srgbClr val="1B2430"/>
                 </a:solidFill>
@@ -17251,56 +16471,16 @@
                 <a:ea typeface="Calibri" pitchFamily="34" charset="-122"/>
                 <a:cs typeface="Segoe UI" panose="020B0502040204020203" pitchFamily="34" charset="0"/>
               </a:rPr>
-              <a:t>App </a:t>
-            </a:r>
-            <a:r>
-              <a:rPr lang="en-US" sz="1050" dirty="0" err="1">
-                <a:solidFill>
-                  <a:srgbClr val="1B2430"/>
-                </a:solidFill>
-                <a:latin typeface="Segoe UI" panose="020B0502040204020203" pitchFamily="34" charset="0"/>
-                <a:ea typeface="Calibri" pitchFamily="34" charset="-122"/>
-                <a:cs typeface="Segoe UI" panose="020B0502040204020203" pitchFamily="34" charset="0"/>
-              </a:rPr>
-              <a:t>mit</a:t>
-            </a:r>
-            <a:r>
-              <a:rPr lang="en-US" sz="1050" dirty="0">
-                <a:solidFill>
-                  <a:srgbClr val="1B2430"/>
-                </a:solidFill>
-                <a:latin typeface="Segoe UI" panose="020B0502040204020203" pitchFamily="34" charset="0"/>
-                <a:ea typeface="Calibri" pitchFamily="34" charset="-122"/>
-                <a:cs typeface="Segoe UI" panose="020B0502040204020203" pitchFamily="34" charset="0"/>
-              </a:rPr>
-              <a:t> </a:t>
-            </a:r>
-            <a:r>
-              <a:rPr lang="en-US" sz="1050" dirty="0" err="1">
-                <a:solidFill>
-                  <a:srgbClr val="1B2430"/>
-                </a:solidFill>
-                <a:latin typeface="Segoe UI" panose="020B0502040204020203" pitchFamily="34" charset="0"/>
-                <a:ea typeface="Calibri" pitchFamily="34" charset="-122"/>
-                <a:cs typeface="Segoe UI" panose="020B0502040204020203" pitchFamily="34" charset="0"/>
-              </a:rPr>
               <a:t>Sofortdiagnose</a:t>
             </a:r>
-            <a:endParaRPr lang="en-US" sz="1050" dirty="0">
-              <a:solidFill>
-                <a:srgbClr val="1B2430"/>
-              </a:solidFill>
-              <a:latin typeface="Segoe UI" panose="020B0502040204020203" pitchFamily="34" charset="0"/>
-              <a:ea typeface="Calibri" pitchFamily="34" charset="-122"/>
-              <a:cs typeface="Segoe UI" panose="020B0502040204020203" pitchFamily="34" charset="0"/>
-            </a:endParaRPr>
+            <a:endParaRPr lang="de-DE" sz="1200"/>
           </a:p>
           <a:p>
             <a:pPr marL="0" indent="0">
               <a:buNone/>
             </a:pPr>
             <a:r>
-              <a:rPr lang="en-US" sz="1050" dirty="0" err="1">
+              <a:rPr lang="de-DE" sz="1200" dirty="0">
                 <a:solidFill>
                   <a:srgbClr val="1B2430"/>
                 </a:solidFill>
@@ -17308,23 +16488,16 @@
                 <a:ea typeface="Calibri" pitchFamily="34" charset="-122"/>
                 <a:cs typeface="Segoe UI" panose="020B0502040204020203" pitchFamily="34" charset="0"/>
               </a:rPr>
-              <a:t>Voranmeldung</a:t>
-            </a:r>
-            <a:endParaRPr lang="en-US" sz="1050" dirty="0">
-              <a:solidFill>
-                <a:srgbClr val="1B2430"/>
-              </a:solidFill>
-              <a:latin typeface="Segoe UI" panose="020B0502040204020203" pitchFamily="34" charset="0"/>
-              <a:ea typeface="Calibri" pitchFamily="34" charset="-122"/>
-              <a:cs typeface="Segoe UI" panose="020B0502040204020203" pitchFamily="34" charset="0"/>
-            </a:endParaRPr>
+              <a:t>KVA freigeben</a:t>
+            </a:r>
+            <a:endParaRPr lang="de-DE" sz="1200"/>
           </a:p>
           <a:p>
             <a:pPr marL="0" indent="0">
               <a:buNone/>
             </a:pPr>
             <a:r>
-              <a:rPr lang="en-US" sz="1050" dirty="0">
+              <a:rPr lang="de-DE" sz="1200" dirty="0">
                 <a:solidFill>
                   <a:srgbClr val="1B2430"/>
                 </a:solidFill>
@@ -17332,47 +16505,9 @@
                 <a:ea typeface="Calibri" pitchFamily="34" charset="-122"/>
                 <a:cs typeface="Segoe UI" panose="020B0502040204020203" pitchFamily="34" charset="0"/>
               </a:rPr>
-              <a:t>KVA-</a:t>
-            </a:r>
-            <a:r>
-              <a:rPr lang="en-US" sz="1050" dirty="0" err="1">
-                <a:solidFill>
-                  <a:srgbClr val="1B2430"/>
-                </a:solidFill>
-                <a:latin typeface="Segoe UI" panose="020B0502040204020203" pitchFamily="34" charset="0"/>
-                <a:ea typeface="Calibri" pitchFamily="34" charset="-122"/>
-                <a:cs typeface="Segoe UI" panose="020B0502040204020203" pitchFamily="34" charset="0"/>
-              </a:rPr>
-              <a:t>Freigabe</a:t>
-            </a:r>
-            <a:endParaRPr lang="en-US" sz="1050" dirty="0">
-              <a:solidFill>
-                <a:srgbClr val="1B2430"/>
-              </a:solidFill>
-              <a:latin typeface="Segoe UI" panose="020B0502040204020203" pitchFamily="34" charset="0"/>
-              <a:ea typeface="Calibri" pitchFamily="34" charset="-122"/>
-              <a:cs typeface="Segoe UI" panose="020B0502040204020203" pitchFamily="34" charset="0"/>
-            </a:endParaRPr>
-          </a:p>
-          <a:p>
-            <a:pPr marL="0" indent="0">
-              <a:buNone/>
-            </a:pPr>
-            <a:r>
-              <a:rPr lang="en-US" sz="1050" dirty="0" err="1">
-                <a:solidFill>
-                  <a:srgbClr val="1B2430"/>
-                </a:solidFill>
-                <a:latin typeface="Segoe UI" panose="020B0502040204020203" pitchFamily="34" charset="0"/>
-                <a:ea typeface="Calibri" pitchFamily="34" charset="-122"/>
-                <a:cs typeface="Segoe UI" panose="020B0502040204020203" pitchFamily="34" charset="0"/>
-              </a:rPr>
-              <a:t>Statusmeldungen</a:t>
-            </a:r>
-            <a:endParaRPr lang="en-US" sz="1050" dirty="0">
-              <a:latin typeface="Segoe UI" panose="020B0502040204020203" pitchFamily="34" charset="0"/>
-              <a:cs typeface="Segoe UI" panose="020B0502040204020203" pitchFamily="34" charset="0"/>
-            </a:endParaRPr>
+              <a:t>Status</a:t>
+            </a:r>
+            <a:endParaRPr lang="de-DE" sz="1200"/>
           </a:p>
         </p:txBody>
       </p:sp>
@@ -17502,7 +16637,7 @@
               <a:buNone/>
             </a:pPr>
             <a:r>
-              <a:rPr lang="en-US" sz="1050" dirty="0" err="1">
+              <a:rPr lang="de-DE" sz="1200" dirty="0">
                 <a:solidFill>
                   <a:srgbClr val="1B2430"/>
                 </a:solidFill>
@@ -17510,23 +16645,16 @@
                 <a:ea typeface="Calibri" pitchFamily="34" charset="-122"/>
                 <a:cs typeface="Segoe UI" panose="020B0502040204020203" pitchFamily="34" charset="0"/>
               </a:rPr>
-              <a:t>Auftragsstatus</a:t>
-            </a:r>
-            <a:endParaRPr lang="en-US" sz="1050" dirty="0">
-              <a:solidFill>
-                <a:srgbClr val="1B2430"/>
-              </a:solidFill>
-              <a:latin typeface="Segoe UI" panose="020B0502040204020203" pitchFamily="34" charset="0"/>
-              <a:ea typeface="Calibri" pitchFamily="34" charset="-122"/>
-              <a:cs typeface="Segoe UI" panose="020B0502040204020203" pitchFamily="34" charset="0"/>
-            </a:endParaRPr>
+              <a:t>Diagnose</a:t>
+            </a:r>
+            <a:endParaRPr lang="de-DE" sz="1200"/>
           </a:p>
           <a:p>
             <a:pPr marL="0" indent="0">
               <a:buNone/>
             </a:pPr>
             <a:r>
-              <a:rPr lang="en-US" sz="1050" dirty="0">
+              <a:rPr lang="de-DE" sz="1200" dirty="0">
                 <a:solidFill>
                   <a:srgbClr val="1B2430"/>
                 </a:solidFill>
@@ -17534,15 +16662,16 @@
                 <a:ea typeface="Calibri" pitchFamily="34" charset="-122"/>
                 <a:cs typeface="Segoe UI" panose="020B0502040204020203" pitchFamily="34" charset="0"/>
               </a:rPr>
-              <a:t>Diagnose</a:t>
-            </a:r>
+              <a:t>Kostenvoranschlag</a:t>
+            </a:r>
+            <a:endParaRPr lang="de-DE" sz="1200"/>
           </a:p>
           <a:p>
             <a:pPr marL="0" indent="0">
               <a:buNone/>
             </a:pPr>
             <a:r>
-              <a:rPr lang="en-US" sz="1050" dirty="0" err="1">
+              <a:rPr lang="de-DE" sz="1200" dirty="0">
                 <a:solidFill>
                   <a:srgbClr val="1B2430"/>
                 </a:solidFill>
@@ -17550,60 +16679,9 @@
                 <a:ea typeface="Calibri" pitchFamily="34" charset="-122"/>
                 <a:cs typeface="Segoe UI" panose="020B0502040204020203" pitchFamily="34" charset="0"/>
               </a:rPr>
-              <a:t>Kostenvoranschlag</a:t>
-            </a:r>
-            <a:endParaRPr lang="en-US" sz="1050" dirty="0">
-              <a:solidFill>
-                <a:srgbClr val="1B2430"/>
-              </a:solidFill>
-              <a:latin typeface="Segoe UI" panose="020B0502040204020203" pitchFamily="34" charset="0"/>
-              <a:ea typeface="Calibri" pitchFamily="34" charset="-122"/>
-              <a:cs typeface="Segoe UI" panose="020B0502040204020203" pitchFamily="34" charset="0"/>
-            </a:endParaRPr>
-          </a:p>
-          <a:p>
-            <a:pPr marL="0" indent="0">
-              <a:buNone/>
-            </a:pPr>
-            <a:r>
-              <a:rPr lang="en-US" sz="1050" dirty="0" err="1">
-                <a:solidFill>
-                  <a:srgbClr val="1B2430"/>
-                </a:solidFill>
-                <a:latin typeface="Segoe UI" panose="020B0502040204020203" pitchFamily="34" charset="0"/>
-                <a:ea typeface="Calibri" pitchFamily="34" charset="-122"/>
-                <a:cs typeface="Segoe UI" panose="020B0502040204020203" pitchFamily="34" charset="0"/>
-              </a:rPr>
-              <a:t>Reparaturschritte</a:t>
-            </a:r>
-            <a:endParaRPr lang="en-US" sz="1050" dirty="0">
-              <a:solidFill>
-                <a:srgbClr val="1B2430"/>
-              </a:solidFill>
-              <a:latin typeface="Segoe UI" panose="020B0502040204020203" pitchFamily="34" charset="0"/>
-              <a:ea typeface="Calibri" pitchFamily="34" charset="-122"/>
-              <a:cs typeface="Segoe UI" panose="020B0502040204020203" pitchFamily="34" charset="0"/>
-            </a:endParaRPr>
-          </a:p>
-          <a:p>
-            <a:pPr marL="0" indent="0">
-              <a:buNone/>
-            </a:pPr>
-            <a:r>
-              <a:rPr lang="en-US" sz="1050" dirty="0" err="1">
-                <a:solidFill>
-                  <a:srgbClr val="1B2430"/>
-                </a:solidFill>
-                <a:latin typeface="Segoe UI" panose="020B0502040204020203" pitchFamily="34" charset="0"/>
-                <a:ea typeface="Calibri" pitchFamily="34" charset="-122"/>
-                <a:cs typeface="Segoe UI" panose="020B0502040204020203" pitchFamily="34" charset="0"/>
-              </a:rPr>
-              <a:t>Endkontrolle</a:t>
-            </a:r>
-            <a:endParaRPr lang="en-US" sz="1050" dirty="0">
-              <a:latin typeface="Segoe UI" panose="020B0502040204020203" pitchFamily="34" charset="0"/>
-              <a:cs typeface="Segoe UI" panose="020B0502040204020203" pitchFamily="34" charset="0"/>
-            </a:endParaRPr>
+              <a:t>Reparatur</a:t>
+            </a:r>
+            <a:endParaRPr lang="de-DE" sz="1200"/>
           </a:p>
         </p:txBody>
       </p:sp>
@@ -17733,7 +16811,7 @@
               <a:buNone/>
             </a:pPr>
             <a:r>
-              <a:rPr lang="en-US" sz="1050" dirty="0">
+              <a:rPr lang="de-DE" sz="1200" dirty="0">
                 <a:solidFill>
                   <a:srgbClr val="1B2430"/>
                 </a:solidFill>
@@ -17741,56 +16819,16 @@
                 <a:ea typeface="Calibri" pitchFamily="34" charset="-122"/>
                 <a:cs typeface="Segoe UI" panose="020B0502040204020203" pitchFamily="34" charset="0"/>
               </a:rPr>
-              <a:t>Bestände </a:t>
-            </a:r>
-            <a:r>
-              <a:rPr lang="en-US" sz="1050" dirty="0" err="1">
-                <a:solidFill>
-                  <a:srgbClr val="1B2430"/>
-                </a:solidFill>
-                <a:latin typeface="Segoe UI" panose="020B0502040204020203" pitchFamily="34" charset="0"/>
-                <a:ea typeface="Calibri" pitchFamily="34" charset="-122"/>
-                <a:cs typeface="Segoe UI" panose="020B0502040204020203" pitchFamily="34" charset="0"/>
-              </a:rPr>
-              <a:t>aller</a:t>
-            </a:r>
-            <a:r>
-              <a:rPr lang="en-US" sz="1050" dirty="0">
-                <a:solidFill>
-                  <a:srgbClr val="1B2430"/>
-                </a:solidFill>
-                <a:latin typeface="Segoe UI" panose="020B0502040204020203" pitchFamily="34" charset="0"/>
-                <a:ea typeface="Calibri" pitchFamily="34" charset="-122"/>
-                <a:cs typeface="Segoe UI" panose="020B0502040204020203" pitchFamily="34" charset="0"/>
-              </a:rPr>
-              <a:t> </a:t>
-            </a:r>
-            <a:r>
-              <a:rPr lang="en-US" sz="1050" dirty="0" err="1">
-                <a:solidFill>
-                  <a:srgbClr val="1B2430"/>
-                </a:solidFill>
-                <a:latin typeface="Segoe UI" panose="020B0502040204020203" pitchFamily="34" charset="0"/>
-                <a:ea typeface="Calibri" pitchFamily="34" charset="-122"/>
-                <a:cs typeface="Segoe UI" panose="020B0502040204020203" pitchFamily="34" charset="0"/>
-              </a:rPr>
-              <a:t>Filialen</a:t>
-            </a:r>
-            <a:endParaRPr lang="en-US" sz="1050" dirty="0">
-              <a:solidFill>
-                <a:srgbClr val="1B2430"/>
-              </a:solidFill>
-              <a:latin typeface="Segoe UI" panose="020B0502040204020203" pitchFamily="34" charset="0"/>
-              <a:ea typeface="Calibri" pitchFamily="34" charset="-122"/>
-              <a:cs typeface="Segoe UI" panose="020B0502040204020203" pitchFamily="34" charset="0"/>
-            </a:endParaRPr>
+              <a:t>Bestände</a:t>
+            </a:r>
+            <a:endParaRPr lang="de-DE" sz="1200"/>
           </a:p>
           <a:p>
             <a:pPr marL="0" indent="0">
               <a:buNone/>
             </a:pPr>
             <a:r>
-              <a:rPr lang="en-US" sz="1050" dirty="0" err="1">
+              <a:rPr lang="de-DE" sz="1200" dirty="0">
                 <a:solidFill>
                   <a:srgbClr val="1B2430"/>
                 </a:solidFill>
@@ -17800,21 +16838,14 @@
               </a:rPr>
               <a:t>Reservierung</a:t>
             </a:r>
-            <a:endParaRPr lang="en-US" sz="1050" dirty="0">
-              <a:solidFill>
-                <a:srgbClr val="1B2430"/>
-              </a:solidFill>
-              <a:latin typeface="Segoe UI" panose="020B0502040204020203" pitchFamily="34" charset="0"/>
-              <a:ea typeface="Calibri" pitchFamily="34" charset="-122"/>
-              <a:cs typeface="Segoe UI" panose="020B0502040204020203" pitchFamily="34" charset="0"/>
-            </a:endParaRPr>
+            <a:endParaRPr lang="de-DE" sz="1200"/>
           </a:p>
           <a:p>
             <a:pPr marL="0" indent="0">
               <a:buNone/>
             </a:pPr>
             <a:r>
-              <a:rPr lang="en-US" sz="1050" dirty="0" err="1">
+              <a:rPr lang="de-DE" sz="1200" dirty="0">
                 <a:solidFill>
                   <a:srgbClr val="1B2430"/>
                 </a:solidFill>
@@ -17822,60 +16853,9 @@
                 <a:ea typeface="Calibri" pitchFamily="34" charset="-122"/>
                 <a:cs typeface="Segoe UI" panose="020B0502040204020203" pitchFamily="34" charset="0"/>
               </a:rPr>
-              <a:t>Umlagerung</a:t>
-            </a:r>
-            <a:endParaRPr lang="en-US" sz="1050" dirty="0">
-              <a:solidFill>
-                <a:srgbClr val="1B2430"/>
-              </a:solidFill>
-              <a:latin typeface="Segoe UI" panose="020B0502040204020203" pitchFamily="34" charset="0"/>
-              <a:ea typeface="Calibri" pitchFamily="34" charset="-122"/>
-              <a:cs typeface="Segoe UI" panose="020B0502040204020203" pitchFamily="34" charset="0"/>
-            </a:endParaRPr>
-          </a:p>
-          <a:p>
-            <a:pPr marL="0" indent="0">
-              <a:buNone/>
-            </a:pPr>
-            <a:r>
-              <a:rPr lang="en-US" sz="1050" dirty="0" err="1">
-                <a:solidFill>
-                  <a:srgbClr val="1B2430"/>
-                </a:solidFill>
-                <a:latin typeface="Segoe UI" panose="020B0502040204020203" pitchFamily="34" charset="0"/>
-                <a:ea typeface="Calibri" pitchFamily="34" charset="-122"/>
-                <a:cs typeface="Segoe UI" panose="020B0502040204020203" pitchFamily="34" charset="0"/>
-              </a:rPr>
               <a:t>Bestellung</a:t>
             </a:r>
-            <a:endParaRPr lang="en-US" sz="1050" dirty="0">
-              <a:solidFill>
-                <a:srgbClr val="1B2430"/>
-              </a:solidFill>
-              <a:latin typeface="Segoe UI" panose="020B0502040204020203" pitchFamily="34" charset="0"/>
-              <a:ea typeface="Calibri" pitchFamily="34" charset="-122"/>
-              <a:cs typeface="Segoe UI" panose="020B0502040204020203" pitchFamily="34" charset="0"/>
-            </a:endParaRPr>
-          </a:p>
-          <a:p>
-            <a:pPr marL="0" indent="0">
-              <a:buNone/>
-            </a:pPr>
-            <a:r>
-              <a:rPr lang="en-US" sz="1050" dirty="0" err="1">
-                <a:solidFill>
-                  <a:srgbClr val="1B2430"/>
-                </a:solidFill>
-                <a:latin typeface="Segoe UI" panose="020B0502040204020203" pitchFamily="34" charset="0"/>
-                <a:ea typeface="Calibri" pitchFamily="34" charset="-122"/>
-                <a:cs typeface="Segoe UI" panose="020B0502040204020203" pitchFamily="34" charset="0"/>
-              </a:rPr>
-              <a:t>Retoure</a:t>
-            </a:r>
-            <a:endParaRPr lang="en-US" sz="1050" dirty="0">
-              <a:latin typeface="Segoe UI" panose="020B0502040204020203" pitchFamily="34" charset="0"/>
-              <a:cs typeface="Segoe UI" panose="020B0502040204020203" pitchFamily="34" charset="0"/>
-            </a:endParaRPr>
+            <a:endParaRPr lang="de-DE" sz="1200"/>
           </a:p>
         </p:txBody>
       </p:sp>
@@ -17947,7 +16927,7 @@
         <p:spPr>
           <a:xfrm>
             <a:off x="7543800" y="2084832"/>
-            <a:ext cx="1051560" cy="457200"/>
+            <a:ext cx="1300000" cy="457200"/>
           </a:xfrm>
           <a:prstGeom prst="rect">
             <a:avLst/>
@@ -18005,7 +16985,7 @@
               <a:buNone/>
             </a:pPr>
             <a:r>
-              <a:rPr lang="en-US" sz="1050" dirty="0" err="1">
+              <a:rPr lang="de-DE" sz="1200" dirty="0">
                 <a:solidFill>
                   <a:srgbClr val="1B2430"/>
                 </a:solidFill>
@@ -18015,21 +16995,14 @@
               </a:rPr>
               <a:t>Rechnung</a:t>
             </a:r>
-            <a:endParaRPr lang="en-US" sz="1050" dirty="0">
-              <a:solidFill>
-                <a:srgbClr val="1B2430"/>
-              </a:solidFill>
-              <a:latin typeface="Segoe UI" panose="020B0502040204020203" pitchFamily="34" charset="0"/>
-              <a:ea typeface="Calibri" pitchFamily="34" charset="-122"/>
-              <a:cs typeface="Segoe UI" panose="020B0502040204020203" pitchFamily="34" charset="0"/>
-            </a:endParaRPr>
+            <a:endParaRPr lang="de-DE" sz="1200"/>
           </a:p>
           <a:p>
             <a:pPr marL="0" indent="0">
               <a:buNone/>
             </a:pPr>
             <a:r>
-              <a:rPr lang="en-US" sz="1050" dirty="0" err="1">
+              <a:rPr lang="de-DE" sz="1200" dirty="0">
                 <a:solidFill>
                   <a:srgbClr val="1B2430"/>
                 </a:solidFill>
@@ -18039,45 +17012,7 @@
               </a:rPr>
               <a:t>Zahlung</a:t>
             </a:r>
-            <a:endParaRPr lang="en-US" sz="1050" dirty="0">
-              <a:solidFill>
-                <a:srgbClr val="1B2430"/>
-              </a:solidFill>
-              <a:latin typeface="Segoe UI" panose="020B0502040204020203" pitchFamily="34" charset="0"/>
-              <a:ea typeface="Calibri" pitchFamily="34" charset="-122"/>
-              <a:cs typeface="Segoe UI" panose="020B0502040204020203" pitchFamily="34" charset="0"/>
-            </a:endParaRPr>
-          </a:p>
-          <a:p>
-            <a:pPr marL="0" indent="0">
-              <a:buNone/>
-            </a:pPr>
-            <a:r>
-              <a:rPr lang="en-US" sz="1050" dirty="0" err="1">
-                <a:solidFill>
-                  <a:srgbClr val="1B2430"/>
-                </a:solidFill>
-                <a:latin typeface="Segoe UI" panose="020B0502040204020203" pitchFamily="34" charset="0"/>
-                <a:ea typeface="Calibri" pitchFamily="34" charset="-122"/>
-                <a:cs typeface="Segoe UI" panose="020B0502040204020203" pitchFamily="34" charset="0"/>
-              </a:rPr>
-              <a:t>Übergabe</a:t>
-            </a:r>
-            <a:r>
-              <a:rPr lang="en-US" sz="1050" dirty="0">
-                <a:solidFill>
-                  <a:srgbClr val="1B2430"/>
-                </a:solidFill>
-                <a:latin typeface="Segoe UI" panose="020B0502040204020203" pitchFamily="34" charset="0"/>
-                <a:ea typeface="Calibri" pitchFamily="34" charset="-122"/>
-                <a:cs typeface="Segoe UI" panose="020B0502040204020203" pitchFamily="34" charset="0"/>
-              </a:rPr>
-              <a:t> an die Buchhaltung</a:t>
-            </a:r>
-            <a:endParaRPr lang="en-US" sz="1050" dirty="0">
-              <a:latin typeface="Segoe UI" panose="020B0502040204020203" pitchFamily="34" charset="0"/>
-              <a:cs typeface="Segoe UI" panose="020B0502040204020203" pitchFamily="34" charset="0"/>
-            </a:endParaRPr>
+            <a:endParaRPr lang="de-DE" sz="1200"/>
           </a:p>
         </p:txBody>
       </p:sp>
@@ -18110,7 +17045,7 @@
               <a:buChar char="•"/>
             </a:pPr>
             <a:r>
-              <a:rPr lang="en-US" sz="1200" dirty="0">
+              <a:rPr lang="de-DE" sz="1200" dirty="0">
                 <a:solidFill>
                   <a:srgbClr val="1B2430"/>
                 </a:solidFill>
@@ -18118,12 +17053,9 @@
                 <a:ea typeface="Calibri" pitchFamily="34" charset="-122"/>
                 <a:cs typeface="Segoe UI" panose="020B0502040204020203" pitchFamily="34" charset="0"/>
               </a:rPr>
-              <a:t>Zielkunden: unabhängige Werkstätten und kleine Ketten mit 2 bis 10 Filialen im DACH-Raum</a:t>
-            </a:r>
-            <a:endParaRPr lang="en-US" sz="1200" dirty="0">
-              <a:latin typeface="Segoe UI" panose="020B0502040204020203" pitchFamily="34" charset="0"/>
-              <a:cs typeface="Segoe UI" panose="020B0502040204020203" pitchFamily="34" charset="0"/>
-            </a:endParaRPr>
+              <a:t>Zielkunden: Werkstätten und kleine Ketten mit 2 bis 10 Filialen</a:t>
+            </a:r>
+            <a:endParaRPr lang="de-DE" sz="1200"/>
           </a:p>
           <a:p>
             <a:pPr marL="342900" indent="-342900">
@@ -18134,7 +17066,7 @@
               <a:buChar char="•"/>
             </a:pPr>
             <a:r>
-              <a:rPr lang="en-US" sz="1200" dirty="0">
+              <a:rPr lang="de-DE" sz="1200" dirty="0">
                 <a:solidFill>
                   <a:srgbClr val="1B2430"/>
                 </a:solidFill>
@@ -18142,12 +17074,9 @@
                 <a:ea typeface="Calibri" pitchFamily="34" charset="-122"/>
                 <a:cs typeface="Segoe UI" panose="020B0502040204020203" pitchFamily="34" charset="0"/>
               </a:rPr>
-              <a:t>Außerhalb der Plattform: physische Reparatur, Lieferantensysteme, Buchhaltung (nur Schnittstellen)</a:t>
-            </a:r>
-            <a:endParaRPr lang="en-US" sz="1200" dirty="0">
-              <a:latin typeface="Segoe UI" panose="020B0502040204020203" pitchFamily="34" charset="0"/>
-              <a:cs typeface="Segoe UI" panose="020B0502040204020203" pitchFamily="34" charset="0"/>
-            </a:endParaRPr>
+              <a:t>Nicht Teil der Plattform: die Reparatur selbst, Lieferantensysteme, Buchhaltung</a:t>
+            </a:r>
+            <a:endParaRPr lang="de-DE" sz="1200"/>
           </a:p>
         </p:txBody>
       </p:sp>
@@ -18483,7 +17412,7 @@
               <a:buNone/>
             </a:pPr>
             <a:r>
-              <a:rPr lang="en-US" sz="2800" b="1" dirty="0">
+              <a:rPr lang="de-DE" sz="2800" b="1" dirty="0">
                 <a:solidFill>
                   <a:schemeClr val="accent2">
                     <a:lumMod val="75000"/>
@@ -18493,35 +17422,13 @@
                 <a:ea typeface="Calibri" pitchFamily="34" charset="-122"/>
                 <a:cs typeface="Segoe UI" panose="020B0502040204020203" pitchFamily="34" charset="0"/>
               </a:rPr>
-              <a:t>Drei </a:t>
-            </a:r>
-            <a:r>
-              <a:rPr lang="en-US" sz="2800" b="1" dirty="0" err="1">
-                <a:solidFill>
-                  <a:schemeClr val="accent2">
-                    <a:lumMod val="75000"/>
-                  </a:schemeClr>
-                </a:solidFill>
-                <a:latin typeface="Segoe UI" panose="020B0502040204020203" pitchFamily="34" charset="0"/>
-                <a:ea typeface="Calibri" pitchFamily="34" charset="-122"/>
-                <a:cs typeface="Segoe UI" panose="020B0502040204020203" pitchFamily="34" charset="0"/>
-              </a:rPr>
-              <a:t>Nutzenversprechen</a:t>
-            </a:r>
-            <a:endParaRPr lang="en-US" sz="2800" b="1" dirty="0">
-              <a:solidFill>
-                <a:schemeClr val="accent2">
-                  <a:lumMod val="75000"/>
-                </a:schemeClr>
-              </a:solidFill>
-              <a:latin typeface="Segoe UI" panose="020B0502040204020203" pitchFamily="34" charset="0"/>
-              <a:ea typeface="Calibri" pitchFamily="34" charset="-122"/>
-              <a:cs typeface="Segoe UI" panose="020B0502040204020203" pitchFamily="34" charset="0"/>
-            </a:endParaRPr>
-          </a:p>
-          <a:p>
-            <a:r>
-              <a:rPr lang="en-US" sz="1400" dirty="0">
+              <a:t>Drei Nutzenversprechen</a:t>
+            </a:r>
+            <a:endParaRPr lang="de-DE" sz="2800"/>
+          </a:p>
+          <a:p>
+            <a:r>
+              <a:rPr lang="de-DE" sz="1400" dirty="0">
                 <a:solidFill>
                   <a:schemeClr val="bg1">
                     <a:lumMod val="50000"/>
@@ -18531,10 +17438,10 @@
                 <a:ea typeface="Calibri" pitchFamily="34" charset="-122"/>
                 <a:cs typeface="Segoe UI" panose="020B0502040204020203" pitchFamily="34" charset="0"/>
               </a:rPr>
-              <a:t>Die </a:t>
-            </a:r>
-            <a:r>
-              <a:rPr lang="en-US" sz="1400" dirty="0" err="1">
+              <a:t>Werkstatt: weniger Telefonate, kürzere Standzeiten, sichtbare Auslastung.</a:t>
+            </a:r>
+            <a:br>
+              <a:rPr lang="de-DE" sz="1400" dirty="0">
                 <a:solidFill>
                   <a:schemeClr val="bg1">
                     <a:lumMod val="50000"/>
@@ -18544,10 +17451,9 @@
                 <a:ea typeface="Calibri" pitchFamily="34" charset="-122"/>
                 <a:cs typeface="Segoe UI" panose="020B0502040204020203" pitchFamily="34" charset="0"/>
               </a:rPr>
-              <a:t>Werkstätten</a:t>
-            </a:r>
-            <a:r>
-              <a:rPr lang="en-US" sz="1400" dirty="0">
+            </a:br>
+            <a:r>
+              <a:rPr lang="de-DE" sz="1400" dirty="0">
                 <a:solidFill>
                   <a:schemeClr val="bg1">
                     <a:lumMod val="50000"/>
@@ -18557,303 +17463,8 @@
                 <a:ea typeface="Calibri" pitchFamily="34" charset="-122"/>
                 <a:cs typeface="Segoe UI" panose="020B0502040204020203" pitchFamily="34" charset="0"/>
               </a:rPr>
-              <a:t> </a:t>
-            </a:r>
-            <a:r>
-              <a:rPr lang="en-US" sz="1400" dirty="0" err="1">
-                <a:solidFill>
-                  <a:schemeClr val="bg1">
-                    <a:lumMod val="50000"/>
-                  </a:schemeClr>
-                </a:solidFill>
-                <a:latin typeface="Segoe UI" panose="020B0502040204020203" pitchFamily="34" charset="0"/>
-                <a:ea typeface="Calibri" pitchFamily="34" charset="-122"/>
-                <a:cs typeface="Segoe UI" panose="020B0502040204020203" pitchFamily="34" charset="0"/>
-              </a:rPr>
-              <a:t>profitieren</a:t>
-            </a:r>
-            <a:r>
-              <a:rPr lang="en-US" sz="1400" dirty="0">
-                <a:solidFill>
-                  <a:schemeClr val="bg1">
-                    <a:lumMod val="50000"/>
-                  </a:schemeClr>
-                </a:solidFill>
-                <a:latin typeface="Segoe UI" panose="020B0502040204020203" pitchFamily="34" charset="0"/>
-                <a:ea typeface="Calibri" pitchFamily="34" charset="-122"/>
-                <a:cs typeface="Segoe UI" panose="020B0502040204020203" pitchFamily="34" charset="0"/>
-              </a:rPr>
-              <a:t> von </a:t>
-            </a:r>
-            <a:r>
-              <a:rPr lang="en-US" sz="1400" dirty="0" err="1">
-                <a:solidFill>
-                  <a:schemeClr val="bg1">
-                    <a:lumMod val="50000"/>
-                  </a:schemeClr>
-                </a:solidFill>
-                <a:latin typeface="Segoe UI" panose="020B0502040204020203" pitchFamily="34" charset="0"/>
-                <a:ea typeface="Calibri" pitchFamily="34" charset="-122"/>
-                <a:cs typeface="Segoe UI" panose="020B0502040204020203" pitchFamily="34" charset="0"/>
-              </a:rPr>
-              <a:t>weniger</a:t>
-            </a:r>
-            <a:r>
-              <a:rPr lang="en-US" sz="1400" dirty="0">
-                <a:solidFill>
-                  <a:schemeClr val="bg1">
-                    <a:lumMod val="50000"/>
-                  </a:schemeClr>
-                </a:solidFill>
-                <a:latin typeface="Segoe UI" panose="020B0502040204020203" pitchFamily="34" charset="0"/>
-                <a:ea typeface="Calibri" pitchFamily="34" charset="-122"/>
-                <a:cs typeface="Segoe UI" panose="020B0502040204020203" pitchFamily="34" charset="0"/>
-              </a:rPr>
-              <a:t> </a:t>
-            </a:r>
-            <a:r>
-              <a:rPr lang="en-US" sz="1400" dirty="0" err="1">
-                <a:solidFill>
-                  <a:schemeClr val="bg1">
-                    <a:lumMod val="50000"/>
-                  </a:schemeClr>
-                </a:solidFill>
-                <a:latin typeface="Segoe UI" panose="020B0502040204020203" pitchFamily="34" charset="0"/>
-                <a:ea typeface="Calibri" pitchFamily="34" charset="-122"/>
-                <a:cs typeface="Segoe UI" panose="020B0502040204020203" pitchFamily="34" charset="0"/>
-              </a:rPr>
-              <a:t>Telefonaten</a:t>
-            </a:r>
-            <a:r>
-              <a:rPr lang="en-US" sz="1400" dirty="0">
-                <a:solidFill>
-                  <a:schemeClr val="bg1">
-                    <a:lumMod val="50000"/>
-                  </a:schemeClr>
-                </a:solidFill>
-                <a:latin typeface="Segoe UI" panose="020B0502040204020203" pitchFamily="34" charset="0"/>
-                <a:ea typeface="Calibri" pitchFamily="34" charset="-122"/>
-                <a:cs typeface="Segoe UI" panose="020B0502040204020203" pitchFamily="34" charset="0"/>
-              </a:rPr>
-              <a:t>, </a:t>
-            </a:r>
-            <a:r>
-              <a:rPr lang="en-US" sz="1400" dirty="0" err="1">
-                <a:solidFill>
-                  <a:schemeClr val="bg1">
-                    <a:lumMod val="50000"/>
-                  </a:schemeClr>
-                </a:solidFill>
-                <a:latin typeface="Segoe UI" panose="020B0502040204020203" pitchFamily="34" charset="0"/>
-                <a:ea typeface="Calibri" pitchFamily="34" charset="-122"/>
-                <a:cs typeface="Segoe UI" panose="020B0502040204020203" pitchFamily="34" charset="0"/>
-              </a:rPr>
-              <a:t>weniger</a:t>
-            </a:r>
-            <a:r>
-              <a:rPr lang="en-US" sz="1400" dirty="0">
-                <a:solidFill>
-                  <a:schemeClr val="bg1">
-                    <a:lumMod val="50000"/>
-                  </a:schemeClr>
-                </a:solidFill>
-                <a:latin typeface="Segoe UI" panose="020B0502040204020203" pitchFamily="34" charset="0"/>
-                <a:ea typeface="Calibri" pitchFamily="34" charset="-122"/>
-                <a:cs typeface="Segoe UI" panose="020B0502040204020203" pitchFamily="34" charset="0"/>
-              </a:rPr>
-              <a:t> </a:t>
-            </a:r>
-            <a:r>
-              <a:rPr lang="en-US" sz="1400" dirty="0" err="1">
-                <a:solidFill>
-                  <a:schemeClr val="bg1">
-                    <a:lumMod val="50000"/>
-                  </a:schemeClr>
-                </a:solidFill>
-                <a:latin typeface="Segoe UI" panose="020B0502040204020203" pitchFamily="34" charset="0"/>
-                <a:ea typeface="Calibri" pitchFamily="34" charset="-122"/>
-                <a:cs typeface="Segoe UI" panose="020B0502040204020203" pitchFamily="34" charset="0"/>
-              </a:rPr>
-              <a:t>Standzeit</a:t>
-            </a:r>
-            <a:r>
-              <a:rPr lang="en-US" sz="1400" dirty="0">
-                <a:solidFill>
-                  <a:schemeClr val="bg1">
-                    <a:lumMod val="50000"/>
-                  </a:schemeClr>
-                </a:solidFill>
-                <a:latin typeface="Segoe UI" panose="020B0502040204020203" pitchFamily="34" charset="0"/>
-                <a:ea typeface="Calibri" pitchFamily="34" charset="-122"/>
-                <a:cs typeface="Segoe UI" panose="020B0502040204020203" pitchFamily="34" charset="0"/>
-              </a:rPr>
-              <a:t> </a:t>
-            </a:r>
-            <a:r>
-              <a:rPr lang="en-US" sz="1400" dirty="0" err="1">
-                <a:solidFill>
-                  <a:schemeClr val="bg1">
-                    <a:lumMod val="50000"/>
-                  </a:schemeClr>
-                </a:solidFill>
-                <a:latin typeface="Segoe UI" panose="020B0502040204020203" pitchFamily="34" charset="0"/>
-                <a:ea typeface="Calibri" pitchFamily="34" charset="-122"/>
-                <a:cs typeface="Segoe UI" panose="020B0502040204020203" pitchFamily="34" charset="0"/>
-              </a:rPr>
-              <a:t>im</a:t>
-            </a:r>
-            <a:r>
-              <a:rPr lang="en-US" sz="1400" dirty="0">
-                <a:solidFill>
-                  <a:schemeClr val="bg1">
-                    <a:lumMod val="50000"/>
-                  </a:schemeClr>
-                </a:solidFill>
-                <a:latin typeface="Segoe UI" panose="020B0502040204020203" pitchFamily="34" charset="0"/>
-                <a:ea typeface="Calibri" pitchFamily="34" charset="-122"/>
-                <a:cs typeface="Segoe UI" panose="020B0502040204020203" pitchFamily="34" charset="0"/>
-              </a:rPr>
-              <a:t> Lager, </a:t>
-            </a:r>
-            <a:r>
-              <a:rPr lang="en-US" sz="1400" dirty="0" err="1">
-                <a:solidFill>
-                  <a:schemeClr val="bg1">
-                    <a:lumMod val="50000"/>
-                  </a:schemeClr>
-                </a:solidFill>
-                <a:latin typeface="Segoe UI" panose="020B0502040204020203" pitchFamily="34" charset="0"/>
-                <a:ea typeface="Calibri" pitchFamily="34" charset="-122"/>
-                <a:cs typeface="Segoe UI" panose="020B0502040204020203" pitchFamily="34" charset="0"/>
-              </a:rPr>
-              <a:t>sichtbare</a:t>
-            </a:r>
-            <a:r>
-              <a:rPr lang="en-US" sz="1400" dirty="0">
-                <a:solidFill>
-                  <a:schemeClr val="bg1">
-                    <a:lumMod val="50000"/>
-                  </a:schemeClr>
-                </a:solidFill>
-                <a:latin typeface="Segoe UI" panose="020B0502040204020203" pitchFamily="34" charset="0"/>
-                <a:ea typeface="Calibri" pitchFamily="34" charset="-122"/>
-                <a:cs typeface="Segoe UI" panose="020B0502040204020203" pitchFamily="34" charset="0"/>
-              </a:rPr>
-              <a:t> </a:t>
-            </a:r>
-            <a:r>
-              <a:rPr lang="en-US" sz="1400" dirty="0" err="1">
-                <a:solidFill>
-                  <a:schemeClr val="bg1">
-                    <a:lumMod val="50000"/>
-                  </a:schemeClr>
-                </a:solidFill>
-                <a:latin typeface="Segoe UI" panose="020B0502040204020203" pitchFamily="34" charset="0"/>
-                <a:ea typeface="Calibri" pitchFamily="34" charset="-122"/>
-                <a:cs typeface="Segoe UI" panose="020B0502040204020203" pitchFamily="34" charset="0"/>
-              </a:rPr>
-              <a:t>Auslastung</a:t>
-            </a:r>
-            <a:r>
-              <a:rPr lang="en-US" sz="1400" dirty="0">
-                <a:solidFill>
-                  <a:schemeClr val="bg1">
-                    <a:lumMod val="50000"/>
-                  </a:schemeClr>
-                </a:solidFill>
-                <a:latin typeface="Segoe UI" panose="020B0502040204020203" pitchFamily="34" charset="0"/>
-                <a:ea typeface="Calibri" pitchFamily="34" charset="-122"/>
-                <a:cs typeface="Segoe UI" panose="020B0502040204020203" pitchFamily="34" charset="0"/>
-              </a:rPr>
-              <a:t>. Die Kunden </a:t>
-            </a:r>
-            <a:r>
-              <a:rPr lang="en-US" sz="1400" dirty="0" err="1">
-                <a:solidFill>
-                  <a:schemeClr val="bg1">
-                    <a:lumMod val="50000"/>
-                  </a:schemeClr>
-                </a:solidFill>
-                <a:latin typeface="Segoe UI" panose="020B0502040204020203" pitchFamily="34" charset="0"/>
-                <a:ea typeface="Calibri" pitchFamily="34" charset="-122"/>
-                <a:cs typeface="Segoe UI" panose="020B0502040204020203" pitchFamily="34" charset="0"/>
-              </a:rPr>
-              <a:t>profitieren</a:t>
-            </a:r>
-            <a:r>
-              <a:rPr lang="en-US" sz="1400" dirty="0">
-                <a:solidFill>
-                  <a:schemeClr val="bg1">
-                    <a:lumMod val="50000"/>
-                  </a:schemeClr>
-                </a:solidFill>
-                <a:latin typeface="Segoe UI" panose="020B0502040204020203" pitchFamily="34" charset="0"/>
-                <a:ea typeface="Calibri" pitchFamily="34" charset="-122"/>
-                <a:cs typeface="Segoe UI" panose="020B0502040204020203" pitchFamily="34" charset="0"/>
-              </a:rPr>
-              <a:t> von  </a:t>
-            </a:r>
-            <a:r>
-              <a:rPr lang="en-US" sz="1400" dirty="0" err="1">
-                <a:solidFill>
-                  <a:schemeClr val="bg1">
-                    <a:lumMod val="50000"/>
-                  </a:schemeClr>
-                </a:solidFill>
-                <a:latin typeface="Segoe UI" panose="020B0502040204020203" pitchFamily="34" charset="0"/>
-                <a:ea typeface="Calibri" pitchFamily="34" charset="-122"/>
-                <a:cs typeface="Segoe UI" panose="020B0502040204020203" pitchFamily="34" charset="0"/>
-              </a:rPr>
-              <a:t>schnelleren</a:t>
-            </a:r>
-            <a:r>
-              <a:rPr lang="en-US" sz="1400" dirty="0">
-                <a:solidFill>
-                  <a:schemeClr val="bg1">
-                    <a:lumMod val="50000"/>
-                  </a:schemeClr>
-                </a:solidFill>
-                <a:latin typeface="Segoe UI" panose="020B0502040204020203" pitchFamily="34" charset="0"/>
-                <a:ea typeface="Calibri" pitchFamily="34" charset="-122"/>
-                <a:cs typeface="Segoe UI" panose="020B0502040204020203" pitchFamily="34" charset="0"/>
-              </a:rPr>
-              <a:t> </a:t>
-            </a:r>
-            <a:r>
-              <a:rPr lang="en-US" sz="1400" dirty="0" err="1">
-                <a:solidFill>
-                  <a:schemeClr val="bg1">
-                    <a:lumMod val="50000"/>
-                  </a:schemeClr>
-                </a:solidFill>
-                <a:latin typeface="Segoe UI" panose="020B0502040204020203" pitchFamily="34" charset="0"/>
-                <a:ea typeface="Calibri" pitchFamily="34" charset="-122"/>
-                <a:cs typeface="Segoe UI" panose="020B0502040204020203" pitchFamily="34" charset="0"/>
-              </a:rPr>
-              <a:t>Antworten</a:t>
-            </a:r>
-            <a:r>
-              <a:rPr lang="en-US" sz="1400" dirty="0">
-                <a:solidFill>
-                  <a:schemeClr val="bg1">
-                    <a:lumMod val="50000"/>
-                  </a:schemeClr>
-                </a:solidFill>
-                <a:latin typeface="Segoe UI" panose="020B0502040204020203" pitchFamily="34" charset="0"/>
-                <a:ea typeface="Calibri" pitchFamily="34" charset="-122"/>
-                <a:cs typeface="Segoe UI" panose="020B0502040204020203" pitchFamily="34" charset="0"/>
-              </a:rPr>
-              <a:t>.</a:t>
-            </a:r>
-            <a:endParaRPr lang="en-US" sz="1400" dirty="0">
-              <a:solidFill>
-                <a:schemeClr val="bg1">
-                  <a:lumMod val="50000"/>
-                </a:schemeClr>
-              </a:solidFill>
-              <a:latin typeface="Segoe UI" panose="020B0502040204020203" pitchFamily="34" charset="0"/>
-              <a:cs typeface="Segoe UI" panose="020B0502040204020203" pitchFamily="34" charset="0"/>
-            </a:endParaRPr>
+              <a:t>Kunde: schnelle Antworten.</a:t>
+            </a:r>
           </a:p>
         </p:txBody>
       </p:sp>
@@ -18888,7 +17499,7 @@
               <a:buNone/>
             </a:pPr>
             <a:r>
-              <a:rPr lang="en-US" sz="1150" dirty="0">
+              <a:rPr lang="de-DE" sz="1400" dirty="0">
                 <a:solidFill>
                   <a:srgbClr val="1B2430"/>
                 </a:solidFill>
@@ -18896,12 +17507,9 @@
                 <a:ea typeface="Calibri" pitchFamily="34" charset="-122"/>
                 <a:cs typeface="Segoe UI" panose="020B0502040204020203" pitchFamily="34" charset="0"/>
               </a:rPr>
-              <a:t>Fahrrad, E-Bike und Elektronik mit einer Kundenbasis und einem gemeinsamen Ersatzteillager. Ein Auftragsstatus für alle.</a:t>
-            </a:r>
-            <a:endParaRPr lang="en-US" sz="1150" dirty="0">
-              <a:latin typeface="Segoe UI" panose="020B0502040204020203" pitchFamily="34" charset="0"/>
-              <a:cs typeface="Segoe UI" panose="020B0502040204020203" pitchFamily="34" charset="0"/>
-            </a:endParaRPr>
+              <a:t>Fahrrad, E-Bike und Elektronik in einem System. Ein Lager, ein Auftragsstatus.</a:t>
+            </a:r>
+            <a:endParaRPr lang="de-DE" sz="1400"/>
           </a:p>
         </p:txBody>
       </p:sp>
@@ -18936,7 +17544,7 @@
               <a:buNone/>
             </a:pPr>
             <a:r>
-              <a:rPr lang="en-US" sz="1150" dirty="0">
+              <a:rPr lang="de-DE" sz="1400" dirty="0">
                 <a:solidFill>
                   <a:srgbClr val="1B2430"/>
                 </a:solidFill>
@@ -18944,12 +17552,9 @@
                 <a:ea typeface="Calibri" pitchFamily="34" charset="-122"/>
                 <a:cs typeface="Segoe UI" panose="020B0502040204020203" pitchFamily="34" charset="0"/>
               </a:rPr>
-              <a:t>Bestände, Reservierungen und Umlagerungen über alle Standorte. Bestellt wird nur, was nirgends liegt.</a:t>
-            </a:r>
-            <a:endParaRPr lang="en-US" sz="1150" dirty="0">
-              <a:latin typeface="Segoe UI" panose="020B0502040204020203" pitchFamily="34" charset="0"/>
-              <a:cs typeface="Segoe UI" panose="020B0502040204020203" pitchFamily="34" charset="0"/>
-            </a:endParaRPr>
+              <a:t>Teile aus allen Filialen. Bestellt wird nur, was fehlt.</a:t>
+            </a:r>
+            <a:endParaRPr lang="de-DE" sz="1400"/>
           </a:p>
         </p:txBody>
       </p:sp>
@@ -18984,7 +17589,7 @@
               <a:buNone/>
             </a:pPr>
             <a:r>
-              <a:rPr lang="en-US" sz="1150" dirty="0">
+              <a:rPr lang="de-DE" sz="1400" dirty="0">
                 <a:solidFill>
                   <a:srgbClr val="1B2430"/>
                 </a:solidFill>
@@ -18992,19 +17597,16 @@
                 <a:ea typeface="Calibri" pitchFamily="34" charset="-122"/>
                 <a:cs typeface="Segoe UI" panose="020B0502040204020203" pitchFamily="34" charset="0"/>
               </a:rPr>
-              <a:t>Foto aus der App, Diagnosevorschlag, vorläufiger Kostenvoranschlag und Termin, bevor der Kunde die Werkstatt betritt.</a:t>
-            </a:r>
-            <a:endParaRPr lang="en-US" sz="1150" dirty="0">
-              <a:latin typeface="Segoe UI" panose="020B0502040204020203" pitchFamily="34" charset="0"/>
-              <a:cs typeface="Segoe UI" panose="020B0502040204020203" pitchFamily="34" charset="0"/>
-            </a:endParaRPr>
+              <a:t>Foto in der App, danach Diagnose, Preis und Termin.</a:t>
+            </a:r>
+            <a:endParaRPr lang="de-DE" sz="1400"/>
           </a:p>
         </p:txBody>
       </p:sp>
     </p:spTree>
     <p:extLst>
       <p:ext uri="{BB962C8B-B14F-4D97-AF65-F5344CB8AC3E}">
-        <p14:creationId xmlns:p14="http://schemas.microsoft.com/office/powerpoint/2010/main" val="7463954"/>
+        <p14:creationId xmlns:p14="http://schemas.microsoft.com/office/powerpoint/2010/main" val="866893269"/>
       </p:ext>
     </p:extLst>
   </p:cSld>

</xml_diff>

<commit_message>
docs: Präsentation und Sprechtext angepasst
</commit_message>
<xml_diff>
--- a/4_praesentation/Abschlusspraesentation.pptx
+++ b/4_praesentation/Abschlusspraesentation.pptx
@@ -186,7 +186,7 @@
   <pc:docChgLst>
     <pc:chgData name="Kilian Platter" userId="c49eb2881fa751ca" providerId="LiveId" clId="{FDA102BF-EFD5-549B-81DE-49FC5087B7E9}"/>
     <pc:docChg chg="addSld delSld modSld sldOrd modSection">
-      <pc:chgData name="Kilian Platter" userId="c49eb2881fa751ca" providerId="LiveId" clId="{FDA102BF-EFD5-549B-81DE-49FC5087B7E9}" dt="2026-10-24T11:35:00.904" v="69" actId="2696"/>
+      <pc:chgData name="Kilian Platter" userId="c49eb2881fa751ca" providerId="LiveId" clId="{FDA102BF-EFD5-549B-81DE-49FC5087B7E9}" dt="2026-10-24T12:17:27.298" v="72" actId="20577"/>
       <pc:docMkLst>
         <pc:docMk/>
       </pc:docMkLst>
@@ -373,12 +373,20 @@
           <pc:sldMk cId="0" sldId="286"/>
         </pc:sldMkLst>
       </pc:sldChg>
-      <pc:sldChg chg="add">
-        <pc:chgData name="Kilian Platter" userId="c49eb2881fa751ca" providerId="LiveId" clId="{FDA102BF-EFD5-549B-81DE-49FC5087B7E9}" dt="2026-10-24T11:34:58.692" v="68"/>
+      <pc:sldChg chg="modSp add mod">
+        <pc:chgData name="Kilian Platter" userId="c49eb2881fa751ca" providerId="LiveId" clId="{FDA102BF-EFD5-549B-81DE-49FC5087B7E9}" dt="2026-10-24T12:17:27.298" v="72" actId="20577"/>
         <pc:sldMkLst>
           <pc:docMk/>
           <pc:sldMk cId="1146934768" sldId="287"/>
         </pc:sldMkLst>
+        <pc:spChg chg="mod">
+          <ac:chgData name="Kilian Platter" userId="c49eb2881fa751ca" providerId="LiveId" clId="{FDA102BF-EFD5-549B-81DE-49FC5087B7E9}" dt="2026-10-24T12:17:27.298" v="72" actId="20577"/>
+          <ac:spMkLst>
+            <pc:docMk/>
+            <pc:sldMk cId="1146934768" sldId="287"/>
+            <ac:spMk id="25" creationId="{00000000-0000-0000-0000-000000000000}"/>
+          </ac:spMkLst>
+        </pc:spChg>
       </pc:sldChg>
     </pc:docChg>
   </pc:docChgLst>
@@ -10106,9 +10114,9 @@
                 <a:ea typeface="Calibri" pitchFamily="34" charset="-122"/>
                 <a:cs typeface="Calibri" pitchFamily="34" charset="-120"/>
               </a:rPr>
-              <a:t>Eine Rolle je Use Case, eigene Oberflächenklassen, KI-Vision realistisch halten.</a:t>
-            </a:r>
-            <a:endParaRPr lang="de-DE" sz="1400"/>
+              <a:t>Eine Rolle je Use Case, eigene Oberflächenklasse.</a:t>
+            </a:r>
+            <a:endParaRPr lang="de-DE" sz="1400" dirty="0"/>
           </a:p>
         </p:txBody>
       </p:sp>

</xml_diff>

<commit_message>
praesentation: Folie 16/17 ohne Doppelung, Foliennummern, Folie 20, Sprechtext Jakob
</commit_message>
<xml_diff>
--- a/4_praesentation/Abschlusspraesentation.pptx
+++ b/4_praesentation/Abschlusspraesentation.pptx
@@ -189,8 +189,8 @@
 <pc:chgInfo xmlns:a="http://schemas.openxmlformats.org/drawingml/2006/main" xmlns:r="http://schemas.openxmlformats.org/officeDocument/2006/relationships" xmlns:ac="http://schemas.microsoft.com/office/drawing/2013/main/command" xmlns:pc="http://schemas.microsoft.com/office/powerpoint/2013/main/command">
   <pc:docChgLst>
     <pc:chgData name="Kilian Platter" userId="c49eb2881fa751ca" providerId="LiveId" clId="{FDA102BF-EFD5-549B-81DE-49FC5087B7E9}"/>
-    <pc:docChg chg="addSld delSld modSld sldOrd delSection modSection">
-      <pc:chgData name="Kilian Platter" userId="c49eb2881fa751ca" providerId="LiveId" clId="{FDA102BF-EFD5-549B-81DE-49FC5087B7E9}" dt="2026-10-25T12:18:37.459" v="71" actId="2696"/>
+    <pc:docChg chg="undo custSel addSld delSld modSld sldOrd delSection modSection">
+      <pc:chgData name="Kilian Platter" userId="c49eb2881fa751ca" providerId="LiveId" clId="{FDA102BF-EFD5-549B-81DE-49FC5087B7E9}" dt="2026-10-25T12:40:17.181" v="114"/>
       <pc:docMkLst>
         <pc:docMk/>
       </pc:docMkLst>
@@ -370,19 +370,35 @@
           <pc:sldMk cId="0" sldId="285"/>
         </pc:sldMkLst>
       </pc:sldChg>
-      <pc:sldChg chg="add setBg">
-        <pc:chgData name="Kilian Platter" userId="c49eb2881fa751ca" providerId="LiveId" clId="{FDA102BF-EFD5-549B-81DE-49FC5087B7E9}" dt="2026-10-24T11:34:51.179" v="66"/>
+      <pc:sldChg chg="modSp add del mod setBg">
+        <pc:chgData name="Kilian Platter" userId="c49eb2881fa751ca" providerId="LiveId" clId="{FDA102BF-EFD5-549B-81DE-49FC5087B7E9}" dt="2026-10-25T12:40:17.181" v="114"/>
         <pc:sldMkLst>
           <pc:docMk/>
           <pc:sldMk cId="0" sldId="286"/>
         </pc:sldMkLst>
+        <pc:spChg chg="mod">
+          <ac:chgData name="Kilian Platter" userId="c49eb2881fa751ca" providerId="LiveId" clId="{FDA102BF-EFD5-549B-81DE-49FC5087B7E9}" dt="2026-10-25T12:37:15.306" v="111" actId="20577"/>
+          <ac:spMkLst>
+            <pc:docMk/>
+            <pc:sldMk cId="0" sldId="286"/>
+            <ac:spMk id="15" creationId="{00000000-0000-0000-0000-000000000000}"/>
+          </ac:spMkLst>
+        </pc:spChg>
       </pc:sldChg>
-      <pc:sldChg chg="add">
-        <pc:chgData name="Kilian Platter" userId="c49eb2881fa751ca" providerId="LiveId" clId="{FDA102BF-EFD5-549B-81DE-49FC5087B7E9}" dt="2026-10-24T11:34:58.692" v="68"/>
+      <pc:sldChg chg="addSp modSp add del mod">
+        <pc:chgData name="Kilian Platter" userId="c49eb2881fa751ca" providerId="LiveId" clId="{FDA102BF-EFD5-549B-81DE-49FC5087B7E9}" dt="2026-10-25T12:40:17.181" v="114"/>
         <pc:sldMkLst>
           <pc:docMk/>
           <pc:sldMk cId="1146934768" sldId="287"/>
         </pc:sldMkLst>
+        <pc:spChg chg="add mod">
+          <ac:chgData name="Kilian Platter" userId="c49eb2881fa751ca" providerId="LiveId" clId="{FDA102BF-EFD5-549B-81DE-49FC5087B7E9}" dt="2026-10-25T12:36:22.176" v="75" actId="767"/>
+          <ac:spMkLst>
+            <pc:docMk/>
+            <pc:sldMk cId="1146934768" sldId="287"/>
+            <ac:spMk id="3" creationId="{AAF87FD1-8161-332C-9A7A-AD7058CCCED3}"/>
+          </ac:spMkLst>
+        </pc:spChg>
       </pc:sldChg>
       <pc:sldChg chg="del">
         <pc:chgData name="Kilian Platter" userId="c49eb2881fa751ca" providerId="LiveId" clId="{FDA102BF-EFD5-549B-81DE-49FC5087B7E9}" dt="2026-10-25T12:18:37.459" v="71" actId="2696"/>
@@ -2897,7 +2913,7 @@
   <p:sldLayoutIdLst>
     <p:sldLayoutId id="2147483649" r:id="rId1"/>
   </p:sldLayoutIdLst>
-  <p:hf sldNum="0" hdr="0" ftr="0" dt="0"/>
+  <p:hf hdr="0" ftr="0" dt="0"/>
   <p:txStyles>
     <p:titleStyle>
       <a:lvl1pPr algn="ctr" defTabSz="914400" rtl="0" eaLnBrk="1" latinLnBrk="0" hangingPunct="1">
@@ -12002,7 +12018,7 @@
                 <a:ea typeface="Calibri" pitchFamily="34" charset="-122"/>
                 <a:cs typeface="Segoe UI" panose="020B0502040204020203" pitchFamily="34" charset="0"/>
               </a:rPr>
-              <a:t>Prozesse für Camunda 8 ergänzt. Zwei Prüfprogramme: 0 Fehler.</a:t>
+              <a:t>Prozesse für Camunda 8 ergänzt. Camunda-Linter und Modeler-Prüfung: 0 Fehler.</a:t>
             </a:r>
             <a:endParaRPr lang="de-DE" sz="1200"/>
           </a:p>
@@ -12706,7 +12722,7 @@
                 <a:ea typeface="Calibri" pitchFamily="34" charset="-122"/>
                 <a:cs typeface="Segoe UI" panose="020B0502040204020203" pitchFamily="34" charset="0"/>
               </a:rPr>
-              <a:t>Drei Modelle, ein Vokabular</a:t>
+              <a:t>Pools und Lanes</a:t>
             </a:r>
             <a:endParaRPr lang="en-US" sz="1400" dirty="0">
               <a:solidFill>
@@ -12753,7 +12769,7 @@
                 <a:ea typeface="Calibri" pitchFamily="34" charset="-122"/>
                 <a:cs typeface="Segoe UI" panose="020B0502040204020203" pitchFamily="34" charset="0"/>
               </a:rPr>
-              <a:t>Klassen, Datenobjekte und Statuswerte heißen überall gleich.</a:t>
+              <a:t>Ein Pool mit Rollen als Lanes. Der Kunde bekam einen eigenen Ablauf.</a:t>
             </a:r>
             <a:endParaRPr lang="de-DE" sz="1400">
               <a:latin typeface="Segoe UI" panose="020B0502040204020203" pitchFamily="34" charset="0"/>
@@ -12863,7 +12879,7 @@
                 <a:ea typeface="Calibri" pitchFamily="34" charset="-122"/>
                 <a:cs typeface="Segoe UI" panose="020B0502040204020203" pitchFamily="34" charset="0"/>
               </a:rPr>
-              <a:t>Keine Fehler im Camunda Modeler</a:t>
+              <a:t>Überschriebene Diagramme</a:t>
             </a:r>
             <a:endParaRPr lang="de-DE" sz="1400" dirty="0">
               <a:latin typeface="Segoe UI" panose="020B0502040204020203" pitchFamily="34" charset="0"/>
@@ -12905,7 +12921,7 @@
                 <a:ea typeface="Calibri" pitchFamily="34" charset="-122"/>
                 <a:cs typeface="Segoe UI" panose="020B0502040204020203" pitchFamily="34" charset="0"/>
               </a:rPr>
-              <a:t>Diagramme so lange ergänzt, bis keine Fehler mehr kamen.</a:t>
+              <a:t>Ein Teamwork-Update spielte alte Versionen ein. Seitdem: Update vorher, Commit sofort.</a:t>
             </a:r>
             <a:endParaRPr lang="de-DE" sz="1400">
               <a:latin typeface="Segoe UI" panose="020B0502040204020203" pitchFamily="34" charset="0"/>
@@ -22101,186 +22117,6 @@
                         </a:rPr>
                         <a:t>KI-Sofortdiagnose | Was wir gebaut haben: Ergebnisse in Zahlen | Zehn Prozesse, 62 Prozent automatisiert</a:t>
                       </a:r>
-                      <a:r>
-                        <a:rPr lang="en-US" sz="1050" b="0" i="0" u="none" strike="noStrike" kern="1200" cap="none" spc="0" baseline="0" dirty="0" err="1">
-                          <a:solidFill>
-                            <a:schemeClr val="tx1"/>
-                          </a:solidFill>
-                          <a:uFillTx/>
-                          <a:latin typeface="Segoe UI" panose="020B0502040204020203" pitchFamily="34" charset="0"/>
-                          <a:ea typeface="Calibri" pitchFamily="34"/>
-                          <a:cs typeface="Segoe UI" panose="020B0502040204020203" pitchFamily="34" charset="0"/>
-                        </a:rPr>
-                        <a:t/>
-                      </a:r>
-                      <a:r>
-                        <a:rPr lang="en-US" sz="1050" b="0" i="0" u="none" strike="noStrike" kern="1200" cap="none" spc="0" baseline="0" dirty="0">
-                          <a:solidFill>
-                            <a:schemeClr val="tx1"/>
-                          </a:solidFill>
-                          <a:uFillTx/>
-                          <a:latin typeface="Segoe UI" panose="020B0502040204020203" pitchFamily="34" charset="0"/>
-                          <a:ea typeface="Calibri" pitchFamily="34"/>
-                          <a:cs typeface="Segoe UI" panose="020B0502040204020203" pitchFamily="34" charset="0"/>
-                        </a:rPr>
-                        <a:t/>
-                      </a:r>
-                      <a:r>
-                        <a:rPr lang="en-US" sz="1050" b="0" i="0" u="none" strike="noStrike" kern="1200" cap="none" spc="0" baseline="0" dirty="0" err="1">
-                          <a:solidFill>
-                            <a:schemeClr val="tx1"/>
-                          </a:solidFill>
-                          <a:uFillTx/>
-                          <a:latin typeface="Segoe UI" panose="020B0502040204020203" pitchFamily="34" charset="0"/>
-                          <a:ea typeface="Calibri" pitchFamily="34"/>
-                          <a:cs typeface="Segoe UI" panose="020B0502040204020203" pitchFamily="34" charset="0"/>
-                        </a:rPr>
-                        <a:t/>
-                      </a:r>
-                      <a:r>
-                        <a:rPr lang="en-US" sz="1050" b="0" i="0" u="none" strike="noStrike" kern="1200" cap="none" spc="0" baseline="0" dirty="0">
-                          <a:solidFill>
-                            <a:schemeClr val="tx1"/>
-                          </a:solidFill>
-                          <a:uFillTx/>
-                          <a:latin typeface="Segoe UI" panose="020B0502040204020203" pitchFamily="34" charset="0"/>
-                          <a:ea typeface="Calibri" pitchFamily="34"/>
-                          <a:cs typeface="Segoe UI" panose="020B0502040204020203" pitchFamily="34" charset="0"/>
-                        </a:rPr>
-                        <a:t/>
-                      </a:r>
-                      <a:r>
-                        <a:rPr lang="en-US" sz="1050" b="0" i="0" u="none" strike="noStrike" kern="1200" cap="none" spc="0" baseline="0" dirty="0" err="1">
-                          <a:solidFill>
-                            <a:schemeClr val="tx1"/>
-                          </a:solidFill>
-                          <a:uFillTx/>
-                          <a:latin typeface="Segoe UI" panose="020B0502040204020203" pitchFamily="34" charset="0"/>
-                          <a:ea typeface="Calibri" pitchFamily="34"/>
-                          <a:cs typeface="Segoe UI" panose="020B0502040204020203" pitchFamily="34" charset="0"/>
-                        </a:rPr>
-                        <a:t/>
-                      </a:r>
-                      <a:r>
-                        <a:rPr lang="en-US" sz="1050" b="0" i="0" u="none" strike="noStrike" kern="1200" cap="none" spc="0" baseline="0" dirty="0">
-                          <a:solidFill>
-                            <a:schemeClr val="tx1"/>
-                          </a:solidFill>
-                          <a:uFillTx/>
-                          <a:latin typeface="Segoe UI" panose="020B0502040204020203" pitchFamily="34" charset="0"/>
-                          <a:ea typeface="Calibri" pitchFamily="34"/>
-                          <a:cs typeface="Segoe UI" panose="020B0502040204020203" pitchFamily="34" charset="0"/>
-                        </a:rPr>
-                        <a:t/>
-                      </a:r>
-                      <a:r>
-                        <a:rPr lang="en-US" sz="1050" b="0" i="0" u="none" strike="noStrike" kern="1200" cap="none" spc="0" baseline="0" dirty="0" err="1">
-                          <a:solidFill>
-                            <a:schemeClr val="tx1"/>
-                          </a:solidFill>
-                          <a:uFillTx/>
-                          <a:latin typeface="Segoe UI" panose="020B0502040204020203" pitchFamily="34" charset="0"/>
-                          <a:ea typeface="Calibri" pitchFamily="34"/>
-                          <a:cs typeface="Segoe UI" panose="020B0502040204020203" pitchFamily="34" charset="0"/>
-                        </a:rPr>
-                        <a:t/>
-                      </a:r>
-                      <a:r>
-                        <a:rPr lang="en-US" sz="1050" b="0" i="0" u="none" strike="noStrike" kern="1200" cap="none" spc="0" baseline="0" dirty="0">
-                          <a:solidFill>
-                            <a:schemeClr val="tx1"/>
-                          </a:solidFill>
-                          <a:uFillTx/>
-                          <a:latin typeface="Segoe UI" panose="020B0502040204020203" pitchFamily="34" charset="0"/>
-                          <a:ea typeface="Calibri" pitchFamily="34"/>
-                          <a:cs typeface="Segoe UI" panose="020B0502040204020203" pitchFamily="34" charset="0"/>
-                        </a:rPr>
-                        <a:t/>
-                      </a:r>
-                      <a:r>
-                        <a:rPr lang="en-US" sz="1050" b="0" i="0" u="none" strike="noStrike" kern="1200" cap="none" spc="0" baseline="0" dirty="0" err="1">
-                          <a:solidFill>
-                            <a:schemeClr val="tx1"/>
-                          </a:solidFill>
-                          <a:uFillTx/>
-                          <a:latin typeface="Segoe UI" panose="020B0502040204020203" pitchFamily="34" charset="0"/>
-                          <a:ea typeface="Calibri" pitchFamily="34"/>
-                          <a:cs typeface="Segoe UI" panose="020B0502040204020203" pitchFamily="34" charset="0"/>
-                        </a:rPr>
-                        <a:t/>
-                      </a:r>
-                      <a:r>
-                        <a:rPr lang="en-US" sz="1050" b="0" i="0" u="none" strike="noStrike" kern="1200" cap="none" spc="0" baseline="0" dirty="0">
-                          <a:solidFill>
-                            <a:schemeClr val="tx1"/>
-                          </a:solidFill>
-                          <a:uFillTx/>
-                          <a:latin typeface="Segoe UI" panose="020B0502040204020203" pitchFamily="34" charset="0"/>
-                          <a:ea typeface="Calibri" pitchFamily="34"/>
-                          <a:cs typeface="Segoe UI" panose="020B0502040204020203" pitchFamily="34" charset="0"/>
-                        </a:rPr>
-                        <a:t/>
-                      </a:r>
-                      <a:r>
-                        <a:rPr lang="en-US" sz="1050" b="0" i="0" u="none" strike="noStrike" kern="1200" cap="none" spc="0" baseline="0" dirty="0" err="1">
-                          <a:solidFill>
-                            <a:schemeClr val="tx1"/>
-                          </a:solidFill>
-                          <a:uFillTx/>
-                          <a:latin typeface="Segoe UI" panose="020B0502040204020203" pitchFamily="34" charset="0"/>
-                          <a:ea typeface="Calibri" pitchFamily="34"/>
-                          <a:cs typeface="Segoe UI" panose="020B0502040204020203" pitchFamily="34" charset="0"/>
-                        </a:rPr>
-                        <a:t/>
-                      </a:r>
-                      <a:r>
-                        <a:rPr lang="en-US" sz="1050" b="0" i="0" u="none" strike="noStrike" kern="1200" cap="none" spc="0" baseline="0" dirty="0">
-                          <a:solidFill>
-                            <a:schemeClr val="tx1"/>
-                          </a:solidFill>
-                          <a:uFillTx/>
-                          <a:latin typeface="Segoe UI" panose="020B0502040204020203" pitchFamily="34" charset="0"/>
-                          <a:ea typeface="Calibri" pitchFamily="34"/>
-                          <a:cs typeface="Segoe UI" panose="020B0502040204020203" pitchFamily="34" charset="0"/>
-                        </a:rPr>
-                        <a:t/>
-                      </a:r>
-                      <a:r>
-                        <a:rPr lang="en-US" sz="1050" b="0" i="0" u="none" strike="noStrike" kern="1200" cap="none" spc="0" baseline="0" dirty="0" err="1">
-                          <a:solidFill>
-                            <a:schemeClr val="tx1"/>
-                          </a:solidFill>
-                          <a:uFillTx/>
-                          <a:latin typeface="Segoe UI" panose="020B0502040204020203" pitchFamily="34" charset="0"/>
-                          <a:ea typeface="Calibri" pitchFamily="34"/>
-                          <a:cs typeface="Segoe UI" panose="020B0502040204020203" pitchFamily="34" charset="0"/>
-                        </a:rPr>
-                        <a:t/>
-                      </a:r>
-                      <a:r>
-                        <a:rPr lang="en-US" sz="1050" b="0" i="0" u="none" strike="noStrike" kern="1200" cap="none" spc="0" baseline="0" dirty="0">
-                          <a:solidFill>
-                            <a:schemeClr val="tx1"/>
-                          </a:solidFill>
-                          <a:uFillTx/>
-                          <a:latin typeface="Segoe UI" panose="020B0502040204020203" pitchFamily="34" charset="0"/>
-                          <a:ea typeface="Calibri" pitchFamily="34"/>
-                          <a:cs typeface="Segoe UI" panose="020B0502040204020203" pitchFamily="34" charset="0"/>
-                        </a:rPr>
-                        <a:t/>
-                      </a:r>
-                      <a:r>
-                        <a:rPr lang="en-US" sz="1050" b="0" i="0" u="none" strike="noStrike" kern="1200" cap="none" spc="0" baseline="0" dirty="0" err="1">
-                          <a:solidFill>
-                            <a:schemeClr val="tx1"/>
-                          </a:solidFill>
-                          <a:uFillTx/>
-                          <a:latin typeface="Segoe UI" panose="020B0502040204020203" pitchFamily="34" charset="0"/>
-                          <a:ea typeface="Calibri" pitchFamily="34"/>
-                          <a:cs typeface="Segoe UI" panose="020B0502040204020203" pitchFamily="34" charset="0"/>
-                        </a:rPr>
-                        <a:t/>
-                      </a:r>
                       <a:endParaRPr lang="en-US" sz="1050" b="0" i="0" u="none" strike="noStrike" kern="1200" cap="none" spc="0" baseline="0" dirty="0">
                         <a:solidFill>
                           <a:schemeClr val="tx1"/>

</xml_diff>

<commit_message>
Beschreibungstexte P06/P08/P09, VPP-Beschreibungen, PPTX Dokument geprüft
- P06, P08, P09: Beschreibung der Kollaboration an das Modell angepasst (nur XML)
- VPP: Beschreibungen Kunde, Betriebsadministrator, Operand SD5 und Argument Botschaft 27 SD3 bereinigt
- PPTX: persönliche Angaben entfernt, Autor Gruppe 1 WWI25B4, Notizen behalten
- TODO.md nachgezogen
</commit_message>
<xml_diff>
--- a/4_praesentation/Abschlusspraesentation.pptx
+++ b/4_praesentation/Abschlusspraesentation.pptx
@@ -186,289 +186,6 @@
     </p:ext>
   </p:extLst>
 </p:presentation>
-</file>
-
-<file path=ppt/changesInfos/changesInfo1.xml><?xml version="1.0" encoding="utf-8"?>
-<pc:chgInfo xmlns:a="http://schemas.openxmlformats.org/drawingml/2006/main" xmlns:r="http://schemas.openxmlformats.org/officeDocument/2006/relationships" xmlns:ac="http://schemas.microsoft.com/office/drawing/2013/main/command" xmlns:pc="http://schemas.microsoft.com/office/powerpoint/2013/main/command">
-  <pc:docChgLst>
-    <pc:chgData name="Kilian Platter" userId="c49eb2881fa751ca" providerId="LiveId" clId="{FDA102BF-EFD5-549B-81DE-49FC5087B7E9}"/>
-    <pc:docChg chg="undo custSel addSld delSld modSld sldOrd delSection modSection">
-      <pc:chgData name="Kilian Platter" userId="c49eb2881fa751ca" providerId="LiveId" clId="{FDA102BF-EFD5-549B-81DE-49FC5087B7E9}" dt="2026-10-25T12:40:17.181" v="114"/>
-      <pc:docMkLst>
-        <pc:docMk/>
-      </pc:docMkLst>
-      <pc:sldChg chg="modSp mod modNotesTx">
-        <pc:chgData name="Kilian Platter" userId="c49eb2881fa751ca" providerId="LiveId" clId="{FDA102BF-EFD5-549B-81DE-49FC5087B7E9}" dt="2026-10-24T10:29:43.816" v="37" actId="20577"/>
-        <pc:sldMkLst>
-          <pc:docMk/>
-          <pc:sldMk cId="0" sldId="256"/>
-        </pc:sldMkLst>
-        <pc:spChg chg="mod">
-          <ac:chgData name="Kilian Platter" userId="c49eb2881fa751ca" providerId="LiveId" clId="{FDA102BF-EFD5-549B-81DE-49FC5087B7E9}" dt="2026-10-24T10:20:16.757" v="5" actId="20577"/>
-          <ac:spMkLst>
-            <pc:docMk/>
-            <pc:sldMk cId="0" sldId="256"/>
-            <ac:spMk id="10" creationId="{00000000-0000-0000-0000-000000000000}"/>
-          </ac:spMkLst>
-        </pc:spChg>
-      </pc:sldChg>
-      <pc:sldChg chg="del modNotesTx">
-        <pc:chgData name="Kilian Platter" userId="c49eb2881fa751ca" providerId="LiveId" clId="{FDA102BF-EFD5-549B-81DE-49FC5087B7E9}" dt="2026-10-24T11:34:28.793" v="63" actId="2696"/>
-        <pc:sldMkLst>
-          <pc:docMk/>
-          <pc:sldMk cId="0" sldId="258"/>
-        </pc:sldMkLst>
-      </pc:sldChg>
-      <pc:sldChg chg="del modNotesTx">
-        <pc:chgData name="Kilian Platter" userId="c49eb2881fa751ca" providerId="LiveId" clId="{FDA102BF-EFD5-549B-81DE-49FC5087B7E9}" dt="2026-10-24T11:34:36.314" v="65" actId="2696"/>
-        <pc:sldMkLst>
-          <pc:docMk/>
-          <pc:sldMk cId="0" sldId="259"/>
-        </pc:sldMkLst>
-      </pc:sldChg>
-      <pc:sldChg chg="ord modNotesTx">
-        <pc:chgData name="Kilian Platter" userId="c49eb2881fa751ca" providerId="LiveId" clId="{FDA102BF-EFD5-549B-81DE-49FC5087B7E9}" dt="2026-10-24T10:30:11.968" v="53" actId="20577"/>
-        <pc:sldMkLst>
-          <pc:docMk/>
-          <pc:sldMk cId="0" sldId="262"/>
-        </pc:sldMkLst>
-      </pc:sldChg>
-      <pc:sldChg chg="modNotesTx">
-        <pc:chgData name="Kilian Platter" userId="c49eb2881fa751ca" providerId="LiveId" clId="{FDA102BF-EFD5-549B-81DE-49FC5087B7E9}" dt="2026-10-24T10:25:34.341" v="22" actId="20577"/>
-        <pc:sldMkLst>
-          <pc:docMk/>
-          <pc:sldMk cId="0" sldId="263"/>
-        </pc:sldMkLst>
-      </pc:sldChg>
-      <pc:sldChg chg="modNotesTx">
-        <pc:chgData name="Kilian Platter" userId="c49eb2881fa751ca" providerId="LiveId" clId="{FDA102BF-EFD5-549B-81DE-49FC5087B7E9}" dt="2026-10-24T10:25:40.161" v="23" actId="20577"/>
-        <pc:sldMkLst>
-          <pc:docMk/>
-          <pc:sldMk cId="0" sldId="264"/>
-        </pc:sldMkLst>
-      </pc:sldChg>
-      <pc:sldChg chg="modNotesTx">
-        <pc:chgData name="Kilian Platter" userId="c49eb2881fa751ca" providerId="LiveId" clId="{FDA102BF-EFD5-549B-81DE-49FC5087B7E9}" dt="2026-10-24T10:25:11.456" v="19" actId="20577"/>
-        <pc:sldMkLst>
-          <pc:docMk/>
-          <pc:sldMk cId="0" sldId="265"/>
-        </pc:sldMkLst>
-      </pc:sldChg>
-      <pc:sldChg chg="del modNotesTx">
-        <pc:chgData name="Kilian Platter" userId="c49eb2881fa751ca" providerId="LiveId" clId="{FDA102BF-EFD5-549B-81DE-49FC5087B7E9}" dt="2026-10-24T11:32:30.127" v="57" actId="2696"/>
-        <pc:sldMkLst>
-          <pc:docMk/>
-          <pc:sldMk cId="0" sldId="266"/>
-        </pc:sldMkLst>
-      </pc:sldChg>
-      <pc:sldChg chg="del modNotesTx">
-        <pc:chgData name="Kilian Platter" userId="c49eb2881fa751ca" providerId="LiveId" clId="{FDA102BF-EFD5-549B-81DE-49FC5087B7E9}" dt="2026-10-24T11:32:58.384" v="59" actId="2696"/>
-        <pc:sldMkLst>
-          <pc:docMk/>
-          <pc:sldMk cId="0" sldId="267"/>
-        </pc:sldMkLst>
-      </pc:sldChg>
-      <pc:sldChg chg="modNotesTx">
-        <pc:chgData name="Kilian Platter" userId="c49eb2881fa751ca" providerId="LiveId" clId="{FDA102BF-EFD5-549B-81DE-49FC5087B7E9}" dt="2026-10-24T10:26:18.025" v="28" actId="20577"/>
-        <pc:sldMkLst>
-          <pc:docMk/>
-          <pc:sldMk cId="1220583403" sldId="268"/>
-        </pc:sldMkLst>
-      </pc:sldChg>
-      <pc:sldChg chg="del modNotesTx">
-        <pc:chgData name="Kilian Platter" userId="c49eb2881fa751ca" providerId="LiveId" clId="{FDA102BF-EFD5-549B-81DE-49FC5087B7E9}" dt="2026-10-24T11:34:54.600" v="67" actId="2696"/>
-        <pc:sldMkLst>
-          <pc:docMk/>
-          <pc:sldMk cId="0" sldId="269"/>
-        </pc:sldMkLst>
-      </pc:sldChg>
-      <pc:sldChg chg="del modNotesTx">
-        <pc:chgData name="Kilian Platter" userId="c49eb2881fa751ca" providerId="LiveId" clId="{FDA102BF-EFD5-549B-81DE-49FC5087B7E9}" dt="2026-10-24T11:35:00.904" v="69" actId="2696"/>
-        <pc:sldMkLst>
-          <pc:docMk/>
-          <pc:sldMk cId="8933715" sldId="270"/>
-        </pc:sldMkLst>
-      </pc:sldChg>
-      <pc:sldChg chg="modNotesTx">
-        <pc:chgData name="Kilian Platter" userId="c49eb2881fa751ca" providerId="LiveId" clId="{FDA102BF-EFD5-549B-81DE-49FC5087B7E9}" dt="2026-10-24T10:26:23.614" v="29" actId="20577"/>
-        <pc:sldMkLst>
-          <pc:docMk/>
-          <pc:sldMk cId="0" sldId="271"/>
-        </pc:sldMkLst>
-      </pc:sldChg>
-      <pc:sldChg chg="modNotesTx">
-        <pc:chgData name="Kilian Platter" userId="c49eb2881fa751ca" providerId="LiveId" clId="{FDA102BF-EFD5-549B-81DE-49FC5087B7E9}" dt="2026-10-24T10:26:29.054" v="31" actId="20577"/>
-        <pc:sldMkLst>
-          <pc:docMk/>
-          <pc:sldMk cId="0" sldId="272"/>
-        </pc:sldMkLst>
-      </pc:sldChg>
-      <pc:sldChg chg="modNotesTx">
-        <pc:chgData name="Kilian Platter" userId="c49eb2881fa751ca" providerId="LiveId" clId="{FDA102BF-EFD5-549B-81DE-49FC5087B7E9}" dt="2026-10-24T10:26:35.628" v="32" actId="20577"/>
-        <pc:sldMkLst>
-          <pc:docMk/>
-          <pc:sldMk cId="0" sldId="273"/>
-        </pc:sldMkLst>
-      </pc:sldChg>
-      <pc:sldChg chg="del modNotesTx">
-        <pc:chgData name="Kilian Platter" userId="c49eb2881fa751ca" providerId="LiveId" clId="{FDA102BF-EFD5-549B-81DE-49FC5087B7E9}" dt="2026-10-24T11:32:07.142" v="55" actId="2696"/>
-        <pc:sldMkLst>
-          <pc:docMk/>
-          <pc:sldMk cId="7463954" sldId="274"/>
-        </pc:sldMkLst>
-      </pc:sldChg>
-      <pc:sldChg chg="modNotesTx">
-        <pc:chgData name="Kilian Platter" userId="c49eb2881fa751ca" providerId="LiveId" clId="{FDA102BF-EFD5-549B-81DE-49FC5087B7E9}" dt="2026-10-24T10:30:00.119" v="46" actId="20577"/>
-        <pc:sldMkLst>
-          <pc:docMk/>
-          <pc:sldMk cId="967035767" sldId="276"/>
-        </pc:sldMkLst>
-      </pc:sldChg>
-      <pc:sldChg chg="modNotesTx">
-        <pc:chgData name="Kilian Platter" userId="c49eb2881fa751ca" providerId="LiveId" clId="{FDA102BF-EFD5-549B-81DE-49FC5087B7E9}" dt="2026-10-24T10:24:35.859" v="13" actId="20577"/>
-        <pc:sldMkLst>
-          <pc:docMk/>
-          <pc:sldMk cId="0" sldId="279"/>
-        </pc:sldMkLst>
-      </pc:sldChg>
-      <pc:sldChg chg="modNotesTx">
-        <pc:chgData name="Kilian Platter" userId="c49eb2881fa751ca" providerId="LiveId" clId="{FDA102BF-EFD5-549B-81DE-49FC5087B7E9}" dt="2026-10-24T10:25:17.161" v="20" actId="20577"/>
-        <pc:sldMkLst>
-          <pc:docMk/>
-          <pc:sldMk cId="3044169480" sldId="280"/>
-        </pc:sldMkLst>
-      </pc:sldChg>
-      <pc:sldChg chg="add">
-        <pc:chgData name="Kilian Platter" userId="c49eb2881fa751ca" providerId="LiveId" clId="{FDA102BF-EFD5-549B-81DE-49FC5087B7E9}" dt="2026-10-24T11:32:02.070" v="54"/>
-        <pc:sldMkLst>
-          <pc:docMk/>
-          <pc:sldMk cId="866893269" sldId="281"/>
-        </pc:sldMkLst>
-      </pc:sldChg>
-      <pc:sldChg chg="add setBg">
-        <pc:chgData name="Kilian Platter" userId="c49eb2881fa751ca" providerId="LiveId" clId="{FDA102BF-EFD5-549B-81DE-49FC5087B7E9}" dt="2026-10-24T11:32:26.169" v="56"/>
-        <pc:sldMkLst>
-          <pc:docMk/>
-          <pc:sldMk cId="0" sldId="282"/>
-        </pc:sldMkLst>
-      </pc:sldChg>
-      <pc:sldChg chg="add setBg">
-        <pc:chgData name="Kilian Platter" userId="c49eb2881fa751ca" providerId="LiveId" clId="{FDA102BF-EFD5-549B-81DE-49FC5087B7E9}" dt="2026-10-24T11:32:53.375" v="58"/>
-        <pc:sldMkLst>
-          <pc:docMk/>
-          <pc:sldMk cId="0" sldId="283"/>
-        </pc:sldMkLst>
-      </pc:sldChg>
-      <pc:sldChg chg="add del setBg">
-        <pc:chgData name="Kilian Platter" userId="c49eb2881fa751ca" providerId="LiveId" clId="{FDA102BF-EFD5-549B-81DE-49FC5087B7E9}" dt="2026-10-24T11:34:27.546" v="62"/>
-        <pc:sldMkLst>
-          <pc:docMk/>
-          <pc:sldMk cId="0" sldId="284"/>
-        </pc:sldMkLst>
-      </pc:sldChg>
-      <pc:sldChg chg="add setBg">
-        <pc:chgData name="Kilian Platter" userId="c49eb2881fa751ca" providerId="LiveId" clId="{FDA102BF-EFD5-549B-81DE-49FC5087B7E9}" dt="2026-10-24T11:34:33.716" v="64"/>
-        <pc:sldMkLst>
-          <pc:docMk/>
-          <pc:sldMk cId="0" sldId="285"/>
-        </pc:sldMkLst>
-      </pc:sldChg>
-      <pc:sldChg chg="modSp add del mod setBg">
-        <pc:chgData name="Kilian Platter" userId="c49eb2881fa751ca" providerId="LiveId" clId="{FDA102BF-EFD5-549B-81DE-49FC5087B7E9}" dt="2026-10-25T12:40:17.181" v="114"/>
-        <pc:sldMkLst>
-          <pc:docMk/>
-          <pc:sldMk cId="0" sldId="286"/>
-        </pc:sldMkLst>
-        <pc:spChg chg="mod">
-          <ac:chgData name="Kilian Platter" userId="c49eb2881fa751ca" providerId="LiveId" clId="{FDA102BF-EFD5-549B-81DE-49FC5087B7E9}" dt="2026-10-25T12:37:15.306" v="111" actId="20577"/>
-          <ac:spMkLst>
-            <pc:docMk/>
-            <pc:sldMk cId="0" sldId="286"/>
-            <ac:spMk id="15" creationId="{00000000-0000-0000-0000-000000000000}"/>
-          </ac:spMkLst>
-        </pc:spChg>
-      </pc:sldChg>
-      <pc:sldChg chg="addSp modSp add del mod">
-        <pc:chgData name="Kilian Platter" userId="c49eb2881fa751ca" providerId="LiveId" clId="{FDA102BF-EFD5-549B-81DE-49FC5087B7E9}" dt="2026-10-25T12:40:17.181" v="114"/>
-        <pc:sldMkLst>
-          <pc:docMk/>
-          <pc:sldMk cId="1146934768" sldId="287"/>
-        </pc:sldMkLst>
-        <pc:spChg chg="add mod">
-          <ac:chgData name="Kilian Platter" userId="c49eb2881fa751ca" providerId="LiveId" clId="{FDA102BF-EFD5-549B-81DE-49FC5087B7E9}" dt="2026-10-25T12:36:22.176" v="75" actId="767"/>
-          <ac:spMkLst>
-            <pc:docMk/>
-            <pc:sldMk cId="1146934768" sldId="287"/>
-            <ac:spMk id="3" creationId="{AAF87FD1-8161-332C-9A7A-AD7058CCCED3}"/>
-          </ac:spMkLst>
-        </pc:spChg>
-      </pc:sldChg>
-      <pc:sldChg chg="del">
-        <pc:chgData name="Kilian Platter" userId="c49eb2881fa751ca" providerId="LiveId" clId="{FDA102BF-EFD5-549B-81DE-49FC5087B7E9}" dt="2026-10-25T12:18:37.459" v="71" actId="2696"/>
-        <pc:sldMkLst>
-          <pc:docMk/>
-          <pc:sldMk cId="2371977166" sldId="298"/>
-        </pc:sldMkLst>
-      </pc:sldChg>
-      <pc:sldChg chg="del">
-        <pc:chgData name="Kilian Platter" userId="c49eb2881fa751ca" providerId="LiveId" clId="{FDA102BF-EFD5-549B-81DE-49FC5087B7E9}" dt="2026-10-25T12:18:37.459" v="71" actId="2696"/>
-        <pc:sldMkLst>
-          <pc:docMk/>
-          <pc:sldMk cId="2928356131" sldId="299"/>
-        </pc:sldMkLst>
-      </pc:sldChg>
-      <pc:sldChg chg="del">
-        <pc:chgData name="Kilian Platter" userId="c49eb2881fa751ca" providerId="LiveId" clId="{FDA102BF-EFD5-549B-81DE-49FC5087B7E9}" dt="2026-10-25T12:18:37.459" v="71" actId="2696"/>
-        <pc:sldMkLst>
-          <pc:docMk/>
-          <pc:sldMk cId="347267247" sldId="300"/>
-        </pc:sldMkLst>
-      </pc:sldChg>
-      <pc:sldChg chg="del">
-        <pc:chgData name="Kilian Platter" userId="c49eb2881fa751ca" providerId="LiveId" clId="{FDA102BF-EFD5-549B-81DE-49FC5087B7E9}" dt="2026-10-25T12:18:37.459" v="71" actId="2696"/>
-        <pc:sldMkLst>
-          <pc:docMk/>
-          <pc:sldMk cId="952413891" sldId="301"/>
-        </pc:sldMkLst>
-      </pc:sldChg>
-      <pc:sldChg chg="del">
-        <pc:chgData name="Kilian Platter" userId="c49eb2881fa751ca" providerId="LiveId" clId="{FDA102BF-EFD5-549B-81DE-49FC5087B7E9}" dt="2026-10-25T12:18:37.459" v="71" actId="2696"/>
-        <pc:sldMkLst>
-          <pc:docMk/>
-          <pc:sldMk cId="2455471251" sldId="302"/>
-        </pc:sldMkLst>
-      </pc:sldChg>
-      <pc:sldChg chg="del">
-        <pc:chgData name="Kilian Platter" userId="c49eb2881fa751ca" providerId="LiveId" clId="{FDA102BF-EFD5-549B-81DE-49FC5087B7E9}" dt="2026-10-25T12:18:37.459" v="71" actId="2696"/>
-        <pc:sldMkLst>
-          <pc:docMk/>
-          <pc:sldMk cId="4028699230" sldId="303"/>
-        </pc:sldMkLst>
-      </pc:sldChg>
-      <pc:sldChg chg="del">
-        <pc:chgData name="Kilian Platter" userId="c49eb2881fa751ca" providerId="LiveId" clId="{FDA102BF-EFD5-549B-81DE-49FC5087B7E9}" dt="2026-10-25T12:18:37.459" v="71" actId="2696"/>
-        <pc:sldMkLst>
-          <pc:docMk/>
-          <pc:sldMk cId="2621225341" sldId="304"/>
-        </pc:sldMkLst>
-      </pc:sldChg>
-      <pc:sldChg chg="del">
-        <pc:chgData name="Kilian Platter" userId="c49eb2881fa751ca" providerId="LiveId" clId="{FDA102BF-EFD5-549B-81DE-49FC5087B7E9}" dt="2026-10-25T12:18:37.459" v="71" actId="2696"/>
-        <pc:sldMkLst>
-          <pc:docMk/>
-          <pc:sldMk cId="2207933256" sldId="305"/>
-        </pc:sldMkLst>
-      </pc:sldChg>
-      <pc:sldChg chg="del">
-        <pc:chgData name="Kilian Platter" userId="c49eb2881fa751ca" providerId="LiveId" clId="{FDA102BF-EFD5-549B-81DE-49FC5087B7E9}" dt="2026-10-25T12:18:37.459" v="71" actId="2696"/>
-        <pc:sldMkLst>
-          <pc:docMk/>
-          <pc:sldMk cId="2794711449" sldId="306"/>
-        </pc:sldMkLst>
-      </pc:sldChg>
-    </pc:docChg>
-  </pc:docChgLst>
-</pc:chgInfo>
 </file>
 
 <file path=ppt/notesMasters/notesMaster1.xml><?xml version="1.0" encoding="utf-8"?>

</xml_diff>

<commit_message>
cooles bild von jakob
</commit_message>
<xml_diff>
--- a/4_praesentation/Abschlusspraesentation.pptx
+++ b/4_praesentation/Abschlusspraesentation.pptx
@@ -5,33 +5,33 @@
     <p:sldMasterId id="2147483648" r:id="rId1"/>
   </p:sldMasterIdLst>
   <p:notesMasterIdLst>
-    <p:notesMasterId r:id="rId23"/>
+    <p:notesMasterId r:id="rId26"/>
   </p:notesMasterIdLst>
   <p:sldIdLst>
-    <p:sldId id="308" r:id="rId29"/>
-    <p:sldId id="309" r:id="rId30"/>
-    <p:sldId id="310" r:id="rId31"/>
-    <p:sldId id="311" r:id="rId32"/>
-    <p:sldId id="312" r:id="rId33"/>
-    <p:sldId id="313" r:id="rId34"/>
-    <p:sldId id="314" r:id="rId35"/>
-    <p:sldId id="281" r:id="rId6"/>
-    <p:sldId id="288" r:id="rId7"/>
-    <p:sldId id="289" r:id="rId8"/>
-    <p:sldId id="265" r:id="rId9"/>
-    <p:sldId id="280" r:id="rId10"/>
-    <p:sldId id="290" r:id="rId11"/>
-    <p:sldId id="291" r:id="rId12"/>
-    <p:sldId id="292" r:id="rId13"/>
-    <p:sldId id="293" r:id="rId14"/>
-    <p:sldId id="282" r:id="rId15"/>
-    <p:sldId id="283" r:id="rId16"/>
-    <p:sldId id="286" r:id="rId17"/>
-    <p:sldId id="287" r:id="rId18"/>
-    <p:sldId id="294" r:id="rId19"/>
-    <p:sldId id="295" r:id="rId20"/>
-    <p:sldId id="296" r:id="rId21"/>
-    <p:sldId id="297" r:id="rId22"/>
+    <p:sldId id="308" r:id="rId2"/>
+    <p:sldId id="309" r:id="rId3"/>
+    <p:sldId id="310" r:id="rId4"/>
+    <p:sldId id="311" r:id="rId5"/>
+    <p:sldId id="312" r:id="rId6"/>
+    <p:sldId id="313" r:id="rId7"/>
+    <p:sldId id="314" r:id="rId8"/>
+    <p:sldId id="281" r:id="rId9"/>
+    <p:sldId id="288" r:id="rId10"/>
+    <p:sldId id="289" r:id="rId11"/>
+    <p:sldId id="265" r:id="rId12"/>
+    <p:sldId id="280" r:id="rId13"/>
+    <p:sldId id="290" r:id="rId14"/>
+    <p:sldId id="291" r:id="rId15"/>
+    <p:sldId id="292" r:id="rId16"/>
+    <p:sldId id="293" r:id="rId17"/>
+    <p:sldId id="282" r:id="rId18"/>
+    <p:sldId id="283" r:id="rId19"/>
+    <p:sldId id="286" r:id="rId20"/>
+    <p:sldId id="287" r:id="rId21"/>
+    <p:sldId id="294" r:id="rId22"/>
+    <p:sldId id="295" r:id="rId23"/>
+    <p:sldId id="296" r:id="rId24"/>
+    <p:sldId id="297" r:id="rId25"/>
   </p:sldIdLst>
   <p:sldSz cx="9144000" cy="5143500" type="screen16x9"/>
   <p:notesSz cx="5143500" cy="9144000"/>
@@ -132,10 +132,13 @@
       <p14:sectionLst xmlns:p14="http://schemas.microsoft.com/office/powerpoint/2010/main">
         <p14:section name="David" id="{88BB6C5F-BCA4-9943-807C-50A57D629305}">
           <p14:sldIdLst>
-            <p14:sldId id="307"/>
-            <p14:sldId id="279"/>
-            <p14:sldId id="284"/>
-            <p14:sldId id="285"/>
+            <p14:sldId id="308"/>
+            <p14:sldId id="309"/>
+            <p14:sldId id="310"/>
+            <p14:sldId id="311"/>
+            <p14:sldId id="312"/>
+            <p14:sldId id="313"/>
+            <p14:sldId id="314"/>
           </p14:sldIdLst>
         </p14:section>
         <p14:section name="Kilian" id="{1139A1D9-944E-3441-9BD8-35E9CEF6D225}">
@@ -313,7 +316,7 @@
 </p:notesMaster>
 </file>
 
-<file path=ppt/notesSlides/notesSlide10.xml><?xml version="1.0" encoding="utf-8"?>
+<file path=ppt/notesSlides/notesSlide1.xml><?xml version="1.0" encoding="utf-8"?>
 <p:notes xmlns:a="http://schemas.openxmlformats.org/drawingml/2006/main" xmlns:r="http://schemas.openxmlformats.org/officeDocument/2006/relationships" xmlns:p="http://schemas.openxmlformats.org/presentationml/2006/main">
   <p:cSld>
     <p:spTree>
@@ -332,10 +335,107 @@
       </p:grpSpPr>
       <p:sp>
         <p:nvSpPr>
+          <p:cNvPr id="2" name="Slide Image Placeholder 1"/>
+          <p:cNvSpPr>
+            <a:spLocks noGrp="1" noRot="1" noChangeAspect="1"/>
+          </p:cNvSpPr>
+          <p:nvPr>
+            <p:ph type="sldImg"/>
+          </p:nvPr>
+        </p:nvSpPr>
+        <p:spPr/>
+      </p:sp>
+      <p:sp>
+        <p:nvSpPr>
+          <p:cNvPr id="3" name="Notes Placeholder 2"/>
+          <p:cNvSpPr>
+            <a:spLocks noGrp="1"/>
+          </p:cNvSpPr>
+          <p:nvPr>
+            <p:ph type="body" idx="1"/>
+          </p:nvPr>
+        </p:nvSpPr>
+        <p:spPr/>
+        <p:txBody>
+          <a:bodyPr/>
+          <a:lstStyle/>
+          <a:p>
+            <a:r>
+              <a:rPr dirty="0" err="1"/>
+              <a:t>Vortragende</a:t>
+            </a:r>
+            <a:r>
+              <a:rPr dirty="0"/>
+              <a:t>(r): David</a:t>
+            </a:r>
+          </a:p>
+        </p:txBody>
+      </p:sp>
+      <p:sp>
+        <p:nvSpPr>
+          <p:cNvPr id="4" name="Slide Number Placeholder 3"/>
+          <p:cNvSpPr>
+            <a:spLocks noGrp="1"/>
+          </p:cNvSpPr>
+          <p:nvPr>
+            <p:ph type="sldNum" sz="quarter" idx="10"/>
+          </p:nvPr>
+        </p:nvSpPr>
+        <p:spPr/>
+        <p:txBody>
+          <a:bodyPr/>
+          <a:lstStyle/>
+          <a:p>
+            <a:fld id="{F7021451-1387-4CA6-816F-3879F97B5CBC}" type="slidenum">
+              <a:rPr lang="en-US"/>
+              <a:t>1</a:t>
+            </a:fld>
+            <a:endParaRPr lang="en-US"/>
+          </a:p>
+        </p:txBody>
+      </p:sp>
+    </p:spTree>
+    <p:extLst>
+      <p:ext uri="{BB962C8B-B14F-4D97-AF65-F5344CB8AC3E}">
+        <p14:creationId xmlns:p14="http://schemas.microsoft.com/office/powerpoint/2010/main" val="1024086991"/>
+      </p:ext>
+    </p:extLst>
+  </p:cSld>
+  <p:clrMapOvr>
+    <a:masterClrMapping/>
+  </p:clrMapOvr>
+</p:notes>
+</file>
+
+<file path=ppt/notesSlides/notesSlide10.xml><?xml version="1.0" encoding="utf-8"?>
+<p:notes xmlns:a="http://schemas.openxmlformats.org/drawingml/2006/main" xmlns:r="http://schemas.openxmlformats.org/officeDocument/2006/relationships" xmlns:p="http://schemas.openxmlformats.org/presentationml/2006/main">
+  <p:cSld>
+    <p:spTree>
+      <p:nvGrpSpPr>
+        <p:cNvPr id="1" name="">
+          <a:extLst>
+            <a:ext uri="{FF2B5EF4-FFF2-40B4-BE49-F238E27FC236}">
+              <a16:creationId xmlns:a16="http://schemas.microsoft.com/office/drawing/2014/main" id="{FF608250-25F3-8992-43BF-D14C84D1A263}"/>
+            </a:ext>
+          </a:extLst>
+        </p:cNvPr>
+        <p:cNvGrpSpPr/>
+        <p:nvPr/>
+      </p:nvGrpSpPr>
+      <p:grpSpPr>
+        <a:xfrm>
+          <a:off x="0" y="0"/>
+          <a:ext cx="0" cy="0"/>
+          <a:chOff x="0" y="0"/>
+          <a:chExt cx="0" cy="0"/>
+        </a:xfrm>
+      </p:grpSpPr>
+      <p:sp>
+        <p:nvSpPr>
           <p:cNvPr id="2" name="Slide Image Placeholder 1">
             <a:extLst>
               <a:ext uri="{FF2B5EF4-FFF2-40B4-BE49-F238E27FC236}">
-                <a16:creationId xmlns:a16="http://schemas.microsoft.com/office/drawing/2014/main" id="{75A087AE-59E9-F656-21AD-17E30BF0FB7C}"/>
+                <a16:creationId xmlns:a16="http://schemas.microsoft.com/office/drawing/2014/main" id="{F1B0F22A-F00F-0057-1149-92CC4CD87D88}"/>
               </a:ext>
             </a:extLst>
           </p:cNvPr>
@@ -346,66 +446,42 @@
             <p:ph type="sldImg"/>
           </p:nvPr>
         </p:nvSpPr>
-        <p:spPr>
-          <a:xfrm>
-            <a:off x="0" y="0"/>
-            <a:ext cx="0" cy="0"/>
-          </a:xfrm>
-          <a:prstGeom prst="rect">
-            <a:avLst/>
-          </a:prstGeom>
-          <a:noFill/>
-          <a:ln>
-            <a:noFill/>
-            <a:prstDash val="solid"/>
-          </a:ln>
-        </p:spPr>
+        <p:spPr/>
       </p:sp>
       <p:sp>
         <p:nvSpPr>
           <p:cNvPr id="3" name="Notes Placeholder 2">
             <a:extLst>
               <a:ext uri="{FF2B5EF4-FFF2-40B4-BE49-F238E27FC236}">
-                <a16:creationId xmlns:a16="http://schemas.microsoft.com/office/drawing/2014/main" id="{9C02448F-04F1-D2F9-3105-094753D8C29B}"/>
+                <a16:creationId xmlns:a16="http://schemas.microsoft.com/office/drawing/2014/main" id="{590DD66A-29A7-BD23-7479-99308DB3DD27}"/>
               </a:ext>
             </a:extLst>
           </p:cNvPr>
-          <p:cNvSpPr txBox="1">
+          <p:cNvSpPr>
             <a:spLocks noGrp="1"/>
           </p:cNvSpPr>
           <p:nvPr>
             <p:ph type="body" idx="1"/>
           </p:nvPr>
         </p:nvSpPr>
-        <p:spPr>
-          <a:xfrm>
-            <a:off x="0" y="0"/>
-            <a:ext cx="0" cy="0"/>
-          </a:xfrm>
-          <a:prstGeom prst="rect">
-            <a:avLst/>
-          </a:prstGeom>
-          <a:noFill/>
-          <a:ln>
-            <a:noFill/>
-          </a:ln>
-        </p:spPr>
+        <p:spPr/>
         <p:txBody>
-          <a:bodyPr vert="horz" wrap="square" lIns="91440" tIns="45720" rIns="91440" bIns="45720" anchor="t" anchorCtr="0" compatLnSpc="1">
-            <a:noAutofit/>
-          </a:bodyPr>
+          <a:bodyPr/>
           <a:lstStyle/>
           <a:p>
-            <a:pPr lvl="0"/>
-            <a:r>
-              <a:rPr lang="de-DE">
-                <a:solidFill>
-                  <a:srgbClr val="000000"/>
-                </a:solidFill>
-                <a:latin typeface="Aptos"/>
-              </a:rPr>
-              <a:t>Vortragende(r): Adrian</a:t>
-            </a:r>
+            <a:r>
+              <a:rPr dirty="0" err="1"/>
+              <a:t>Vortragende</a:t>
+            </a:r>
+            <a:r>
+              <a:rPr dirty="0"/>
+              <a:t>(r): </a:t>
+            </a:r>
+            <a:r>
+              <a:rPr lang="de-DE" dirty="0"/>
+              <a:t>Maximilian</a:t>
+            </a:r>
+            <a:endParaRPr dirty="0"/>
           </a:p>
         </p:txBody>
       </p:sp>
@@ -414,50 +490,36 @@
           <p:cNvPr id="4" name="Slide Number Placeholder 3">
             <a:extLst>
               <a:ext uri="{FF2B5EF4-FFF2-40B4-BE49-F238E27FC236}">
-                <a16:creationId xmlns:a16="http://schemas.microsoft.com/office/drawing/2014/main" id="{BE5C70A5-D35D-67E6-5B60-F0EB047265A1}"/>
+                <a16:creationId xmlns:a16="http://schemas.microsoft.com/office/drawing/2014/main" id="{6AD8F6E3-73AF-D838-73CC-427E21B55663}"/>
               </a:ext>
             </a:extLst>
           </p:cNvPr>
-          <p:cNvSpPr txBox="1">
+          <p:cNvSpPr>
             <a:spLocks noGrp="1"/>
           </p:cNvSpPr>
           <p:nvPr>
-            <p:ph type="sldNum" sz="quarter" idx="8"/>
+            <p:ph type="sldNum" sz="quarter" idx="10"/>
           </p:nvPr>
         </p:nvSpPr>
-        <p:spPr>
-          <a:xfrm>
-            <a:off x="0" y="0"/>
-            <a:ext cx="0" cy="0"/>
-          </a:xfrm>
-          <a:prstGeom prst="rect">
-            <a:avLst/>
-          </a:prstGeom>
-          <a:noFill/>
-          <a:ln>
-            <a:noFill/>
-          </a:ln>
-        </p:spPr>
+        <p:spPr/>
         <p:txBody>
-          <a:bodyPr vert="horz" wrap="square" lIns="91440" tIns="45720" rIns="91440" bIns="45720" anchor="t" anchorCtr="0" compatLnSpc="1">
-            <a:noAutofit/>
-          </a:bodyPr>
+          <a:bodyPr/>
           <a:lstStyle/>
           <a:p>
-            <a:pPr lvl="0"/>
-            <a:fld id="{16115379-4AB9-6B41-AE94-366B276EC789}" type="slidenum">
+            <a:fld id="{F7021451-1387-4CA6-816F-3879F97B5CBC}" type="slidenum">
+              <a:rPr lang="en-US"/>
               <a:t>10</a:t>
             </a:fld>
-            <a:endParaRPr lang="en-US">
-              <a:solidFill>
-                <a:srgbClr val="000000"/>
-              </a:solidFill>
-              <a:latin typeface="Aptos"/>
-            </a:endParaRPr>
+            <a:endParaRPr lang="en-US"/>
           </a:p>
         </p:txBody>
       </p:sp>
     </p:spTree>
+    <p:extLst>
+      <p:ext uri="{BB962C8B-B14F-4D97-AF65-F5344CB8AC3E}">
+        <p14:creationId xmlns:p14="http://schemas.microsoft.com/office/powerpoint/2010/main" val="4112070376"/>
+      </p:ext>
+    </p:extLst>
   </p:cSld>
   <p:clrMapOvr>
     <a:masterClrMapping/>
@@ -484,13 +546,7 @@
       </p:grpSpPr>
       <p:sp>
         <p:nvSpPr>
-          <p:cNvPr id="2" name="Slide Image Placeholder 1">
-            <a:extLst>
-              <a:ext uri="{FF2B5EF4-FFF2-40B4-BE49-F238E27FC236}">
-                <a16:creationId xmlns:a16="http://schemas.microsoft.com/office/drawing/2014/main" id="{5B968CA1-F530-BD2F-1902-B7803C5072AF}"/>
-              </a:ext>
-            </a:extLst>
-          </p:cNvPr>
+          <p:cNvPr id="2" name="Slide Image Placeholder 1"/>
           <p:cNvSpPr>
             <a:spLocks noGrp="1" noRot="1" noChangeAspect="1"/>
           </p:cNvSpPr>
@@ -498,118 +554,68 @@
             <p:ph type="sldImg"/>
           </p:nvPr>
         </p:nvSpPr>
-        <p:spPr>
-          <a:xfrm>
-            <a:off x="0" y="0"/>
-            <a:ext cx="0" cy="0"/>
-          </a:xfrm>
-          <a:prstGeom prst="rect">
-            <a:avLst/>
-          </a:prstGeom>
-          <a:noFill/>
-          <a:ln>
-            <a:noFill/>
-            <a:prstDash val="solid"/>
-          </a:ln>
-        </p:spPr>
-      </p:sp>
-      <p:sp>
-        <p:nvSpPr>
-          <p:cNvPr id="3" name="Notes Placeholder 2">
-            <a:extLst>
-              <a:ext uri="{FF2B5EF4-FFF2-40B4-BE49-F238E27FC236}">
-                <a16:creationId xmlns:a16="http://schemas.microsoft.com/office/drawing/2014/main" id="{68BE084C-5A20-9E62-2AF6-F121F17F389E}"/>
-              </a:ext>
-            </a:extLst>
-          </p:cNvPr>
-          <p:cNvSpPr txBox="1">
+        <p:spPr/>
+      </p:sp>
+      <p:sp>
+        <p:nvSpPr>
+          <p:cNvPr id="3" name="Notes Placeholder 2"/>
+          <p:cNvSpPr>
             <a:spLocks noGrp="1"/>
           </p:cNvSpPr>
           <p:nvPr>
             <p:ph type="body" idx="1"/>
           </p:nvPr>
         </p:nvSpPr>
-        <p:spPr>
-          <a:xfrm>
-            <a:off x="0" y="0"/>
-            <a:ext cx="0" cy="0"/>
-          </a:xfrm>
-          <a:prstGeom prst="rect">
-            <a:avLst/>
-          </a:prstGeom>
-          <a:noFill/>
-          <a:ln>
-            <a:noFill/>
-          </a:ln>
-        </p:spPr>
+        <p:spPr/>
         <p:txBody>
-          <a:bodyPr vert="horz" wrap="square" lIns="91440" tIns="45720" rIns="91440" bIns="45720" anchor="t" anchorCtr="0" compatLnSpc="1">
-            <a:noAutofit/>
-          </a:bodyPr>
+          <a:bodyPr/>
           <a:lstStyle/>
           <a:p>
-            <a:pPr lvl="0"/>
-            <a:r>
-              <a:rPr lang="de-DE">
-                <a:solidFill>
-                  <a:srgbClr val="000000"/>
-                </a:solidFill>
-                <a:latin typeface="Aptos"/>
-              </a:rPr>
-              <a:t>Vortragende(r): Adrian</a:t>
-            </a:r>
+            <a:r>
+              <a:rPr dirty="0" err="1"/>
+              <a:t>Vortragende</a:t>
+            </a:r>
+            <a:r>
+              <a:rPr dirty="0"/>
+              <a:t>(r): </a:t>
+            </a:r>
+            <a:r>
+              <a:rPr lang="de-DE" dirty="0"/>
+              <a:t>Maximilian</a:t>
+            </a:r>
+            <a:endParaRPr dirty="0"/>
           </a:p>
         </p:txBody>
       </p:sp>
       <p:sp>
         <p:nvSpPr>
-          <p:cNvPr id="4" name="Slide Number Placeholder 3">
-            <a:extLst>
-              <a:ext uri="{FF2B5EF4-FFF2-40B4-BE49-F238E27FC236}">
-                <a16:creationId xmlns:a16="http://schemas.microsoft.com/office/drawing/2014/main" id="{7BFCD28C-CB29-26BF-F79C-9BD6014FD52B}"/>
-              </a:ext>
-            </a:extLst>
-          </p:cNvPr>
-          <p:cNvSpPr txBox="1">
+          <p:cNvPr id="4" name="Slide Number Placeholder 3"/>
+          <p:cNvSpPr>
             <a:spLocks noGrp="1"/>
           </p:cNvSpPr>
           <p:nvPr>
-            <p:ph type="sldNum" sz="quarter" idx="8"/>
+            <p:ph type="sldNum" sz="quarter" idx="10"/>
           </p:nvPr>
         </p:nvSpPr>
-        <p:spPr>
-          <a:xfrm>
-            <a:off x="0" y="0"/>
-            <a:ext cx="0" cy="0"/>
-          </a:xfrm>
-          <a:prstGeom prst="rect">
-            <a:avLst/>
-          </a:prstGeom>
-          <a:noFill/>
-          <a:ln>
-            <a:noFill/>
-          </a:ln>
-        </p:spPr>
+        <p:spPr/>
         <p:txBody>
-          <a:bodyPr vert="horz" wrap="square" lIns="91440" tIns="45720" rIns="91440" bIns="45720" anchor="t" anchorCtr="0" compatLnSpc="1">
-            <a:noAutofit/>
-          </a:bodyPr>
+          <a:bodyPr/>
           <a:lstStyle/>
           <a:p>
-            <a:pPr lvl="0"/>
-            <a:fld id="{795690C6-63E1-D346-B37B-BB7E56D14EF1}" type="slidenum">
-              <a:t>12</a:t>
+            <a:fld id="{F7021451-1387-4CA6-816F-3879F97B5CBC}" type="slidenum">
+              <a:rPr lang="en-US"/>
+              <a:t>11</a:t>
             </a:fld>
-            <a:endParaRPr lang="en-US">
-              <a:solidFill>
-                <a:srgbClr val="000000"/>
-              </a:solidFill>
-              <a:latin typeface="Aptos"/>
-            </a:endParaRPr>
+            <a:endParaRPr lang="en-US"/>
           </a:p>
         </p:txBody>
       </p:sp>
     </p:spTree>
+    <p:extLst>
+      <p:ext uri="{BB962C8B-B14F-4D97-AF65-F5344CB8AC3E}">
+        <p14:creationId xmlns:p14="http://schemas.microsoft.com/office/powerpoint/2010/main" val="1024086991"/>
+      </p:ext>
+    </p:extLst>
   </p:cSld>
   <p:clrMapOvr>
     <a:masterClrMapping/>
@@ -636,128 +642,32 @@
       </p:grpSpPr>
       <p:sp>
         <p:nvSpPr>
-          <p:cNvPr id="2" name="Slide Image Placeholder 1">
-            <a:extLst>
-              <a:ext uri="{FF2B5EF4-FFF2-40B4-BE49-F238E27FC236}">
-                <a16:creationId xmlns:a16="http://schemas.microsoft.com/office/drawing/2014/main" id="{22503FFB-D33B-5B7D-5230-105F479800B0}"/>
-              </a:ext>
-            </a:extLst>
-          </p:cNvPr>
+          <p:cNvPr id="3" name="Notes Placeholder 2"/>
           <p:cNvSpPr>
-            <a:spLocks noGrp="1" noRot="1" noChangeAspect="1"/>
-          </p:cNvSpPr>
-          <p:nvPr>
-            <p:ph type="sldImg"/>
-          </p:nvPr>
-        </p:nvSpPr>
-        <p:spPr>
-          <a:xfrm>
-            <a:off x="0" y="0"/>
-            <a:ext cx="0" cy="0"/>
-          </a:xfrm>
-          <a:prstGeom prst="rect">
-            <a:avLst/>
-          </a:prstGeom>
-          <a:noFill/>
-          <a:ln>
-            <a:noFill/>
-            <a:prstDash val="solid"/>
-          </a:ln>
-        </p:spPr>
-      </p:sp>
-      <p:sp>
-        <p:nvSpPr>
-          <p:cNvPr id="3" name="Notes Placeholder 2">
-            <a:extLst>
-              <a:ext uri="{FF2B5EF4-FFF2-40B4-BE49-F238E27FC236}">
-                <a16:creationId xmlns:a16="http://schemas.microsoft.com/office/drawing/2014/main" id="{8EE047C3-A45E-A32B-1C8D-9400DFC0A561}"/>
-              </a:ext>
-            </a:extLst>
-          </p:cNvPr>
-          <p:cNvSpPr txBox="1">
             <a:spLocks noGrp="1"/>
           </p:cNvSpPr>
           <p:nvPr>
             <p:ph type="body" idx="1"/>
           </p:nvPr>
         </p:nvSpPr>
-        <p:spPr>
-          <a:xfrm>
-            <a:off x="0" y="0"/>
-            <a:ext cx="0" cy="0"/>
-          </a:xfrm>
-          <a:prstGeom prst="rect">
-            <a:avLst/>
-          </a:prstGeom>
-          <a:noFill/>
-          <a:ln>
-            <a:noFill/>
-          </a:ln>
-        </p:spPr>
+        <p:spPr/>
         <p:txBody>
-          <a:bodyPr vert="horz" wrap="square" lIns="91440" tIns="45720" rIns="91440" bIns="45720" anchor="t" anchorCtr="0" compatLnSpc="1">
-            <a:noAutofit/>
-          </a:bodyPr>
+          <a:bodyPr/>
           <a:lstStyle/>
           <a:p>
-            <a:pPr lvl="0"/>
-            <a:r>
-              <a:rPr lang="de-DE">
-                <a:solidFill>
-                  <a:srgbClr val="000000"/>
-                </a:solidFill>
-                <a:latin typeface="Aptos"/>
-              </a:rPr>
-              <a:t>Vortragende(r): Adrian</a:t>
-            </a:r>
-          </a:p>
-        </p:txBody>
-      </p:sp>
-      <p:sp>
-        <p:nvSpPr>
-          <p:cNvPr id="4" name="Slide Number Placeholder 3">
-            <a:extLst>
-              <a:ext uri="{FF2B5EF4-FFF2-40B4-BE49-F238E27FC236}">
-                <a16:creationId xmlns:a16="http://schemas.microsoft.com/office/drawing/2014/main" id="{5BFE4DA9-A6D9-16E2-ED2A-6B6DD9480B52}"/>
-              </a:ext>
-            </a:extLst>
-          </p:cNvPr>
-          <p:cNvSpPr txBox="1">
-            <a:spLocks noGrp="1"/>
-          </p:cNvSpPr>
-          <p:nvPr>
-            <p:ph type="sldNum" sz="quarter" idx="8"/>
-          </p:nvPr>
-        </p:nvSpPr>
-        <p:spPr>
-          <a:xfrm>
-            <a:off x="0" y="0"/>
-            <a:ext cx="0" cy="0"/>
-          </a:xfrm>
-          <a:prstGeom prst="rect">
-            <a:avLst/>
-          </a:prstGeom>
-          <a:noFill/>
-          <a:ln>
-            <a:noFill/>
-          </a:ln>
-        </p:spPr>
-        <p:txBody>
-          <a:bodyPr vert="horz" wrap="square" lIns="91440" tIns="45720" rIns="91440" bIns="45720" anchor="t" anchorCtr="0" compatLnSpc="1">
-            <a:noAutofit/>
-          </a:bodyPr>
-          <a:lstStyle/>
-          <a:p>
-            <a:pPr lvl="0"/>
-            <a:fld id="{A6CA3CBC-C7DC-8B4A-B2D9-7035F42B3713}" type="slidenum">
-              <a:t>13</a:t>
-            </a:fld>
-            <a:endParaRPr lang="en-US">
-              <a:solidFill>
-                <a:srgbClr val="000000"/>
-              </a:solidFill>
-              <a:latin typeface="Aptos"/>
-            </a:endParaRPr>
+            <a:r>
+              <a:rPr dirty="0" err="1"/>
+              <a:t>Vortragende</a:t>
+            </a:r>
+            <a:r>
+              <a:rPr dirty="0"/>
+              <a:t>(r): </a:t>
+            </a:r>
+            <a:r>
+              <a:rPr lang="de-DE" dirty="0"/>
+              <a:t>Maximilian</a:t>
+            </a:r>
+            <a:endParaRPr dirty="0"/>
           </a:p>
         </p:txBody>
       </p:sp>
@@ -788,7 +698,13 @@
       </p:grpSpPr>
       <p:sp>
         <p:nvSpPr>
-          <p:cNvPr id="2" name="Slide Image Placeholder 1"/>
+          <p:cNvPr id="2" name="Slide Image Placeholder 1">
+            <a:extLst>
+              <a:ext uri="{FF2B5EF4-FFF2-40B4-BE49-F238E27FC236}">
+                <a16:creationId xmlns:a16="http://schemas.microsoft.com/office/drawing/2014/main" id="{75A087AE-59E9-F656-21AD-17E30BF0FB7C}"/>
+              </a:ext>
+            </a:extLst>
+          </p:cNvPr>
           <p:cNvSpPr>
             <a:spLocks noGrp="1" noRot="1" noChangeAspect="1"/>
           </p:cNvSpPr>
@@ -796,63 +712,118 @@
             <p:ph type="sldImg"/>
           </p:nvPr>
         </p:nvSpPr>
-        <p:spPr/>
-      </p:sp>
-      <p:sp>
-        <p:nvSpPr>
-          <p:cNvPr id="3" name="Notes Placeholder 2"/>
-          <p:cNvSpPr>
+        <p:spPr>
+          <a:xfrm>
+            <a:off x="0" y="0"/>
+            <a:ext cx="0" cy="0"/>
+          </a:xfrm>
+          <a:prstGeom prst="rect">
+            <a:avLst/>
+          </a:prstGeom>
+          <a:noFill/>
+          <a:ln>
+            <a:noFill/>
+            <a:prstDash val="solid"/>
+          </a:ln>
+        </p:spPr>
+      </p:sp>
+      <p:sp>
+        <p:nvSpPr>
+          <p:cNvPr id="3" name="Notes Placeholder 2">
+            <a:extLst>
+              <a:ext uri="{FF2B5EF4-FFF2-40B4-BE49-F238E27FC236}">
+                <a16:creationId xmlns:a16="http://schemas.microsoft.com/office/drawing/2014/main" id="{9C02448F-04F1-D2F9-3105-094753D8C29B}"/>
+              </a:ext>
+            </a:extLst>
+          </p:cNvPr>
+          <p:cNvSpPr txBox="1">
             <a:spLocks noGrp="1"/>
           </p:cNvSpPr>
           <p:nvPr>
             <p:ph type="body" idx="1"/>
           </p:nvPr>
         </p:nvSpPr>
-        <p:spPr/>
+        <p:spPr>
+          <a:xfrm>
+            <a:off x="0" y="0"/>
+            <a:ext cx="0" cy="0"/>
+          </a:xfrm>
+          <a:prstGeom prst="rect">
+            <a:avLst/>
+          </a:prstGeom>
+          <a:noFill/>
+          <a:ln>
+            <a:noFill/>
+          </a:ln>
+        </p:spPr>
         <p:txBody>
-          <a:bodyPr/>
+          <a:bodyPr vert="horz" wrap="square" lIns="91440" tIns="45720" rIns="91440" bIns="45720" anchor="t" anchorCtr="0" compatLnSpc="1">
+            <a:noAutofit/>
+          </a:bodyPr>
           <a:lstStyle/>
           <a:p>
-            <a:r>
-              <a:rPr dirty="0" err="1"/>
-              <a:t>Vortragende</a:t>
-            </a:r>
-            <a:r>
-              <a:rPr dirty="0"/>
-              <a:t>(r): Kilian</a:t>
+            <a:pPr lvl="0"/>
+            <a:r>
+              <a:rPr lang="de-DE">
+                <a:solidFill>
+                  <a:srgbClr val="000000"/>
+                </a:solidFill>
+                <a:latin typeface="Aptos"/>
+              </a:rPr>
+              <a:t>Vortragende(r): Adrian</a:t>
             </a:r>
           </a:p>
         </p:txBody>
       </p:sp>
       <p:sp>
         <p:nvSpPr>
-          <p:cNvPr id="4" name="Slide Number Placeholder 3"/>
-          <p:cNvSpPr>
+          <p:cNvPr id="4" name="Slide Number Placeholder 3">
+            <a:extLst>
+              <a:ext uri="{FF2B5EF4-FFF2-40B4-BE49-F238E27FC236}">
+                <a16:creationId xmlns:a16="http://schemas.microsoft.com/office/drawing/2014/main" id="{BE5C70A5-D35D-67E6-5B60-F0EB047265A1}"/>
+              </a:ext>
+            </a:extLst>
+          </p:cNvPr>
+          <p:cNvSpPr txBox="1">
             <a:spLocks noGrp="1"/>
           </p:cNvSpPr>
           <p:nvPr>
-            <p:ph type="sldNum" sz="quarter" idx="10"/>
+            <p:ph type="sldNum" sz="quarter" idx="8"/>
           </p:nvPr>
         </p:nvSpPr>
-        <p:spPr/>
+        <p:spPr>
+          <a:xfrm>
+            <a:off x="0" y="0"/>
+            <a:ext cx="0" cy="0"/>
+          </a:xfrm>
+          <a:prstGeom prst="rect">
+            <a:avLst/>
+          </a:prstGeom>
+          <a:noFill/>
+          <a:ln>
+            <a:noFill/>
+          </a:ln>
+        </p:spPr>
         <p:txBody>
-          <a:bodyPr/>
+          <a:bodyPr vert="horz" wrap="square" lIns="91440" tIns="45720" rIns="91440" bIns="45720" anchor="t" anchorCtr="0" compatLnSpc="1">
+            <a:noAutofit/>
+          </a:bodyPr>
           <a:lstStyle/>
           <a:p>
-            <a:fld id="{F7021451-1387-4CA6-816F-3879F97B5CBC}" type="slidenum">
-              <a:rPr lang="en-US"/>
-              <a:t>14</a:t>
+            <a:pPr lvl="0"/>
+            <a:fld id="{16115379-4AB9-6B41-AE94-366B276EC789}" type="slidenum">
+              <a:t>13</a:t>
             </a:fld>
-            <a:endParaRPr lang="en-US"/>
+            <a:endParaRPr lang="en-US">
+              <a:solidFill>
+                <a:srgbClr val="000000"/>
+              </a:solidFill>
+              <a:latin typeface="Aptos"/>
+            </a:endParaRPr>
           </a:p>
         </p:txBody>
       </p:sp>
     </p:spTree>
-    <p:extLst>
-      <p:ext uri="{BB962C8B-B14F-4D97-AF65-F5344CB8AC3E}">
-        <p14:creationId xmlns:p14="http://schemas.microsoft.com/office/powerpoint/2010/main" val="1024086991"/>
-      </p:ext>
-    </p:extLst>
   </p:cSld>
   <p:clrMapOvr>
     <a:masterClrMapping/>
@@ -879,7 +850,13 @@
       </p:grpSpPr>
       <p:sp>
         <p:nvSpPr>
-          <p:cNvPr id="2" name="Slide Image Placeholder 1"/>
+          <p:cNvPr id="2" name="Slide Image Placeholder 1">
+            <a:extLst>
+              <a:ext uri="{FF2B5EF4-FFF2-40B4-BE49-F238E27FC236}">
+                <a16:creationId xmlns:a16="http://schemas.microsoft.com/office/drawing/2014/main" id="{75A087AE-59E9-F656-21AD-17E30BF0FB7C}"/>
+              </a:ext>
+            </a:extLst>
+          </p:cNvPr>
           <p:cNvSpPr>
             <a:spLocks noGrp="1" noRot="1" noChangeAspect="1"/>
           </p:cNvSpPr>
@@ -887,63 +864,118 @@
             <p:ph type="sldImg"/>
           </p:nvPr>
         </p:nvSpPr>
-        <p:spPr/>
-      </p:sp>
-      <p:sp>
-        <p:nvSpPr>
-          <p:cNvPr id="3" name="Notes Placeholder 2"/>
-          <p:cNvSpPr>
+        <p:spPr>
+          <a:xfrm>
+            <a:off x="0" y="0"/>
+            <a:ext cx="0" cy="0"/>
+          </a:xfrm>
+          <a:prstGeom prst="rect">
+            <a:avLst/>
+          </a:prstGeom>
+          <a:noFill/>
+          <a:ln>
+            <a:noFill/>
+            <a:prstDash val="solid"/>
+          </a:ln>
+        </p:spPr>
+      </p:sp>
+      <p:sp>
+        <p:nvSpPr>
+          <p:cNvPr id="3" name="Notes Placeholder 2">
+            <a:extLst>
+              <a:ext uri="{FF2B5EF4-FFF2-40B4-BE49-F238E27FC236}">
+                <a16:creationId xmlns:a16="http://schemas.microsoft.com/office/drawing/2014/main" id="{9C02448F-04F1-D2F9-3105-094753D8C29B}"/>
+              </a:ext>
+            </a:extLst>
+          </p:cNvPr>
+          <p:cNvSpPr txBox="1">
             <a:spLocks noGrp="1"/>
           </p:cNvSpPr>
           <p:nvPr>
             <p:ph type="body" idx="1"/>
           </p:nvPr>
         </p:nvSpPr>
-        <p:spPr/>
+        <p:spPr>
+          <a:xfrm>
+            <a:off x="0" y="0"/>
+            <a:ext cx="0" cy="0"/>
+          </a:xfrm>
+          <a:prstGeom prst="rect">
+            <a:avLst/>
+          </a:prstGeom>
+          <a:noFill/>
+          <a:ln>
+            <a:noFill/>
+          </a:ln>
+        </p:spPr>
         <p:txBody>
-          <a:bodyPr/>
+          <a:bodyPr vert="horz" wrap="square" lIns="91440" tIns="45720" rIns="91440" bIns="45720" anchor="t" anchorCtr="0" compatLnSpc="1">
+            <a:noAutofit/>
+          </a:bodyPr>
           <a:lstStyle/>
           <a:p>
-            <a:r>
-              <a:rPr dirty="0" err="1"/>
-              <a:t>Vortragende</a:t>
-            </a:r>
-            <a:r>
-              <a:rPr dirty="0"/>
-              <a:t>(r): Kilian</a:t>
+            <a:pPr lvl="0"/>
+            <a:r>
+              <a:rPr lang="de-DE">
+                <a:solidFill>
+                  <a:srgbClr val="000000"/>
+                </a:solidFill>
+                <a:latin typeface="Aptos"/>
+              </a:rPr>
+              <a:t>Vortragende(r): Adrian</a:t>
             </a:r>
           </a:p>
         </p:txBody>
       </p:sp>
       <p:sp>
         <p:nvSpPr>
-          <p:cNvPr id="4" name="Slide Number Placeholder 3"/>
-          <p:cNvSpPr>
+          <p:cNvPr id="4" name="Slide Number Placeholder 3">
+            <a:extLst>
+              <a:ext uri="{FF2B5EF4-FFF2-40B4-BE49-F238E27FC236}">
+                <a16:creationId xmlns:a16="http://schemas.microsoft.com/office/drawing/2014/main" id="{BE5C70A5-D35D-67E6-5B60-F0EB047265A1}"/>
+              </a:ext>
+            </a:extLst>
+          </p:cNvPr>
+          <p:cNvSpPr txBox="1">
             <a:spLocks noGrp="1"/>
           </p:cNvSpPr>
           <p:nvPr>
-            <p:ph type="sldNum" sz="quarter" idx="10"/>
+            <p:ph type="sldNum" sz="quarter" idx="8"/>
           </p:nvPr>
         </p:nvSpPr>
-        <p:spPr/>
+        <p:spPr>
+          <a:xfrm>
+            <a:off x="0" y="0"/>
+            <a:ext cx="0" cy="0"/>
+          </a:xfrm>
+          <a:prstGeom prst="rect">
+            <a:avLst/>
+          </a:prstGeom>
+          <a:noFill/>
+          <a:ln>
+            <a:noFill/>
+          </a:ln>
+        </p:spPr>
         <p:txBody>
-          <a:bodyPr/>
+          <a:bodyPr vert="horz" wrap="square" lIns="91440" tIns="45720" rIns="91440" bIns="45720" anchor="t" anchorCtr="0" compatLnSpc="1">
+            <a:noAutofit/>
+          </a:bodyPr>
           <a:lstStyle/>
           <a:p>
-            <a:fld id="{F7021451-1387-4CA6-816F-3879F97B5CBC}" type="slidenum">
-              <a:rPr lang="en-US"/>
-              <a:t>15</a:t>
+            <a:pPr lvl="0"/>
+            <a:fld id="{16115379-4AB9-6B41-AE94-366B276EC789}" type="slidenum">
+              <a:t>14</a:t>
             </a:fld>
-            <a:endParaRPr lang="en-US"/>
+            <a:endParaRPr lang="en-US">
+              <a:solidFill>
+                <a:srgbClr val="000000"/>
+              </a:solidFill>
+              <a:latin typeface="Aptos"/>
+            </a:endParaRPr>
           </a:p>
         </p:txBody>
       </p:sp>
     </p:spTree>
-    <p:extLst>
-      <p:ext uri="{BB962C8B-B14F-4D97-AF65-F5344CB8AC3E}">
-        <p14:creationId xmlns:p14="http://schemas.microsoft.com/office/powerpoint/2010/main" val="1024086991"/>
-      </p:ext>
-    </p:extLst>
   </p:cSld>
   <p:clrMapOvr>
     <a:masterClrMapping/>
@@ -970,7 +1002,13 @@
       </p:grpSpPr>
       <p:sp>
         <p:nvSpPr>
-          <p:cNvPr id="2" name="Slide Image Placeholder 1"/>
+          <p:cNvPr id="2" name="Slide Image Placeholder 1">
+            <a:extLst>
+              <a:ext uri="{FF2B5EF4-FFF2-40B4-BE49-F238E27FC236}">
+                <a16:creationId xmlns:a16="http://schemas.microsoft.com/office/drawing/2014/main" id="{5B968CA1-F530-BD2F-1902-B7803C5072AF}"/>
+              </a:ext>
+            </a:extLst>
+          </p:cNvPr>
           <p:cNvSpPr>
             <a:spLocks noGrp="1" noRot="1" noChangeAspect="1"/>
           </p:cNvSpPr>
@@ -978,63 +1016,118 @@
             <p:ph type="sldImg"/>
           </p:nvPr>
         </p:nvSpPr>
-        <p:spPr/>
-      </p:sp>
-      <p:sp>
-        <p:nvSpPr>
-          <p:cNvPr id="3" name="Notes Placeholder 2"/>
-          <p:cNvSpPr>
+        <p:spPr>
+          <a:xfrm>
+            <a:off x="0" y="0"/>
+            <a:ext cx="0" cy="0"/>
+          </a:xfrm>
+          <a:prstGeom prst="rect">
+            <a:avLst/>
+          </a:prstGeom>
+          <a:noFill/>
+          <a:ln>
+            <a:noFill/>
+            <a:prstDash val="solid"/>
+          </a:ln>
+        </p:spPr>
+      </p:sp>
+      <p:sp>
+        <p:nvSpPr>
+          <p:cNvPr id="3" name="Notes Placeholder 2">
+            <a:extLst>
+              <a:ext uri="{FF2B5EF4-FFF2-40B4-BE49-F238E27FC236}">
+                <a16:creationId xmlns:a16="http://schemas.microsoft.com/office/drawing/2014/main" id="{68BE084C-5A20-9E62-2AF6-F121F17F389E}"/>
+              </a:ext>
+            </a:extLst>
+          </p:cNvPr>
+          <p:cNvSpPr txBox="1">
             <a:spLocks noGrp="1"/>
           </p:cNvSpPr>
           <p:nvPr>
             <p:ph type="body" idx="1"/>
           </p:nvPr>
         </p:nvSpPr>
-        <p:spPr/>
+        <p:spPr>
+          <a:xfrm>
+            <a:off x="0" y="0"/>
+            <a:ext cx="0" cy="0"/>
+          </a:xfrm>
+          <a:prstGeom prst="rect">
+            <a:avLst/>
+          </a:prstGeom>
+          <a:noFill/>
+          <a:ln>
+            <a:noFill/>
+          </a:ln>
+        </p:spPr>
         <p:txBody>
-          <a:bodyPr/>
+          <a:bodyPr vert="horz" wrap="square" lIns="91440" tIns="45720" rIns="91440" bIns="45720" anchor="t" anchorCtr="0" compatLnSpc="1">
+            <a:noAutofit/>
+          </a:bodyPr>
           <a:lstStyle/>
           <a:p>
-            <a:r>
-              <a:rPr dirty="0" err="1"/>
-              <a:t>Vortragende</a:t>
-            </a:r>
-            <a:r>
-              <a:rPr dirty="0"/>
-              <a:t>(r): Jakob</a:t>
+            <a:pPr lvl="0"/>
+            <a:r>
+              <a:rPr lang="de-DE">
+                <a:solidFill>
+                  <a:srgbClr val="000000"/>
+                </a:solidFill>
+                <a:latin typeface="Aptos"/>
+              </a:rPr>
+              <a:t>Vortragende(r): Adrian</a:t>
             </a:r>
           </a:p>
         </p:txBody>
       </p:sp>
       <p:sp>
         <p:nvSpPr>
-          <p:cNvPr id="4" name="Slide Number Placeholder 3"/>
-          <p:cNvSpPr>
+          <p:cNvPr id="4" name="Slide Number Placeholder 3">
+            <a:extLst>
+              <a:ext uri="{FF2B5EF4-FFF2-40B4-BE49-F238E27FC236}">
+                <a16:creationId xmlns:a16="http://schemas.microsoft.com/office/drawing/2014/main" id="{7BFCD28C-CB29-26BF-F79C-9BD6014FD52B}"/>
+              </a:ext>
+            </a:extLst>
+          </p:cNvPr>
+          <p:cNvSpPr txBox="1">
             <a:spLocks noGrp="1"/>
           </p:cNvSpPr>
           <p:nvPr>
-            <p:ph type="sldNum" sz="quarter" idx="10"/>
+            <p:ph type="sldNum" sz="quarter" idx="8"/>
           </p:nvPr>
         </p:nvSpPr>
-        <p:spPr/>
+        <p:spPr>
+          <a:xfrm>
+            <a:off x="0" y="0"/>
+            <a:ext cx="0" cy="0"/>
+          </a:xfrm>
+          <a:prstGeom prst="rect">
+            <a:avLst/>
+          </a:prstGeom>
+          <a:noFill/>
+          <a:ln>
+            <a:noFill/>
+          </a:ln>
+        </p:spPr>
         <p:txBody>
-          <a:bodyPr/>
+          <a:bodyPr vert="horz" wrap="square" lIns="91440" tIns="45720" rIns="91440" bIns="45720" anchor="t" anchorCtr="0" compatLnSpc="1">
+            <a:noAutofit/>
+          </a:bodyPr>
           <a:lstStyle/>
           <a:p>
-            <a:fld id="{F7021451-1387-4CA6-816F-3879F97B5CBC}" type="slidenum">
-              <a:rPr lang="en-US"/>
-              <a:t>16</a:t>
+            <a:pPr lvl="0"/>
+            <a:fld id="{795690C6-63E1-D346-B37B-BB7E56D14EF1}" type="slidenum">
+              <a:t>15</a:t>
             </a:fld>
-            <a:endParaRPr lang="en-US"/>
+            <a:endParaRPr lang="en-US">
+              <a:solidFill>
+                <a:srgbClr val="000000"/>
+              </a:solidFill>
+              <a:latin typeface="Aptos"/>
+            </a:endParaRPr>
           </a:p>
         </p:txBody>
       </p:sp>
     </p:spTree>
-    <p:extLst>
-      <p:ext uri="{BB962C8B-B14F-4D97-AF65-F5344CB8AC3E}">
-        <p14:creationId xmlns:p14="http://schemas.microsoft.com/office/powerpoint/2010/main" val="1024086991"/>
-      </p:ext>
-    </p:extLst>
   </p:cSld>
   <p:clrMapOvr>
     <a:masterClrMapping/>
@@ -1061,7 +1154,13 @@
       </p:grpSpPr>
       <p:sp>
         <p:nvSpPr>
-          <p:cNvPr id="2" name="Slide Image Placeholder 1"/>
+          <p:cNvPr id="2" name="Slide Image Placeholder 1">
+            <a:extLst>
+              <a:ext uri="{FF2B5EF4-FFF2-40B4-BE49-F238E27FC236}">
+                <a16:creationId xmlns:a16="http://schemas.microsoft.com/office/drawing/2014/main" id="{22503FFB-D33B-5B7D-5230-105F479800B0}"/>
+              </a:ext>
+            </a:extLst>
+          </p:cNvPr>
           <p:cNvSpPr>
             <a:spLocks noGrp="1" noRot="1" noChangeAspect="1"/>
           </p:cNvSpPr>
@@ -1069,63 +1168,118 @@
             <p:ph type="sldImg"/>
           </p:nvPr>
         </p:nvSpPr>
-        <p:spPr/>
-      </p:sp>
-      <p:sp>
-        <p:nvSpPr>
-          <p:cNvPr id="3" name="Notes Placeholder 2"/>
-          <p:cNvSpPr>
+        <p:spPr>
+          <a:xfrm>
+            <a:off x="0" y="0"/>
+            <a:ext cx="0" cy="0"/>
+          </a:xfrm>
+          <a:prstGeom prst="rect">
+            <a:avLst/>
+          </a:prstGeom>
+          <a:noFill/>
+          <a:ln>
+            <a:noFill/>
+            <a:prstDash val="solid"/>
+          </a:ln>
+        </p:spPr>
+      </p:sp>
+      <p:sp>
+        <p:nvSpPr>
+          <p:cNvPr id="3" name="Notes Placeholder 2">
+            <a:extLst>
+              <a:ext uri="{FF2B5EF4-FFF2-40B4-BE49-F238E27FC236}">
+                <a16:creationId xmlns:a16="http://schemas.microsoft.com/office/drawing/2014/main" id="{8EE047C3-A45E-A32B-1C8D-9400DFC0A561}"/>
+              </a:ext>
+            </a:extLst>
+          </p:cNvPr>
+          <p:cNvSpPr txBox="1">
             <a:spLocks noGrp="1"/>
           </p:cNvSpPr>
           <p:nvPr>
             <p:ph type="body" idx="1"/>
           </p:nvPr>
         </p:nvSpPr>
-        <p:spPr/>
+        <p:spPr>
+          <a:xfrm>
+            <a:off x="0" y="0"/>
+            <a:ext cx="0" cy="0"/>
+          </a:xfrm>
+          <a:prstGeom prst="rect">
+            <a:avLst/>
+          </a:prstGeom>
+          <a:noFill/>
+          <a:ln>
+            <a:noFill/>
+          </a:ln>
+        </p:spPr>
         <p:txBody>
-          <a:bodyPr/>
+          <a:bodyPr vert="horz" wrap="square" lIns="91440" tIns="45720" rIns="91440" bIns="45720" anchor="t" anchorCtr="0" compatLnSpc="1">
+            <a:noAutofit/>
+          </a:bodyPr>
           <a:lstStyle/>
           <a:p>
-            <a:r>
-              <a:rPr dirty="0" err="1"/>
-              <a:t>Vortragende</a:t>
-            </a:r>
-            <a:r>
-              <a:rPr dirty="0"/>
-              <a:t>(r): Jakob</a:t>
+            <a:pPr lvl="0"/>
+            <a:r>
+              <a:rPr lang="de-DE">
+                <a:solidFill>
+                  <a:srgbClr val="000000"/>
+                </a:solidFill>
+                <a:latin typeface="Aptos"/>
+              </a:rPr>
+              <a:t>Vortragende(r): Adrian</a:t>
             </a:r>
           </a:p>
         </p:txBody>
       </p:sp>
       <p:sp>
         <p:nvSpPr>
-          <p:cNvPr id="4" name="Slide Number Placeholder 3"/>
-          <p:cNvSpPr>
+          <p:cNvPr id="4" name="Slide Number Placeholder 3">
+            <a:extLst>
+              <a:ext uri="{FF2B5EF4-FFF2-40B4-BE49-F238E27FC236}">
+                <a16:creationId xmlns:a16="http://schemas.microsoft.com/office/drawing/2014/main" id="{5BFE4DA9-A6D9-16E2-ED2A-6B6DD9480B52}"/>
+              </a:ext>
+            </a:extLst>
+          </p:cNvPr>
+          <p:cNvSpPr txBox="1">
             <a:spLocks noGrp="1"/>
           </p:cNvSpPr>
           <p:nvPr>
-            <p:ph type="sldNum" sz="quarter" idx="10"/>
+            <p:ph type="sldNum" sz="quarter" idx="8"/>
           </p:nvPr>
         </p:nvSpPr>
-        <p:spPr/>
+        <p:spPr>
+          <a:xfrm>
+            <a:off x="0" y="0"/>
+            <a:ext cx="0" cy="0"/>
+          </a:xfrm>
+          <a:prstGeom prst="rect">
+            <a:avLst/>
+          </a:prstGeom>
+          <a:noFill/>
+          <a:ln>
+            <a:noFill/>
+          </a:ln>
+        </p:spPr>
         <p:txBody>
-          <a:bodyPr/>
+          <a:bodyPr vert="horz" wrap="square" lIns="91440" tIns="45720" rIns="91440" bIns="45720" anchor="t" anchorCtr="0" compatLnSpc="1">
+            <a:noAutofit/>
+          </a:bodyPr>
           <a:lstStyle/>
           <a:p>
-            <a:fld id="{F7021451-1387-4CA6-816F-3879F97B5CBC}" type="slidenum">
-              <a:rPr lang="en-US"/>
-              <a:t>17</a:t>
+            <a:pPr lvl="0"/>
+            <a:fld id="{A6CA3CBC-C7DC-8B4A-B2D9-7035F42B3713}" type="slidenum">
+              <a:t>16</a:t>
             </a:fld>
-            <a:endParaRPr lang="en-US"/>
+            <a:endParaRPr lang="en-US">
+              <a:solidFill>
+                <a:srgbClr val="000000"/>
+              </a:solidFill>
+              <a:latin typeface="Aptos"/>
+            </a:endParaRPr>
           </a:p>
         </p:txBody>
       </p:sp>
     </p:spTree>
-    <p:extLst>
-      <p:ext uri="{BB962C8B-B14F-4D97-AF65-F5344CB8AC3E}">
-        <p14:creationId xmlns:p14="http://schemas.microsoft.com/office/powerpoint/2010/main" val="1285418441"/>
-      </p:ext>
-    </p:extLst>
   </p:cSld>
   <p:clrMapOvr>
     <a:masterClrMapping/>
@@ -1152,13 +1306,7 @@
       </p:grpSpPr>
       <p:sp>
         <p:nvSpPr>
-          <p:cNvPr id="2" name="Slide Image Placeholder 1">
-            <a:extLst>
-              <a:ext uri="{FF2B5EF4-FFF2-40B4-BE49-F238E27FC236}">
-                <a16:creationId xmlns:a16="http://schemas.microsoft.com/office/drawing/2014/main" id="{4C667BE3-F584-F4AD-6A7E-91C8E60DD128}"/>
-              </a:ext>
-            </a:extLst>
-          </p:cNvPr>
+          <p:cNvPr id="2" name="Slide Image Placeholder 1"/>
           <p:cNvSpPr>
             <a:spLocks noGrp="1" noRot="1" noChangeAspect="1"/>
           </p:cNvSpPr>
@@ -1166,118 +1314,63 @@
             <p:ph type="sldImg"/>
           </p:nvPr>
         </p:nvSpPr>
-        <p:spPr>
-          <a:xfrm>
-            <a:off x="0" y="0"/>
-            <a:ext cx="0" cy="0"/>
-          </a:xfrm>
-          <a:prstGeom prst="rect">
-            <a:avLst/>
-          </a:prstGeom>
-          <a:noFill/>
-          <a:ln>
-            <a:noFill/>
-            <a:prstDash val="solid"/>
-          </a:ln>
-        </p:spPr>
-      </p:sp>
-      <p:sp>
-        <p:nvSpPr>
-          <p:cNvPr id="3" name="Notes Placeholder 2">
-            <a:extLst>
-              <a:ext uri="{FF2B5EF4-FFF2-40B4-BE49-F238E27FC236}">
-                <a16:creationId xmlns:a16="http://schemas.microsoft.com/office/drawing/2014/main" id="{1CE6684E-30C2-470F-1135-CE8A6088E846}"/>
-              </a:ext>
-            </a:extLst>
-          </p:cNvPr>
-          <p:cNvSpPr txBox="1">
+        <p:spPr/>
+      </p:sp>
+      <p:sp>
+        <p:nvSpPr>
+          <p:cNvPr id="3" name="Notes Placeholder 2"/>
+          <p:cNvSpPr>
             <a:spLocks noGrp="1"/>
           </p:cNvSpPr>
           <p:nvPr>
             <p:ph type="body" idx="1"/>
           </p:nvPr>
         </p:nvSpPr>
-        <p:spPr>
-          <a:xfrm>
-            <a:off x="0" y="0"/>
-            <a:ext cx="0" cy="0"/>
-          </a:xfrm>
-          <a:prstGeom prst="rect">
-            <a:avLst/>
-          </a:prstGeom>
-          <a:noFill/>
-          <a:ln>
-            <a:noFill/>
-          </a:ln>
-        </p:spPr>
+        <p:spPr/>
         <p:txBody>
-          <a:bodyPr vert="horz" wrap="square" lIns="91440" tIns="45720" rIns="91440" bIns="45720" anchor="t" anchorCtr="0" compatLnSpc="1">
-            <a:noAutofit/>
-          </a:bodyPr>
+          <a:bodyPr/>
           <a:lstStyle/>
           <a:p>
-            <a:pPr lvl="0"/>
-            <a:r>
-              <a:rPr lang="de-DE">
-                <a:solidFill>
-                  <a:srgbClr val="000000"/>
-                </a:solidFill>
-                <a:latin typeface="Aptos"/>
-              </a:rPr>
-              <a:t>Vortragende(r): Nina</a:t>
+            <a:r>
+              <a:rPr dirty="0" err="1"/>
+              <a:t>Vortragende</a:t>
+            </a:r>
+            <a:r>
+              <a:rPr dirty="0"/>
+              <a:t>(r): Kilian</a:t>
             </a:r>
           </a:p>
         </p:txBody>
       </p:sp>
       <p:sp>
         <p:nvSpPr>
-          <p:cNvPr id="4" name="Slide Number Placeholder 3">
-            <a:extLst>
-              <a:ext uri="{FF2B5EF4-FFF2-40B4-BE49-F238E27FC236}">
-                <a16:creationId xmlns:a16="http://schemas.microsoft.com/office/drawing/2014/main" id="{733DB3B2-9E01-E1AA-D5BE-8E0E92792C52}"/>
-              </a:ext>
-            </a:extLst>
-          </p:cNvPr>
-          <p:cNvSpPr txBox="1">
+          <p:cNvPr id="4" name="Slide Number Placeholder 3"/>
+          <p:cNvSpPr>
             <a:spLocks noGrp="1"/>
           </p:cNvSpPr>
           <p:nvPr>
-            <p:ph type="sldNum" sz="quarter" idx="8"/>
+            <p:ph type="sldNum" sz="quarter" idx="10"/>
           </p:nvPr>
         </p:nvSpPr>
-        <p:spPr>
-          <a:xfrm>
-            <a:off x="0" y="0"/>
-            <a:ext cx="0" cy="0"/>
-          </a:xfrm>
-          <a:prstGeom prst="rect">
-            <a:avLst/>
-          </a:prstGeom>
-          <a:noFill/>
-          <a:ln>
-            <a:noFill/>
-          </a:ln>
-        </p:spPr>
+        <p:spPr/>
         <p:txBody>
-          <a:bodyPr vert="horz" wrap="square" lIns="91440" tIns="45720" rIns="91440" bIns="45720" anchor="t" anchorCtr="0" compatLnSpc="1">
-            <a:noAutofit/>
-          </a:bodyPr>
+          <a:bodyPr/>
           <a:lstStyle/>
           <a:p>
-            <a:pPr lvl="0"/>
-            <a:fld id="{06B9D98B-3B64-E343-B19D-892768654EEB}" type="slidenum">
-              <a:t>18</a:t>
+            <a:fld id="{F7021451-1387-4CA6-816F-3879F97B5CBC}" type="slidenum">
+              <a:rPr lang="en-US"/>
+              <a:t>17</a:t>
             </a:fld>
-            <a:endParaRPr lang="en-US">
-              <a:solidFill>
-                <a:srgbClr val="000000"/>
-              </a:solidFill>
-              <a:latin typeface="Aptos"/>
-            </a:endParaRPr>
+            <a:endParaRPr lang="en-US"/>
           </a:p>
         </p:txBody>
       </p:sp>
     </p:spTree>
+    <p:extLst>
+      <p:ext uri="{BB962C8B-B14F-4D97-AF65-F5344CB8AC3E}">
+        <p14:creationId xmlns:p14="http://schemas.microsoft.com/office/powerpoint/2010/main" val="1024086991"/>
+      </p:ext>
+    </p:extLst>
   </p:cSld>
   <p:clrMapOvr>
     <a:masterClrMapping/>
@@ -1304,13 +1397,7 @@
       </p:grpSpPr>
       <p:sp>
         <p:nvSpPr>
-          <p:cNvPr id="2" name="Slide Image Placeholder 1">
-            <a:extLst>
-              <a:ext uri="{FF2B5EF4-FFF2-40B4-BE49-F238E27FC236}">
-                <a16:creationId xmlns:a16="http://schemas.microsoft.com/office/drawing/2014/main" id="{F5E3BD2C-15D2-C1B4-3EE6-465BBFF05A9D}"/>
-              </a:ext>
-            </a:extLst>
-          </p:cNvPr>
+          <p:cNvPr id="2" name="Slide Image Placeholder 1"/>
           <p:cNvSpPr>
             <a:spLocks noGrp="1" noRot="1" noChangeAspect="1"/>
           </p:cNvSpPr>
@@ -1318,118 +1405,63 @@
             <p:ph type="sldImg"/>
           </p:nvPr>
         </p:nvSpPr>
-        <p:spPr>
-          <a:xfrm>
-            <a:off x="0" y="0"/>
-            <a:ext cx="0" cy="0"/>
-          </a:xfrm>
-          <a:prstGeom prst="rect">
-            <a:avLst/>
-          </a:prstGeom>
-          <a:noFill/>
-          <a:ln>
-            <a:noFill/>
-            <a:prstDash val="solid"/>
-          </a:ln>
-        </p:spPr>
-      </p:sp>
-      <p:sp>
-        <p:nvSpPr>
-          <p:cNvPr id="3" name="Notes Placeholder 2">
-            <a:extLst>
-              <a:ext uri="{FF2B5EF4-FFF2-40B4-BE49-F238E27FC236}">
-                <a16:creationId xmlns:a16="http://schemas.microsoft.com/office/drawing/2014/main" id="{7003C668-0CAF-BCEE-759B-5304DD0D99C4}"/>
-              </a:ext>
-            </a:extLst>
-          </p:cNvPr>
-          <p:cNvSpPr txBox="1">
+        <p:spPr/>
+      </p:sp>
+      <p:sp>
+        <p:nvSpPr>
+          <p:cNvPr id="3" name="Notes Placeholder 2"/>
+          <p:cNvSpPr>
             <a:spLocks noGrp="1"/>
           </p:cNvSpPr>
           <p:nvPr>
             <p:ph type="body" idx="1"/>
           </p:nvPr>
         </p:nvSpPr>
-        <p:spPr>
-          <a:xfrm>
-            <a:off x="0" y="0"/>
-            <a:ext cx="0" cy="0"/>
-          </a:xfrm>
-          <a:prstGeom prst="rect">
-            <a:avLst/>
-          </a:prstGeom>
-          <a:noFill/>
-          <a:ln>
-            <a:noFill/>
-          </a:ln>
-        </p:spPr>
+        <p:spPr/>
         <p:txBody>
-          <a:bodyPr vert="horz" wrap="square" lIns="91440" tIns="45720" rIns="91440" bIns="45720" anchor="t" anchorCtr="0" compatLnSpc="1">
-            <a:noAutofit/>
-          </a:bodyPr>
+          <a:bodyPr/>
           <a:lstStyle/>
           <a:p>
-            <a:pPr lvl="0"/>
-            <a:r>
-              <a:rPr lang="de-DE">
-                <a:solidFill>
-                  <a:srgbClr val="000000"/>
-                </a:solidFill>
-                <a:latin typeface="Aptos"/>
-              </a:rPr>
-              <a:t>Vortragende(r): Nina</a:t>
+            <a:r>
+              <a:rPr dirty="0" err="1"/>
+              <a:t>Vortragende</a:t>
+            </a:r>
+            <a:r>
+              <a:rPr dirty="0"/>
+              <a:t>(r): Kilian</a:t>
             </a:r>
           </a:p>
         </p:txBody>
       </p:sp>
       <p:sp>
         <p:nvSpPr>
-          <p:cNvPr id="4" name="Slide Number Placeholder 3">
-            <a:extLst>
-              <a:ext uri="{FF2B5EF4-FFF2-40B4-BE49-F238E27FC236}">
-                <a16:creationId xmlns:a16="http://schemas.microsoft.com/office/drawing/2014/main" id="{95CE91F6-EEAE-87B0-9127-2D18FA0E89E1}"/>
-              </a:ext>
-            </a:extLst>
-          </p:cNvPr>
-          <p:cNvSpPr txBox="1">
+          <p:cNvPr id="4" name="Slide Number Placeholder 3"/>
+          <p:cNvSpPr>
             <a:spLocks noGrp="1"/>
           </p:cNvSpPr>
           <p:nvPr>
-            <p:ph type="sldNum" sz="quarter" idx="8"/>
+            <p:ph type="sldNum" sz="quarter" idx="10"/>
           </p:nvPr>
         </p:nvSpPr>
-        <p:spPr>
-          <a:xfrm>
-            <a:off x="0" y="0"/>
-            <a:ext cx="0" cy="0"/>
-          </a:xfrm>
-          <a:prstGeom prst="rect">
-            <a:avLst/>
-          </a:prstGeom>
-          <a:noFill/>
-          <a:ln>
-            <a:noFill/>
-          </a:ln>
-        </p:spPr>
+        <p:spPr/>
         <p:txBody>
-          <a:bodyPr vert="horz" wrap="square" lIns="91440" tIns="45720" rIns="91440" bIns="45720" anchor="t" anchorCtr="0" compatLnSpc="1">
-            <a:noAutofit/>
-          </a:bodyPr>
+          <a:bodyPr/>
           <a:lstStyle/>
           <a:p>
-            <a:pPr lvl="0"/>
-            <a:fld id="{FAA19FF2-F726-284D-B893-18573D0AAE96}" type="slidenum">
-              <a:t>19</a:t>
+            <a:fld id="{F7021451-1387-4CA6-816F-3879F97B5CBC}" type="slidenum">
+              <a:rPr lang="en-US"/>
+              <a:t>18</a:t>
             </a:fld>
-            <a:endParaRPr lang="en-US">
-              <a:solidFill>
-                <a:srgbClr val="000000"/>
-              </a:solidFill>
-              <a:latin typeface="Aptos"/>
-            </a:endParaRPr>
+            <a:endParaRPr lang="en-US"/>
           </a:p>
         </p:txBody>
       </p:sp>
     </p:spTree>
+    <p:extLst>
+      <p:ext uri="{BB962C8B-B14F-4D97-AF65-F5344CB8AC3E}">
+        <p14:creationId xmlns:p14="http://schemas.microsoft.com/office/powerpoint/2010/main" val="1024086991"/>
+      </p:ext>
+    </p:extLst>
   </p:cSld>
   <p:clrMapOvr>
     <a:masterClrMapping/>
@@ -1456,13 +1488,7 @@
       </p:grpSpPr>
       <p:sp>
         <p:nvSpPr>
-          <p:cNvPr id="2" name="Slide Image Placeholder 1">
-            <a:extLst>
-              <a:ext uri="{FF2B5EF4-FFF2-40B4-BE49-F238E27FC236}">
-                <a16:creationId xmlns:a16="http://schemas.microsoft.com/office/drawing/2014/main" id="{0FFBA9CE-D87F-40B4-DEE0-298BA695A0D2}"/>
-              </a:ext>
-            </a:extLst>
-          </p:cNvPr>
+          <p:cNvPr id="2" name="Slide Image Placeholder 1"/>
           <p:cNvSpPr>
             <a:spLocks noGrp="1" noRot="1" noChangeAspect="1"/>
           </p:cNvSpPr>
@@ -1470,118 +1496,154 @@
             <p:ph type="sldImg"/>
           </p:nvPr>
         </p:nvSpPr>
-        <p:spPr>
-          <a:xfrm>
-            <a:off x="0" y="0"/>
-            <a:ext cx="0" cy="0"/>
-          </a:xfrm>
-          <a:prstGeom prst="rect">
-            <a:avLst/>
-          </a:prstGeom>
-          <a:noFill/>
-          <a:ln>
-            <a:noFill/>
-            <a:prstDash val="solid"/>
-          </a:ln>
-        </p:spPr>
-      </p:sp>
-      <p:sp>
-        <p:nvSpPr>
-          <p:cNvPr id="3" name="Notes Placeholder 2">
-            <a:extLst>
-              <a:ext uri="{FF2B5EF4-FFF2-40B4-BE49-F238E27FC236}">
-                <a16:creationId xmlns:a16="http://schemas.microsoft.com/office/drawing/2014/main" id="{F8C13E9E-E850-F565-8E38-3997AE544C0E}"/>
-              </a:ext>
-            </a:extLst>
-          </p:cNvPr>
-          <p:cNvSpPr txBox="1">
+        <p:spPr/>
+      </p:sp>
+      <p:sp>
+        <p:nvSpPr>
+          <p:cNvPr id="3" name="Notes Placeholder 2"/>
+          <p:cNvSpPr>
             <a:spLocks noGrp="1"/>
           </p:cNvSpPr>
           <p:nvPr>
             <p:ph type="body" idx="1"/>
           </p:nvPr>
         </p:nvSpPr>
-        <p:spPr>
-          <a:xfrm>
-            <a:off x="0" y="0"/>
-            <a:ext cx="0" cy="0"/>
-          </a:xfrm>
-          <a:prstGeom prst="rect">
-            <a:avLst/>
-          </a:prstGeom>
-          <a:noFill/>
-          <a:ln>
-            <a:noFill/>
-          </a:ln>
-        </p:spPr>
+        <p:spPr/>
         <p:txBody>
-          <a:bodyPr vert="horz" wrap="square" lIns="91440" tIns="45720" rIns="91440" bIns="45720" anchor="t" anchorCtr="0" compatLnSpc="1">
-            <a:noAutofit/>
-          </a:bodyPr>
+          <a:bodyPr/>
           <a:lstStyle/>
           <a:p>
-            <a:pPr lvl="0"/>
-            <a:r>
-              <a:rPr lang="de-DE">
-                <a:solidFill>
-                  <a:srgbClr val="000000"/>
-                </a:solidFill>
-                <a:latin typeface="Aptos"/>
-              </a:rPr>
-              <a:t>Vortragende(r): Nina</a:t>
+            <a:r>
+              <a:rPr dirty="0" err="1"/>
+              <a:t>Vortragende</a:t>
+            </a:r>
+            <a:r>
+              <a:rPr dirty="0"/>
+              <a:t>(r): Jakob</a:t>
             </a:r>
           </a:p>
         </p:txBody>
       </p:sp>
       <p:sp>
         <p:nvSpPr>
-          <p:cNvPr id="4" name="Slide Number Placeholder 3">
-            <a:extLst>
-              <a:ext uri="{FF2B5EF4-FFF2-40B4-BE49-F238E27FC236}">
-                <a16:creationId xmlns:a16="http://schemas.microsoft.com/office/drawing/2014/main" id="{0E16D1B8-F5A5-AE1E-0DAF-DDEC9559CB69}"/>
-              </a:ext>
-            </a:extLst>
-          </p:cNvPr>
-          <p:cNvSpPr txBox="1">
+          <p:cNvPr id="4" name="Slide Number Placeholder 3"/>
+          <p:cNvSpPr>
             <a:spLocks noGrp="1"/>
           </p:cNvSpPr>
           <p:nvPr>
-            <p:ph type="sldNum" sz="quarter" idx="8"/>
+            <p:ph type="sldNum" sz="quarter" idx="10"/>
           </p:nvPr>
         </p:nvSpPr>
-        <p:spPr>
-          <a:xfrm>
-            <a:off x="0" y="0"/>
-            <a:ext cx="0" cy="0"/>
-          </a:xfrm>
-          <a:prstGeom prst="rect">
-            <a:avLst/>
-          </a:prstGeom>
-          <a:noFill/>
-          <a:ln>
-            <a:noFill/>
-          </a:ln>
-        </p:spPr>
+        <p:spPr/>
         <p:txBody>
-          <a:bodyPr vert="horz" wrap="square" lIns="91440" tIns="45720" rIns="91440" bIns="45720" anchor="t" anchorCtr="0" compatLnSpc="1">
-            <a:noAutofit/>
-          </a:bodyPr>
+          <a:bodyPr/>
           <a:lstStyle/>
           <a:p>
-            <a:pPr lvl="0"/>
-            <a:fld id="{611CAF38-4B20-3548-B3C6-067F76BFDE63}" type="slidenum">
-              <a:t>20</a:t>
+            <a:fld id="{F7021451-1387-4CA6-816F-3879F97B5CBC}" type="slidenum">
+              <a:rPr lang="en-US"/>
+              <a:t>19</a:t>
             </a:fld>
-            <a:endParaRPr lang="en-US">
-              <a:solidFill>
-                <a:srgbClr val="000000"/>
-              </a:solidFill>
-              <a:latin typeface="Aptos"/>
-            </a:endParaRPr>
+            <a:endParaRPr lang="en-US"/>
           </a:p>
         </p:txBody>
       </p:sp>
     </p:spTree>
+    <p:extLst>
+      <p:ext uri="{BB962C8B-B14F-4D97-AF65-F5344CB8AC3E}">
+        <p14:creationId xmlns:p14="http://schemas.microsoft.com/office/powerpoint/2010/main" val="1024086991"/>
+      </p:ext>
+    </p:extLst>
+  </p:cSld>
+  <p:clrMapOvr>
+    <a:masterClrMapping/>
+  </p:clrMapOvr>
+</p:notes>
+</file>
+
+<file path=ppt/notesSlides/notesSlide2.xml><?xml version="1.0" encoding="utf-8"?>
+<p:notes xmlns:a="http://schemas.openxmlformats.org/drawingml/2006/main" xmlns:r="http://schemas.openxmlformats.org/officeDocument/2006/relationships" xmlns:p="http://schemas.openxmlformats.org/presentationml/2006/main">
+  <p:cSld>
+    <p:spTree>
+      <p:nvGrpSpPr>
+        <p:cNvPr id="1" name=""/>
+        <p:cNvGrpSpPr/>
+        <p:nvPr/>
+      </p:nvGrpSpPr>
+      <p:grpSpPr>
+        <a:xfrm>
+          <a:off x="0" y="0"/>
+          <a:ext cx="0" cy="0"/>
+          <a:chOff x="0" y="0"/>
+          <a:chExt cx="0" cy="0"/>
+        </a:xfrm>
+      </p:grpSpPr>
+      <p:sp>
+        <p:nvSpPr>
+          <p:cNvPr id="2" name="Slide Image Placeholder 1"/>
+          <p:cNvSpPr>
+            <a:spLocks noGrp="1" noRot="1" noChangeAspect="1"/>
+          </p:cNvSpPr>
+          <p:nvPr>
+            <p:ph type="sldImg"/>
+          </p:nvPr>
+        </p:nvSpPr>
+        <p:spPr/>
+      </p:sp>
+      <p:sp>
+        <p:nvSpPr>
+          <p:cNvPr id="3" name="Notes Placeholder 2"/>
+          <p:cNvSpPr>
+            <a:spLocks noGrp="1"/>
+          </p:cNvSpPr>
+          <p:nvPr>
+            <p:ph type="body" idx="1"/>
+          </p:nvPr>
+        </p:nvSpPr>
+        <p:spPr/>
+        <p:txBody>
+          <a:bodyPr/>
+          <a:lstStyle/>
+          <a:p>
+            <a:r>
+              <a:rPr dirty="0" err="1"/>
+              <a:t>Vortragende</a:t>
+            </a:r>
+            <a:r>
+              <a:rPr dirty="0"/>
+              <a:t>(r): David</a:t>
+            </a:r>
+          </a:p>
+        </p:txBody>
+      </p:sp>
+      <p:sp>
+        <p:nvSpPr>
+          <p:cNvPr id="4" name="Slide Number Placeholder 3"/>
+          <p:cNvSpPr>
+            <a:spLocks noGrp="1"/>
+          </p:cNvSpPr>
+          <p:nvPr>
+            <p:ph type="sldNum" sz="quarter" idx="10"/>
+          </p:nvPr>
+        </p:nvSpPr>
+        <p:spPr/>
+        <p:txBody>
+          <a:bodyPr/>
+          <a:lstStyle/>
+          <a:p>
+            <a:fld id="{F7021451-1387-4CA6-816F-3879F97B5CBC}" type="slidenum">
+              <a:rPr lang="en-US"/>
+              <a:t>2</a:t>
+            </a:fld>
+            <a:endParaRPr lang="en-US"/>
+          </a:p>
+        </p:txBody>
+      </p:sp>
+    </p:spTree>
+    <p:extLst>
+      <p:ext uri="{BB962C8B-B14F-4D97-AF65-F5344CB8AC3E}">
+        <p14:creationId xmlns:p14="http://schemas.microsoft.com/office/powerpoint/2010/main" val="1024086991"/>
+      </p:ext>
+    </p:extLst>
   </p:cSld>
   <p:clrMapOvr>
     <a:masterClrMapping/>
@@ -1608,13 +1670,7 @@
       </p:grpSpPr>
       <p:sp>
         <p:nvSpPr>
-          <p:cNvPr id="2" name="Slide Image Placeholder 1">
-            <a:extLst>
-              <a:ext uri="{FF2B5EF4-FFF2-40B4-BE49-F238E27FC236}">
-                <a16:creationId xmlns:a16="http://schemas.microsoft.com/office/drawing/2014/main" id="{B445C18C-3FAA-6A2E-DDF1-DCF386903823}"/>
-              </a:ext>
-            </a:extLst>
-          </p:cNvPr>
+          <p:cNvPr id="2" name="Slide Image Placeholder 1"/>
           <p:cNvSpPr>
             <a:spLocks noGrp="1" noRot="1" noChangeAspect="1"/>
           </p:cNvSpPr>
@@ -1622,109 +1678,63 @@
             <p:ph type="sldImg"/>
           </p:nvPr>
         </p:nvSpPr>
-        <p:spPr>
-          <a:xfrm>
-            <a:off x="0" y="0"/>
-            <a:ext cx="0" cy="0"/>
-          </a:xfrm>
-          <a:prstGeom prst="rect">
-            <a:avLst/>
-          </a:prstGeom>
-          <a:noFill/>
-          <a:ln>
-            <a:noFill/>
-            <a:prstDash val="solid"/>
-          </a:ln>
-        </p:spPr>
-      </p:sp>
-      <p:sp>
-        <p:nvSpPr>
-          <p:cNvPr id="3" name="Notes Placeholder 2">
-            <a:extLst>
-              <a:ext uri="{FF2B5EF4-FFF2-40B4-BE49-F238E27FC236}">
-                <a16:creationId xmlns:a16="http://schemas.microsoft.com/office/drawing/2014/main" id="{9ED72192-D793-6D05-DCAA-F6D4BBC097E6}"/>
-              </a:ext>
-            </a:extLst>
-          </p:cNvPr>
-          <p:cNvSpPr txBox="1">
+        <p:spPr/>
+      </p:sp>
+      <p:sp>
+        <p:nvSpPr>
+          <p:cNvPr id="3" name="Notes Placeholder 2"/>
+          <p:cNvSpPr>
             <a:spLocks noGrp="1"/>
           </p:cNvSpPr>
           <p:nvPr>
             <p:ph type="body" idx="1"/>
           </p:nvPr>
         </p:nvSpPr>
-        <p:spPr>
-          <a:xfrm>
-            <a:off x="0" y="0"/>
-            <a:ext cx="0" cy="0"/>
-          </a:xfrm>
-          <a:prstGeom prst="rect">
-            <a:avLst/>
-          </a:prstGeom>
-          <a:noFill/>
-          <a:ln>
-            <a:noFill/>
-          </a:ln>
-        </p:spPr>
+        <p:spPr/>
         <p:txBody>
-          <a:bodyPr vert="horz" wrap="square" lIns="91440" tIns="45720" rIns="91440" bIns="45720" anchor="t" anchorCtr="0" compatLnSpc="1">
-            <a:noAutofit/>
-          </a:bodyPr>
+          <a:bodyPr/>
           <a:lstStyle/>
           <a:p>
-            <a:endParaRPr lang="de-DE"/>
+            <a:r>
+              <a:rPr dirty="0" err="1"/>
+              <a:t>Vortragende</a:t>
+            </a:r>
+            <a:r>
+              <a:rPr dirty="0"/>
+              <a:t>(r): Jakob</a:t>
+            </a:r>
           </a:p>
         </p:txBody>
       </p:sp>
       <p:sp>
         <p:nvSpPr>
-          <p:cNvPr id="4" name="Slide Number Placeholder 3">
-            <a:extLst>
-              <a:ext uri="{FF2B5EF4-FFF2-40B4-BE49-F238E27FC236}">
-                <a16:creationId xmlns:a16="http://schemas.microsoft.com/office/drawing/2014/main" id="{F4EEA660-87B5-6602-D0F0-EA36A6870F3F}"/>
-              </a:ext>
-            </a:extLst>
-          </p:cNvPr>
-          <p:cNvSpPr txBox="1">
+          <p:cNvPr id="4" name="Slide Number Placeholder 3"/>
+          <p:cNvSpPr>
             <a:spLocks noGrp="1"/>
           </p:cNvSpPr>
           <p:nvPr>
-            <p:ph type="sldNum" sz="quarter" idx="8"/>
+            <p:ph type="sldNum" sz="quarter" idx="10"/>
           </p:nvPr>
         </p:nvSpPr>
-        <p:spPr>
-          <a:xfrm>
-            <a:off x="0" y="0"/>
-            <a:ext cx="0" cy="0"/>
-          </a:xfrm>
-          <a:prstGeom prst="rect">
-            <a:avLst/>
-          </a:prstGeom>
-          <a:noFill/>
-          <a:ln>
-            <a:noFill/>
-          </a:ln>
-        </p:spPr>
+        <p:spPr/>
         <p:txBody>
-          <a:bodyPr vert="horz" wrap="square" lIns="91440" tIns="45720" rIns="91440" bIns="45720" anchor="t" anchorCtr="0" compatLnSpc="1">
-            <a:noAutofit/>
-          </a:bodyPr>
+          <a:bodyPr/>
           <a:lstStyle/>
           <a:p>
-            <a:pPr lvl="0"/>
-            <a:fld id="{88DA254A-75E9-254F-A716-2FD585B78856}" type="slidenum">
-              <a:t>21</a:t>
+            <a:fld id="{F7021451-1387-4CA6-816F-3879F97B5CBC}" type="slidenum">
+              <a:rPr lang="en-US"/>
+              <a:t>20</a:t>
             </a:fld>
-            <a:endParaRPr lang="en-US">
-              <a:solidFill>
-                <a:srgbClr val="000000"/>
-              </a:solidFill>
-              <a:latin typeface="Aptos"/>
-            </a:endParaRPr>
+            <a:endParaRPr lang="en-US"/>
           </a:p>
         </p:txBody>
       </p:sp>
     </p:spTree>
+    <p:extLst>
+      <p:ext uri="{BB962C8B-B14F-4D97-AF65-F5344CB8AC3E}">
+        <p14:creationId xmlns:p14="http://schemas.microsoft.com/office/powerpoint/2010/main" val="1285418441"/>
+      </p:ext>
+    </p:extLst>
   </p:cSld>
   <p:clrMapOvr>
     <a:masterClrMapping/>
@@ -1733,7 +1743,7 @@
 </file>
 
 <file path=ppt/notesSlides/notesSlide21.xml><?xml version="1.0" encoding="utf-8"?>
-<p:notes xmlns:a="http://schemas.openxmlformats.org/drawingml/2006/main" xmlns:p="http://schemas.openxmlformats.org/presentationml/2006/main" xmlns:r="http://schemas.openxmlformats.org/officeDocument/2006/relationships">
+<p:notes xmlns:a="http://schemas.openxmlformats.org/drawingml/2006/main" xmlns:r="http://schemas.openxmlformats.org/officeDocument/2006/relationships" xmlns:p="http://schemas.openxmlformats.org/presentationml/2006/main">
   <p:cSld>
     <p:spTree>
       <p:nvGrpSpPr>
@@ -1751,7 +1761,13 @@
       </p:grpSpPr>
       <p:sp>
         <p:nvSpPr>
-          <p:cNvPr id="2" name="Slide Image Placeholder 1"/>
+          <p:cNvPr id="2" name="Slide Image Placeholder 1">
+            <a:extLst>
+              <a:ext uri="{FF2B5EF4-FFF2-40B4-BE49-F238E27FC236}">
+                <a16:creationId xmlns:a16="http://schemas.microsoft.com/office/drawing/2014/main" id="{4C667BE3-F584-F4AD-6A7E-91C8E60DD128}"/>
+              </a:ext>
+            </a:extLst>
+          </p:cNvPr>
           <p:cNvSpPr>
             <a:spLocks noGrp="1" noRot="1" noChangeAspect="1"/>
           </p:cNvSpPr>
@@ -1759,63 +1775,118 @@
             <p:ph type="sldImg"/>
           </p:nvPr>
         </p:nvSpPr>
-        <p:spPr/>
-      </p:sp>
-      <p:sp>
-        <p:nvSpPr>
-          <p:cNvPr id="3" name="Notes Placeholder 2"/>
-          <p:cNvSpPr>
+        <p:spPr>
+          <a:xfrm>
+            <a:off x="0" y="0"/>
+            <a:ext cx="0" cy="0"/>
+          </a:xfrm>
+          <a:prstGeom prst="rect">
+            <a:avLst/>
+          </a:prstGeom>
+          <a:noFill/>
+          <a:ln>
+            <a:noFill/>
+            <a:prstDash val="solid"/>
+          </a:ln>
+        </p:spPr>
+      </p:sp>
+      <p:sp>
+        <p:nvSpPr>
+          <p:cNvPr id="3" name="Notes Placeholder 2">
+            <a:extLst>
+              <a:ext uri="{FF2B5EF4-FFF2-40B4-BE49-F238E27FC236}">
+                <a16:creationId xmlns:a16="http://schemas.microsoft.com/office/drawing/2014/main" id="{1CE6684E-30C2-470F-1135-CE8A6088E846}"/>
+              </a:ext>
+            </a:extLst>
+          </p:cNvPr>
+          <p:cNvSpPr txBox="1">
             <a:spLocks noGrp="1"/>
           </p:cNvSpPr>
           <p:nvPr>
             <p:ph type="body" idx="1"/>
           </p:nvPr>
         </p:nvSpPr>
-        <p:spPr/>
+        <p:spPr>
+          <a:xfrm>
+            <a:off x="0" y="0"/>
+            <a:ext cx="0" cy="0"/>
+          </a:xfrm>
+          <a:prstGeom prst="rect">
+            <a:avLst/>
+          </a:prstGeom>
+          <a:noFill/>
+          <a:ln>
+            <a:noFill/>
+          </a:ln>
+        </p:spPr>
         <p:txBody>
-          <a:bodyPr/>
+          <a:bodyPr vert="horz" wrap="square" lIns="91440" tIns="45720" rIns="91440" bIns="45720" anchor="t" anchorCtr="0" compatLnSpc="1">
+            <a:noAutofit/>
+          </a:bodyPr>
           <a:lstStyle/>
           <a:p>
-            <a:r>
-              <a:rPr dirty="0" err="1"/>
-              <a:t>Vortragende</a:t>
-            </a:r>
-            <a:r>
-              <a:rPr dirty="0"/>
-              <a:t>(r): David</a:t>
+            <a:pPr lvl="0"/>
+            <a:r>
+              <a:rPr lang="de-DE">
+                <a:solidFill>
+                  <a:srgbClr val="000000"/>
+                </a:solidFill>
+                <a:latin typeface="Aptos"/>
+              </a:rPr>
+              <a:t>Vortragende(r): Nina</a:t>
             </a:r>
           </a:p>
         </p:txBody>
       </p:sp>
       <p:sp>
         <p:nvSpPr>
-          <p:cNvPr id="4" name="Slide Number Placeholder 3"/>
-          <p:cNvSpPr>
+          <p:cNvPr id="4" name="Slide Number Placeholder 3">
+            <a:extLst>
+              <a:ext uri="{FF2B5EF4-FFF2-40B4-BE49-F238E27FC236}">
+                <a16:creationId xmlns:a16="http://schemas.microsoft.com/office/drawing/2014/main" id="{733DB3B2-9E01-E1AA-D5BE-8E0E92792C52}"/>
+              </a:ext>
+            </a:extLst>
+          </p:cNvPr>
+          <p:cNvSpPr txBox="1">
             <a:spLocks noGrp="1"/>
           </p:cNvSpPr>
           <p:nvPr>
-            <p:ph type="sldNum" sz="quarter" idx="10"/>
+            <p:ph type="sldNum" sz="quarter" idx="8"/>
           </p:nvPr>
         </p:nvSpPr>
-        <p:spPr/>
+        <p:spPr>
+          <a:xfrm>
+            <a:off x="0" y="0"/>
+            <a:ext cx="0" cy="0"/>
+          </a:xfrm>
+          <a:prstGeom prst="rect">
+            <a:avLst/>
+          </a:prstGeom>
+          <a:noFill/>
+          <a:ln>
+            <a:noFill/>
+          </a:ln>
+        </p:spPr>
         <p:txBody>
-          <a:bodyPr/>
+          <a:bodyPr vert="horz" wrap="square" lIns="91440" tIns="45720" rIns="91440" bIns="45720" anchor="t" anchorCtr="0" compatLnSpc="1">
+            <a:noAutofit/>
+          </a:bodyPr>
           <a:lstStyle/>
           <a:p>
-            <a:fld id="{F7021451-1387-4CA6-816F-3879F97B5CBC}" type="slidenum">
-              <a:rPr lang="en-US"/>
-              <a:t>3</a:t>
+            <a:pPr lvl="0"/>
+            <a:fld id="{06B9D98B-3B64-E343-B19D-892768654EEB}" type="slidenum">
+              <a:t>21</a:t>
             </a:fld>
-            <a:endParaRPr lang="en-US"/>
+            <a:endParaRPr lang="en-US">
+              <a:solidFill>
+                <a:srgbClr val="000000"/>
+              </a:solidFill>
+              <a:latin typeface="Aptos"/>
+            </a:endParaRPr>
           </a:p>
         </p:txBody>
       </p:sp>
     </p:spTree>
-    <p:extLst>
-      <p:ext uri="{BB962C8B-B14F-4D97-AF65-F5344CB8AC3E}">
-        <p14:creationId xmlns:p14="http://schemas.microsoft.com/office/powerpoint/2010/main" val="1024086991"/>
-      </p:ext>
-    </p:extLst>
   </p:cSld>
   <p:clrMapOvr>
     <a:masterClrMapping/>
@@ -1824,7 +1895,7 @@
 </file>
 
 <file path=ppt/notesSlides/notesSlide22.xml><?xml version="1.0" encoding="utf-8"?>
-<p:notes xmlns:a="http://schemas.openxmlformats.org/drawingml/2006/main" xmlns:p="http://schemas.openxmlformats.org/presentationml/2006/main" xmlns:r="http://schemas.openxmlformats.org/officeDocument/2006/relationships">
+<p:notes xmlns:a="http://schemas.openxmlformats.org/drawingml/2006/main" xmlns:r="http://schemas.openxmlformats.org/officeDocument/2006/relationships" xmlns:p="http://schemas.openxmlformats.org/presentationml/2006/main">
   <p:cSld>
     <p:spTree>
       <p:nvGrpSpPr>
@@ -1842,7 +1913,13 @@
       </p:grpSpPr>
       <p:sp>
         <p:nvSpPr>
-          <p:cNvPr id="2" name="Slide Image Placeholder 1"/>
+          <p:cNvPr id="2" name="Slide Image Placeholder 1">
+            <a:extLst>
+              <a:ext uri="{FF2B5EF4-FFF2-40B4-BE49-F238E27FC236}">
+                <a16:creationId xmlns:a16="http://schemas.microsoft.com/office/drawing/2014/main" id="{F5E3BD2C-15D2-C1B4-3EE6-465BBFF05A9D}"/>
+              </a:ext>
+            </a:extLst>
+          </p:cNvPr>
           <p:cNvSpPr>
             <a:spLocks noGrp="1" noRot="1" noChangeAspect="1"/>
           </p:cNvSpPr>
@@ -1850,63 +1927,118 @@
             <p:ph type="sldImg"/>
           </p:nvPr>
         </p:nvSpPr>
-        <p:spPr/>
-      </p:sp>
-      <p:sp>
-        <p:nvSpPr>
-          <p:cNvPr id="3" name="Notes Placeholder 2"/>
-          <p:cNvSpPr>
+        <p:spPr>
+          <a:xfrm>
+            <a:off x="0" y="0"/>
+            <a:ext cx="0" cy="0"/>
+          </a:xfrm>
+          <a:prstGeom prst="rect">
+            <a:avLst/>
+          </a:prstGeom>
+          <a:noFill/>
+          <a:ln>
+            <a:noFill/>
+            <a:prstDash val="solid"/>
+          </a:ln>
+        </p:spPr>
+      </p:sp>
+      <p:sp>
+        <p:nvSpPr>
+          <p:cNvPr id="3" name="Notes Placeholder 2">
+            <a:extLst>
+              <a:ext uri="{FF2B5EF4-FFF2-40B4-BE49-F238E27FC236}">
+                <a16:creationId xmlns:a16="http://schemas.microsoft.com/office/drawing/2014/main" id="{7003C668-0CAF-BCEE-759B-5304DD0D99C4}"/>
+              </a:ext>
+            </a:extLst>
+          </p:cNvPr>
+          <p:cNvSpPr txBox="1">
             <a:spLocks noGrp="1"/>
           </p:cNvSpPr>
           <p:nvPr>
             <p:ph type="body" idx="1"/>
           </p:nvPr>
         </p:nvSpPr>
-        <p:spPr/>
+        <p:spPr>
+          <a:xfrm>
+            <a:off x="0" y="0"/>
+            <a:ext cx="0" cy="0"/>
+          </a:xfrm>
+          <a:prstGeom prst="rect">
+            <a:avLst/>
+          </a:prstGeom>
+          <a:noFill/>
+          <a:ln>
+            <a:noFill/>
+          </a:ln>
+        </p:spPr>
         <p:txBody>
-          <a:bodyPr/>
+          <a:bodyPr vert="horz" wrap="square" lIns="91440" tIns="45720" rIns="91440" bIns="45720" anchor="t" anchorCtr="0" compatLnSpc="1">
+            <a:noAutofit/>
+          </a:bodyPr>
           <a:lstStyle/>
           <a:p>
-            <a:r>
-              <a:rPr dirty="0" err="1"/>
-              <a:t>Vortragende</a:t>
-            </a:r>
-            <a:r>
-              <a:rPr dirty="0"/>
-              <a:t>(r): David</a:t>
+            <a:pPr lvl="0"/>
+            <a:r>
+              <a:rPr lang="de-DE">
+                <a:solidFill>
+                  <a:srgbClr val="000000"/>
+                </a:solidFill>
+                <a:latin typeface="Aptos"/>
+              </a:rPr>
+              <a:t>Vortragende(r): Nina</a:t>
             </a:r>
           </a:p>
         </p:txBody>
       </p:sp>
       <p:sp>
         <p:nvSpPr>
-          <p:cNvPr id="4" name="Slide Number Placeholder 3"/>
-          <p:cNvSpPr>
+          <p:cNvPr id="4" name="Slide Number Placeholder 3">
+            <a:extLst>
+              <a:ext uri="{FF2B5EF4-FFF2-40B4-BE49-F238E27FC236}">
+                <a16:creationId xmlns:a16="http://schemas.microsoft.com/office/drawing/2014/main" id="{95CE91F6-EEAE-87B0-9127-2D18FA0E89E1}"/>
+              </a:ext>
+            </a:extLst>
+          </p:cNvPr>
+          <p:cNvSpPr txBox="1">
             <a:spLocks noGrp="1"/>
           </p:cNvSpPr>
           <p:nvPr>
-            <p:ph type="sldNum" sz="quarter" idx="10"/>
+            <p:ph type="sldNum" sz="quarter" idx="8"/>
           </p:nvPr>
         </p:nvSpPr>
-        <p:spPr/>
+        <p:spPr>
+          <a:xfrm>
+            <a:off x="0" y="0"/>
+            <a:ext cx="0" cy="0"/>
+          </a:xfrm>
+          <a:prstGeom prst="rect">
+            <a:avLst/>
+          </a:prstGeom>
+          <a:noFill/>
+          <a:ln>
+            <a:noFill/>
+          </a:ln>
+        </p:spPr>
         <p:txBody>
-          <a:bodyPr/>
+          <a:bodyPr vert="horz" wrap="square" lIns="91440" tIns="45720" rIns="91440" bIns="45720" anchor="t" anchorCtr="0" compatLnSpc="1">
+            <a:noAutofit/>
+          </a:bodyPr>
           <a:lstStyle/>
           <a:p>
-            <a:fld id="{F7021451-1387-4CA6-816F-3879F97B5CBC}" type="slidenum">
-              <a:rPr lang="en-US"/>
-              <a:t>3</a:t>
+            <a:pPr lvl="0"/>
+            <a:fld id="{FAA19FF2-F726-284D-B893-18573D0AAE96}" type="slidenum">
+              <a:t>22</a:t>
             </a:fld>
-            <a:endParaRPr lang="en-US"/>
+            <a:endParaRPr lang="en-US">
+              <a:solidFill>
+                <a:srgbClr val="000000"/>
+              </a:solidFill>
+              <a:latin typeface="Aptos"/>
+            </a:endParaRPr>
           </a:p>
         </p:txBody>
       </p:sp>
     </p:spTree>
-    <p:extLst>
-      <p:ext uri="{BB962C8B-B14F-4D97-AF65-F5344CB8AC3E}">
-        <p14:creationId xmlns:p14="http://schemas.microsoft.com/office/powerpoint/2010/main" val="1024086991"/>
-      </p:ext>
-    </p:extLst>
   </p:cSld>
   <p:clrMapOvr>
     <a:masterClrMapping/>
@@ -1915,7 +2047,7 @@
 </file>
 
 <file path=ppt/notesSlides/notesSlide23.xml><?xml version="1.0" encoding="utf-8"?>
-<p:notes xmlns:a="http://schemas.openxmlformats.org/drawingml/2006/main" xmlns:p="http://schemas.openxmlformats.org/presentationml/2006/main" xmlns:r="http://schemas.openxmlformats.org/officeDocument/2006/relationships">
+<p:notes xmlns:a="http://schemas.openxmlformats.org/drawingml/2006/main" xmlns:r="http://schemas.openxmlformats.org/officeDocument/2006/relationships" xmlns:p="http://schemas.openxmlformats.org/presentationml/2006/main">
   <p:cSld>
     <p:spTree>
       <p:nvGrpSpPr>
@@ -1933,7 +2065,13 @@
       </p:grpSpPr>
       <p:sp>
         <p:nvSpPr>
-          <p:cNvPr id="2" name="Slide Image Placeholder 1"/>
+          <p:cNvPr id="2" name="Slide Image Placeholder 1">
+            <a:extLst>
+              <a:ext uri="{FF2B5EF4-FFF2-40B4-BE49-F238E27FC236}">
+                <a16:creationId xmlns:a16="http://schemas.microsoft.com/office/drawing/2014/main" id="{0FFBA9CE-D87F-40B4-DEE0-298BA695A0D2}"/>
+              </a:ext>
+            </a:extLst>
+          </p:cNvPr>
           <p:cNvSpPr>
             <a:spLocks noGrp="1" noRot="1" noChangeAspect="1"/>
           </p:cNvSpPr>
@@ -1941,63 +2079,118 @@
             <p:ph type="sldImg"/>
           </p:nvPr>
         </p:nvSpPr>
-        <p:spPr/>
-      </p:sp>
-      <p:sp>
-        <p:nvSpPr>
-          <p:cNvPr id="3" name="Notes Placeholder 2"/>
-          <p:cNvSpPr>
+        <p:spPr>
+          <a:xfrm>
+            <a:off x="0" y="0"/>
+            <a:ext cx="0" cy="0"/>
+          </a:xfrm>
+          <a:prstGeom prst="rect">
+            <a:avLst/>
+          </a:prstGeom>
+          <a:noFill/>
+          <a:ln>
+            <a:noFill/>
+            <a:prstDash val="solid"/>
+          </a:ln>
+        </p:spPr>
+      </p:sp>
+      <p:sp>
+        <p:nvSpPr>
+          <p:cNvPr id="3" name="Notes Placeholder 2">
+            <a:extLst>
+              <a:ext uri="{FF2B5EF4-FFF2-40B4-BE49-F238E27FC236}">
+                <a16:creationId xmlns:a16="http://schemas.microsoft.com/office/drawing/2014/main" id="{F8C13E9E-E850-F565-8E38-3997AE544C0E}"/>
+              </a:ext>
+            </a:extLst>
+          </p:cNvPr>
+          <p:cNvSpPr txBox="1">
             <a:spLocks noGrp="1"/>
           </p:cNvSpPr>
           <p:nvPr>
             <p:ph type="body" idx="1"/>
           </p:nvPr>
         </p:nvSpPr>
-        <p:spPr/>
+        <p:spPr>
+          <a:xfrm>
+            <a:off x="0" y="0"/>
+            <a:ext cx="0" cy="0"/>
+          </a:xfrm>
+          <a:prstGeom prst="rect">
+            <a:avLst/>
+          </a:prstGeom>
+          <a:noFill/>
+          <a:ln>
+            <a:noFill/>
+          </a:ln>
+        </p:spPr>
         <p:txBody>
-          <a:bodyPr/>
+          <a:bodyPr vert="horz" wrap="square" lIns="91440" tIns="45720" rIns="91440" bIns="45720" anchor="t" anchorCtr="0" compatLnSpc="1">
+            <a:noAutofit/>
+          </a:bodyPr>
           <a:lstStyle/>
           <a:p>
-            <a:r>
-              <a:rPr dirty="0" err="1"/>
-              <a:t>Vortragende</a:t>
-            </a:r>
-            <a:r>
-              <a:rPr dirty="0"/>
-              <a:t>(r): David</a:t>
+            <a:pPr lvl="0"/>
+            <a:r>
+              <a:rPr lang="de-DE">
+                <a:solidFill>
+                  <a:srgbClr val="000000"/>
+                </a:solidFill>
+                <a:latin typeface="Aptos"/>
+              </a:rPr>
+              <a:t>Vortragende(r): Nina</a:t>
             </a:r>
           </a:p>
         </p:txBody>
       </p:sp>
       <p:sp>
         <p:nvSpPr>
-          <p:cNvPr id="4" name="Slide Number Placeholder 3"/>
-          <p:cNvSpPr>
+          <p:cNvPr id="4" name="Slide Number Placeholder 3">
+            <a:extLst>
+              <a:ext uri="{FF2B5EF4-FFF2-40B4-BE49-F238E27FC236}">
+                <a16:creationId xmlns:a16="http://schemas.microsoft.com/office/drawing/2014/main" id="{0E16D1B8-F5A5-AE1E-0DAF-DDEC9559CB69}"/>
+              </a:ext>
+            </a:extLst>
+          </p:cNvPr>
+          <p:cNvSpPr txBox="1">
             <a:spLocks noGrp="1"/>
           </p:cNvSpPr>
           <p:nvPr>
-            <p:ph type="sldNum" sz="quarter" idx="10"/>
+            <p:ph type="sldNum" sz="quarter" idx="8"/>
           </p:nvPr>
         </p:nvSpPr>
-        <p:spPr/>
+        <p:spPr>
+          <a:xfrm>
+            <a:off x="0" y="0"/>
+            <a:ext cx="0" cy="0"/>
+          </a:xfrm>
+          <a:prstGeom prst="rect">
+            <a:avLst/>
+          </a:prstGeom>
+          <a:noFill/>
+          <a:ln>
+            <a:noFill/>
+          </a:ln>
+        </p:spPr>
         <p:txBody>
-          <a:bodyPr/>
+          <a:bodyPr vert="horz" wrap="square" lIns="91440" tIns="45720" rIns="91440" bIns="45720" anchor="t" anchorCtr="0" compatLnSpc="1">
+            <a:noAutofit/>
+          </a:bodyPr>
           <a:lstStyle/>
           <a:p>
-            <a:fld id="{F7021451-1387-4CA6-816F-3879F97B5CBC}" type="slidenum">
-              <a:rPr lang="en-US"/>
-              <a:t>3</a:t>
+            <a:pPr lvl="0"/>
+            <a:fld id="{611CAF38-4B20-3548-B3C6-067F76BFDE63}" type="slidenum">
+              <a:t>23</a:t>
             </a:fld>
-            <a:endParaRPr lang="en-US"/>
+            <a:endParaRPr lang="en-US">
+              <a:solidFill>
+                <a:srgbClr val="000000"/>
+              </a:solidFill>
+              <a:latin typeface="Aptos"/>
+            </a:endParaRPr>
           </a:p>
         </p:txBody>
       </p:sp>
     </p:spTree>
-    <p:extLst>
-      <p:ext uri="{BB962C8B-B14F-4D97-AF65-F5344CB8AC3E}">
-        <p14:creationId xmlns:p14="http://schemas.microsoft.com/office/powerpoint/2010/main" val="1024086991"/>
-      </p:ext>
-    </p:extLst>
   </p:cSld>
   <p:clrMapOvr>
     <a:masterClrMapping/>
@@ -2006,7 +2199,7 @@
 </file>
 
 <file path=ppt/notesSlides/notesSlide24.xml><?xml version="1.0" encoding="utf-8"?>
-<p:notes xmlns:a="http://schemas.openxmlformats.org/drawingml/2006/main" xmlns:p="http://schemas.openxmlformats.org/presentationml/2006/main" xmlns:r="http://schemas.openxmlformats.org/officeDocument/2006/relationships">
+<p:notes xmlns:a="http://schemas.openxmlformats.org/drawingml/2006/main" xmlns:r="http://schemas.openxmlformats.org/officeDocument/2006/relationships" xmlns:p="http://schemas.openxmlformats.org/presentationml/2006/main">
   <p:cSld>
     <p:spTree>
       <p:nvGrpSpPr>
@@ -2024,7 +2217,13 @@
       </p:grpSpPr>
       <p:sp>
         <p:nvSpPr>
-          <p:cNvPr id="2" name="Slide Image Placeholder 1"/>
+          <p:cNvPr id="2" name="Slide Image Placeholder 1">
+            <a:extLst>
+              <a:ext uri="{FF2B5EF4-FFF2-40B4-BE49-F238E27FC236}">
+                <a16:creationId xmlns:a16="http://schemas.microsoft.com/office/drawing/2014/main" id="{B445C18C-3FAA-6A2E-DDF1-DCF386903823}"/>
+              </a:ext>
+            </a:extLst>
+          </p:cNvPr>
           <p:cNvSpPr>
             <a:spLocks noGrp="1" noRot="1" noChangeAspect="1"/>
           </p:cNvSpPr>
@@ -2032,63 +2231,109 @@
             <p:ph type="sldImg"/>
           </p:nvPr>
         </p:nvSpPr>
-        <p:spPr/>
-      </p:sp>
-      <p:sp>
-        <p:nvSpPr>
-          <p:cNvPr id="3" name="Notes Placeholder 2"/>
-          <p:cNvSpPr>
+        <p:spPr>
+          <a:xfrm>
+            <a:off x="0" y="0"/>
+            <a:ext cx="0" cy="0"/>
+          </a:xfrm>
+          <a:prstGeom prst="rect">
+            <a:avLst/>
+          </a:prstGeom>
+          <a:noFill/>
+          <a:ln>
+            <a:noFill/>
+            <a:prstDash val="solid"/>
+          </a:ln>
+        </p:spPr>
+      </p:sp>
+      <p:sp>
+        <p:nvSpPr>
+          <p:cNvPr id="3" name="Notes Placeholder 2">
+            <a:extLst>
+              <a:ext uri="{FF2B5EF4-FFF2-40B4-BE49-F238E27FC236}">
+                <a16:creationId xmlns:a16="http://schemas.microsoft.com/office/drawing/2014/main" id="{9ED72192-D793-6D05-DCAA-F6D4BBC097E6}"/>
+              </a:ext>
+            </a:extLst>
+          </p:cNvPr>
+          <p:cNvSpPr txBox="1">
             <a:spLocks noGrp="1"/>
           </p:cNvSpPr>
           <p:nvPr>
             <p:ph type="body" idx="1"/>
           </p:nvPr>
         </p:nvSpPr>
-        <p:spPr/>
+        <p:spPr>
+          <a:xfrm>
+            <a:off x="0" y="0"/>
+            <a:ext cx="0" cy="0"/>
+          </a:xfrm>
+          <a:prstGeom prst="rect">
+            <a:avLst/>
+          </a:prstGeom>
+          <a:noFill/>
+          <a:ln>
+            <a:noFill/>
+          </a:ln>
+        </p:spPr>
         <p:txBody>
-          <a:bodyPr/>
+          <a:bodyPr vert="horz" wrap="square" lIns="91440" tIns="45720" rIns="91440" bIns="45720" anchor="t" anchorCtr="0" compatLnSpc="1">
+            <a:noAutofit/>
+          </a:bodyPr>
           <a:lstStyle/>
           <a:p>
-            <a:r>
-              <a:rPr dirty="0" err="1"/>
-              <a:t>Vortragende</a:t>
-            </a:r>
-            <a:r>
-              <a:rPr dirty="0"/>
-              <a:t>(r): David</a:t>
-            </a:r>
+            <a:endParaRPr lang="de-DE"/>
           </a:p>
         </p:txBody>
       </p:sp>
       <p:sp>
         <p:nvSpPr>
-          <p:cNvPr id="4" name="Slide Number Placeholder 3"/>
-          <p:cNvSpPr>
+          <p:cNvPr id="4" name="Slide Number Placeholder 3">
+            <a:extLst>
+              <a:ext uri="{FF2B5EF4-FFF2-40B4-BE49-F238E27FC236}">
+                <a16:creationId xmlns:a16="http://schemas.microsoft.com/office/drawing/2014/main" id="{F4EEA660-87B5-6602-D0F0-EA36A6870F3F}"/>
+              </a:ext>
+            </a:extLst>
+          </p:cNvPr>
+          <p:cNvSpPr txBox="1">
             <a:spLocks noGrp="1"/>
           </p:cNvSpPr>
           <p:nvPr>
-            <p:ph type="sldNum" sz="quarter" idx="10"/>
+            <p:ph type="sldNum" sz="quarter" idx="8"/>
           </p:nvPr>
         </p:nvSpPr>
-        <p:spPr/>
+        <p:spPr>
+          <a:xfrm>
+            <a:off x="0" y="0"/>
+            <a:ext cx="0" cy="0"/>
+          </a:xfrm>
+          <a:prstGeom prst="rect">
+            <a:avLst/>
+          </a:prstGeom>
+          <a:noFill/>
+          <a:ln>
+            <a:noFill/>
+          </a:ln>
+        </p:spPr>
         <p:txBody>
-          <a:bodyPr/>
+          <a:bodyPr vert="horz" wrap="square" lIns="91440" tIns="45720" rIns="91440" bIns="45720" anchor="t" anchorCtr="0" compatLnSpc="1">
+            <a:noAutofit/>
+          </a:bodyPr>
           <a:lstStyle/>
           <a:p>
-            <a:fld id="{F7021451-1387-4CA6-816F-3879F97B5CBC}" type="slidenum">
-              <a:rPr lang="en-US"/>
-              <a:t>3</a:t>
+            <a:pPr lvl="0"/>
+            <a:fld id="{88DA254A-75E9-254F-A716-2FD585B78856}" type="slidenum">
+              <a:t>24</a:t>
             </a:fld>
-            <a:endParaRPr lang="en-US"/>
+            <a:endParaRPr lang="en-US">
+              <a:solidFill>
+                <a:srgbClr val="000000"/>
+              </a:solidFill>
+              <a:latin typeface="Aptos"/>
+            </a:endParaRPr>
           </a:p>
         </p:txBody>
       </p:sp>
     </p:spTree>
-    <p:extLst>
-      <p:ext uri="{BB962C8B-B14F-4D97-AF65-F5344CB8AC3E}">
-        <p14:creationId xmlns:p14="http://schemas.microsoft.com/office/powerpoint/2010/main" val="1024086991"/>
-      </p:ext>
-    </p:extLst>
   </p:cSld>
   <p:clrMapOvr>
     <a:masterClrMapping/>
@@ -2096,8 +2341,8 @@
 </p:notes>
 </file>
 
-<file path=ppt/notesSlides/notesSlide25.xml><?xml version="1.0" encoding="utf-8"?>
-<p:notes xmlns:a="http://schemas.openxmlformats.org/drawingml/2006/main" xmlns:p="http://schemas.openxmlformats.org/presentationml/2006/main" xmlns:r="http://schemas.openxmlformats.org/officeDocument/2006/relationships">
+<file path=ppt/notesSlides/notesSlide3.xml><?xml version="1.0" encoding="utf-8"?>
+<p:notes xmlns:a="http://schemas.openxmlformats.org/drawingml/2006/main" xmlns:r="http://schemas.openxmlformats.org/officeDocument/2006/relationships" xmlns:p="http://schemas.openxmlformats.org/presentationml/2006/main">
   <p:cSld>
     <p:spTree>
       <p:nvGrpSpPr>
@@ -2187,8 +2432,8 @@
 </p:notes>
 </file>
 
-<file path=ppt/notesSlides/notesSlide26.xml><?xml version="1.0" encoding="utf-8"?>
-<p:notes xmlns:a="http://schemas.openxmlformats.org/drawingml/2006/main" xmlns:p="http://schemas.openxmlformats.org/presentationml/2006/main" xmlns:r="http://schemas.openxmlformats.org/officeDocument/2006/relationships">
+<file path=ppt/notesSlides/notesSlide4.xml><?xml version="1.0" encoding="utf-8"?>
+<p:notes xmlns:a="http://schemas.openxmlformats.org/drawingml/2006/main" xmlns:r="http://schemas.openxmlformats.org/officeDocument/2006/relationships" xmlns:p="http://schemas.openxmlformats.org/presentationml/2006/main">
   <p:cSld>
     <p:spTree>
       <p:nvGrpSpPr>
@@ -2259,7 +2504,7 @@
           <a:p>
             <a:fld id="{F7021451-1387-4CA6-816F-3879F97B5CBC}" type="slidenum">
               <a:rPr lang="en-US"/>
-              <a:t>3</a:t>
+              <a:t>4</a:t>
             </a:fld>
             <a:endParaRPr lang="en-US"/>
           </a:p>
@@ -2271,249 +2516,6 @@
         <p14:creationId xmlns:p14="http://schemas.microsoft.com/office/powerpoint/2010/main" val="1024086991"/>
       </p:ext>
     </p:extLst>
-  </p:cSld>
-  <p:clrMapOvr>
-    <a:masterClrMapping/>
-  </p:clrMapOvr>
-</p:notes>
-</file>
-
-<file path=ppt/notesSlides/notesSlide27.xml><?xml version="1.0" encoding="utf-8"?>
-<p:notes xmlns:a="http://schemas.openxmlformats.org/drawingml/2006/main" xmlns:p="http://schemas.openxmlformats.org/presentationml/2006/main" xmlns:r="http://schemas.openxmlformats.org/officeDocument/2006/relationships">
-  <p:cSld>
-    <p:spTree>
-      <p:nvGrpSpPr>
-        <p:cNvPr id="1" name=""/>
-        <p:cNvGrpSpPr/>
-        <p:nvPr/>
-      </p:nvGrpSpPr>
-      <p:grpSpPr>
-        <a:xfrm>
-          <a:off x="0" y="0"/>
-          <a:ext cx="0" cy="0"/>
-          <a:chOff x="0" y="0"/>
-          <a:chExt cx="0" cy="0"/>
-        </a:xfrm>
-      </p:grpSpPr>
-      <p:sp>
-        <p:nvSpPr>
-          <p:cNvPr id="2" name="Slide Image Placeholder 1"/>
-          <p:cNvSpPr>
-            <a:spLocks noGrp="1" noRot="1" noChangeAspect="1"/>
-          </p:cNvSpPr>
-          <p:nvPr>
-            <p:ph type="sldImg"/>
-          </p:nvPr>
-        </p:nvSpPr>
-        <p:spPr/>
-      </p:sp>
-      <p:sp>
-        <p:nvSpPr>
-          <p:cNvPr id="3" name="Notes Placeholder 2"/>
-          <p:cNvSpPr>
-            <a:spLocks noGrp="1"/>
-          </p:cNvSpPr>
-          <p:nvPr>
-            <p:ph type="body" idx="1"/>
-          </p:nvPr>
-        </p:nvSpPr>
-        <p:spPr/>
-        <p:txBody>
-          <a:bodyPr/>
-          <a:lstStyle/>
-          <a:p>
-            <a:r>
-              <a:rPr dirty="0" err="1"/>
-              <a:t>Vortragende</a:t>
-            </a:r>
-            <a:r>
-              <a:rPr dirty="0"/>
-              <a:t>(r): David</a:t>
-            </a:r>
-          </a:p>
-        </p:txBody>
-      </p:sp>
-      <p:sp>
-        <p:nvSpPr>
-          <p:cNvPr id="4" name="Slide Number Placeholder 3"/>
-          <p:cNvSpPr>
-            <a:spLocks noGrp="1"/>
-          </p:cNvSpPr>
-          <p:nvPr>
-            <p:ph type="sldNum" sz="quarter" idx="10"/>
-          </p:nvPr>
-        </p:nvSpPr>
-        <p:spPr/>
-        <p:txBody>
-          <a:bodyPr/>
-          <a:lstStyle/>
-          <a:p>
-            <a:fld id="{F7021451-1387-4CA6-816F-3879F97B5CBC}" type="slidenum">
-              <a:rPr lang="en-US"/>
-              <a:t>3</a:t>
-            </a:fld>
-            <a:endParaRPr lang="en-US"/>
-          </a:p>
-        </p:txBody>
-      </p:sp>
-    </p:spTree>
-    <p:extLst>
-      <p:ext uri="{BB962C8B-B14F-4D97-AF65-F5344CB8AC3E}">
-        <p14:creationId xmlns:p14="http://schemas.microsoft.com/office/powerpoint/2010/main" val="1024086991"/>
-      </p:ext>
-    </p:extLst>
-  </p:cSld>
-  <p:clrMapOvr>
-    <a:masterClrMapping/>
-  </p:clrMapOvr>
-</p:notes>
-</file>
-
-<file path=ppt/notesSlides/notesSlide4.xml><?xml version="1.0" encoding="utf-8"?>
-<p:notes xmlns:a="http://schemas.openxmlformats.org/drawingml/2006/main" xmlns:p="http://schemas.openxmlformats.org/presentationml/2006/main" xmlns:r="http://schemas.openxmlformats.org/officeDocument/2006/relationships">
-  <p:cSld>
-    <p:spTree>
-      <p:nvGrpSpPr>
-        <p:cNvPr id="1" name=""/>
-        <p:cNvGrpSpPr/>
-        <p:nvPr/>
-      </p:nvGrpSpPr>
-      <p:grpSpPr>
-        <a:xfrm>
-          <a:off x="0" y="0"/>
-          <a:ext cx="0" cy="0"/>
-          <a:chOff x="0" y="0"/>
-          <a:chExt cx="0" cy="0"/>
-        </a:xfrm>
-      </p:grpSpPr>
-      <p:sp>
-        <p:nvSpPr>
-          <p:cNvPr id="2" name="Slide Image Placeholder 1">
-            <a:extLst>
-              <a:ext uri="{FF2B5EF4-FFF2-40B4-BE49-F238E27FC236}">
-                <a16:creationId xmlns:a16="http://schemas.microsoft.com/office/drawing/2014/main" id="{75A087AE-59E9-F656-21AD-17E30BF0FB7C}"/>
-              </a:ext>
-            </a:extLst>
-          </p:cNvPr>
-          <p:cNvSpPr>
-            <a:spLocks noGrp="1" noRot="1" noChangeAspect="1"/>
-          </p:cNvSpPr>
-          <p:nvPr>
-            <p:ph type="sldImg"/>
-          </p:nvPr>
-        </p:nvSpPr>
-        <p:spPr>
-          <a:xfrm>
-            <a:off x="0" y="0"/>
-            <a:ext cx="0" cy="0"/>
-          </a:xfrm>
-          <a:prstGeom prst="rect">
-            <a:avLst/>
-          </a:prstGeom>
-          <a:noFill/>
-          <a:ln>
-            <a:noFill/>
-            <a:prstDash val="solid"/>
-          </a:ln>
-        </p:spPr>
-      </p:sp>
-      <p:sp>
-        <p:nvSpPr>
-          <p:cNvPr id="3" name="Notes Placeholder 2">
-            <a:extLst>
-              <a:ext uri="{FF2B5EF4-FFF2-40B4-BE49-F238E27FC236}">
-                <a16:creationId xmlns:a16="http://schemas.microsoft.com/office/drawing/2014/main" id="{9C02448F-04F1-D2F9-3105-094753D8C29B}"/>
-              </a:ext>
-            </a:extLst>
-          </p:cNvPr>
-          <p:cNvSpPr txBox="1">
-            <a:spLocks noGrp="1"/>
-          </p:cNvSpPr>
-          <p:nvPr>
-            <p:ph type="body" idx="1"/>
-          </p:nvPr>
-        </p:nvSpPr>
-        <p:spPr>
-          <a:xfrm>
-            <a:off x="0" y="0"/>
-            <a:ext cx="0" cy="0"/>
-          </a:xfrm>
-          <a:prstGeom prst="rect">
-            <a:avLst/>
-          </a:prstGeom>
-          <a:noFill/>
-          <a:ln>
-            <a:noFill/>
-          </a:ln>
-        </p:spPr>
-        <p:txBody>
-          <a:bodyPr vert="horz" wrap="square" lIns="91440" tIns="45720" rIns="91440" bIns="45720" anchor="t" anchorCtr="0" compatLnSpc="1">
-            <a:noAutofit/>
-          </a:bodyPr>
-          <a:lstStyle/>
-          <a:p>
-            <a:pPr lvl="0"/>
-            <a:r>
-              <a:rPr lang="de-DE">
-                <a:solidFill>
-                  <a:srgbClr val="000000"/>
-                </a:solidFill>
-                <a:latin typeface="Aptos"/>
-              </a:rPr>
-              <a:t>Vortragende(r): Adrian</a:t>
-            </a:r>
-          </a:p>
-        </p:txBody>
-      </p:sp>
-      <p:sp>
-        <p:nvSpPr>
-          <p:cNvPr id="4" name="Slide Number Placeholder 3">
-            <a:extLst>
-              <a:ext uri="{FF2B5EF4-FFF2-40B4-BE49-F238E27FC236}">
-                <a16:creationId xmlns:a16="http://schemas.microsoft.com/office/drawing/2014/main" id="{BE5C70A5-D35D-67E6-5B60-F0EB047265A1}"/>
-              </a:ext>
-            </a:extLst>
-          </p:cNvPr>
-          <p:cNvSpPr txBox="1">
-            <a:spLocks noGrp="1"/>
-          </p:cNvSpPr>
-          <p:nvPr>
-            <p:ph type="sldNum" sz="quarter" idx="8"/>
-          </p:nvPr>
-        </p:nvSpPr>
-        <p:spPr>
-          <a:xfrm>
-            <a:off x="0" y="0"/>
-            <a:ext cx="0" cy="0"/>
-          </a:xfrm>
-          <a:prstGeom prst="rect">
-            <a:avLst/>
-          </a:prstGeom>
-          <a:noFill/>
-          <a:ln>
-            <a:noFill/>
-          </a:ln>
-        </p:spPr>
-        <p:txBody>
-          <a:bodyPr vert="horz" wrap="square" lIns="91440" tIns="45720" rIns="91440" bIns="45720" anchor="t" anchorCtr="0" compatLnSpc="1">
-            <a:noAutofit/>
-          </a:bodyPr>
-          <a:lstStyle/>
-          <a:p>
-            <a:pPr lvl="0"/>
-            <a:fld id="{16115379-4AB9-6B41-AE94-366B276EC789}" type="slidenum">
-              <a:t>10</a:t>
-            </a:fld>
-            <a:endParaRPr lang="en-US">
-              <a:solidFill>
-                <a:srgbClr val="000000"/>
-              </a:solidFill>
-              <a:latin typeface="Aptos"/>
-            </a:endParaRPr>
-          </a:p>
-        </p:txBody>
-      </p:sp>
-    </p:spTree>
   </p:cSld>
   <p:clrMapOvr>
     <a:masterClrMapping/>
@@ -2540,6 +2542,18 @@
       </p:grpSpPr>
       <p:sp>
         <p:nvSpPr>
+          <p:cNvPr id="2" name="Slide Image Placeholder 1"/>
+          <p:cNvSpPr>
+            <a:spLocks noGrp="1" noRot="1" noChangeAspect="1"/>
+          </p:cNvSpPr>
+          <p:nvPr>
+            <p:ph type="sldImg"/>
+          </p:nvPr>
+        </p:nvSpPr>
+        <p:spPr/>
+      </p:sp>
+      <p:sp>
+        <p:nvSpPr>
           <p:cNvPr id="3" name="Notes Placeholder 2"/>
           <p:cNvSpPr>
             <a:spLocks noGrp="1"/>
@@ -2559,17 +2573,40 @@
             </a:r>
             <a:r>
               <a:rPr dirty="0"/>
-              <a:t>(r): </a:t>
-            </a:r>
-            <a:r>
-              <a:rPr lang="de-DE" dirty="0"/>
-              <a:t>Kilian</a:t>
-            </a:r>
-            <a:endParaRPr dirty="0"/>
+              <a:t>(r): David</a:t>
+            </a:r>
           </a:p>
         </p:txBody>
       </p:sp>
+      <p:sp>
+        <p:nvSpPr>
+          <p:cNvPr id="4" name="Slide Number Placeholder 3"/>
+          <p:cNvSpPr>
+            <a:spLocks noGrp="1"/>
+          </p:cNvSpPr>
+          <p:nvPr>
+            <p:ph type="sldNum" sz="quarter" idx="10"/>
+          </p:nvPr>
+        </p:nvSpPr>
+        <p:spPr/>
+        <p:txBody>
+          <a:bodyPr/>
+          <a:lstStyle/>
+          <a:p>
+            <a:fld id="{F7021451-1387-4CA6-816F-3879F97B5CBC}" type="slidenum">
+              <a:rPr lang="en-US"/>
+              <a:t>5</a:t>
+            </a:fld>
+            <a:endParaRPr lang="en-US"/>
+          </a:p>
+        </p:txBody>
+      </p:sp>
     </p:spTree>
+    <p:extLst>
+      <p:ext uri="{BB962C8B-B14F-4D97-AF65-F5344CB8AC3E}">
+        <p14:creationId xmlns:p14="http://schemas.microsoft.com/office/powerpoint/2010/main" val="1024086991"/>
+      </p:ext>
+    </p:extLst>
   </p:cSld>
   <p:clrMapOvr>
     <a:masterClrMapping/>
@@ -2582,13 +2619,7 @@
   <p:cSld>
     <p:spTree>
       <p:nvGrpSpPr>
-        <p:cNvPr id="1" name="">
-          <a:extLst>
-            <a:ext uri="{FF2B5EF4-FFF2-40B4-BE49-F238E27FC236}">
-              <a16:creationId xmlns:a16="http://schemas.microsoft.com/office/drawing/2014/main" id="{CD7D0EEA-6A4B-472F-D803-9483494B10BA}"/>
-            </a:ext>
-          </a:extLst>
-        </p:cNvPr>
+        <p:cNvPr id="1" name=""/>
         <p:cNvGrpSpPr/>
         <p:nvPr/>
       </p:nvGrpSpPr>
@@ -2602,13 +2633,7 @@
       </p:grpSpPr>
       <p:sp>
         <p:nvSpPr>
-          <p:cNvPr id="2" name="Slide Image Placeholder 1">
-            <a:extLst>
-              <a:ext uri="{FF2B5EF4-FFF2-40B4-BE49-F238E27FC236}">
-                <a16:creationId xmlns:a16="http://schemas.microsoft.com/office/drawing/2014/main" id="{6A37A22C-9C37-FB09-92CB-A880171C5F51}"/>
-              </a:ext>
-            </a:extLst>
-          </p:cNvPr>
+          <p:cNvPr id="2" name="Slide Image Placeholder 1"/>
           <p:cNvSpPr>
             <a:spLocks noGrp="1" noRot="1" noChangeAspect="1"/>
           </p:cNvSpPr>
@@ -2620,13 +2645,7 @@
       </p:sp>
       <p:sp>
         <p:nvSpPr>
-          <p:cNvPr id="3" name="Notes Placeholder 2">
-            <a:extLst>
-              <a:ext uri="{FF2B5EF4-FFF2-40B4-BE49-F238E27FC236}">
-                <a16:creationId xmlns:a16="http://schemas.microsoft.com/office/drawing/2014/main" id="{669F109A-BF7E-E094-E2CA-78949371440A}"/>
-              </a:ext>
-            </a:extLst>
-          </p:cNvPr>
+          <p:cNvPr id="3" name="Notes Placeholder 2"/>
           <p:cNvSpPr>
             <a:spLocks noGrp="1"/>
           </p:cNvSpPr>
@@ -2645,25 +2664,14 @@
             </a:r>
             <a:r>
               <a:rPr dirty="0"/>
-              <a:t>(r): </a:t>
-            </a:r>
-            <a:r>
-              <a:rPr lang="de-DE" dirty="0"/>
-              <a:t>Maximilian</a:t>
-            </a:r>
-            <a:endParaRPr dirty="0"/>
+              <a:t>(r): David</a:t>
+            </a:r>
           </a:p>
         </p:txBody>
       </p:sp>
       <p:sp>
         <p:nvSpPr>
-          <p:cNvPr id="4" name="Slide Number Placeholder 3">
-            <a:extLst>
-              <a:ext uri="{FF2B5EF4-FFF2-40B4-BE49-F238E27FC236}">
-                <a16:creationId xmlns:a16="http://schemas.microsoft.com/office/drawing/2014/main" id="{ACFCA1B7-5D2D-27A7-2F24-3D6E7658880A}"/>
-              </a:ext>
-            </a:extLst>
-          </p:cNvPr>
+          <p:cNvPr id="4" name="Slide Number Placeholder 3"/>
           <p:cNvSpPr>
             <a:spLocks noGrp="1"/>
           </p:cNvSpPr>
@@ -2687,7 +2695,7 @@
     </p:spTree>
     <p:extLst>
       <p:ext uri="{BB962C8B-B14F-4D97-AF65-F5344CB8AC3E}">
-        <p14:creationId xmlns:p14="http://schemas.microsoft.com/office/powerpoint/2010/main" val="2229023290"/>
+        <p14:creationId xmlns:p14="http://schemas.microsoft.com/office/powerpoint/2010/main" val="1024086991"/>
       </p:ext>
     </p:extLst>
   </p:cSld>
@@ -2702,13 +2710,7 @@
   <p:cSld>
     <p:spTree>
       <p:nvGrpSpPr>
-        <p:cNvPr id="1" name="">
-          <a:extLst>
-            <a:ext uri="{FF2B5EF4-FFF2-40B4-BE49-F238E27FC236}">
-              <a16:creationId xmlns:a16="http://schemas.microsoft.com/office/drawing/2014/main" id="{FF608250-25F3-8992-43BF-D14C84D1A263}"/>
-            </a:ext>
-          </a:extLst>
-        </p:cNvPr>
+        <p:cNvPr id="1" name=""/>
         <p:cNvGrpSpPr/>
         <p:nvPr/>
       </p:nvGrpSpPr>
@@ -2722,13 +2724,7 @@
       </p:grpSpPr>
       <p:sp>
         <p:nvSpPr>
-          <p:cNvPr id="2" name="Slide Image Placeholder 1">
-            <a:extLst>
-              <a:ext uri="{FF2B5EF4-FFF2-40B4-BE49-F238E27FC236}">
-                <a16:creationId xmlns:a16="http://schemas.microsoft.com/office/drawing/2014/main" id="{F1B0F22A-F00F-0057-1149-92CC4CD87D88}"/>
-              </a:ext>
-            </a:extLst>
-          </p:cNvPr>
+          <p:cNvPr id="2" name="Slide Image Placeholder 1"/>
           <p:cNvSpPr>
             <a:spLocks noGrp="1" noRot="1" noChangeAspect="1"/>
           </p:cNvSpPr>
@@ -2740,13 +2736,7 @@
       </p:sp>
       <p:sp>
         <p:nvSpPr>
-          <p:cNvPr id="3" name="Notes Placeholder 2">
-            <a:extLst>
-              <a:ext uri="{FF2B5EF4-FFF2-40B4-BE49-F238E27FC236}">
-                <a16:creationId xmlns:a16="http://schemas.microsoft.com/office/drawing/2014/main" id="{590DD66A-29A7-BD23-7479-99308DB3DD27}"/>
-              </a:ext>
-            </a:extLst>
-          </p:cNvPr>
+          <p:cNvPr id="3" name="Notes Placeholder 2"/>
           <p:cNvSpPr>
             <a:spLocks noGrp="1"/>
           </p:cNvSpPr>
@@ -2765,25 +2755,14 @@
             </a:r>
             <a:r>
               <a:rPr dirty="0"/>
-              <a:t>(r): </a:t>
-            </a:r>
-            <a:r>
-              <a:rPr lang="de-DE" dirty="0"/>
-              <a:t>Maximilian</a:t>
-            </a:r>
-            <a:endParaRPr dirty="0"/>
+              <a:t>(r): David</a:t>
+            </a:r>
           </a:p>
         </p:txBody>
       </p:sp>
       <p:sp>
         <p:nvSpPr>
-          <p:cNvPr id="4" name="Slide Number Placeholder 3">
-            <a:extLst>
-              <a:ext uri="{FF2B5EF4-FFF2-40B4-BE49-F238E27FC236}">
-                <a16:creationId xmlns:a16="http://schemas.microsoft.com/office/drawing/2014/main" id="{6AD8F6E3-73AF-D838-73CC-427E21B55663}"/>
-              </a:ext>
-            </a:extLst>
-          </p:cNvPr>
+          <p:cNvPr id="4" name="Slide Number Placeholder 3"/>
           <p:cNvSpPr>
             <a:spLocks noGrp="1"/>
           </p:cNvSpPr>
@@ -2807,7 +2786,7 @@
     </p:spTree>
     <p:extLst>
       <p:ext uri="{BB962C8B-B14F-4D97-AF65-F5344CB8AC3E}">
-        <p14:creationId xmlns:p14="http://schemas.microsoft.com/office/powerpoint/2010/main" val="4112070376"/>
+        <p14:creationId xmlns:p14="http://schemas.microsoft.com/office/powerpoint/2010/main" val="1024086991"/>
       </p:ext>
     </p:extLst>
   </p:cSld>
@@ -2836,18 +2815,6 @@
       </p:grpSpPr>
       <p:sp>
         <p:nvSpPr>
-          <p:cNvPr id="2" name="Slide Image Placeholder 1"/>
-          <p:cNvSpPr>
-            <a:spLocks noGrp="1" noRot="1" noChangeAspect="1"/>
-          </p:cNvSpPr>
-          <p:nvPr>
-            <p:ph type="sldImg"/>
-          </p:nvPr>
-        </p:nvSpPr>
-        <p:spPr/>
-      </p:sp>
-      <p:sp>
-        <p:nvSpPr>
           <p:cNvPr id="3" name="Notes Placeholder 2"/>
           <p:cNvSpPr>
             <a:spLocks noGrp="1"/>
@@ -2871,41 +2838,13 @@
             </a:r>
             <a:r>
               <a:rPr lang="de-DE" dirty="0"/>
-              <a:t>Maximilian</a:t>
+              <a:t>Kilian</a:t>
             </a:r>
             <a:endParaRPr dirty="0"/>
           </a:p>
         </p:txBody>
       </p:sp>
-      <p:sp>
-        <p:nvSpPr>
-          <p:cNvPr id="4" name="Slide Number Placeholder 3"/>
-          <p:cNvSpPr>
-            <a:spLocks noGrp="1"/>
-          </p:cNvSpPr>
-          <p:nvPr>
-            <p:ph type="sldNum" sz="quarter" idx="10"/>
-          </p:nvPr>
-        </p:nvSpPr>
-        <p:spPr/>
-        <p:txBody>
-          <a:bodyPr/>
-          <a:lstStyle/>
-          <a:p>
-            <a:fld id="{F7021451-1387-4CA6-816F-3879F97B5CBC}" type="slidenum">
-              <a:rPr lang="en-US"/>
-              <a:t>8</a:t>
-            </a:fld>
-            <a:endParaRPr lang="en-US"/>
-          </a:p>
-        </p:txBody>
-      </p:sp>
     </p:spTree>
-    <p:extLst>
-      <p:ext uri="{BB962C8B-B14F-4D97-AF65-F5344CB8AC3E}">
-        <p14:creationId xmlns:p14="http://schemas.microsoft.com/office/powerpoint/2010/main" val="1024086991"/>
-      </p:ext>
-    </p:extLst>
   </p:cSld>
   <p:clrMapOvr>
     <a:masterClrMapping/>
@@ -2918,7 +2857,13 @@
   <p:cSld>
     <p:spTree>
       <p:nvGrpSpPr>
-        <p:cNvPr id="1" name=""/>
+        <p:cNvPr id="1" name="">
+          <a:extLst>
+            <a:ext uri="{FF2B5EF4-FFF2-40B4-BE49-F238E27FC236}">
+              <a16:creationId xmlns:a16="http://schemas.microsoft.com/office/drawing/2014/main" id="{CD7D0EEA-6A4B-472F-D803-9483494B10BA}"/>
+            </a:ext>
+          </a:extLst>
+        </p:cNvPr>
         <p:cNvGrpSpPr/>
         <p:nvPr/>
       </p:nvGrpSpPr>
@@ -2932,7 +2877,31 @@
       </p:grpSpPr>
       <p:sp>
         <p:nvSpPr>
-          <p:cNvPr id="3" name="Notes Placeholder 2"/>
+          <p:cNvPr id="2" name="Slide Image Placeholder 1">
+            <a:extLst>
+              <a:ext uri="{FF2B5EF4-FFF2-40B4-BE49-F238E27FC236}">
+                <a16:creationId xmlns:a16="http://schemas.microsoft.com/office/drawing/2014/main" id="{6A37A22C-9C37-FB09-92CB-A880171C5F51}"/>
+              </a:ext>
+            </a:extLst>
+          </p:cNvPr>
+          <p:cNvSpPr>
+            <a:spLocks noGrp="1" noRot="1" noChangeAspect="1"/>
+          </p:cNvSpPr>
+          <p:nvPr>
+            <p:ph type="sldImg"/>
+          </p:nvPr>
+        </p:nvSpPr>
+        <p:spPr/>
+      </p:sp>
+      <p:sp>
+        <p:nvSpPr>
+          <p:cNvPr id="3" name="Notes Placeholder 2">
+            <a:extLst>
+              <a:ext uri="{FF2B5EF4-FFF2-40B4-BE49-F238E27FC236}">
+                <a16:creationId xmlns:a16="http://schemas.microsoft.com/office/drawing/2014/main" id="{669F109A-BF7E-E094-E2CA-78949371440A}"/>
+              </a:ext>
+            </a:extLst>
+          </p:cNvPr>
           <p:cNvSpPr>
             <a:spLocks noGrp="1"/>
           </p:cNvSpPr>
@@ -2961,7 +2930,41 @@
           </a:p>
         </p:txBody>
       </p:sp>
+      <p:sp>
+        <p:nvSpPr>
+          <p:cNvPr id="4" name="Slide Number Placeholder 3">
+            <a:extLst>
+              <a:ext uri="{FF2B5EF4-FFF2-40B4-BE49-F238E27FC236}">
+                <a16:creationId xmlns:a16="http://schemas.microsoft.com/office/drawing/2014/main" id="{ACFCA1B7-5D2D-27A7-2F24-3D6E7658880A}"/>
+              </a:ext>
+            </a:extLst>
+          </p:cNvPr>
+          <p:cNvSpPr>
+            <a:spLocks noGrp="1"/>
+          </p:cNvSpPr>
+          <p:nvPr>
+            <p:ph type="sldNum" sz="quarter" idx="10"/>
+          </p:nvPr>
+        </p:nvSpPr>
+        <p:spPr/>
+        <p:txBody>
+          <a:bodyPr/>
+          <a:lstStyle/>
+          <a:p>
+            <a:fld id="{F7021451-1387-4CA6-816F-3879F97B5CBC}" type="slidenum">
+              <a:rPr lang="en-US"/>
+              <a:t>9</a:t>
+            </a:fld>
+            <a:endParaRPr lang="en-US"/>
+          </a:p>
+        </p:txBody>
+      </p:sp>
     </p:spTree>
+    <p:extLst>
+      <p:ext uri="{BB962C8B-B14F-4D97-AF65-F5344CB8AC3E}">
+        <p14:creationId xmlns:p14="http://schemas.microsoft.com/office/powerpoint/2010/main" val="2229023290"/>
+      </p:ext>
+    </p:extLst>
   </p:cSld>
   <p:clrMapOvr>
     <a:masterClrMapping/>
@@ -3388,6 +3391,7 @@
           <a:lstStyle/>
           <a:p>
             <a:pPr algn="ctr"/>
+            <a:endParaRPr/>
           </a:p>
         </p:txBody>
       </p:sp>
@@ -3449,6 +3453,7 @@
           <a:lstStyle/>
           <a:p>
             <a:pPr algn="ctr"/>
+            <a:endParaRPr/>
           </a:p>
         </p:txBody>
       </p:sp>
@@ -3469,7 +3474,7 @@
           <a:noFill/>
         </p:spPr>
         <p:txBody>
-          <a:bodyPr wrap="square" lIns="0" rIns="0" tIns="0" bIns="0" anchor="t">
+          <a:bodyPr wrap="square" lIns="0" tIns="0" rIns="0" bIns="0" anchor="t">
             <a:spAutoFit/>
           </a:bodyPr>
           <a:lstStyle/>
@@ -3504,7 +3509,7 @@
           <a:noFill/>
         </p:spPr>
         <p:txBody>
-          <a:bodyPr wrap="square" lIns="0" rIns="0" tIns="0" bIns="0" anchor="t">
+          <a:bodyPr wrap="square" lIns="0" tIns="0" rIns="0" bIns="0" anchor="t">
             <a:spAutoFit/>
           </a:bodyPr>
           <a:lstStyle/>
@@ -3575,6 +3580,7 @@
           <a:lstStyle/>
           <a:p>
             <a:pPr algn="ctr"/>
+            <a:endParaRPr/>
           </a:p>
         </p:txBody>
       </p:sp>
@@ -3595,7 +3601,7 @@
           <a:noFill/>
         </p:spPr>
         <p:txBody>
-          <a:bodyPr wrap="square" lIns="0" rIns="0" tIns="0" bIns="0" anchor="t">
+          <a:bodyPr wrap="square" lIns="0" tIns="0" rIns="0" bIns="0" anchor="t">
             <a:spAutoFit/>
           </a:bodyPr>
           <a:lstStyle/>
@@ -3630,7 +3636,7 @@
           <a:noFill/>
         </p:spPr>
         <p:txBody>
-          <a:bodyPr wrap="square" lIns="0" rIns="0" tIns="0" bIns="0" anchor="t">
+          <a:bodyPr wrap="square" lIns="0" tIns="0" rIns="0" bIns="0" anchor="t">
             <a:spAutoFit/>
           </a:bodyPr>
           <a:lstStyle/>
@@ -15001,7 +15007,7 @@
 </file>
 
 <file path=ppt/slides/slide2.xml><?xml version="1.0" encoding="utf-8"?>
-<p:sld xmlns:a="http://schemas.openxmlformats.org/drawingml/2006/main" xmlns:p="http://schemas.openxmlformats.org/presentationml/2006/main" xmlns:r="http://schemas.openxmlformats.org/officeDocument/2006/relationships">
+<p:sld xmlns:a="http://schemas.openxmlformats.org/drawingml/2006/main" xmlns:r="http://schemas.openxmlformats.org/officeDocument/2006/relationships" xmlns:p="http://schemas.openxmlformats.org/presentationml/2006/main">
   <p:cSld>
     <p:spTree>
       <p:nvGrpSpPr>
@@ -15009,7 +15015,14 @@
         <p:cNvGrpSpPr/>
         <p:nvPr/>
       </p:nvGrpSpPr>
-      <p:grpSpPr/>
+      <p:grpSpPr>
+        <a:xfrm>
+          <a:off x="0" y="0"/>
+          <a:ext cx="0" cy="0"/>
+          <a:chOff x="0" y="0"/>
+          <a:chExt cx="0" cy="0"/>
+        </a:xfrm>
+      </p:grpSpPr>
       <p:sp>
         <p:nvSpPr>
           <p:cNvPr id="2" name="Text 0"/>
@@ -15076,7 +15089,7 @@
           <a:noFill/>
         </p:spPr>
         <p:txBody>
-          <a:bodyPr wrap="square" lIns="0" rIns="0" tIns="0" bIns="0" anchor="t">
+          <a:bodyPr wrap="square" lIns="0" tIns="0" rIns="0" bIns="0" anchor="t">
             <a:spAutoFit/>
           </a:bodyPr>
           <a:lstStyle/>
@@ -15140,7 +15153,7 @@
           <a:noFill/>
         </p:spPr>
         <p:txBody>
-          <a:bodyPr wrap="square" lIns="0" rIns="0" tIns="0" bIns="0" anchor="t">
+          <a:bodyPr wrap="square" lIns="0" tIns="0" rIns="0" bIns="0" anchor="t">
             <a:spAutoFit/>
           </a:bodyPr>
           <a:lstStyle/>
@@ -15175,7 +15188,7 @@
           <a:noFill/>
         </p:spPr>
         <p:txBody>
-          <a:bodyPr wrap="square" lIns="0" rIns="0" tIns="0" bIns="0" anchor="t">
+          <a:bodyPr wrap="square" lIns="0" tIns="0" rIns="0" bIns="0" anchor="t">
             <a:spAutoFit/>
           </a:bodyPr>
           <a:lstStyle/>
@@ -15222,7 +15235,7 @@
           <a:noFill/>
         </p:spPr>
         <p:txBody>
-          <a:bodyPr wrap="square" lIns="0" rIns="0" tIns="0" bIns="0" anchor="t">
+          <a:bodyPr wrap="square" lIns="0" tIns="0" rIns="0" bIns="0" anchor="t">
             <a:spAutoFit/>
           </a:bodyPr>
           <a:lstStyle/>
@@ -15286,7 +15299,7 @@
           <a:noFill/>
         </p:spPr>
         <p:txBody>
-          <a:bodyPr wrap="square" lIns="0" rIns="0" tIns="0" bIns="0" anchor="t">
+          <a:bodyPr wrap="square" lIns="0" tIns="0" rIns="0" bIns="0" anchor="t">
             <a:spAutoFit/>
           </a:bodyPr>
           <a:lstStyle/>
@@ -15321,7 +15334,7 @@
           <a:noFill/>
         </p:spPr>
         <p:txBody>
-          <a:bodyPr wrap="square" lIns="0" rIns="0" tIns="0" bIns="0" anchor="t">
+          <a:bodyPr wrap="square" lIns="0" tIns="0" rIns="0" bIns="0" anchor="t">
             <a:spAutoFit/>
           </a:bodyPr>
           <a:lstStyle/>
@@ -15368,7 +15381,7 @@
           <a:noFill/>
         </p:spPr>
         <p:txBody>
-          <a:bodyPr wrap="square" lIns="0" rIns="0" tIns="0" bIns="0" anchor="t">
+          <a:bodyPr wrap="square" lIns="0" tIns="0" rIns="0" bIns="0" anchor="t">
             <a:spAutoFit/>
           </a:bodyPr>
           <a:lstStyle/>
@@ -15432,7 +15445,7 @@
           <a:noFill/>
         </p:spPr>
         <p:txBody>
-          <a:bodyPr wrap="square" lIns="0" rIns="0" tIns="0" bIns="0" anchor="t">
+          <a:bodyPr wrap="square" lIns="0" tIns="0" rIns="0" bIns="0" anchor="t">
             <a:spAutoFit/>
           </a:bodyPr>
           <a:lstStyle/>
@@ -15467,7 +15480,7 @@
           <a:noFill/>
         </p:spPr>
         <p:txBody>
-          <a:bodyPr wrap="square" lIns="0" rIns="0" tIns="0" bIns="0" anchor="t">
+          <a:bodyPr wrap="square" lIns="0" tIns="0" rIns="0" bIns="0" anchor="t">
             <a:spAutoFit/>
           </a:bodyPr>
           <a:lstStyle/>
@@ -15514,7 +15527,7 @@
           <a:noFill/>
         </p:spPr>
         <p:txBody>
-          <a:bodyPr wrap="square" lIns="0" rIns="0" tIns="0" bIns="0" anchor="t">
+          <a:bodyPr wrap="square" lIns="0" tIns="0" rIns="0" bIns="0" anchor="t">
             <a:spAutoFit/>
           </a:bodyPr>
           <a:lstStyle/>
@@ -15578,7 +15591,7 @@
           <a:noFill/>
         </p:spPr>
         <p:txBody>
-          <a:bodyPr wrap="square" lIns="0" rIns="0" tIns="0" bIns="0" anchor="t">
+          <a:bodyPr wrap="square" lIns="0" tIns="0" rIns="0" bIns="0" anchor="t">
             <a:spAutoFit/>
           </a:bodyPr>
           <a:lstStyle/>
@@ -15613,7 +15626,7 @@
           <a:noFill/>
         </p:spPr>
         <p:txBody>
-          <a:bodyPr wrap="square" lIns="0" rIns="0" tIns="0" bIns="0" anchor="t">
+          <a:bodyPr wrap="square" lIns="0" tIns="0" rIns="0" bIns="0" anchor="t">
             <a:spAutoFit/>
           </a:bodyPr>
           <a:lstStyle/>
@@ -15648,7 +15661,7 @@
           <a:noFill/>
         </p:spPr>
         <p:txBody>
-          <a:bodyPr wrap="square" lIns="0" rIns="0" tIns="0" bIns="0" anchor="t">
+          <a:bodyPr wrap="square" lIns="0" tIns="0" rIns="0" bIns="0" anchor="t">
             <a:spAutoFit/>
           </a:bodyPr>
           <a:lstStyle/>
@@ -15668,7 +15681,7 @@
       </p:sp>
       <p:pic>
         <p:nvPicPr>
-          <p:cNvPr id="20" name="Picture 19" descr="Jakob.jpg"/>
+          <p:cNvPr id="20" name="Picture 19"/>
           <p:cNvPicPr>
             <a:picLocks noChangeAspect="1"/>
           </p:cNvPicPr>
@@ -15676,9 +15689,8 @@
         </p:nvPicPr>
         <p:blipFill>
           <a:blip r:embed="rId7"/>
-          <a:stretch>
-            <a:fillRect/>
-          </a:stretch>
+          <a:srcRect t="15245" b="15245"/>
+          <a:stretch/>
         </p:blipFill>
         <p:spPr>
           <a:xfrm>
@@ -15712,7 +15724,7 @@
           <a:noFill/>
         </p:spPr>
         <p:txBody>
-          <a:bodyPr wrap="square" lIns="0" rIns="0" tIns="0" bIns="0" anchor="t">
+          <a:bodyPr wrap="square" lIns="0" tIns="0" rIns="0" bIns="0" anchor="t">
             <a:spAutoFit/>
           </a:bodyPr>
           <a:lstStyle/>
@@ -15747,7 +15759,7 @@
           <a:noFill/>
         </p:spPr>
         <p:txBody>
-          <a:bodyPr wrap="square" lIns="0" rIns="0" tIns="0" bIns="0" anchor="t">
+          <a:bodyPr wrap="square" lIns="0" tIns="0" rIns="0" bIns="0" anchor="t">
             <a:spAutoFit/>
           </a:bodyPr>
           <a:lstStyle/>
@@ -15794,7 +15806,7 @@
           <a:noFill/>
         </p:spPr>
         <p:txBody>
-          <a:bodyPr wrap="square" lIns="0" rIns="0" tIns="0" bIns="0" anchor="t">
+          <a:bodyPr wrap="square" lIns="0" tIns="0" rIns="0" bIns="0" anchor="t">
             <a:spAutoFit/>
           </a:bodyPr>
           <a:lstStyle/>
@@ -15821,7 +15833,7 @@
           <p:nvPr/>
         </p:nvPicPr>
         <p:blipFill>
-          <a:blip r:embed="rId2"/>
+          <a:blip r:embed="rId8"/>
           <a:stretch>
             <a:fillRect/>
           </a:stretch>
@@ -15858,7 +15870,7 @@
           <a:noFill/>
         </p:spPr>
         <p:txBody>
-          <a:bodyPr wrap="square" lIns="0" rIns="0" tIns="0" bIns="0" anchor="t">
+          <a:bodyPr wrap="square" lIns="0" tIns="0" rIns="0" bIns="0" anchor="t">
             <a:spAutoFit/>
           </a:bodyPr>
           <a:lstStyle/>
@@ -15893,7 +15905,7 @@
           <a:noFill/>
         </p:spPr>
         <p:txBody>
-          <a:bodyPr wrap="square" lIns="0" rIns="0" tIns="0" bIns="0" anchor="t">
+          <a:bodyPr wrap="square" lIns="0" tIns="0" rIns="0" bIns="0" anchor="t">
             <a:spAutoFit/>
           </a:bodyPr>
           <a:lstStyle/>
@@ -15928,7 +15940,7 @@
           <a:noFill/>
         </p:spPr>
         <p:txBody>
-          <a:bodyPr wrap="square" lIns="0" rIns="0" tIns="0" bIns="0" anchor="t">
+          <a:bodyPr wrap="square" lIns="0" tIns="0" rIns="0" bIns="0" anchor="t">
             <a:spAutoFit/>
           </a:bodyPr>
           <a:lstStyle/>
@@ -25395,7 +25407,7 @@
           <a:noFill/>
         </p:spPr>
         <p:txBody>
-          <a:bodyPr wrap="square" lIns="0" rIns="0" tIns="0" bIns="0" anchor="t">
+          <a:bodyPr wrap="square" lIns="0" tIns="0" rIns="0" bIns="0" anchor="t">
             <a:spAutoFit/>
           </a:bodyPr>
           <a:lstStyle/>
@@ -25458,6 +25470,7 @@
           <a:lstStyle/>
           <a:p>
             <a:pPr algn="ctr"/>
+            <a:endParaRPr/>
           </a:p>
         </p:txBody>
       </p:sp>
@@ -25478,7 +25491,7 @@
           <a:noFill/>
         </p:spPr>
         <p:txBody>
-          <a:bodyPr wrap="square" lIns="0" rIns="0" tIns="0" bIns="0" anchor="t">
+          <a:bodyPr wrap="square" lIns="0" tIns="0" rIns="0" bIns="0" anchor="t">
             <a:spAutoFit/>
           </a:bodyPr>
           <a:lstStyle/>
@@ -25537,6 +25550,7 @@
           <a:lstStyle/>
           <a:p>
             <a:pPr algn="ctr"/>
+            <a:endParaRPr/>
           </a:p>
         </p:txBody>
       </p:sp>
@@ -25557,7 +25571,7 @@
           <a:noFill/>
         </p:spPr>
         <p:txBody>
-          <a:bodyPr wrap="square" lIns="0" rIns="0" tIns="0" bIns="0" anchor="t">
+          <a:bodyPr wrap="square" lIns="0" tIns="0" rIns="0" bIns="0" anchor="t">
             <a:spAutoFit/>
           </a:bodyPr>
           <a:lstStyle/>
@@ -25616,6 +25630,7 @@
           <a:lstStyle/>
           <a:p>
             <a:pPr algn="ctr"/>
+            <a:endParaRPr/>
           </a:p>
         </p:txBody>
       </p:sp>
@@ -25636,7 +25651,7 @@
           <a:noFill/>
         </p:spPr>
         <p:txBody>
-          <a:bodyPr wrap="square" lIns="0" rIns="0" tIns="0" bIns="0" anchor="t">
+          <a:bodyPr wrap="square" lIns="0" tIns="0" rIns="0" bIns="0" anchor="t">
             <a:spAutoFit/>
           </a:bodyPr>
           <a:lstStyle/>
@@ -25671,7 +25686,7 @@
           <a:noFill/>
         </p:spPr>
         <p:txBody>
-          <a:bodyPr wrap="square" lIns="0" rIns="0" tIns="0" bIns="0" anchor="t">
+          <a:bodyPr wrap="square" lIns="0" tIns="0" rIns="0" bIns="0" anchor="t">
             <a:spAutoFit/>
           </a:bodyPr>
           <a:lstStyle/>
@@ -25706,7 +25721,7 @@
           <a:noFill/>
         </p:spPr>
         <p:txBody>
-          <a:bodyPr wrap="square" lIns="0" rIns="0" tIns="0" bIns="0" anchor="t">
+          <a:bodyPr wrap="square" lIns="0" tIns="0" rIns="0" bIns="0" anchor="t">
             <a:spAutoFit/>
           </a:bodyPr>
           <a:lstStyle/>
@@ -25741,7 +25756,7 @@
           <a:noFill/>
         </p:spPr>
         <p:txBody>
-          <a:bodyPr wrap="square" lIns="0" rIns="0" tIns="0" bIns="0" anchor="t">
+          <a:bodyPr wrap="square" lIns="0" tIns="0" rIns="0" bIns="0" anchor="t">
             <a:spAutoFit/>
           </a:bodyPr>
           <a:lstStyle/>
@@ -25776,7 +25791,7 @@
           <a:noFill/>
         </p:spPr>
         <p:txBody>
-          <a:bodyPr wrap="square" lIns="0" rIns="0" tIns="0" bIns="0" anchor="t">
+          <a:bodyPr wrap="square" lIns="0" tIns="0" rIns="0" bIns="0" anchor="t">
             <a:spAutoFit/>
           </a:bodyPr>
           <a:lstStyle/>
@@ -25811,7 +25826,7 @@
           <a:noFill/>
         </p:spPr>
         <p:txBody>
-          <a:bodyPr wrap="square" lIns="0" rIns="0" tIns="0" bIns="0" anchor="t">
+          <a:bodyPr wrap="square" lIns="0" tIns="0" rIns="0" bIns="0" anchor="t">
             <a:spAutoFit/>
           </a:bodyPr>
           <a:lstStyle/>
@@ -25846,7 +25861,7 @@
           <a:noFill/>
         </p:spPr>
         <p:txBody>
-          <a:bodyPr wrap="square" lIns="0" rIns="0" tIns="0" bIns="0" anchor="t">
+          <a:bodyPr wrap="square" lIns="0" tIns="0" rIns="0" bIns="0" anchor="t">
             <a:spAutoFit/>
           </a:bodyPr>
           <a:lstStyle/>
@@ -25881,7 +25896,7 @@
           <a:noFill/>
         </p:spPr>
         <p:txBody>
-          <a:bodyPr wrap="square" lIns="0" rIns="0" tIns="0" bIns="0" anchor="t">
+          <a:bodyPr wrap="square" lIns="0" tIns="0" rIns="0" bIns="0" anchor="t">
             <a:spAutoFit/>
           </a:bodyPr>
           <a:lstStyle/>
@@ -25916,7 +25931,7 @@
           <a:noFill/>
         </p:spPr>
         <p:txBody>
-          <a:bodyPr wrap="square" lIns="0" rIns="0" tIns="0" bIns="0" anchor="t">
+          <a:bodyPr wrap="square" lIns="0" tIns="0" rIns="0" bIns="0" anchor="t">
             <a:spAutoFit/>
           </a:bodyPr>
           <a:lstStyle/>
@@ -25951,7 +25966,7 @@
           <a:noFill/>
         </p:spPr>
         <p:txBody>
-          <a:bodyPr wrap="square" lIns="0" rIns="0" tIns="0" bIns="0" anchor="t">
+          <a:bodyPr wrap="square" lIns="0" tIns="0" rIns="0" bIns="0" anchor="t">
             <a:spAutoFit/>
           </a:bodyPr>
           <a:lstStyle/>
@@ -25986,7 +26001,7 @@
           <a:noFill/>
         </p:spPr>
         <p:txBody>
-          <a:bodyPr wrap="square" lIns="0" rIns="0" tIns="0" bIns="0" anchor="t">
+          <a:bodyPr wrap="square" lIns="0" tIns="0" rIns="0" bIns="0" anchor="t">
             <a:spAutoFit/>
           </a:bodyPr>
           <a:lstStyle/>
@@ -26021,7 +26036,7 @@
           <a:noFill/>
         </p:spPr>
         <p:txBody>
-          <a:bodyPr wrap="square" lIns="0" rIns="0" tIns="0" bIns="0" anchor="t">
+          <a:bodyPr wrap="square" lIns="0" tIns="0" rIns="0" bIns="0" anchor="t">
             <a:spAutoFit/>
           </a:bodyPr>
           <a:lstStyle/>
@@ -26056,7 +26071,7 @@
           <a:noFill/>
         </p:spPr>
         <p:txBody>
-          <a:bodyPr wrap="square" lIns="0" rIns="0" tIns="0" bIns="0" anchor="t">
+          <a:bodyPr wrap="square" lIns="0" tIns="0" rIns="0" bIns="0" anchor="t">
             <a:spAutoFit/>
           </a:bodyPr>
           <a:lstStyle/>
@@ -26091,7 +26106,7 @@
           <a:noFill/>
         </p:spPr>
         <p:txBody>
-          <a:bodyPr wrap="square" lIns="0" rIns="0" tIns="0" bIns="0" anchor="t">
+          <a:bodyPr wrap="square" lIns="0" tIns="0" rIns="0" bIns="0" anchor="t">
             <a:spAutoFit/>
           </a:bodyPr>
           <a:lstStyle/>
@@ -26126,7 +26141,7 @@
           <a:noFill/>
         </p:spPr>
         <p:txBody>
-          <a:bodyPr wrap="square" lIns="0" rIns="0" tIns="0" bIns="0" anchor="t">
+          <a:bodyPr wrap="square" lIns="0" tIns="0" rIns="0" bIns="0" anchor="t">
             <a:spAutoFit/>
           </a:bodyPr>
           <a:lstStyle/>
@@ -26161,7 +26176,7 @@
           <a:noFill/>
         </p:spPr>
         <p:txBody>
-          <a:bodyPr wrap="square" lIns="0" rIns="0" tIns="0" bIns="0" anchor="t">
+          <a:bodyPr wrap="square" lIns="0" tIns="0" rIns="0" bIns="0" anchor="t">
             <a:spAutoFit/>
           </a:bodyPr>
           <a:lstStyle/>
@@ -26196,7 +26211,7 @@
           <a:noFill/>
         </p:spPr>
         <p:txBody>
-          <a:bodyPr wrap="square" lIns="0" rIns="0" tIns="0" bIns="0" anchor="t">
+          <a:bodyPr wrap="square" lIns="0" tIns="0" rIns="0" bIns="0" anchor="t">
             <a:spAutoFit/>
           </a:bodyPr>
           <a:lstStyle/>
@@ -26231,7 +26246,7 @@
           <a:noFill/>
         </p:spPr>
         <p:txBody>
-          <a:bodyPr wrap="square" lIns="0" rIns="0" tIns="0" bIns="0" anchor="t">
+          <a:bodyPr wrap="square" lIns="0" tIns="0" rIns="0" bIns="0" anchor="t">
             <a:spAutoFit/>
           </a:bodyPr>
           <a:lstStyle/>
@@ -26266,7 +26281,7 @@
           <a:noFill/>
         </p:spPr>
         <p:txBody>
-          <a:bodyPr wrap="square" lIns="0" rIns="0" tIns="0" bIns="0" anchor="t">
+          <a:bodyPr wrap="square" lIns="0" tIns="0" rIns="0" bIns="0" anchor="t">
             <a:spAutoFit/>
           </a:bodyPr>
           <a:lstStyle/>
@@ -26301,7 +26316,7 @@
           <a:noFill/>
         </p:spPr>
         <p:txBody>
-          <a:bodyPr wrap="square" lIns="0" rIns="0" tIns="0" bIns="0" anchor="t">
+          <a:bodyPr wrap="square" lIns="0" tIns="0" rIns="0" bIns="0" anchor="t">
             <a:spAutoFit/>
           </a:bodyPr>
           <a:lstStyle/>
@@ -26336,7 +26351,7 @@
           <a:noFill/>
         </p:spPr>
         <p:txBody>
-          <a:bodyPr wrap="square" lIns="0" rIns="0" tIns="0" bIns="0" anchor="t">
+          <a:bodyPr wrap="square" lIns="0" tIns="0" rIns="0" bIns="0" anchor="t">
             <a:spAutoFit/>
           </a:bodyPr>
           <a:lstStyle/>
@@ -26371,7 +26386,7 @@
           <a:noFill/>
         </p:spPr>
         <p:txBody>
-          <a:bodyPr wrap="square" lIns="0" rIns="0" tIns="0" bIns="0" anchor="t">
+          <a:bodyPr wrap="square" lIns="0" tIns="0" rIns="0" bIns="0" anchor="t">
             <a:spAutoFit/>
           </a:bodyPr>
           <a:lstStyle/>
@@ -26406,7 +26421,7 @@
           <a:noFill/>
         </p:spPr>
         <p:txBody>
-          <a:bodyPr wrap="square" lIns="0" rIns="0" tIns="0" bIns="0" anchor="t">
+          <a:bodyPr wrap="square" lIns="0" tIns="0" rIns="0" bIns="0" anchor="t">
             <a:spAutoFit/>
           </a:bodyPr>
           <a:lstStyle/>
@@ -26441,7 +26456,7 @@
           <a:noFill/>
         </p:spPr>
         <p:txBody>
-          <a:bodyPr wrap="square" lIns="0" rIns="0" tIns="0" bIns="0" anchor="t">
+          <a:bodyPr wrap="square" lIns="0" tIns="0" rIns="0" bIns="0" anchor="t">
             <a:spAutoFit/>
           </a:bodyPr>
           <a:lstStyle/>
@@ -26468,7 +26483,7 @@
 </file>
 
 <file path=ppt/slides/slide4.xml><?xml version="1.0" encoding="utf-8"?>
-<p:sld xmlns:a="http://schemas.openxmlformats.org/drawingml/2006/main" xmlns:p="http://schemas.openxmlformats.org/presentationml/2006/main" xmlns:r="http://schemas.openxmlformats.org/officeDocument/2006/relationships">
+<p:sld xmlns:a="http://schemas.openxmlformats.org/drawingml/2006/main" xmlns:r="http://schemas.openxmlformats.org/officeDocument/2006/relationships" xmlns:p="http://schemas.openxmlformats.org/presentationml/2006/main">
   <p:cSld>
     <p:spTree>
       <p:nvGrpSpPr>
@@ -26476,7 +26491,14 @@
         <p:cNvGrpSpPr/>
         <p:nvPr/>
       </p:nvGrpSpPr>
-      <p:grpSpPr/>
+      <p:grpSpPr>
+        <a:xfrm>
+          <a:off x="0" y="0"/>
+          <a:ext cx="0" cy="0"/>
+          <a:chOff x="0" y="0"/>
+          <a:chExt cx="0" cy="0"/>
+        </a:xfrm>
+      </p:grpSpPr>
       <p:sp>
         <p:nvSpPr>
           <p:cNvPr id="2" name="!!titel"/>
@@ -26543,7 +26565,7 @@
           <a:noFill/>
         </p:spPr>
         <p:txBody>
-          <a:bodyPr wrap="square" lIns="0" rIns="0" tIns="0" bIns="0" anchor="t">
+          <a:bodyPr wrap="square" lIns="0" tIns="0" rIns="0" bIns="0" anchor="t">
             <a:spAutoFit/>
           </a:bodyPr>
           <a:lstStyle/>
@@ -26606,6 +26628,7 @@
           <a:lstStyle/>
           <a:p>
             <a:pPr algn="ctr"/>
+            <a:endParaRPr/>
           </a:p>
         </p:txBody>
       </p:sp>
@@ -26626,7 +26649,7 @@
           <a:noFill/>
         </p:spPr>
         <p:txBody>
-          <a:bodyPr wrap="square" lIns="0" rIns="0" tIns="0" bIns="0" anchor="t">
+          <a:bodyPr wrap="square" lIns="0" tIns="0" rIns="0" bIns="0" anchor="t">
             <a:spAutoFit/>
           </a:bodyPr>
           <a:lstStyle/>
@@ -26685,6 +26708,7 @@
           <a:lstStyle/>
           <a:p>
             <a:pPr algn="ctr"/>
+            <a:endParaRPr/>
           </a:p>
         </p:txBody>
       </p:sp>
@@ -26705,7 +26729,7 @@
           <a:noFill/>
         </p:spPr>
         <p:txBody>
-          <a:bodyPr wrap="square" lIns="0" rIns="0" tIns="0" bIns="0" anchor="t">
+          <a:bodyPr wrap="square" lIns="0" tIns="0" rIns="0" bIns="0" anchor="t">
             <a:spAutoFit/>
           </a:bodyPr>
           <a:lstStyle/>
@@ -26764,6 +26788,7 @@
           <a:lstStyle/>
           <a:p>
             <a:pPr algn="ctr"/>
+            <a:endParaRPr/>
           </a:p>
         </p:txBody>
       </p:sp>
@@ -26784,7 +26809,7 @@
           <a:noFill/>
         </p:spPr>
         <p:txBody>
-          <a:bodyPr wrap="square" lIns="0" rIns="0" tIns="0" bIns="0" anchor="t">
+          <a:bodyPr wrap="square" lIns="0" tIns="0" rIns="0" bIns="0" anchor="t">
             <a:spAutoFit/>
           </a:bodyPr>
           <a:lstStyle/>
@@ -26819,7 +26844,7 @@
           <a:noFill/>
         </p:spPr>
         <p:txBody>
-          <a:bodyPr wrap="square" lIns="0" rIns="0" tIns="0" bIns="0" anchor="t">
+          <a:bodyPr wrap="square" lIns="0" tIns="0" rIns="0" bIns="0" anchor="t">
             <a:spAutoFit/>
           </a:bodyPr>
           <a:lstStyle/>
@@ -26854,7 +26879,7 @@
           <a:noFill/>
         </p:spPr>
         <p:txBody>
-          <a:bodyPr wrap="square" lIns="0" rIns="0" tIns="0" bIns="0" anchor="t">
+          <a:bodyPr wrap="square" lIns="0" tIns="0" rIns="0" bIns="0" anchor="t">
             <a:spAutoFit/>
           </a:bodyPr>
           <a:lstStyle/>
@@ -26889,7 +26914,7 @@
           <a:noFill/>
         </p:spPr>
         <p:txBody>
-          <a:bodyPr wrap="square" lIns="0" rIns="0" tIns="0" bIns="0" anchor="t">
+          <a:bodyPr wrap="square" lIns="0" tIns="0" rIns="0" bIns="0" anchor="t">
             <a:spAutoFit/>
           </a:bodyPr>
           <a:lstStyle/>
@@ -26924,7 +26949,7 @@
           <a:noFill/>
         </p:spPr>
         <p:txBody>
-          <a:bodyPr wrap="square" lIns="0" rIns="0" tIns="0" bIns="0" anchor="t">
+          <a:bodyPr wrap="square" lIns="0" tIns="0" rIns="0" bIns="0" anchor="t">
             <a:spAutoFit/>
           </a:bodyPr>
           <a:lstStyle/>
@@ -26959,7 +26984,7 @@
           <a:noFill/>
         </p:spPr>
         <p:txBody>
-          <a:bodyPr wrap="square" lIns="0" rIns="0" tIns="0" bIns="0" anchor="t">
+          <a:bodyPr wrap="square" lIns="0" tIns="0" rIns="0" bIns="0" anchor="t">
             <a:spAutoFit/>
           </a:bodyPr>
           <a:lstStyle/>
@@ -26994,7 +27019,7 @@
           <a:noFill/>
         </p:spPr>
         <p:txBody>
-          <a:bodyPr wrap="square" lIns="0" rIns="0" tIns="0" bIns="0" anchor="t">
+          <a:bodyPr wrap="square" lIns="0" tIns="0" rIns="0" bIns="0" anchor="t">
             <a:spAutoFit/>
           </a:bodyPr>
           <a:lstStyle/>
@@ -27029,7 +27054,7 @@
           <a:noFill/>
         </p:spPr>
         <p:txBody>
-          <a:bodyPr wrap="square" lIns="0" rIns="0" tIns="0" bIns="0" anchor="t">
+          <a:bodyPr wrap="square" lIns="0" tIns="0" rIns="0" bIns="0" anchor="t">
             <a:spAutoFit/>
           </a:bodyPr>
           <a:lstStyle/>
@@ -27064,7 +27089,7 @@
           <a:noFill/>
         </p:spPr>
         <p:txBody>
-          <a:bodyPr wrap="square" lIns="0" rIns="0" tIns="0" bIns="0" anchor="t">
+          <a:bodyPr wrap="square" lIns="0" tIns="0" rIns="0" bIns="0" anchor="t">
             <a:spAutoFit/>
           </a:bodyPr>
           <a:lstStyle/>
@@ -27099,7 +27124,7 @@
           <a:noFill/>
         </p:spPr>
         <p:txBody>
-          <a:bodyPr wrap="square" lIns="0" rIns="0" tIns="0" bIns="0" anchor="t">
+          <a:bodyPr wrap="square" lIns="0" tIns="0" rIns="0" bIns="0" anchor="t">
             <a:spAutoFit/>
           </a:bodyPr>
           <a:lstStyle/>
@@ -27134,7 +27159,7 @@
           <a:noFill/>
         </p:spPr>
         <p:txBody>
-          <a:bodyPr wrap="square" lIns="0" rIns="0" tIns="0" bIns="0" anchor="t">
+          <a:bodyPr wrap="square" lIns="0" tIns="0" rIns="0" bIns="0" anchor="t">
             <a:spAutoFit/>
           </a:bodyPr>
           <a:lstStyle/>
@@ -27169,7 +27194,7 @@
           <a:noFill/>
         </p:spPr>
         <p:txBody>
-          <a:bodyPr wrap="square" lIns="0" rIns="0" tIns="0" bIns="0" anchor="t">
+          <a:bodyPr wrap="square" lIns="0" tIns="0" rIns="0" bIns="0" anchor="t">
             <a:spAutoFit/>
           </a:bodyPr>
           <a:lstStyle/>
@@ -27204,7 +27229,7 @@
           <a:noFill/>
         </p:spPr>
         <p:txBody>
-          <a:bodyPr wrap="square" lIns="0" rIns="0" tIns="0" bIns="0" anchor="t">
+          <a:bodyPr wrap="square" lIns="0" tIns="0" rIns="0" bIns="0" anchor="t">
             <a:spAutoFit/>
           </a:bodyPr>
           <a:lstStyle/>
@@ -27239,7 +27264,7 @@
           <a:noFill/>
         </p:spPr>
         <p:txBody>
-          <a:bodyPr wrap="square" lIns="0" rIns="0" tIns="0" bIns="0" anchor="t">
+          <a:bodyPr wrap="square" lIns="0" tIns="0" rIns="0" bIns="0" anchor="t">
             <a:spAutoFit/>
           </a:bodyPr>
           <a:lstStyle/>
@@ -27274,7 +27299,7 @@
           <a:noFill/>
         </p:spPr>
         <p:txBody>
-          <a:bodyPr wrap="square" lIns="0" rIns="0" tIns="0" bIns="0" anchor="t">
+          <a:bodyPr wrap="square" lIns="0" tIns="0" rIns="0" bIns="0" anchor="t">
             <a:spAutoFit/>
           </a:bodyPr>
           <a:lstStyle/>
@@ -27309,7 +27334,7 @@
           <a:noFill/>
         </p:spPr>
         <p:txBody>
-          <a:bodyPr wrap="square" lIns="0" rIns="0" tIns="0" bIns="0" anchor="t">
+          <a:bodyPr wrap="square" lIns="0" tIns="0" rIns="0" bIns="0" anchor="t">
             <a:spAutoFit/>
           </a:bodyPr>
           <a:lstStyle/>
@@ -27344,7 +27369,7 @@
           <a:noFill/>
         </p:spPr>
         <p:txBody>
-          <a:bodyPr wrap="square" lIns="0" rIns="0" tIns="0" bIns="0" anchor="t">
+          <a:bodyPr wrap="square" lIns="0" tIns="0" rIns="0" bIns="0" anchor="t">
             <a:spAutoFit/>
           </a:bodyPr>
           <a:lstStyle/>
@@ -27379,7 +27404,7 @@
           <a:noFill/>
         </p:spPr>
         <p:txBody>
-          <a:bodyPr wrap="square" lIns="0" rIns="0" tIns="0" bIns="0" anchor="t">
+          <a:bodyPr wrap="square" lIns="0" tIns="0" rIns="0" bIns="0" anchor="t">
             <a:spAutoFit/>
           </a:bodyPr>
           <a:lstStyle/>
@@ -27414,7 +27439,7 @@
           <a:noFill/>
         </p:spPr>
         <p:txBody>
-          <a:bodyPr wrap="square" lIns="0" rIns="0" tIns="0" bIns="0" anchor="t">
+          <a:bodyPr wrap="square" lIns="0" tIns="0" rIns="0" bIns="0" anchor="t">
             <a:spAutoFit/>
           </a:bodyPr>
           <a:lstStyle/>
@@ -27449,7 +27474,7 @@
           <a:noFill/>
         </p:spPr>
         <p:txBody>
-          <a:bodyPr wrap="square" lIns="0" rIns="0" tIns="0" bIns="0" anchor="t">
+          <a:bodyPr wrap="square" lIns="0" tIns="0" rIns="0" bIns="0" anchor="t">
             <a:spAutoFit/>
           </a:bodyPr>
           <a:lstStyle/>
@@ -27484,7 +27509,7 @@
           <a:noFill/>
         </p:spPr>
         <p:txBody>
-          <a:bodyPr wrap="square" lIns="0" rIns="0" tIns="0" bIns="0" anchor="t">
+          <a:bodyPr wrap="square" lIns="0" tIns="0" rIns="0" bIns="0" anchor="t">
             <a:spAutoFit/>
           </a:bodyPr>
           <a:lstStyle/>
@@ -27519,7 +27544,7 @@
           <a:noFill/>
         </p:spPr>
         <p:txBody>
-          <a:bodyPr wrap="square" lIns="0" rIns="0" tIns="0" bIns="0" anchor="t">
+          <a:bodyPr wrap="square" lIns="0" tIns="0" rIns="0" bIns="0" anchor="t">
             <a:spAutoFit/>
           </a:bodyPr>
           <a:lstStyle/>
@@ -27554,7 +27579,7 @@
           <a:noFill/>
         </p:spPr>
         <p:txBody>
-          <a:bodyPr wrap="square" lIns="0" rIns="0" tIns="0" bIns="0" anchor="t">
+          <a:bodyPr wrap="square" lIns="0" tIns="0" rIns="0" bIns="0" anchor="t">
             <a:spAutoFit/>
           </a:bodyPr>
           <a:lstStyle/>
@@ -27589,7 +27614,7 @@
           <a:noFill/>
         </p:spPr>
         <p:txBody>
-          <a:bodyPr wrap="square" lIns="0" rIns="0" tIns="0" bIns="0" anchor="t">
+          <a:bodyPr wrap="square" lIns="0" tIns="0" rIns="0" bIns="0" anchor="t">
             <a:spAutoFit/>
           </a:bodyPr>
           <a:lstStyle/>
@@ -27612,13 +27637,13 @@
   <p:clrMapOvr>
     <a:masterClrMapping/>
   </p:clrMapOvr>
-  <mc:AlternateContent xmlns:mc="http://schemas.openxmlformats.org/markup-compatibility/2006">
-    <mc:Choice xmlns:p159="http://schemas.microsoft.com/office/powerpoint/2015/09/main" Requires="p159">
-      <p:transition xmlns:p14="http://schemas.microsoft.com/office/powerpoint/2010/main" spd="slow" p14:dur="1000">
+  <mc:AlternateContent xmlns:mc="http://schemas.openxmlformats.org/markup-compatibility/2006" xmlns:p159="http://schemas.microsoft.com/office/powerpoint/2015/09/main">
+    <mc:Choice Requires="p159">
+      <p:transition spd="slow">
         <p159:morph option="byObject"/>
       </p:transition>
     </mc:Choice>
-    <mc:Fallback>
+    <mc:Fallback xmlns="">
       <p:transition spd="slow">
         <p:fade/>
       </p:transition>
@@ -27710,7 +27735,7 @@
           <a:noFill/>
         </p:spPr>
         <p:txBody>
-          <a:bodyPr wrap="square" lIns="0" rIns="0" tIns="0" bIns="0" anchor="t">
+          <a:bodyPr wrap="square" lIns="0" tIns="0" rIns="0" bIns="0" anchor="t">
             <a:spAutoFit/>
           </a:bodyPr>
           <a:lstStyle/>
@@ -27745,7 +27770,7 @@
           <a:noFill/>
         </p:spPr>
         <p:txBody>
-          <a:bodyPr wrap="square" lIns="0" rIns="0" tIns="0" bIns="0" anchor="t">
+          <a:bodyPr wrap="square" lIns="0" tIns="0" rIns="0" bIns="0" anchor="t">
             <a:spAutoFit/>
           </a:bodyPr>
           <a:lstStyle/>
@@ -27804,6 +27829,7 @@
           <a:lstStyle/>
           <a:p>
             <a:pPr algn="ctr"/>
+            <a:endParaRPr/>
           </a:p>
         </p:txBody>
       </p:sp>
@@ -27848,6 +27874,7 @@
           <a:lstStyle/>
           <a:p>
             <a:pPr algn="ctr"/>
+            <a:endParaRPr/>
           </a:p>
         </p:txBody>
       </p:sp>
@@ -27892,6 +27919,7 @@
           <a:lstStyle/>
           <a:p>
             <a:pPr algn="ctr"/>
+            <a:endParaRPr/>
           </a:p>
         </p:txBody>
       </p:sp>
@@ -27936,7 +27964,7 @@
           <a:noFill/>
         </p:spPr>
         <p:txBody>
-          <a:bodyPr wrap="square" lIns="0" rIns="0" tIns="0" bIns="0" anchor="t">
+          <a:bodyPr wrap="square" lIns="0" tIns="0" rIns="0" bIns="0" anchor="t">
             <a:spAutoFit/>
           </a:bodyPr>
           <a:lstStyle/>
@@ -27971,7 +27999,7 @@
           <a:noFill/>
         </p:spPr>
         <p:txBody>
-          <a:bodyPr wrap="square" lIns="0" rIns="0" tIns="0" bIns="0" anchor="t">
+          <a:bodyPr wrap="square" lIns="0" tIns="0" rIns="0" bIns="0" anchor="t">
             <a:spAutoFit/>
           </a:bodyPr>
           <a:lstStyle/>
@@ -28030,6 +28058,7 @@
           <a:lstStyle/>
           <a:p>
             <a:pPr algn="ctr"/>
+            <a:endParaRPr/>
           </a:p>
         </p:txBody>
       </p:sp>
@@ -28074,7 +28103,7 @@
           <a:noFill/>
         </p:spPr>
         <p:txBody>
-          <a:bodyPr wrap="square" lIns="0" rIns="0" tIns="0" bIns="0" anchor="t">
+          <a:bodyPr wrap="square" lIns="0" tIns="0" rIns="0" bIns="0" anchor="t">
             <a:spAutoFit/>
           </a:bodyPr>
           <a:lstStyle/>
@@ -28109,7 +28138,7 @@
           <a:noFill/>
         </p:spPr>
         <p:txBody>
-          <a:bodyPr wrap="square" lIns="0" rIns="0" tIns="0" bIns="0" anchor="t">
+          <a:bodyPr wrap="square" lIns="0" tIns="0" rIns="0" bIns="0" anchor="t">
             <a:spAutoFit/>
           </a:bodyPr>
           <a:lstStyle/>
@@ -28168,6 +28197,7 @@
           <a:lstStyle/>
           <a:p>
             <a:pPr algn="ctr"/>
+            <a:endParaRPr/>
           </a:p>
         </p:txBody>
       </p:sp>
@@ -28212,7 +28242,7 @@
           <a:noFill/>
         </p:spPr>
         <p:txBody>
-          <a:bodyPr wrap="square" lIns="0" rIns="0" tIns="0" bIns="0" anchor="t">
+          <a:bodyPr wrap="square" lIns="0" tIns="0" rIns="0" bIns="0" anchor="t">
             <a:spAutoFit/>
           </a:bodyPr>
           <a:lstStyle/>
@@ -28247,7 +28277,7 @@
           <a:noFill/>
         </p:spPr>
         <p:txBody>
-          <a:bodyPr wrap="square" lIns="0" rIns="0" tIns="0" bIns="0" anchor="t">
+          <a:bodyPr wrap="square" lIns="0" tIns="0" rIns="0" bIns="0" anchor="t">
             <a:spAutoFit/>
           </a:bodyPr>
           <a:lstStyle/>
@@ -28306,6 +28336,7 @@
           <a:lstStyle/>
           <a:p>
             <a:pPr algn="ctr"/>
+            <a:endParaRPr/>
           </a:p>
         </p:txBody>
       </p:sp>
@@ -28350,7 +28381,7 @@
           <a:noFill/>
         </p:spPr>
         <p:txBody>
-          <a:bodyPr wrap="square" lIns="0" rIns="0" tIns="0" bIns="0" anchor="t">
+          <a:bodyPr wrap="square" lIns="0" tIns="0" rIns="0" bIns="0" anchor="t">
             <a:spAutoFit/>
           </a:bodyPr>
           <a:lstStyle/>
@@ -28385,7 +28416,7 @@
           <a:noFill/>
         </p:spPr>
         <p:txBody>
-          <a:bodyPr wrap="square" lIns="0" rIns="0" tIns="0" bIns="0" anchor="t">
+          <a:bodyPr wrap="square" lIns="0" tIns="0" rIns="0" bIns="0" anchor="t">
             <a:spAutoFit/>
           </a:bodyPr>
           <a:lstStyle/>
@@ -28494,7 +28525,7 @@
           <a:noFill/>
         </p:spPr>
         <p:txBody>
-          <a:bodyPr wrap="square" lIns="0" rIns="0" tIns="0" bIns="0" anchor="t">
+          <a:bodyPr wrap="square" lIns="0" tIns="0" rIns="0" bIns="0" anchor="t">
             <a:spAutoFit/>
           </a:bodyPr>
           <a:lstStyle/>
@@ -28529,7 +28560,7 @@
           <a:noFill/>
         </p:spPr>
         <p:txBody>
-          <a:bodyPr wrap="square" lIns="0" rIns="0" tIns="0" bIns="0" anchor="t">
+          <a:bodyPr wrap="square" lIns="0" tIns="0" rIns="0" bIns="0" anchor="t">
             <a:spAutoFit/>
           </a:bodyPr>
           <a:lstStyle/>
@@ -28564,7 +28595,7 @@
           <a:noFill/>
         </p:spPr>
         <p:txBody>
-          <a:bodyPr wrap="square" lIns="0" rIns="0" tIns="0" bIns="0" anchor="t">
+          <a:bodyPr wrap="square" lIns="0" tIns="0" rIns="0" bIns="0" anchor="t">
             <a:spAutoFit/>
           </a:bodyPr>
           <a:lstStyle/>
@@ -28627,6 +28658,7 @@
           <a:lstStyle/>
           <a:p>
             <a:pPr algn="ctr"/>
+            <a:endParaRPr/>
           </a:p>
         </p:txBody>
       </p:sp>
@@ -28647,7 +28679,7 @@
           <a:noFill/>
         </p:spPr>
         <p:txBody>
-          <a:bodyPr wrap="square" lIns="0" rIns="0" tIns="0" bIns="0" anchor="t">
+          <a:bodyPr wrap="square" lIns="0" tIns="0" rIns="0" bIns="0" anchor="t">
             <a:spAutoFit/>
           </a:bodyPr>
           <a:lstStyle/>
@@ -28706,7 +28738,7 @@
           <a:noFill/>
         </p:spPr>
         <p:txBody>
-          <a:bodyPr wrap="square" lIns="0" rIns="0" tIns="0" bIns="0" anchor="t">
+          <a:bodyPr wrap="square" lIns="0" tIns="0" rIns="0" bIns="0" anchor="t">
             <a:spAutoFit/>
           </a:bodyPr>
           <a:lstStyle/>
@@ -28777,7 +28809,7 @@
           <a:noFill/>
         </p:spPr>
         <p:txBody>
-          <a:bodyPr wrap="square" lIns="0" rIns="0" tIns="0" bIns="0" anchor="t">
+          <a:bodyPr wrap="square" lIns="0" tIns="0" rIns="0" bIns="0" anchor="t">
             <a:spAutoFit/>
           </a:bodyPr>
           <a:lstStyle/>
@@ -28848,7 +28880,7 @@
           <a:noFill/>
         </p:spPr>
         <p:txBody>
-          <a:bodyPr wrap="square" lIns="0" rIns="0" tIns="0" bIns="0" anchor="t">
+          <a:bodyPr wrap="square" lIns="0" tIns="0" rIns="0" bIns="0" anchor="t">
             <a:spAutoFit/>
           </a:bodyPr>
           <a:lstStyle/>
@@ -28919,7 +28951,7 @@
           <a:noFill/>
         </p:spPr>
         <p:txBody>
-          <a:bodyPr wrap="square" lIns="0" rIns="0" tIns="0" bIns="0" anchor="t">
+          <a:bodyPr wrap="square" lIns="0" tIns="0" rIns="0" bIns="0" anchor="t">
             <a:spAutoFit/>
           </a:bodyPr>
           <a:lstStyle/>
@@ -28946,7 +28978,7 @@
 </file>
 
 <file path=ppt/slides/slide7.xml><?xml version="1.0" encoding="utf-8"?>
-<p:sld xmlns:a="http://schemas.openxmlformats.org/drawingml/2006/main" xmlns:p="http://schemas.openxmlformats.org/presentationml/2006/main" xmlns:r="http://schemas.openxmlformats.org/officeDocument/2006/relationships">
+<p:sld xmlns:a="http://schemas.openxmlformats.org/drawingml/2006/main" xmlns:r="http://schemas.openxmlformats.org/officeDocument/2006/relationships" xmlns:p="http://schemas.openxmlformats.org/presentationml/2006/main">
   <p:cSld>
     <p:spTree>
       <p:nvGrpSpPr>
@@ -28954,7 +28986,14 @@
         <p:cNvGrpSpPr/>
         <p:nvPr/>
       </p:nvGrpSpPr>
-      <p:grpSpPr/>
+      <p:grpSpPr>
+        <a:xfrm>
+          <a:off x="0" y="0"/>
+          <a:ext cx="0" cy="0"/>
+          <a:chOff x="0" y="0"/>
+          <a:chExt cx="0" cy="0"/>
+        </a:xfrm>
+      </p:grpSpPr>
       <p:sp>
         <p:nvSpPr>
           <p:cNvPr id="2" name="!!titel"/>
@@ -29021,7 +29060,7 @@
           <a:noFill/>
         </p:spPr>
         <p:txBody>
-          <a:bodyPr wrap="square" lIns="0" rIns="0" tIns="0" bIns="0" anchor="t">
+          <a:bodyPr wrap="square" lIns="0" tIns="0" rIns="0" bIns="0" anchor="t">
             <a:spAutoFit/>
           </a:bodyPr>
           <a:lstStyle/>
@@ -29084,6 +29123,7 @@
           <a:lstStyle/>
           <a:p>
             <a:pPr algn="ctr"/>
+            <a:endParaRPr/>
           </a:p>
         </p:txBody>
       </p:sp>
@@ -29104,7 +29144,7 @@
           <a:noFill/>
         </p:spPr>
         <p:txBody>
-          <a:bodyPr wrap="square" lIns="0" rIns="0" tIns="0" bIns="0" anchor="t">
+          <a:bodyPr wrap="square" lIns="0" tIns="0" rIns="0" bIns="0" anchor="t">
             <a:spAutoFit/>
           </a:bodyPr>
           <a:lstStyle/>
@@ -29163,7 +29203,7 @@
           <a:noFill/>
         </p:spPr>
         <p:txBody>
-          <a:bodyPr wrap="square" lIns="0" rIns="0" tIns="0" bIns="0" anchor="t">
+          <a:bodyPr wrap="square" lIns="0" tIns="0" rIns="0" bIns="0" anchor="t">
             <a:spAutoFit/>
           </a:bodyPr>
           <a:lstStyle/>
@@ -29234,7 +29274,7 @@
           <a:noFill/>
         </p:spPr>
         <p:txBody>
-          <a:bodyPr wrap="square" lIns="0" rIns="0" tIns="0" bIns="0" anchor="t">
+          <a:bodyPr wrap="square" lIns="0" tIns="0" rIns="0" bIns="0" anchor="t">
             <a:spAutoFit/>
           </a:bodyPr>
           <a:lstStyle/>
@@ -29305,7 +29345,7 @@
           <a:noFill/>
         </p:spPr>
         <p:txBody>
-          <a:bodyPr wrap="square" lIns="0" rIns="0" tIns="0" bIns="0" anchor="t">
+          <a:bodyPr wrap="square" lIns="0" tIns="0" rIns="0" bIns="0" anchor="t">
             <a:spAutoFit/>
           </a:bodyPr>
           <a:lstStyle/>
@@ -29344,7 +29384,7 @@
           <p:nvPr/>
         </p:nvPicPr>
         <p:blipFill>
-          <a:blip r:embed="rId2"/>
+          <a:blip r:embed="rId6"/>
           <a:stretch>
             <a:fillRect/>
           </a:stretch>
@@ -29376,7 +29416,7 @@
           <a:noFill/>
         </p:spPr>
         <p:txBody>
-          <a:bodyPr wrap="square" lIns="0" rIns="0" tIns="0" bIns="0" anchor="t">
+          <a:bodyPr wrap="square" lIns="0" tIns="0" rIns="0" bIns="0" anchor="t">
             <a:spAutoFit/>
           </a:bodyPr>
           <a:lstStyle/>
@@ -29449,7 +29489,7 @@
           </a:solidFill>
         </p:spPr>
         <p:txBody>
-          <a:bodyPr wrap="square" lIns="0" rIns="0" tIns="0" bIns="0" anchor="t">
+          <a:bodyPr wrap="square" lIns="0" tIns="0" rIns="0" bIns="0" anchor="t">
             <a:spAutoFit/>
           </a:bodyPr>
           <a:lstStyle/>
@@ -29484,7 +29524,7 @@
           <a:noFill/>
         </p:spPr>
         <p:txBody>
-          <a:bodyPr wrap="square" lIns="0" rIns="0" tIns="0" bIns="0" anchor="t">
+          <a:bodyPr wrap="square" lIns="0" tIns="0" rIns="0" bIns="0" anchor="t">
             <a:spAutoFit/>
           </a:bodyPr>
           <a:lstStyle/>
@@ -29578,7 +29618,7 @@
           <a:noFill/>
         </p:spPr>
         <p:txBody>
-          <a:bodyPr wrap="square" lIns="0" rIns="0" tIns="0" bIns="0" anchor="t">
+          <a:bodyPr wrap="square" lIns="0" tIns="0" rIns="0" bIns="0" anchor="t">
             <a:spAutoFit/>
           </a:bodyPr>
           <a:lstStyle/>
@@ -29613,7 +29653,7 @@
           <a:noFill/>
         </p:spPr>
         <p:txBody>
-          <a:bodyPr wrap="square" lIns="0" rIns="0" tIns="0" bIns="0" anchor="t">
+          <a:bodyPr wrap="square" lIns="0" tIns="0" rIns="0" bIns="0" anchor="t">
             <a:spAutoFit/>
           </a:bodyPr>
           <a:lstStyle/>
@@ -29672,7 +29712,7 @@
           <a:noFill/>
         </p:spPr>
         <p:txBody>
-          <a:bodyPr wrap="square" lIns="0" rIns="0" tIns="0" bIns="0" anchor="t">
+          <a:bodyPr wrap="square" lIns="0" tIns="0" rIns="0" bIns="0" anchor="t">
             <a:spAutoFit/>
           </a:bodyPr>
           <a:lstStyle/>
@@ -29707,7 +29747,7 @@
           <a:noFill/>
         </p:spPr>
         <p:txBody>
-          <a:bodyPr wrap="square" lIns="0" rIns="0" tIns="0" bIns="0" anchor="t">
+          <a:bodyPr wrap="square" lIns="0" tIns="0" rIns="0" bIns="0" anchor="t">
             <a:spAutoFit/>
           </a:bodyPr>
           <a:lstStyle/>
@@ -29742,7 +29782,7 @@
           <a:noFill/>
         </p:spPr>
         <p:txBody>
-          <a:bodyPr wrap="square" lIns="0" rIns="0" tIns="0" bIns="0" anchor="t">
+          <a:bodyPr wrap="square" lIns="0" tIns="0" rIns="0" bIns="0" anchor="t">
             <a:spAutoFit/>
           </a:bodyPr>
           <a:lstStyle/>
@@ -29836,7 +29876,7 @@
           <a:noFill/>
         </p:spPr>
         <p:txBody>
-          <a:bodyPr wrap="square" lIns="0" rIns="0" tIns="0" bIns="0" anchor="t">
+          <a:bodyPr wrap="square" lIns="0" tIns="0" rIns="0" bIns="0" anchor="t">
             <a:spAutoFit/>
           </a:bodyPr>
           <a:lstStyle/>
@@ -29871,7 +29911,7 @@
           <a:noFill/>
         </p:spPr>
         <p:txBody>
-          <a:bodyPr wrap="square" lIns="0" rIns="0" tIns="0" bIns="0" anchor="t">
+          <a:bodyPr wrap="square" lIns="0" tIns="0" rIns="0" bIns="0" anchor="t">
             <a:spAutoFit/>
           </a:bodyPr>
           <a:lstStyle/>
@@ -29930,7 +29970,7 @@
           <a:noFill/>
         </p:spPr>
         <p:txBody>
-          <a:bodyPr wrap="square" lIns="0" rIns="0" tIns="0" bIns="0" anchor="t">
+          <a:bodyPr wrap="square" lIns="0" tIns="0" rIns="0" bIns="0" anchor="t">
             <a:spAutoFit/>
           </a:bodyPr>
           <a:lstStyle/>
@@ -29965,7 +30005,7 @@
           <a:noFill/>
         </p:spPr>
         <p:txBody>
-          <a:bodyPr wrap="square" lIns="0" rIns="0" tIns="0" bIns="0" anchor="t">
+          <a:bodyPr wrap="square" lIns="0" tIns="0" rIns="0" bIns="0" anchor="t">
             <a:spAutoFit/>
           </a:bodyPr>
           <a:lstStyle/>
@@ -30024,7 +30064,7 @@
           <a:noFill/>
         </p:spPr>
         <p:txBody>
-          <a:bodyPr wrap="square" lIns="0" rIns="0" tIns="0" bIns="0" anchor="t">
+          <a:bodyPr wrap="square" lIns="0" tIns="0" rIns="0" bIns="0" anchor="t">
             <a:spAutoFit/>
           </a:bodyPr>
           <a:lstStyle/>
@@ -30059,7 +30099,7 @@
           <a:noFill/>
         </p:spPr>
         <p:txBody>
-          <a:bodyPr wrap="square" lIns="0" rIns="0" tIns="0" bIns="0" anchor="t">
+          <a:bodyPr wrap="square" lIns="0" tIns="0" rIns="0" bIns="0" anchor="t">
             <a:spAutoFit/>
           </a:bodyPr>
           <a:lstStyle/>
@@ -30094,7 +30134,7 @@
           <a:noFill/>
         </p:spPr>
         <p:txBody>
-          <a:bodyPr wrap="square" lIns="0" rIns="0" tIns="0" bIns="0" anchor="t">
+          <a:bodyPr wrap="square" lIns="0" tIns="0" rIns="0" bIns="0" anchor="t">
             <a:spAutoFit/>
           </a:bodyPr>
           <a:lstStyle/>
@@ -30188,7 +30228,7 @@
           <a:noFill/>
         </p:spPr>
         <p:txBody>
-          <a:bodyPr wrap="square" lIns="0" rIns="0" tIns="0" bIns="0" anchor="t">
+          <a:bodyPr wrap="square" lIns="0" tIns="0" rIns="0" bIns="0" anchor="t">
             <a:spAutoFit/>
           </a:bodyPr>
           <a:lstStyle/>
@@ -30223,7 +30263,7 @@
           <a:noFill/>
         </p:spPr>
         <p:txBody>
-          <a:bodyPr wrap="square" lIns="0" rIns="0" tIns="0" bIns="0" anchor="t">
+          <a:bodyPr wrap="square" lIns="0" tIns="0" rIns="0" bIns="0" anchor="t">
             <a:spAutoFit/>
           </a:bodyPr>
           <a:lstStyle/>
@@ -30246,13 +30286,13 @@
   <p:clrMapOvr>
     <a:masterClrMapping/>
   </p:clrMapOvr>
-  <mc:AlternateContent xmlns:mc="http://schemas.openxmlformats.org/markup-compatibility/2006">
-    <mc:Choice xmlns:p159="http://schemas.microsoft.com/office/powerpoint/2015/09/main" Requires="p159">
-      <p:transition xmlns:p14="http://schemas.microsoft.com/office/powerpoint/2010/main" spd="slow" p14:dur="700">
+  <mc:AlternateContent xmlns:mc="http://schemas.openxmlformats.org/markup-compatibility/2006" xmlns:p159="http://schemas.microsoft.com/office/powerpoint/2015/09/main">
+    <mc:Choice Requires="p159">
+      <p:transition xmlns:p14="http://schemas.microsoft.com/office/powerpoint/2010/main" spd="med" p14:dur="700">
         <p159:morph option="byObject"/>
       </p:transition>
     </mc:Choice>
-    <mc:Fallback>
+    <mc:Fallback xmlns="">
       <p:transition spd="slow">
         <p:fade/>
       </p:transition>
@@ -33162,5 +33202,6 @@
 <file path=docMetadata/LabelInfo.xml><?xml version="1.0" encoding="utf-8"?>
 <clbl:labelList xmlns:clbl="http://schemas.microsoft.com/office/2020/mipLabelMetadata">
   <clbl:label id="{0cf7ac0a-4681-4823-ab0b-04ef02c5f873}" enabled="1" method="Standard" siteId="{42f7676c-f455-423c-82f6-dc2d99791af7}" contentBits="0" removed="0"/>
+  <clbl:label id="{ef8fba50-8da3-4418-b31b-a5eabe482877}" enabled="1" method="Standard" siteId="{655bc315-ddc8-46fd-8e94-a3e104272732}" contentBits="0" removed="0"/>
 </clbl:labelList>
 </file>
</xml_diff>